<commit_message>
Multi-client server, bursty cross-traffic proxy and eval, polite-mode sweep, docs updated
Co-Authored-By: Claude Sonnet 5.5 <noreply@anthropic.com>
Claude-Session: https://claude.ai/code/session_01NX2zRNpdVAnzFNKmqomzKu
</commit_message>
<xml_diff>
--- a/docs/RUDP_Presentation.pptx
+++ b/docs/RUDP_Presentation.pptx
@@ -37,9 +37,10 @@
     <p:sldId id="285" r:id="rId31"/>
     <p:sldId id="286" r:id="rId32"/>
     <p:sldId id="287" r:id="rId33"/>
+    <p:sldId id="288" r:id="rId34"/>
   </p:sldIdLst>
   <p:notesMasterIdLst>
-    <p:notesMasterId r:id="rId34"/>
+    <p:notesMasterId r:id="rId35"/>
   </p:notesMasterIdLst>
   <p:sldSz cx="12192000" cy="6858000"/>
   <p:notesSz cx="6858000" cy="12192000"/>
@@ -3058,6 +3059,94 @@
             <a:fld id="{F7021451-1387-4CA6-816F-3879F97B5CBC}" type="slidenum">
               <a:rPr lang="en-US"/>
               <a:t>32</a:t>
+            </a:fld>
+            <a:endParaRPr lang="en-US"/>
+          </a:p>
+        </p:txBody>
+      </p:sp>
+    </p:spTree>
+    <p:extLst>
+      <p:ext uri="{BB962C8B-B14F-4D97-AF65-F5344CB8AC3E}">
+        <p14:creationId xmlns:p14="http://schemas.microsoft.com/office/powerpoint/2010/main" val="1024086991"/>
+      </p:ext>
+    </p:extLst>
+  </p:cSld>
+  <p:clrMapOvr>
+    <a:masterClrMapping/>
+  </p:clrMapOvr>
+</p:notes>
+</file>
+
+<file path=ppt/notesSlides/notesSlide33.xml><?xml version="1.0" encoding="utf-8"?>
+<p:notes xmlns:a="http://schemas.openxmlformats.org/drawingml/2006/main" xmlns:r="http://schemas.openxmlformats.org/officeDocument/2006/relationships" xmlns:p="http://schemas.openxmlformats.org/presentationml/2006/main">
+  <p:cSld>
+    <p:spTree>
+      <p:nvGrpSpPr>
+        <p:cNvPr id="1" name=""/>
+        <p:cNvGrpSpPr/>
+        <p:nvPr/>
+      </p:nvGrpSpPr>
+      <p:grpSpPr>
+        <a:xfrm>
+          <a:off x="0" y="0"/>
+          <a:ext cx="0" cy="0"/>
+          <a:chOff x="0" y="0"/>
+          <a:chExt cx="0" cy="0"/>
+        </a:xfrm>
+      </p:grpSpPr>
+      <p:sp>
+        <p:nvSpPr>
+          <p:cNvPr id="2" name="Slide Image Placeholder 1"/>
+          <p:cNvSpPr>
+            <a:spLocks noGrp="1" noRot="1" noChangeAspect="1"/>
+          </p:cNvSpPr>
+          <p:nvPr>
+            <p:ph type="sldImg"/>
+          </p:nvPr>
+        </p:nvSpPr>
+        <p:spPr/>
+      </p:sp>
+      <p:sp>
+        <p:nvSpPr>
+          <p:cNvPr id="3" name="Notes Placeholder 2"/>
+          <p:cNvSpPr>
+            <a:spLocks noGrp="1"/>
+          </p:cNvSpPr>
+          <p:nvPr>
+            <p:ph type="body" idx="1"/>
+          </p:nvPr>
+        </p:nvSpPr>
+        <p:spPr/>
+        <p:txBody>
+          <a:bodyPr/>
+          <a:lstStyle/>
+          <a:p>
+            <a:r>
+              <a:rPr lang="en-US" dirty="0"/>
+              <a:t/>
+            </a:r>
+            <a:endParaRPr lang="en-US" dirty="0"/>
+          </a:p>
+        </p:txBody>
+      </p:sp>
+      <p:sp>
+        <p:nvSpPr>
+          <p:cNvPr id="4" name="Slide Number Placeholder 3"/>
+          <p:cNvSpPr>
+            <a:spLocks noGrp="1"/>
+          </p:cNvSpPr>
+          <p:nvPr>
+            <p:ph type="sldNum" sz="quarter" idx="10"/>
+          </p:nvPr>
+        </p:nvSpPr>
+        <p:spPr/>
+        <p:txBody>
+          <a:bodyPr/>
+          <a:lstStyle/>
+          <a:p>
+            <a:fld id="{F7021451-1387-4CA6-816F-3879F97B5CBC}" type="slidenum">
+              <a:rPr lang="en-US"/>
+              <a:t>33</a:t>
             </a:fld>
             <a:endParaRPr lang="en-US"/>
           </a:p>
@@ -4195,7 +4284,7 @@
                 <a:ea typeface="Courier New" pitchFamily="34" charset="-122"/>
                 <a:cs typeface="Courier New" pitchFamily="34" charset="-120"/>
               </a:rPr>
-              <a:t>10 / 32   Smart-RUDP</a:t>
+              <a:t>10 / 33   Smart-RUDP</a:t>
             </a:r>
             <a:endParaRPr lang="en-US" sz="1000" dirty="0"/>
           </a:p>
@@ -4392,7 +4481,7 @@
                 <a:ea typeface="Courier New" pitchFamily="34" charset="-122"/>
                 <a:cs typeface="Courier New" pitchFamily="34" charset="-120"/>
               </a:rPr>
-              <a:t>11 / 32   Smart-RUDP</a:t>
+              <a:t>11 / 33   Smart-RUDP</a:t>
             </a:r>
             <a:endParaRPr lang="en-US" sz="1000" dirty="0"/>
           </a:p>
@@ -5222,7 +5311,7 @@
                 <a:ea typeface="Courier New" pitchFamily="34" charset="-122"/>
                 <a:cs typeface="Courier New" pitchFamily="34" charset="-120"/>
               </a:rPr>
-              <a:t>12 / 32   Smart-RUDP</a:t>
+              <a:t>12 / 33   Smart-RUDP</a:t>
             </a:r>
             <a:endParaRPr lang="en-US" sz="1000" dirty="0"/>
           </a:p>
@@ -5519,7 +5608,7 @@
                 <a:ea typeface="Courier New" pitchFamily="34" charset="-122"/>
                 <a:cs typeface="Courier New" pitchFamily="34" charset="-120"/>
               </a:rPr>
-              <a:t>13 / 32   Smart-RUDP</a:t>
+              <a:t>13 / 33   Smart-RUDP</a:t>
             </a:r>
             <a:endParaRPr lang="en-US" sz="1000" dirty="0"/>
           </a:p>
@@ -5819,7 +5908,7 @@
                 <a:ea typeface="Courier New" pitchFamily="34" charset="-122"/>
                 <a:cs typeface="Courier New" pitchFamily="34" charset="-120"/>
               </a:rPr>
-              <a:t>14 / 32   Smart-RUDP</a:t>
+              <a:t>14 / 33   Smart-RUDP</a:t>
             </a:r>
             <a:endParaRPr lang="en-US" sz="1000" dirty="0"/>
           </a:p>
@@ -6203,7 +6292,7 @@
                 <a:ea typeface="Courier New" pitchFamily="34" charset="-122"/>
                 <a:cs typeface="Courier New" pitchFamily="34" charset="-120"/>
               </a:rPr>
-              <a:t>15 / 32   Smart-RUDP</a:t>
+              <a:t>15 / 33   Smart-RUDP</a:t>
             </a:r>
             <a:endParaRPr lang="en-US" sz="1000" dirty="0"/>
           </a:p>
@@ -6661,7 +6750,7 @@
                 <a:ea typeface="Courier New" pitchFamily="34" charset="-122"/>
                 <a:cs typeface="Courier New" pitchFamily="34" charset="-120"/>
               </a:rPr>
-              <a:t>16 / 32   Smart-RUDP</a:t>
+              <a:t>16 / 33   Smart-RUDP</a:t>
             </a:r>
             <a:endParaRPr lang="en-US" sz="1000" dirty="0"/>
           </a:p>
@@ -7346,7 +7435,7 @@
                 <a:ea typeface="Courier New" pitchFamily="34" charset="-122"/>
                 <a:cs typeface="Courier New" pitchFamily="34" charset="-120"/>
               </a:rPr>
-              <a:t>17 / 32   Smart-RUDP</a:t>
+              <a:t>17 / 33   Smart-RUDP</a:t>
             </a:r>
             <a:endParaRPr lang="en-US" sz="1000" dirty="0"/>
           </a:p>
@@ -7586,7 +7675,7 @@
                 <a:ea typeface="Courier New" pitchFamily="34" charset="-122"/>
                 <a:cs typeface="Courier New" pitchFamily="34" charset="-120"/>
               </a:rPr>
-              <a:t>18 / 32   Smart-RUDP</a:t>
+              <a:t>18 / 33   Smart-RUDP</a:t>
             </a:r>
             <a:endParaRPr lang="en-US" sz="1000" dirty="0"/>
           </a:p>
@@ -7826,7 +7915,7 @@
                 <a:ea typeface="Courier New" pitchFamily="34" charset="-122"/>
                 <a:cs typeface="Courier New" pitchFamily="34" charset="-120"/>
               </a:rPr>
-              <a:t>19 / 32   Smart-RUDP</a:t>
+              <a:t>19 / 33   Smart-RUDP</a:t>
             </a:r>
             <a:endParaRPr lang="en-US" sz="1000" dirty="0"/>
           </a:p>
@@ -8048,7 +8137,7 @@
                 <a:ea typeface="Courier New" pitchFamily="34" charset="-122"/>
                 <a:cs typeface="Courier New" pitchFamily="34" charset="-120"/>
               </a:rPr>
-              <a:t>2 / 32   Smart-RUDP</a:t>
+              <a:t>2 / 33   Smart-RUDP</a:t>
             </a:r>
             <a:endParaRPr lang="en-US" sz="1000" dirty="0"/>
           </a:p>
@@ -8442,7 +8531,7 @@
                 <a:ea typeface="Courier New" pitchFamily="34" charset="-122"/>
                 <a:cs typeface="Courier New" pitchFamily="34" charset="-120"/>
               </a:rPr>
-              <a:t>20 / 32   Smart-RUDP</a:t>
+              <a:t>20 / 33   Smart-RUDP</a:t>
             </a:r>
             <a:endParaRPr lang="en-US" sz="1000" dirty="0"/>
           </a:p>
@@ -8766,7 +8855,7 @@
                 <a:ea typeface="Courier New" pitchFamily="34" charset="-122"/>
                 <a:cs typeface="Courier New" pitchFamily="34" charset="-120"/>
               </a:rPr>
-              <a:t>21 / 32   Smart-RUDP</a:t>
+              <a:t>21 / 33   Smart-RUDP</a:t>
             </a:r>
             <a:endParaRPr lang="en-US" sz="1000" dirty="0"/>
           </a:p>
@@ -10473,7 +10562,7 @@
                 <a:ea typeface="Courier New" pitchFamily="34" charset="-122"/>
                 <a:cs typeface="Courier New" pitchFamily="34" charset="-120"/>
               </a:rPr>
-              <a:t>22 / 32   Smart-RUDP</a:t>
+              <a:t>22 / 33   Smart-RUDP</a:t>
             </a:r>
             <a:endParaRPr lang="en-US" sz="1000" dirty="0"/>
           </a:p>
@@ -11856,7 +11945,7 @@
                 <a:ea typeface="Courier New" pitchFamily="34" charset="-122"/>
                 <a:cs typeface="Courier New" pitchFamily="34" charset="-120"/>
               </a:rPr>
-              <a:t>23 / 32   Smart-RUDP</a:t>
+              <a:t>23 / 33   Smart-RUDP</a:t>
             </a:r>
             <a:endParaRPr lang="en-US" sz="1000" dirty="0"/>
           </a:p>
@@ -13399,7 +13488,7 @@
                 <a:ea typeface="Courier New" pitchFamily="34" charset="-122"/>
                 <a:cs typeface="Courier New" pitchFamily="34" charset="-120"/>
               </a:rPr>
-              <a:t>24 / 32   Smart-RUDP</a:t>
+              <a:t>24 / 33   Smart-RUDP</a:t>
             </a:r>
             <a:endParaRPr lang="en-US" sz="1000" dirty="0"/>
           </a:p>
@@ -15077,7 +15166,7 @@
                 <a:ea typeface="Courier New" pitchFamily="34" charset="-122"/>
                 <a:cs typeface="Courier New" pitchFamily="34" charset="-120"/>
               </a:rPr>
-              <a:t>25 / 32   Smart-RUDP</a:t>
+              <a:t>25 / 33   Smart-RUDP</a:t>
             </a:r>
             <a:endParaRPr lang="en-US" sz="1000" dirty="0"/>
           </a:p>
@@ -16755,7 +16844,7 @@
                 <a:ea typeface="Courier New" pitchFamily="34" charset="-122"/>
                 <a:cs typeface="Courier New" pitchFamily="34" charset="-120"/>
               </a:rPr>
-              <a:t>26 / 32   Smart-RUDP</a:t>
+              <a:t>26 / 33   Smart-RUDP</a:t>
             </a:r>
             <a:endParaRPr lang="en-US" sz="1000" dirty="0"/>
           </a:p>
@@ -19095,7 +19184,7 @@
                 <a:ea typeface="Courier New" pitchFamily="34" charset="-122"/>
                 <a:cs typeface="Courier New" pitchFamily="34" charset="-120"/>
               </a:rPr>
-              <a:t>27 / 32   Smart-RUDP</a:t>
+              <a:t>27 / 33   Smart-RUDP</a:t>
             </a:r>
             <a:endParaRPr lang="en-US" sz="1000" dirty="0"/>
           </a:p>
@@ -19553,7 +19642,7 @@
                 <a:ea typeface="Courier New" pitchFamily="34" charset="-122"/>
                 <a:cs typeface="Courier New" pitchFamily="34" charset="-120"/>
               </a:rPr>
-              <a:t>28 / 32   Smart-RUDP</a:t>
+              <a:t>28 / 33   Smart-RUDP</a:t>
             </a:r>
             <a:endParaRPr lang="en-US" sz="1000" dirty="0"/>
           </a:p>
@@ -19785,7 +19874,7 @@
                 <a:ea typeface="Courier New" pitchFamily="34" charset="-122"/>
                 <a:cs typeface="Courier New" pitchFamily="34" charset="-120"/>
               </a:rPr>
-              <a:t>29 / 32   Smart-RUDP</a:t>
+              <a:t>29 / 33   Smart-RUDP</a:t>
             </a:r>
             <a:endParaRPr lang="en-US" sz="1000" dirty="0"/>
           </a:p>
@@ -22531,7 +22620,7 @@
                 <a:ea typeface="Courier New" pitchFamily="34" charset="-122"/>
                 <a:cs typeface="Courier New" pitchFamily="34" charset="-120"/>
               </a:rPr>
-              <a:t>3 / 32   Smart-RUDP</a:t>
+              <a:t>3 / 33   Smart-RUDP</a:t>
             </a:r>
             <a:endParaRPr lang="en-US" sz="1000" dirty="0"/>
           </a:p>
@@ -22886,7 +22975,7 @@
                 <a:ea typeface="Courier New" pitchFamily="34" charset="-122"/>
                 <a:cs typeface="Courier New" pitchFamily="34" charset="-120"/>
               </a:rPr>
-              <a:t>Learnings and future work</a:t>
+              <a:t>Closing gaps: fairness and cross traffic</a:t>
             </a:r>
             <a:endParaRPr lang="en-US" sz="3000" dirty="0"/>
           </a:p>
@@ -22925,86 +23014,2144 @@
                 <a:ea typeface="Courier New" pitchFamily="34" charset="-122"/>
                 <a:cs typeface="Courier New" pitchFamily="34" charset="-120"/>
               </a:rPr>
-              <a:t>30 / 32   Smart-RUDP</a:t>
+              <a:t>30 / 33   Smart-RUDP</a:t>
             </a:r>
             <a:endParaRPr lang="en-US" sz="1000" dirty="0"/>
           </a:p>
         </p:txBody>
       </p:sp>
-      <p:sp>
-        <p:nvSpPr>
-          <p:cNvPr id="4" name="Shape 2"/>
+      <p:graphicFrame>
+        <p:nvGraphicFramePr>
+          <p:cNvPr id="31" name="Table 0"/>
+          <p:cNvGraphicFramePr>
+            <a:graphicFrameLocks noGrp="1"/>
+          </p:cNvGraphicFramePr>
+          <p:nvPr>
+            <p:extLst>
+              <p:ext uri="{D42A27DB-BD31-4B8C-83A1-F6EECF244321}">
+                <p14:modId xmlns:p14="http://schemas.microsoft.com/office/powerpoint/2010/main" val="1579011935"/>
+              </p:ext>
+            </p:extLst>
+          </p:nvPr>
+        </p:nvGraphicFramePr>
+        <p:xfrm>
+          <a:off x="548640" y="1188720"/>
+          <a:ext cx="5394960" cy="914400"/>
+        </p:xfrm>
+        <a:graphic>
+          <a:graphicData uri="http://schemas.openxmlformats.org/drawingml/2006/table">
+            <a:tbl>
+              <a:tblPr/>
+              <a:tblGrid>
+                <a:gridCol w="2651760"/>
+                <a:gridCol w="1463040"/>
+                <a:gridCol w="1280160"/>
+              </a:tblGrid>
+              <a:tr h="384048">
+                <a:tc>
+                  <a:txBody>
+                    <a:bodyPr/>
+                    <a:lstStyle/>
+                    <a:p>
+                      <a:pPr indent="0" marL="0">
+                        <a:buNone/>
+                      </a:pPr>
+                      <a:r>
+                        <a:rPr lang="en-US" sz="1300" b="1" dirty="0">
+                          <a:solidFill>
+                            <a:srgbClr val="0B0F14"/>
+                          </a:solidFill>
+                          <a:latin typeface="Courier New" pitchFamily="34" charset="0"/>
+                          <a:ea typeface="Courier New" pitchFamily="34" charset="-122"/>
+                          <a:cs typeface="Courier New" pitchFamily="34" charset="-120"/>
+                        </a:rPr>
+                        <a:t>Neural vs tuned AIMD</a:t>
+                      </a:r>
+                      <a:endParaRPr lang="en-US" sz="1300" dirty="0">
+                        <a:latin typeface="Courier New" charset="0"/>
+                        <a:ea typeface="Courier New" charset="0"/>
+                        <a:cs typeface="Courier New" charset="0"/>
+                      </a:endParaRPr>
+                    </a:p>
+                  </a:txBody>
+                  <a:tcPr marL="91440" marR="91440" marT="45720" marB="45720">
+                    <a:lnL w="12700" cap="flat" cmpd="sng" algn="ctr">
+                      <a:solidFill>
+                        <a:srgbClr val="2A3441"/>
+                      </a:solidFill>
+                      <a:prstDash val="solid"/>
+                      <a:round/>
+                      <a:headEnd type="none" w="med" len="med"/>
+                      <a:tailEnd type="none" w="med" len="med"/>
+                    </a:lnL>
+                    <a:lnR w="12700" cap="flat" cmpd="sng" algn="ctr">
+                      <a:solidFill>
+                        <a:srgbClr val="2A3441"/>
+                      </a:solidFill>
+                      <a:prstDash val="solid"/>
+                      <a:round/>
+                      <a:headEnd type="none" w="med" len="med"/>
+                      <a:tailEnd type="none" w="med" len="med"/>
+                    </a:lnR>
+                    <a:lnT w="12700" cap="flat" cmpd="sng" algn="ctr">
+                      <a:solidFill>
+                        <a:srgbClr val="2A3441"/>
+                      </a:solidFill>
+                      <a:prstDash val="solid"/>
+                      <a:round/>
+                      <a:headEnd type="none" w="med" len="med"/>
+                      <a:tailEnd type="none" w="med" len="med"/>
+                    </a:lnT>
+                    <a:lnB w="12700" cap="flat" cmpd="sng" algn="ctr">
+                      <a:solidFill>
+                        <a:srgbClr val="2A3441"/>
+                      </a:solidFill>
+                      <a:prstDash val="solid"/>
+                      <a:round/>
+                      <a:headEnd type="none" w="med" len="med"/>
+                      <a:tailEnd type="none" w="med" len="med"/>
+                    </a:lnB>
+                    <a:solidFill>
+                      <a:srgbClr val="39FF88"/>
+                    </a:solidFill>
+                  </a:tcPr>
+                </a:tc>
+                <a:tc>
+                  <a:txBody>
+                    <a:bodyPr/>
+                    <a:lstStyle/>
+                    <a:p>
+                      <a:pPr indent="0" marL="0">
+                        <a:buNone/>
+                      </a:pPr>
+                      <a:r>
+                        <a:rPr lang="en-US" sz="1300" b="1" dirty="0">
+                          <a:solidFill>
+                            <a:srgbClr val="0B0F14"/>
+                          </a:solidFill>
+                          <a:latin typeface="Courier New" pitchFamily="34" charset="0"/>
+                          <a:ea typeface="Courier New" pitchFamily="34" charset="-122"/>
+                          <a:cs typeface="Courier New" pitchFamily="34" charset="-120"/>
+                        </a:rPr>
+                        <a:t>Agent share</a:t>
+                      </a:r>
+                      <a:endParaRPr lang="en-US" sz="1300" dirty="0">
+                        <a:latin typeface="Courier New" charset="0"/>
+                        <a:ea typeface="Courier New" charset="0"/>
+                        <a:cs typeface="Courier New" charset="0"/>
+                      </a:endParaRPr>
+                    </a:p>
+                  </a:txBody>
+                  <a:tcPr marL="91440" marR="91440" marT="45720" marB="45720">
+                    <a:lnL w="12700" cap="flat" cmpd="sng" algn="ctr">
+                      <a:solidFill>
+                        <a:srgbClr val="2A3441"/>
+                      </a:solidFill>
+                      <a:prstDash val="solid"/>
+                      <a:round/>
+                      <a:headEnd type="none" w="med" len="med"/>
+                      <a:tailEnd type="none" w="med" len="med"/>
+                    </a:lnL>
+                    <a:lnR w="12700" cap="flat" cmpd="sng" algn="ctr">
+                      <a:solidFill>
+                        <a:srgbClr val="2A3441"/>
+                      </a:solidFill>
+                      <a:prstDash val="solid"/>
+                      <a:round/>
+                      <a:headEnd type="none" w="med" len="med"/>
+                      <a:tailEnd type="none" w="med" len="med"/>
+                    </a:lnR>
+                    <a:lnT w="12700" cap="flat" cmpd="sng" algn="ctr">
+                      <a:solidFill>
+                        <a:srgbClr val="2A3441"/>
+                      </a:solidFill>
+                      <a:prstDash val="solid"/>
+                      <a:round/>
+                      <a:headEnd type="none" w="med" len="med"/>
+                      <a:tailEnd type="none" w="med" len="med"/>
+                    </a:lnT>
+                    <a:lnB w="12700" cap="flat" cmpd="sng" algn="ctr">
+                      <a:solidFill>
+                        <a:srgbClr val="2A3441"/>
+                      </a:solidFill>
+                      <a:prstDash val="solid"/>
+                      <a:round/>
+                      <a:headEnd type="none" w="med" len="med"/>
+                      <a:tailEnd type="none" w="med" len="med"/>
+                    </a:lnB>
+                    <a:solidFill>
+                      <a:srgbClr val="39FF88"/>
+                    </a:solidFill>
+                  </a:tcPr>
+                </a:tc>
+                <a:tc>
+                  <a:txBody>
+                    <a:bodyPr/>
+                    <a:lstStyle/>
+                    <a:p>
+                      <a:pPr indent="0" marL="0">
+                        <a:buNone/>
+                      </a:pPr>
+                      <a:r>
+                        <a:rPr lang="en-US" sz="1300" b="1" dirty="0">
+                          <a:solidFill>
+                            <a:srgbClr val="0B0F14"/>
+                          </a:solidFill>
+                          <a:latin typeface="Courier New" pitchFamily="34" charset="0"/>
+                          <a:ea typeface="Courier New" pitchFamily="34" charset="-122"/>
+                          <a:cs typeface="Courier New" pitchFamily="34" charset="-120"/>
+                        </a:rPr>
+                        <a:t>Jain</a:t>
+                      </a:r>
+                      <a:endParaRPr lang="en-US" sz="1300" dirty="0">
+                        <a:latin typeface="Courier New" charset="0"/>
+                        <a:ea typeface="Courier New" charset="0"/>
+                        <a:cs typeface="Courier New" charset="0"/>
+                      </a:endParaRPr>
+                    </a:p>
+                  </a:txBody>
+                  <a:tcPr marL="91440" marR="91440" marT="45720" marB="45720">
+                    <a:lnL w="12700" cap="flat" cmpd="sng" algn="ctr">
+                      <a:solidFill>
+                        <a:srgbClr val="2A3441"/>
+                      </a:solidFill>
+                      <a:prstDash val="solid"/>
+                      <a:round/>
+                      <a:headEnd type="none" w="med" len="med"/>
+                      <a:tailEnd type="none" w="med" len="med"/>
+                    </a:lnL>
+                    <a:lnR w="12700" cap="flat" cmpd="sng" algn="ctr">
+                      <a:solidFill>
+                        <a:srgbClr val="2A3441"/>
+                      </a:solidFill>
+                      <a:prstDash val="solid"/>
+                      <a:round/>
+                      <a:headEnd type="none" w="med" len="med"/>
+                      <a:tailEnd type="none" w="med" len="med"/>
+                    </a:lnR>
+                    <a:lnT w="12700" cap="flat" cmpd="sng" algn="ctr">
+                      <a:solidFill>
+                        <a:srgbClr val="2A3441"/>
+                      </a:solidFill>
+                      <a:prstDash val="solid"/>
+                      <a:round/>
+                      <a:headEnd type="none" w="med" len="med"/>
+                      <a:tailEnd type="none" w="med" len="med"/>
+                    </a:lnT>
+                    <a:lnB w="12700" cap="flat" cmpd="sng" algn="ctr">
+                      <a:solidFill>
+                        <a:srgbClr val="2A3441"/>
+                      </a:solidFill>
+                      <a:prstDash val="solid"/>
+                      <a:round/>
+                      <a:headEnd type="none" w="med" len="med"/>
+                      <a:tailEnd type="none" w="med" len="med"/>
+                    </a:lnB>
+                    <a:solidFill>
+                      <a:srgbClr val="39FF88"/>
+                    </a:solidFill>
+                  </a:tcPr>
+                </a:tc>
+              </a:tr>
+              <a:tr h="384048">
+                <a:tc>
+                  <a:txBody>
+                    <a:bodyPr/>
+                    <a:lstStyle/>
+                    <a:p>
+                      <a:pPr indent="0" marL="0">
+                        <a:buNone/>
+                      </a:pPr>
+                      <a:r>
+                        <a:rPr lang="en-US" sz="1300" dirty="0">
+                          <a:solidFill>
+                            <a:srgbClr val="E6EDF3"/>
+                          </a:solidFill>
+                          <a:latin typeface="Calibri" pitchFamily="34" charset="0"/>
+                          <a:ea typeface="Calibri" pitchFamily="34" charset="-122"/>
+                          <a:cs typeface="Calibri" pitchFamily="34" charset="-120"/>
+                        </a:rPr>
+                        <a:t>Default</a:t>
+                      </a:r>
+                      <a:endParaRPr lang="en-US" sz="1300" dirty="0">
+                        <a:latin typeface="Calibri" charset="0"/>
+                        <a:ea typeface="Calibri" charset="0"/>
+                        <a:cs typeface="Calibri" charset="0"/>
+                      </a:endParaRPr>
+                    </a:p>
+                  </a:txBody>
+                  <a:tcPr marL="91440" marR="91440" marT="45720" marB="45720">
+                    <a:lnL w="12700" cap="flat" cmpd="sng" algn="ctr">
+                      <a:solidFill>
+                        <a:srgbClr val="2A3441"/>
+                      </a:solidFill>
+                      <a:prstDash val="solid"/>
+                      <a:round/>
+                      <a:headEnd type="none" w="med" len="med"/>
+                      <a:tailEnd type="none" w="med" len="med"/>
+                    </a:lnL>
+                    <a:lnR w="12700" cap="flat" cmpd="sng" algn="ctr">
+                      <a:solidFill>
+                        <a:srgbClr val="2A3441"/>
+                      </a:solidFill>
+                      <a:prstDash val="solid"/>
+                      <a:round/>
+                      <a:headEnd type="none" w="med" len="med"/>
+                      <a:tailEnd type="none" w="med" len="med"/>
+                    </a:lnR>
+                    <a:lnT w="12700" cap="flat" cmpd="sng" algn="ctr">
+                      <a:solidFill>
+                        <a:srgbClr val="2A3441"/>
+                      </a:solidFill>
+                      <a:prstDash val="solid"/>
+                      <a:round/>
+                      <a:headEnd type="none" w="med" len="med"/>
+                      <a:tailEnd type="none" w="med" len="med"/>
+                    </a:lnT>
+                    <a:lnB w="12700" cap="flat" cmpd="sng" algn="ctr">
+                      <a:solidFill>
+                        <a:srgbClr val="2A3441"/>
+                      </a:solidFill>
+                      <a:prstDash val="solid"/>
+                      <a:round/>
+                      <a:headEnd type="none" w="med" len="med"/>
+                      <a:tailEnd type="none" w="med" len="med"/>
+                    </a:lnB>
+                    <a:solidFill>
+                      <a:srgbClr val="141B24"/>
+                    </a:solidFill>
+                  </a:tcPr>
+                </a:tc>
+                <a:tc>
+                  <a:txBody>
+                    <a:bodyPr/>
+                    <a:lstStyle/>
+                    <a:p>
+                      <a:pPr indent="0" marL="0">
+                        <a:buNone/>
+                      </a:pPr>
+                      <a:r>
+                        <a:rPr lang="en-US" sz="1300" dirty="0">
+                          <a:solidFill>
+                            <a:srgbClr val="E6EDF3"/>
+                          </a:solidFill>
+                          <a:latin typeface="Calibri" pitchFamily="34" charset="0"/>
+                          <a:ea typeface="Calibri" pitchFamily="34" charset="-122"/>
+                          <a:cs typeface="Calibri" pitchFamily="34" charset="-120"/>
+                        </a:rPr>
+                        <a:t>70%</a:t>
+                      </a:r>
+                      <a:endParaRPr lang="en-US" sz="1300" dirty="0">
+                        <a:latin typeface="Calibri" charset="0"/>
+                        <a:ea typeface="Calibri" charset="0"/>
+                        <a:cs typeface="Calibri" charset="0"/>
+                      </a:endParaRPr>
+                    </a:p>
+                  </a:txBody>
+                  <a:tcPr marL="91440" marR="91440" marT="45720" marB="45720">
+                    <a:lnL w="12700" cap="flat" cmpd="sng" algn="ctr">
+                      <a:solidFill>
+                        <a:srgbClr val="2A3441"/>
+                      </a:solidFill>
+                      <a:prstDash val="solid"/>
+                      <a:round/>
+                      <a:headEnd type="none" w="med" len="med"/>
+                      <a:tailEnd type="none" w="med" len="med"/>
+                    </a:lnL>
+                    <a:lnR w="12700" cap="flat" cmpd="sng" algn="ctr">
+                      <a:solidFill>
+                        <a:srgbClr val="2A3441"/>
+                      </a:solidFill>
+                      <a:prstDash val="solid"/>
+                      <a:round/>
+                      <a:headEnd type="none" w="med" len="med"/>
+                      <a:tailEnd type="none" w="med" len="med"/>
+                    </a:lnR>
+                    <a:lnT w="12700" cap="flat" cmpd="sng" algn="ctr">
+                      <a:solidFill>
+                        <a:srgbClr val="2A3441"/>
+                      </a:solidFill>
+                      <a:prstDash val="solid"/>
+                      <a:round/>
+                      <a:headEnd type="none" w="med" len="med"/>
+                      <a:tailEnd type="none" w="med" len="med"/>
+                    </a:lnT>
+                    <a:lnB w="12700" cap="flat" cmpd="sng" algn="ctr">
+                      <a:solidFill>
+                        <a:srgbClr val="2A3441"/>
+                      </a:solidFill>
+                      <a:prstDash val="solid"/>
+                      <a:round/>
+                      <a:headEnd type="none" w="med" len="med"/>
+                      <a:tailEnd type="none" w="med" len="med"/>
+                    </a:lnB>
+                    <a:solidFill>
+                      <a:srgbClr val="141B24"/>
+                    </a:solidFill>
+                  </a:tcPr>
+                </a:tc>
+                <a:tc>
+                  <a:txBody>
+                    <a:bodyPr/>
+                    <a:lstStyle/>
+                    <a:p>
+                      <a:pPr indent="0" marL="0">
+                        <a:buNone/>
+                      </a:pPr>
+                      <a:r>
+                        <a:rPr lang="en-US" sz="1300" dirty="0">
+                          <a:solidFill>
+                            <a:srgbClr val="E6EDF3"/>
+                          </a:solidFill>
+                          <a:latin typeface="Calibri" pitchFamily="34" charset="0"/>
+                          <a:ea typeface="Calibri" pitchFamily="34" charset="-122"/>
+                          <a:cs typeface="Calibri" pitchFamily="34" charset="-120"/>
+                        </a:rPr>
+                        <a:t>0.86</a:t>
+                      </a:r>
+                      <a:endParaRPr lang="en-US" sz="1300" dirty="0">
+                        <a:latin typeface="Calibri" charset="0"/>
+                        <a:ea typeface="Calibri" charset="0"/>
+                        <a:cs typeface="Calibri" charset="0"/>
+                      </a:endParaRPr>
+                    </a:p>
+                  </a:txBody>
+                  <a:tcPr marL="91440" marR="91440" marT="45720" marB="45720">
+                    <a:lnL w="12700" cap="flat" cmpd="sng" algn="ctr">
+                      <a:solidFill>
+                        <a:srgbClr val="2A3441"/>
+                      </a:solidFill>
+                      <a:prstDash val="solid"/>
+                      <a:round/>
+                      <a:headEnd type="none" w="med" len="med"/>
+                      <a:tailEnd type="none" w="med" len="med"/>
+                    </a:lnL>
+                    <a:lnR w="12700" cap="flat" cmpd="sng" algn="ctr">
+                      <a:solidFill>
+                        <a:srgbClr val="2A3441"/>
+                      </a:solidFill>
+                      <a:prstDash val="solid"/>
+                      <a:round/>
+                      <a:headEnd type="none" w="med" len="med"/>
+                      <a:tailEnd type="none" w="med" len="med"/>
+                    </a:lnR>
+                    <a:lnT w="12700" cap="flat" cmpd="sng" algn="ctr">
+                      <a:solidFill>
+                        <a:srgbClr val="2A3441"/>
+                      </a:solidFill>
+                      <a:prstDash val="solid"/>
+                      <a:round/>
+                      <a:headEnd type="none" w="med" len="med"/>
+                      <a:tailEnd type="none" w="med" len="med"/>
+                    </a:lnT>
+                    <a:lnB w="12700" cap="flat" cmpd="sng" algn="ctr">
+                      <a:solidFill>
+                        <a:srgbClr val="2A3441"/>
+                      </a:solidFill>
+                      <a:prstDash val="solid"/>
+                      <a:round/>
+                      <a:headEnd type="none" w="med" len="med"/>
+                      <a:tailEnd type="none" w="med" len="med"/>
+                    </a:lnB>
+                    <a:solidFill>
+                      <a:srgbClr val="141B24"/>
+                    </a:solidFill>
+                  </a:tcPr>
+                </a:tc>
+              </a:tr>
+              <a:tr h="384048">
+                <a:tc>
+                  <a:txBody>
+                    <a:bodyPr/>
+                    <a:lstStyle/>
+                    <a:p>
+                      <a:pPr indent="0" marL="0">
+                        <a:buNone/>
+                      </a:pPr>
+                      <a:r>
+                        <a:rPr lang="en-US" sz="1300" dirty="0">
+                          <a:solidFill>
+                            <a:srgbClr val="E6EDF3"/>
+                          </a:solidFill>
+                          <a:latin typeface="Calibri" pitchFamily="34" charset="0"/>
+                          <a:ea typeface="Calibri" pitchFamily="34" charset="-122"/>
+                          <a:cs typeface="Calibri" pitchFamily="34" charset="-120"/>
+                        </a:rPr>
+                        <a:t>--polite 1.2</a:t>
+                      </a:r>
+                      <a:endParaRPr lang="en-US" sz="1300" dirty="0">
+                        <a:latin typeface="Calibri" charset="0"/>
+                        <a:ea typeface="Calibri" charset="0"/>
+                        <a:cs typeface="Calibri" charset="0"/>
+                      </a:endParaRPr>
+                    </a:p>
+                  </a:txBody>
+                  <a:tcPr marL="91440" marR="91440" marT="45720" marB="45720">
+                    <a:lnL w="12700" cap="flat" cmpd="sng" algn="ctr">
+                      <a:solidFill>
+                        <a:srgbClr val="2A3441"/>
+                      </a:solidFill>
+                      <a:prstDash val="solid"/>
+                      <a:round/>
+                      <a:headEnd type="none" w="med" len="med"/>
+                      <a:tailEnd type="none" w="med" len="med"/>
+                    </a:lnL>
+                    <a:lnR w="12700" cap="flat" cmpd="sng" algn="ctr">
+                      <a:solidFill>
+                        <a:srgbClr val="2A3441"/>
+                      </a:solidFill>
+                      <a:prstDash val="solid"/>
+                      <a:round/>
+                      <a:headEnd type="none" w="med" len="med"/>
+                      <a:tailEnd type="none" w="med" len="med"/>
+                    </a:lnR>
+                    <a:lnT w="12700" cap="flat" cmpd="sng" algn="ctr">
+                      <a:solidFill>
+                        <a:srgbClr val="2A3441"/>
+                      </a:solidFill>
+                      <a:prstDash val="solid"/>
+                      <a:round/>
+                      <a:headEnd type="none" w="med" len="med"/>
+                      <a:tailEnd type="none" w="med" len="med"/>
+                    </a:lnT>
+                    <a:lnB w="12700" cap="flat" cmpd="sng" algn="ctr">
+                      <a:solidFill>
+                        <a:srgbClr val="2A3441"/>
+                      </a:solidFill>
+                      <a:prstDash val="solid"/>
+                      <a:round/>
+                      <a:headEnd type="none" w="med" len="med"/>
+                      <a:tailEnd type="none" w="med" len="med"/>
+                    </a:lnB>
+                    <a:solidFill>
+                      <a:srgbClr val="141B24"/>
+                    </a:solidFill>
+                  </a:tcPr>
+                </a:tc>
+                <a:tc>
+                  <a:txBody>
+                    <a:bodyPr/>
+                    <a:lstStyle/>
+                    <a:p>
+                      <a:pPr indent="0" marL="0">
+                        <a:buNone/>
+                      </a:pPr>
+                      <a:r>
+                        <a:rPr lang="en-US" sz="1300" dirty="0">
+                          <a:solidFill>
+                            <a:srgbClr val="E6EDF3"/>
+                          </a:solidFill>
+                          <a:latin typeface="Calibri" pitchFamily="34" charset="0"/>
+                          <a:ea typeface="Calibri" pitchFamily="34" charset="-122"/>
+                          <a:cs typeface="Calibri" pitchFamily="34" charset="-120"/>
+                        </a:rPr>
+                        <a:t>49%</a:t>
+                      </a:r>
+                      <a:endParaRPr lang="en-US" sz="1300" dirty="0">
+                        <a:latin typeface="Calibri" charset="0"/>
+                        <a:ea typeface="Calibri" charset="0"/>
+                        <a:cs typeface="Calibri" charset="0"/>
+                      </a:endParaRPr>
+                    </a:p>
+                  </a:txBody>
+                  <a:tcPr marL="91440" marR="91440" marT="45720" marB="45720">
+                    <a:lnL w="12700" cap="flat" cmpd="sng" algn="ctr">
+                      <a:solidFill>
+                        <a:srgbClr val="2A3441"/>
+                      </a:solidFill>
+                      <a:prstDash val="solid"/>
+                      <a:round/>
+                      <a:headEnd type="none" w="med" len="med"/>
+                      <a:tailEnd type="none" w="med" len="med"/>
+                    </a:lnL>
+                    <a:lnR w="12700" cap="flat" cmpd="sng" algn="ctr">
+                      <a:solidFill>
+                        <a:srgbClr val="2A3441"/>
+                      </a:solidFill>
+                      <a:prstDash val="solid"/>
+                      <a:round/>
+                      <a:headEnd type="none" w="med" len="med"/>
+                      <a:tailEnd type="none" w="med" len="med"/>
+                    </a:lnR>
+                    <a:lnT w="12700" cap="flat" cmpd="sng" algn="ctr">
+                      <a:solidFill>
+                        <a:srgbClr val="2A3441"/>
+                      </a:solidFill>
+                      <a:prstDash val="solid"/>
+                      <a:round/>
+                      <a:headEnd type="none" w="med" len="med"/>
+                      <a:tailEnd type="none" w="med" len="med"/>
+                    </a:lnT>
+                    <a:lnB w="12700" cap="flat" cmpd="sng" algn="ctr">
+                      <a:solidFill>
+                        <a:srgbClr val="2A3441"/>
+                      </a:solidFill>
+                      <a:prstDash val="solid"/>
+                      <a:round/>
+                      <a:headEnd type="none" w="med" len="med"/>
+                      <a:tailEnd type="none" w="med" len="med"/>
+                    </a:lnB>
+                    <a:solidFill>
+                      <a:srgbClr val="141B24"/>
+                    </a:solidFill>
+                  </a:tcPr>
+                </a:tc>
+                <a:tc>
+                  <a:txBody>
+                    <a:bodyPr/>
+                    <a:lstStyle/>
+                    <a:p>
+                      <a:pPr indent="0" marL="0">
+                        <a:buNone/>
+                      </a:pPr>
+                      <a:r>
+                        <a:rPr lang="en-US" sz="1300" dirty="0">
+                          <a:solidFill>
+                            <a:srgbClr val="E6EDF3"/>
+                          </a:solidFill>
+                          <a:latin typeface="Calibri" pitchFamily="34" charset="0"/>
+                          <a:ea typeface="Calibri" pitchFamily="34" charset="-122"/>
+                          <a:cs typeface="Calibri" pitchFamily="34" charset="-120"/>
+                        </a:rPr>
+                        <a:t>0.95</a:t>
+                      </a:r>
+                      <a:endParaRPr lang="en-US" sz="1300" dirty="0">
+                        <a:latin typeface="Calibri" charset="0"/>
+                        <a:ea typeface="Calibri" charset="0"/>
+                        <a:cs typeface="Calibri" charset="0"/>
+                      </a:endParaRPr>
+                    </a:p>
+                  </a:txBody>
+                  <a:tcPr marL="91440" marR="91440" marT="45720" marB="45720">
+                    <a:lnL w="12700" cap="flat" cmpd="sng" algn="ctr">
+                      <a:solidFill>
+                        <a:srgbClr val="2A3441"/>
+                      </a:solidFill>
+                      <a:prstDash val="solid"/>
+                      <a:round/>
+                      <a:headEnd type="none" w="med" len="med"/>
+                      <a:tailEnd type="none" w="med" len="med"/>
+                    </a:lnL>
+                    <a:lnR w="12700" cap="flat" cmpd="sng" algn="ctr">
+                      <a:solidFill>
+                        <a:srgbClr val="2A3441"/>
+                      </a:solidFill>
+                      <a:prstDash val="solid"/>
+                      <a:round/>
+                      <a:headEnd type="none" w="med" len="med"/>
+                      <a:tailEnd type="none" w="med" len="med"/>
+                    </a:lnR>
+                    <a:lnT w="12700" cap="flat" cmpd="sng" algn="ctr">
+                      <a:solidFill>
+                        <a:srgbClr val="2A3441"/>
+                      </a:solidFill>
+                      <a:prstDash val="solid"/>
+                      <a:round/>
+                      <a:headEnd type="none" w="med" len="med"/>
+                      <a:tailEnd type="none" w="med" len="med"/>
+                    </a:lnT>
+                    <a:lnB w="12700" cap="flat" cmpd="sng" algn="ctr">
+                      <a:solidFill>
+                        <a:srgbClr val="2A3441"/>
+                      </a:solidFill>
+                      <a:prstDash val="solid"/>
+                      <a:round/>
+                      <a:headEnd type="none" w="med" len="med"/>
+                      <a:tailEnd type="none" w="med" len="med"/>
+                    </a:lnB>
+                    <a:solidFill>
+                      <a:srgbClr val="141B24"/>
+                    </a:solidFill>
+                  </a:tcPr>
+                </a:tc>
+              </a:tr>
+              <a:tr h="384048">
+                <a:tc>
+                  <a:txBody>
+                    <a:bodyPr/>
+                    <a:lstStyle/>
+                    <a:p>
+                      <a:pPr indent="0" marL="0">
+                        <a:buNone/>
+                      </a:pPr>
+                      <a:r>
+                        <a:rPr lang="en-US" sz="1300" dirty="0">
+                          <a:solidFill>
+                            <a:srgbClr val="E6EDF3"/>
+                          </a:solidFill>
+                          <a:latin typeface="Calibri" pitchFamily="34" charset="0"/>
+                          <a:ea typeface="Calibri" pitchFamily="34" charset="-122"/>
+                          <a:cs typeface="Calibri" pitchFamily="34" charset="-120"/>
+                        </a:rPr>
+                        <a:t>--polite 1.3</a:t>
+                      </a:r>
+                      <a:endParaRPr lang="en-US" sz="1300" dirty="0">
+                        <a:latin typeface="Calibri" charset="0"/>
+                        <a:ea typeface="Calibri" charset="0"/>
+                        <a:cs typeface="Calibri" charset="0"/>
+                      </a:endParaRPr>
+                    </a:p>
+                  </a:txBody>
+                  <a:tcPr marL="91440" marR="91440" marT="45720" marB="45720">
+                    <a:lnL w="12700" cap="flat" cmpd="sng" algn="ctr">
+                      <a:solidFill>
+                        <a:srgbClr val="2A3441"/>
+                      </a:solidFill>
+                      <a:prstDash val="solid"/>
+                      <a:round/>
+                      <a:headEnd type="none" w="med" len="med"/>
+                      <a:tailEnd type="none" w="med" len="med"/>
+                    </a:lnL>
+                    <a:lnR w="12700" cap="flat" cmpd="sng" algn="ctr">
+                      <a:solidFill>
+                        <a:srgbClr val="2A3441"/>
+                      </a:solidFill>
+                      <a:prstDash val="solid"/>
+                      <a:round/>
+                      <a:headEnd type="none" w="med" len="med"/>
+                      <a:tailEnd type="none" w="med" len="med"/>
+                    </a:lnR>
+                    <a:lnT w="12700" cap="flat" cmpd="sng" algn="ctr">
+                      <a:solidFill>
+                        <a:srgbClr val="2A3441"/>
+                      </a:solidFill>
+                      <a:prstDash val="solid"/>
+                      <a:round/>
+                      <a:headEnd type="none" w="med" len="med"/>
+                      <a:tailEnd type="none" w="med" len="med"/>
+                    </a:lnT>
+                    <a:lnB w="12700" cap="flat" cmpd="sng" algn="ctr">
+                      <a:solidFill>
+                        <a:srgbClr val="2A3441"/>
+                      </a:solidFill>
+                      <a:prstDash val="solid"/>
+                      <a:round/>
+                      <a:headEnd type="none" w="med" len="med"/>
+                      <a:tailEnd type="none" w="med" len="med"/>
+                    </a:lnB>
+                    <a:solidFill>
+                      <a:srgbClr val="141B24"/>
+                    </a:solidFill>
+                  </a:tcPr>
+                </a:tc>
+                <a:tc>
+                  <a:txBody>
+                    <a:bodyPr/>
+                    <a:lstStyle/>
+                    <a:p>
+                      <a:pPr indent="0" marL="0">
+                        <a:buNone/>
+                      </a:pPr>
+                      <a:r>
+                        <a:rPr lang="en-US" sz="1300" dirty="0">
+                          <a:solidFill>
+                            <a:srgbClr val="E6EDF3"/>
+                          </a:solidFill>
+                          <a:latin typeface="Calibri" pitchFamily="34" charset="0"/>
+                          <a:ea typeface="Calibri" pitchFamily="34" charset="-122"/>
+                          <a:cs typeface="Calibri" pitchFamily="34" charset="-120"/>
+                        </a:rPr>
+                        <a:t>52%</a:t>
+                      </a:r>
+                      <a:endParaRPr lang="en-US" sz="1300" dirty="0">
+                        <a:latin typeface="Calibri" charset="0"/>
+                        <a:ea typeface="Calibri" charset="0"/>
+                        <a:cs typeface="Calibri" charset="0"/>
+                      </a:endParaRPr>
+                    </a:p>
+                  </a:txBody>
+                  <a:tcPr marL="91440" marR="91440" marT="45720" marB="45720">
+                    <a:lnL w="12700" cap="flat" cmpd="sng" algn="ctr">
+                      <a:solidFill>
+                        <a:srgbClr val="2A3441"/>
+                      </a:solidFill>
+                      <a:prstDash val="solid"/>
+                      <a:round/>
+                      <a:headEnd type="none" w="med" len="med"/>
+                      <a:tailEnd type="none" w="med" len="med"/>
+                    </a:lnL>
+                    <a:lnR w="12700" cap="flat" cmpd="sng" algn="ctr">
+                      <a:solidFill>
+                        <a:srgbClr val="2A3441"/>
+                      </a:solidFill>
+                      <a:prstDash val="solid"/>
+                      <a:round/>
+                      <a:headEnd type="none" w="med" len="med"/>
+                      <a:tailEnd type="none" w="med" len="med"/>
+                    </a:lnR>
+                    <a:lnT w="12700" cap="flat" cmpd="sng" algn="ctr">
+                      <a:solidFill>
+                        <a:srgbClr val="2A3441"/>
+                      </a:solidFill>
+                      <a:prstDash val="solid"/>
+                      <a:round/>
+                      <a:headEnd type="none" w="med" len="med"/>
+                      <a:tailEnd type="none" w="med" len="med"/>
+                    </a:lnT>
+                    <a:lnB w="12700" cap="flat" cmpd="sng" algn="ctr">
+                      <a:solidFill>
+                        <a:srgbClr val="2A3441"/>
+                      </a:solidFill>
+                      <a:prstDash val="solid"/>
+                      <a:round/>
+                      <a:headEnd type="none" w="med" len="med"/>
+                      <a:tailEnd type="none" w="med" len="med"/>
+                    </a:lnB>
+                    <a:solidFill>
+                      <a:srgbClr val="141B24"/>
+                    </a:solidFill>
+                  </a:tcPr>
+                </a:tc>
+                <a:tc>
+                  <a:txBody>
+                    <a:bodyPr/>
+                    <a:lstStyle/>
+                    <a:p>
+                      <a:pPr indent="0" marL="0">
+                        <a:buNone/>
+                      </a:pPr>
+                      <a:r>
+                        <a:rPr lang="en-US" sz="1300" dirty="0">
+                          <a:solidFill>
+                            <a:srgbClr val="E6EDF3"/>
+                          </a:solidFill>
+                          <a:latin typeface="Calibri" pitchFamily="34" charset="0"/>
+                          <a:ea typeface="Calibri" pitchFamily="34" charset="-122"/>
+                          <a:cs typeface="Calibri" pitchFamily="34" charset="-120"/>
+                        </a:rPr>
+                        <a:t>0.94</a:t>
+                      </a:r>
+                      <a:endParaRPr lang="en-US" sz="1300" dirty="0">
+                        <a:latin typeface="Calibri" charset="0"/>
+                        <a:ea typeface="Calibri" charset="0"/>
+                        <a:cs typeface="Calibri" charset="0"/>
+                      </a:endParaRPr>
+                    </a:p>
+                  </a:txBody>
+                  <a:tcPr marL="91440" marR="91440" marT="45720" marB="45720">
+                    <a:lnL w="12700" cap="flat" cmpd="sng" algn="ctr">
+                      <a:solidFill>
+                        <a:srgbClr val="2A3441"/>
+                      </a:solidFill>
+                      <a:prstDash val="solid"/>
+                      <a:round/>
+                      <a:headEnd type="none" w="med" len="med"/>
+                      <a:tailEnd type="none" w="med" len="med"/>
+                    </a:lnL>
+                    <a:lnR w="12700" cap="flat" cmpd="sng" algn="ctr">
+                      <a:solidFill>
+                        <a:srgbClr val="2A3441"/>
+                      </a:solidFill>
+                      <a:prstDash val="solid"/>
+                      <a:round/>
+                      <a:headEnd type="none" w="med" len="med"/>
+                      <a:tailEnd type="none" w="med" len="med"/>
+                    </a:lnR>
+                    <a:lnT w="12700" cap="flat" cmpd="sng" algn="ctr">
+                      <a:solidFill>
+                        <a:srgbClr val="2A3441"/>
+                      </a:solidFill>
+                      <a:prstDash val="solid"/>
+                      <a:round/>
+                      <a:headEnd type="none" w="med" len="med"/>
+                      <a:tailEnd type="none" w="med" len="med"/>
+                    </a:lnT>
+                    <a:lnB w="12700" cap="flat" cmpd="sng" algn="ctr">
+                      <a:solidFill>
+                        <a:srgbClr val="2A3441"/>
+                      </a:solidFill>
+                      <a:prstDash val="solid"/>
+                      <a:round/>
+                      <a:headEnd type="none" w="med" len="med"/>
+                      <a:tailEnd type="none" w="med" len="med"/>
+                    </a:lnB>
+                    <a:solidFill>
+                      <a:srgbClr val="141B24"/>
+                    </a:solidFill>
+                  </a:tcPr>
+                </a:tc>
+              </a:tr>
+              <a:tr h="384048">
+                <a:tc>
+                  <a:txBody>
+                    <a:bodyPr/>
+                    <a:lstStyle/>
+                    <a:p>
+                      <a:pPr indent="0" marL="0">
+                        <a:buNone/>
+                      </a:pPr>
+                      <a:r>
+                        <a:rPr lang="en-US" sz="1300" dirty="0">
+                          <a:solidFill>
+                            <a:srgbClr val="E6EDF3"/>
+                          </a:solidFill>
+                          <a:latin typeface="Calibri" pitchFamily="34" charset="0"/>
+                          <a:ea typeface="Calibri" pitchFamily="34" charset="-122"/>
+                          <a:cs typeface="Calibri" pitchFamily="34" charset="-120"/>
+                        </a:rPr>
+                        <a:t>--polite 1.5</a:t>
+                      </a:r>
+                      <a:endParaRPr lang="en-US" sz="1300" dirty="0">
+                        <a:latin typeface="Calibri" charset="0"/>
+                        <a:ea typeface="Calibri" charset="0"/>
+                        <a:cs typeface="Calibri" charset="0"/>
+                      </a:endParaRPr>
+                    </a:p>
+                  </a:txBody>
+                  <a:tcPr marL="91440" marR="91440" marT="45720" marB="45720">
+                    <a:lnL w="12700" cap="flat" cmpd="sng" algn="ctr">
+                      <a:solidFill>
+                        <a:srgbClr val="2A3441"/>
+                      </a:solidFill>
+                      <a:prstDash val="solid"/>
+                      <a:round/>
+                      <a:headEnd type="none" w="med" len="med"/>
+                      <a:tailEnd type="none" w="med" len="med"/>
+                    </a:lnL>
+                    <a:lnR w="12700" cap="flat" cmpd="sng" algn="ctr">
+                      <a:solidFill>
+                        <a:srgbClr val="2A3441"/>
+                      </a:solidFill>
+                      <a:prstDash val="solid"/>
+                      <a:round/>
+                      <a:headEnd type="none" w="med" len="med"/>
+                      <a:tailEnd type="none" w="med" len="med"/>
+                    </a:lnR>
+                    <a:lnT w="12700" cap="flat" cmpd="sng" algn="ctr">
+                      <a:solidFill>
+                        <a:srgbClr val="2A3441"/>
+                      </a:solidFill>
+                      <a:prstDash val="solid"/>
+                      <a:round/>
+                      <a:headEnd type="none" w="med" len="med"/>
+                      <a:tailEnd type="none" w="med" len="med"/>
+                    </a:lnT>
+                    <a:lnB w="12700" cap="flat" cmpd="sng" algn="ctr">
+                      <a:solidFill>
+                        <a:srgbClr val="2A3441"/>
+                      </a:solidFill>
+                      <a:prstDash val="solid"/>
+                      <a:round/>
+                      <a:headEnd type="none" w="med" len="med"/>
+                      <a:tailEnd type="none" w="med" len="med"/>
+                    </a:lnB>
+                    <a:solidFill>
+                      <a:srgbClr val="141B24"/>
+                    </a:solidFill>
+                  </a:tcPr>
+                </a:tc>
+                <a:tc>
+                  <a:txBody>
+                    <a:bodyPr/>
+                    <a:lstStyle/>
+                    <a:p>
+                      <a:pPr indent="0" marL="0">
+                        <a:buNone/>
+                      </a:pPr>
+                      <a:r>
+                        <a:rPr lang="en-US" sz="1300" dirty="0">
+                          <a:solidFill>
+                            <a:srgbClr val="E6EDF3"/>
+                          </a:solidFill>
+                          <a:latin typeface="Calibri" pitchFamily="34" charset="0"/>
+                          <a:ea typeface="Calibri" pitchFamily="34" charset="-122"/>
+                          <a:cs typeface="Calibri" pitchFamily="34" charset="-120"/>
+                        </a:rPr>
+                        <a:t>59%</a:t>
+                      </a:r>
+                      <a:endParaRPr lang="en-US" sz="1300" dirty="0">
+                        <a:latin typeface="Calibri" charset="0"/>
+                        <a:ea typeface="Calibri" charset="0"/>
+                        <a:cs typeface="Calibri" charset="0"/>
+                      </a:endParaRPr>
+                    </a:p>
+                  </a:txBody>
+                  <a:tcPr marL="91440" marR="91440" marT="45720" marB="45720">
+                    <a:lnL w="12700" cap="flat" cmpd="sng" algn="ctr">
+                      <a:solidFill>
+                        <a:srgbClr val="2A3441"/>
+                      </a:solidFill>
+                      <a:prstDash val="solid"/>
+                      <a:round/>
+                      <a:headEnd type="none" w="med" len="med"/>
+                      <a:tailEnd type="none" w="med" len="med"/>
+                    </a:lnL>
+                    <a:lnR w="12700" cap="flat" cmpd="sng" algn="ctr">
+                      <a:solidFill>
+                        <a:srgbClr val="2A3441"/>
+                      </a:solidFill>
+                      <a:prstDash val="solid"/>
+                      <a:round/>
+                      <a:headEnd type="none" w="med" len="med"/>
+                      <a:tailEnd type="none" w="med" len="med"/>
+                    </a:lnR>
+                    <a:lnT w="12700" cap="flat" cmpd="sng" algn="ctr">
+                      <a:solidFill>
+                        <a:srgbClr val="2A3441"/>
+                      </a:solidFill>
+                      <a:prstDash val="solid"/>
+                      <a:round/>
+                      <a:headEnd type="none" w="med" len="med"/>
+                      <a:tailEnd type="none" w="med" len="med"/>
+                    </a:lnT>
+                    <a:lnB w="12700" cap="flat" cmpd="sng" algn="ctr">
+                      <a:solidFill>
+                        <a:srgbClr val="2A3441"/>
+                      </a:solidFill>
+                      <a:prstDash val="solid"/>
+                      <a:round/>
+                      <a:headEnd type="none" w="med" len="med"/>
+                      <a:tailEnd type="none" w="med" len="med"/>
+                    </a:lnB>
+                    <a:solidFill>
+                      <a:srgbClr val="141B24"/>
+                    </a:solidFill>
+                  </a:tcPr>
+                </a:tc>
+                <a:tc>
+                  <a:txBody>
+                    <a:bodyPr/>
+                    <a:lstStyle/>
+                    <a:p>
+                      <a:pPr indent="0" marL="0">
+                        <a:buNone/>
+                      </a:pPr>
+                      <a:r>
+                        <a:rPr lang="en-US" sz="1300" dirty="0">
+                          <a:solidFill>
+                            <a:srgbClr val="E6EDF3"/>
+                          </a:solidFill>
+                          <a:latin typeface="Calibri" pitchFamily="34" charset="0"/>
+                          <a:ea typeface="Calibri" pitchFamily="34" charset="-122"/>
+                          <a:cs typeface="Calibri" pitchFamily="34" charset="-120"/>
+                        </a:rPr>
+                        <a:t>0.90</a:t>
+                      </a:r>
+                      <a:endParaRPr lang="en-US" sz="1300" dirty="0">
+                        <a:latin typeface="Calibri" charset="0"/>
+                        <a:ea typeface="Calibri" charset="0"/>
+                        <a:cs typeface="Calibri" charset="0"/>
+                      </a:endParaRPr>
+                    </a:p>
+                  </a:txBody>
+                  <a:tcPr marL="91440" marR="91440" marT="45720" marB="45720">
+                    <a:lnL w="12700" cap="flat" cmpd="sng" algn="ctr">
+                      <a:solidFill>
+                        <a:srgbClr val="2A3441"/>
+                      </a:solidFill>
+                      <a:prstDash val="solid"/>
+                      <a:round/>
+                      <a:headEnd type="none" w="med" len="med"/>
+                      <a:tailEnd type="none" w="med" len="med"/>
+                    </a:lnL>
+                    <a:lnR w="12700" cap="flat" cmpd="sng" algn="ctr">
+                      <a:solidFill>
+                        <a:srgbClr val="2A3441"/>
+                      </a:solidFill>
+                      <a:prstDash val="solid"/>
+                      <a:round/>
+                      <a:headEnd type="none" w="med" len="med"/>
+                      <a:tailEnd type="none" w="med" len="med"/>
+                    </a:lnR>
+                    <a:lnT w="12700" cap="flat" cmpd="sng" algn="ctr">
+                      <a:solidFill>
+                        <a:srgbClr val="2A3441"/>
+                      </a:solidFill>
+                      <a:prstDash val="solid"/>
+                      <a:round/>
+                      <a:headEnd type="none" w="med" len="med"/>
+                      <a:tailEnd type="none" w="med" len="med"/>
+                    </a:lnT>
+                    <a:lnB w="12700" cap="flat" cmpd="sng" algn="ctr">
+                      <a:solidFill>
+                        <a:srgbClr val="2A3441"/>
+                      </a:solidFill>
+                      <a:prstDash val="solid"/>
+                      <a:round/>
+                      <a:headEnd type="none" w="med" len="med"/>
+                      <a:tailEnd type="none" w="med" len="med"/>
+                    </a:lnB>
+                    <a:solidFill>
+                      <a:srgbClr val="141B24"/>
+                    </a:solidFill>
+                  </a:tcPr>
+                </a:tc>
+              </a:tr>
+            </a:tbl>
+          </a:graphicData>
+        </a:graphic>
+      </p:graphicFrame>
+      <p:graphicFrame>
+        <p:nvGraphicFramePr>
+          <p:cNvPr id="61" name="Table 1"/>
+          <p:cNvGraphicFramePr>
+            <a:graphicFrameLocks noGrp="1"/>
+          </p:cNvGraphicFramePr>
+          <p:nvPr>
+            <p:extLst>
+              <p:ext uri="{D42A27DB-BD31-4B8C-83A1-F6EECF244321}">
+                <p14:modId xmlns:p14="http://schemas.microsoft.com/office/powerpoint/2010/main" val="1579011935"/>
+              </p:ext>
+            </p:extLst>
+          </p:nvPr>
+        </p:nvGraphicFramePr>
+        <p:xfrm>
+          <a:off x="6309360" y="1188720"/>
+          <a:ext cx="5394960" cy="914400"/>
+        </p:xfrm>
+        <a:graphic>
+          <a:graphicData uri="http://schemas.openxmlformats.org/drawingml/2006/table">
+            <a:tbl>
+              <a:tblPr/>
+              <a:tblGrid>
+                <a:gridCol w="2651760"/>
+                <a:gridCol w="1371600"/>
+                <a:gridCol w="1371600"/>
+              </a:tblGrid>
+              <a:tr h="384048">
+                <a:tc>
+                  <a:txBody>
+                    <a:bodyPr/>
+                    <a:lstStyle/>
+                    <a:p>
+                      <a:pPr indent="0" marL="0">
+                        <a:buNone/>
+                      </a:pPr>
+                      <a:r>
+                        <a:rPr lang="en-US" sz="1300" b="1" dirty="0">
+                          <a:solidFill>
+                            <a:srgbClr val="0B0F14"/>
+                          </a:solidFill>
+                          <a:latin typeface="Courier New" pitchFamily="34" charset="0"/>
+                          <a:ea typeface="Courier New" pitchFamily="34" charset="-122"/>
+                          <a:cs typeface="Courier New" pitchFamily="34" charset="-120"/>
+                        </a:rPr>
+                        <a:t>Bursty cross traffic</a:t>
+                      </a:r>
+                      <a:endParaRPr lang="en-US" sz="1300" dirty="0">
+                        <a:latin typeface="Courier New" charset="0"/>
+                        <a:ea typeface="Courier New" charset="0"/>
+                        <a:cs typeface="Courier New" charset="0"/>
+                      </a:endParaRPr>
+                    </a:p>
+                  </a:txBody>
+                  <a:tcPr marL="91440" marR="91440" marT="45720" marB="45720">
+                    <a:lnL w="12700" cap="flat" cmpd="sng" algn="ctr">
+                      <a:solidFill>
+                        <a:srgbClr val="2A3441"/>
+                      </a:solidFill>
+                      <a:prstDash val="solid"/>
+                      <a:round/>
+                      <a:headEnd type="none" w="med" len="med"/>
+                      <a:tailEnd type="none" w="med" len="med"/>
+                    </a:lnL>
+                    <a:lnR w="12700" cap="flat" cmpd="sng" algn="ctr">
+                      <a:solidFill>
+                        <a:srgbClr val="2A3441"/>
+                      </a:solidFill>
+                      <a:prstDash val="solid"/>
+                      <a:round/>
+                      <a:headEnd type="none" w="med" len="med"/>
+                      <a:tailEnd type="none" w="med" len="med"/>
+                    </a:lnR>
+                    <a:lnT w="12700" cap="flat" cmpd="sng" algn="ctr">
+                      <a:solidFill>
+                        <a:srgbClr val="2A3441"/>
+                      </a:solidFill>
+                      <a:prstDash val="solid"/>
+                      <a:round/>
+                      <a:headEnd type="none" w="med" len="med"/>
+                      <a:tailEnd type="none" w="med" len="med"/>
+                    </a:lnT>
+                    <a:lnB w="12700" cap="flat" cmpd="sng" algn="ctr">
+                      <a:solidFill>
+                        <a:srgbClr val="2A3441"/>
+                      </a:solidFill>
+                      <a:prstDash val="solid"/>
+                      <a:round/>
+                      <a:headEnd type="none" w="med" len="med"/>
+                      <a:tailEnd type="none" w="med" len="med"/>
+                    </a:lnB>
+                    <a:solidFill>
+                      <a:srgbClr val="39FF88"/>
+                    </a:solidFill>
+                  </a:tcPr>
+                </a:tc>
+                <a:tc>
+                  <a:txBody>
+                    <a:bodyPr/>
+                    <a:lstStyle/>
+                    <a:p>
+                      <a:pPr indent="0" marL="0">
+                        <a:buNone/>
+                      </a:pPr>
+                      <a:r>
+                        <a:rPr lang="en-US" sz="1300" b="1" dirty="0">
+                          <a:solidFill>
+                            <a:srgbClr val="0B0F14"/>
+                          </a:solidFill>
+                          <a:latin typeface="Courier New" pitchFamily="34" charset="0"/>
+                          <a:ea typeface="Courier New" pitchFamily="34" charset="-122"/>
+                          <a:cs typeface="Courier New" pitchFamily="34" charset="-120"/>
+                        </a:rPr>
+                        <a:t>Time</a:t>
+                      </a:r>
+                      <a:endParaRPr lang="en-US" sz="1300" dirty="0">
+                        <a:latin typeface="Courier New" charset="0"/>
+                        <a:ea typeface="Courier New" charset="0"/>
+                        <a:cs typeface="Courier New" charset="0"/>
+                      </a:endParaRPr>
+                    </a:p>
+                  </a:txBody>
+                  <a:tcPr marL="91440" marR="91440" marT="45720" marB="45720">
+                    <a:lnL w="12700" cap="flat" cmpd="sng" algn="ctr">
+                      <a:solidFill>
+                        <a:srgbClr val="2A3441"/>
+                      </a:solidFill>
+                      <a:prstDash val="solid"/>
+                      <a:round/>
+                      <a:headEnd type="none" w="med" len="med"/>
+                      <a:tailEnd type="none" w="med" len="med"/>
+                    </a:lnL>
+                    <a:lnR w="12700" cap="flat" cmpd="sng" algn="ctr">
+                      <a:solidFill>
+                        <a:srgbClr val="2A3441"/>
+                      </a:solidFill>
+                      <a:prstDash val="solid"/>
+                      <a:round/>
+                      <a:headEnd type="none" w="med" len="med"/>
+                      <a:tailEnd type="none" w="med" len="med"/>
+                    </a:lnR>
+                    <a:lnT w="12700" cap="flat" cmpd="sng" algn="ctr">
+                      <a:solidFill>
+                        <a:srgbClr val="2A3441"/>
+                      </a:solidFill>
+                      <a:prstDash val="solid"/>
+                      <a:round/>
+                      <a:headEnd type="none" w="med" len="med"/>
+                      <a:tailEnd type="none" w="med" len="med"/>
+                    </a:lnT>
+                    <a:lnB w="12700" cap="flat" cmpd="sng" algn="ctr">
+                      <a:solidFill>
+                        <a:srgbClr val="2A3441"/>
+                      </a:solidFill>
+                      <a:prstDash val="solid"/>
+                      <a:round/>
+                      <a:headEnd type="none" w="med" len="med"/>
+                      <a:tailEnd type="none" w="med" len="med"/>
+                    </a:lnB>
+                    <a:solidFill>
+                      <a:srgbClr val="39FF88"/>
+                    </a:solidFill>
+                  </a:tcPr>
+                </a:tc>
+                <a:tc>
+                  <a:txBody>
+                    <a:bodyPr/>
+                    <a:lstStyle/>
+                    <a:p>
+                      <a:pPr indent="0" marL="0">
+                        <a:buNone/>
+                      </a:pPr>
+                      <a:r>
+                        <a:rPr lang="en-US" sz="1300" b="1" dirty="0">
+                          <a:solidFill>
+                            <a:srgbClr val="0B0F14"/>
+                          </a:solidFill>
+                          <a:latin typeface="Courier New" pitchFamily="34" charset="0"/>
+                          <a:ea typeface="Courier New" pitchFamily="34" charset="-122"/>
+                          <a:cs typeface="Courier New" pitchFamily="34" charset="-120"/>
+                        </a:rPr>
+                        <a:t>vs AIMD</a:t>
+                      </a:r>
+                      <a:endParaRPr lang="en-US" sz="1300" dirty="0">
+                        <a:latin typeface="Courier New" charset="0"/>
+                        <a:ea typeface="Courier New" charset="0"/>
+                        <a:cs typeface="Courier New" charset="0"/>
+                      </a:endParaRPr>
+                    </a:p>
+                  </a:txBody>
+                  <a:tcPr marL="91440" marR="91440" marT="45720" marB="45720">
+                    <a:lnL w="12700" cap="flat" cmpd="sng" algn="ctr">
+                      <a:solidFill>
+                        <a:srgbClr val="2A3441"/>
+                      </a:solidFill>
+                      <a:prstDash val="solid"/>
+                      <a:round/>
+                      <a:headEnd type="none" w="med" len="med"/>
+                      <a:tailEnd type="none" w="med" len="med"/>
+                    </a:lnL>
+                    <a:lnR w="12700" cap="flat" cmpd="sng" algn="ctr">
+                      <a:solidFill>
+                        <a:srgbClr val="2A3441"/>
+                      </a:solidFill>
+                      <a:prstDash val="solid"/>
+                      <a:round/>
+                      <a:headEnd type="none" w="med" len="med"/>
+                      <a:tailEnd type="none" w="med" len="med"/>
+                    </a:lnR>
+                    <a:lnT w="12700" cap="flat" cmpd="sng" algn="ctr">
+                      <a:solidFill>
+                        <a:srgbClr val="2A3441"/>
+                      </a:solidFill>
+                      <a:prstDash val="solid"/>
+                      <a:round/>
+                      <a:headEnd type="none" w="med" len="med"/>
+                      <a:tailEnd type="none" w="med" len="med"/>
+                    </a:lnT>
+                    <a:lnB w="12700" cap="flat" cmpd="sng" algn="ctr">
+                      <a:solidFill>
+                        <a:srgbClr val="2A3441"/>
+                      </a:solidFill>
+                      <a:prstDash val="solid"/>
+                      <a:round/>
+                      <a:headEnd type="none" w="med" len="med"/>
+                      <a:tailEnd type="none" w="med" len="med"/>
+                    </a:lnB>
+                    <a:solidFill>
+                      <a:srgbClr val="39FF88"/>
+                    </a:solidFill>
+                  </a:tcPr>
+                </a:tc>
+              </a:tr>
+              <a:tr h="384048">
+                <a:tc>
+                  <a:txBody>
+                    <a:bodyPr/>
+                    <a:lstStyle/>
+                    <a:p>
+                      <a:pPr indent="0" marL="0">
+                        <a:buNone/>
+                      </a:pPr>
+                      <a:r>
+                        <a:rPr lang="en-US" sz="1300" dirty="0">
+                          <a:solidFill>
+                            <a:srgbClr val="E6EDF3"/>
+                          </a:solidFill>
+                          <a:latin typeface="Calibri" pitchFamily="34" charset="0"/>
+                          <a:ea typeface="Calibri" pitchFamily="34" charset="-122"/>
+                          <a:cs typeface="Calibri" pitchFamily="34" charset="-120"/>
+                        </a:rPr>
+                        <a:t>AIMD tuned</a:t>
+                      </a:r>
+                      <a:endParaRPr lang="en-US" sz="1300" dirty="0">
+                        <a:latin typeface="Calibri" charset="0"/>
+                        <a:ea typeface="Calibri" charset="0"/>
+                        <a:cs typeface="Calibri" charset="0"/>
+                      </a:endParaRPr>
+                    </a:p>
+                  </a:txBody>
+                  <a:tcPr marL="91440" marR="91440" marT="45720" marB="45720">
+                    <a:lnL w="12700" cap="flat" cmpd="sng" algn="ctr">
+                      <a:solidFill>
+                        <a:srgbClr val="2A3441"/>
+                      </a:solidFill>
+                      <a:prstDash val="solid"/>
+                      <a:round/>
+                      <a:headEnd type="none" w="med" len="med"/>
+                      <a:tailEnd type="none" w="med" len="med"/>
+                    </a:lnL>
+                    <a:lnR w="12700" cap="flat" cmpd="sng" algn="ctr">
+                      <a:solidFill>
+                        <a:srgbClr val="2A3441"/>
+                      </a:solidFill>
+                      <a:prstDash val="solid"/>
+                      <a:round/>
+                      <a:headEnd type="none" w="med" len="med"/>
+                      <a:tailEnd type="none" w="med" len="med"/>
+                    </a:lnR>
+                    <a:lnT w="12700" cap="flat" cmpd="sng" algn="ctr">
+                      <a:solidFill>
+                        <a:srgbClr val="2A3441"/>
+                      </a:solidFill>
+                      <a:prstDash val="solid"/>
+                      <a:round/>
+                      <a:headEnd type="none" w="med" len="med"/>
+                      <a:tailEnd type="none" w="med" len="med"/>
+                    </a:lnT>
+                    <a:lnB w="12700" cap="flat" cmpd="sng" algn="ctr">
+                      <a:solidFill>
+                        <a:srgbClr val="2A3441"/>
+                      </a:solidFill>
+                      <a:prstDash val="solid"/>
+                      <a:round/>
+                      <a:headEnd type="none" w="med" len="med"/>
+                      <a:tailEnd type="none" w="med" len="med"/>
+                    </a:lnB>
+                    <a:solidFill>
+                      <a:srgbClr val="141B24"/>
+                    </a:solidFill>
+                  </a:tcPr>
+                </a:tc>
+                <a:tc>
+                  <a:txBody>
+                    <a:bodyPr/>
+                    <a:lstStyle/>
+                    <a:p>
+                      <a:pPr indent="0" marL="0">
+                        <a:buNone/>
+                      </a:pPr>
+                      <a:r>
+                        <a:rPr lang="en-US" sz="1300" dirty="0">
+                          <a:solidFill>
+                            <a:srgbClr val="E6EDF3"/>
+                          </a:solidFill>
+                          <a:latin typeface="Calibri" pitchFamily="34" charset="0"/>
+                          <a:ea typeface="Calibri" pitchFamily="34" charset="-122"/>
+                          <a:cs typeface="Calibri" pitchFamily="34" charset="-120"/>
+                        </a:rPr>
+                        <a:t>5.73 s</a:t>
+                      </a:r>
+                      <a:endParaRPr lang="en-US" sz="1300" dirty="0">
+                        <a:latin typeface="Calibri" charset="0"/>
+                        <a:ea typeface="Calibri" charset="0"/>
+                        <a:cs typeface="Calibri" charset="0"/>
+                      </a:endParaRPr>
+                    </a:p>
+                  </a:txBody>
+                  <a:tcPr marL="91440" marR="91440" marT="45720" marB="45720">
+                    <a:lnL w="12700" cap="flat" cmpd="sng" algn="ctr">
+                      <a:solidFill>
+                        <a:srgbClr val="2A3441"/>
+                      </a:solidFill>
+                      <a:prstDash val="solid"/>
+                      <a:round/>
+                      <a:headEnd type="none" w="med" len="med"/>
+                      <a:tailEnd type="none" w="med" len="med"/>
+                    </a:lnL>
+                    <a:lnR w="12700" cap="flat" cmpd="sng" algn="ctr">
+                      <a:solidFill>
+                        <a:srgbClr val="2A3441"/>
+                      </a:solidFill>
+                      <a:prstDash val="solid"/>
+                      <a:round/>
+                      <a:headEnd type="none" w="med" len="med"/>
+                      <a:tailEnd type="none" w="med" len="med"/>
+                    </a:lnR>
+                    <a:lnT w="12700" cap="flat" cmpd="sng" algn="ctr">
+                      <a:solidFill>
+                        <a:srgbClr val="2A3441"/>
+                      </a:solidFill>
+                      <a:prstDash val="solid"/>
+                      <a:round/>
+                      <a:headEnd type="none" w="med" len="med"/>
+                      <a:tailEnd type="none" w="med" len="med"/>
+                    </a:lnT>
+                    <a:lnB w="12700" cap="flat" cmpd="sng" algn="ctr">
+                      <a:solidFill>
+                        <a:srgbClr val="2A3441"/>
+                      </a:solidFill>
+                      <a:prstDash val="solid"/>
+                      <a:round/>
+                      <a:headEnd type="none" w="med" len="med"/>
+                      <a:tailEnd type="none" w="med" len="med"/>
+                    </a:lnB>
+                    <a:solidFill>
+                      <a:srgbClr val="141B24"/>
+                    </a:solidFill>
+                  </a:tcPr>
+                </a:tc>
+                <a:tc>
+                  <a:txBody>
+                    <a:bodyPr/>
+                    <a:lstStyle/>
+                    <a:p>
+                      <a:pPr indent="0" marL="0">
+                        <a:buNone/>
+                      </a:pPr>
+                      <a:r>
+                        <a:rPr lang="en-US" sz="1300" dirty="0">
+                          <a:solidFill>
+                            <a:srgbClr val="E6EDF3"/>
+                          </a:solidFill>
+                          <a:latin typeface="Calibri" pitchFamily="34" charset="0"/>
+                          <a:ea typeface="Calibri" pitchFamily="34" charset="-122"/>
+                          <a:cs typeface="Calibri" pitchFamily="34" charset="-120"/>
+                        </a:rPr>
+                        <a:t>1.00</a:t>
+                      </a:r>
+                      <a:endParaRPr lang="en-US" sz="1300" dirty="0">
+                        <a:latin typeface="Calibri" charset="0"/>
+                        <a:ea typeface="Calibri" charset="0"/>
+                        <a:cs typeface="Calibri" charset="0"/>
+                      </a:endParaRPr>
+                    </a:p>
+                  </a:txBody>
+                  <a:tcPr marL="91440" marR="91440" marT="45720" marB="45720">
+                    <a:lnL w="12700" cap="flat" cmpd="sng" algn="ctr">
+                      <a:solidFill>
+                        <a:srgbClr val="2A3441"/>
+                      </a:solidFill>
+                      <a:prstDash val="solid"/>
+                      <a:round/>
+                      <a:headEnd type="none" w="med" len="med"/>
+                      <a:tailEnd type="none" w="med" len="med"/>
+                    </a:lnL>
+                    <a:lnR w="12700" cap="flat" cmpd="sng" algn="ctr">
+                      <a:solidFill>
+                        <a:srgbClr val="2A3441"/>
+                      </a:solidFill>
+                      <a:prstDash val="solid"/>
+                      <a:round/>
+                      <a:headEnd type="none" w="med" len="med"/>
+                      <a:tailEnd type="none" w="med" len="med"/>
+                    </a:lnR>
+                    <a:lnT w="12700" cap="flat" cmpd="sng" algn="ctr">
+                      <a:solidFill>
+                        <a:srgbClr val="2A3441"/>
+                      </a:solidFill>
+                      <a:prstDash val="solid"/>
+                      <a:round/>
+                      <a:headEnd type="none" w="med" len="med"/>
+                      <a:tailEnd type="none" w="med" len="med"/>
+                    </a:lnT>
+                    <a:lnB w="12700" cap="flat" cmpd="sng" algn="ctr">
+                      <a:solidFill>
+                        <a:srgbClr val="2A3441"/>
+                      </a:solidFill>
+                      <a:prstDash val="solid"/>
+                      <a:round/>
+                      <a:headEnd type="none" w="med" len="med"/>
+                      <a:tailEnd type="none" w="med" len="med"/>
+                    </a:lnB>
+                    <a:solidFill>
+                      <a:srgbClr val="141B24"/>
+                    </a:solidFill>
+                  </a:tcPr>
+                </a:tc>
+              </a:tr>
+              <a:tr h="384048">
+                <a:tc>
+                  <a:txBody>
+                    <a:bodyPr/>
+                    <a:lstStyle/>
+                    <a:p>
+                      <a:pPr indent="0" marL="0">
+                        <a:buNone/>
+                      </a:pPr>
+                      <a:r>
+                        <a:rPr lang="en-US" sz="1300" dirty="0">
+                          <a:solidFill>
+                            <a:srgbClr val="E6EDF3"/>
+                          </a:solidFill>
+                          <a:latin typeface="Calibri" pitchFamily="34" charset="0"/>
+                          <a:ea typeface="Calibri" pitchFamily="34" charset="-122"/>
+                          <a:cs typeface="Calibri" pitchFamily="34" charset="-120"/>
+                        </a:rPr>
+                        <a:t>CUBIC tuned</a:t>
+                      </a:r>
+                      <a:endParaRPr lang="en-US" sz="1300" dirty="0">
+                        <a:latin typeface="Calibri" charset="0"/>
+                        <a:ea typeface="Calibri" charset="0"/>
+                        <a:cs typeface="Calibri" charset="0"/>
+                      </a:endParaRPr>
+                    </a:p>
+                  </a:txBody>
+                  <a:tcPr marL="91440" marR="91440" marT="45720" marB="45720">
+                    <a:lnL w="12700" cap="flat" cmpd="sng" algn="ctr">
+                      <a:solidFill>
+                        <a:srgbClr val="2A3441"/>
+                      </a:solidFill>
+                      <a:prstDash val="solid"/>
+                      <a:round/>
+                      <a:headEnd type="none" w="med" len="med"/>
+                      <a:tailEnd type="none" w="med" len="med"/>
+                    </a:lnL>
+                    <a:lnR w="12700" cap="flat" cmpd="sng" algn="ctr">
+                      <a:solidFill>
+                        <a:srgbClr val="2A3441"/>
+                      </a:solidFill>
+                      <a:prstDash val="solid"/>
+                      <a:round/>
+                      <a:headEnd type="none" w="med" len="med"/>
+                      <a:tailEnd type="none" w="med" len="med"/>
+                    </a:lnR>
+                    <a:lnT w="12700" cap="flat" cmpd="sng" algn="ctr">
+                      <a:solidFill>
+                        <a:srgbClr val="2A3441"/>
+                      </a:solidFill>
+                      <a:prstDash val="solid"/>
+                      <a:round/>
+                      <a:headEnd type="none" w="med" len="med"/>
+                      <a:tailEnd type="none" w="med" len="med"/>
+                    </a:lnT>
+                    <a:lnB w="12700" cap="flat" cmpd="sng" algn="ctr">
+                      <a:solidFill>
+                        <a:srgbClr val="2A3441"/>
+                      </a:solidFill>
+                      <a:prstDash val="solid"/>
+                      <a:round/>
+                      <a:headEnd type="none" w="med" len="med"/>
+                      <a:tailEnd type="none" w="med" len="med"/>
+                    </a:lnB>
+                    <a:solidFill>
+                      <a:srgbClr val="141B24"/>
+                    </a:solidFill>
+                  </a:tcPr>
+                </a:tc>
+                <a:tc>
+                  <a:txBody>
+                    <a:bodyPr/>
+                    <a:lstStyle/>
+                    <a:p>
+                      <a:pPr indent="0" marL="0">
+                        <a:buNone/>
+                      </a:pPr>
+                      <a:r>
+                        <a:rPr lang="en-US" sz="1300" dirty="0">
+                          <a:solidFill>
+                            <a:srgbClr val="E6EDF3"/>
+                          </a:solidFill>
+                          <a:latin typeface="Calibri" pitchFamily="34" charset="0"/>
+                          <a:ea typeface="Calibri" pitchFamily="34" charset="-122"/>
+                          <a:cs typeface="Calibri" pitchFamily="34" charset="-120"/>
+                        </a:rPr>
+                        <a:t>4.55 s</a:t>
+                      </a:r>
+                      <a:endParaRPr lang="en-US" sz="1300" dirty="0">
+                        <a:latin typeface="Calibri" charset="0"/>
+                        <a:ea typeface="Calibri" charset="0"/>
+                        <a:cs typeface="Calibri" charset="0"/>
+                      </a:endParaRPr>
+                    </a:p>
+                  </a:txBody>
+                  <a:tcPr marL="91440" marR="91440" marT="45720" marB="45720">
+                    <a:lnL w="12700" cap="flat" cmpd="sng" algn="ctr">
+                      <a:solidFill>
+                        <a:srgbClr val="2A3441"/>
+                      </a:solidFill>
+                      <a:prstDash val="solid"/>
+                      <a:round/>
+                      <a:headEnd type="none" w="med" len="med"/>
+                      <a:tailEnd type="none" w="med" len="med"/>
+                    </a:lnL>
+                    <a:lnR w="12700" cap="flat" cmpd="sng" algn="ctr">
+                      <a:solidFill>
+                        <a:srgbClr val="2A3441"/>
+                      </a:solidFill>
+                      <a:prstDash val="solid"/>
+                      <a:round/>
+                      <a:headEnd type="none" w="med" len="med"/>
+                      <a:tailEnd type="none" w="med" len="med"/>
+                    </a:lnR>
+                    <a:lnT w="12700" cap="flat" cmpd="sng" algn="ctr">
+                      <a:solidFill>
+                        <a:srgbClr val="2A3441"/>
+                      </a:solidFill>
+                      <a:prstDash val="solid"/>
+                      <a:round/>
+                      <a:headEnd type="none" w="med" len="med"/>
+                      <a:tailEnd type="none" w="med" len="med"/>
+                    </a:lnT>
+                    <a:lnB w="12700" cap="flat" cmpd="sng" algn="ctr">
+                      <a:solidFill>
+                        <a:srgbClr val="2A3441"/>
+                      </a:solidFill>
+                      <a:prstDash val="solid"/>
+                      <a:round/>
+                      <a:headEnd type="none" w="med" len="med"/>
+                      <a:tailEnd type="none" w="med" len="med"/>
+                    </a:lnB>
+                    <a:solidFill>
+                      <a:srgbClr val="141B24"/>
+                    </a:solidFill>
+                  </a:tcPr>
+                </a:tc>
+                <a:tc>
+                  <a:txBody>
+                    <a:bodyPr/>
+                    <a:lstStyle/>
+                    <a:p>
+                      <a:pPr indent="0" marL="0">
+                        <a:buNone/>
+                      </a:pPr>
+                      <a:r>
+                        <a:rPr lang="en-US" sz="1300" dirty="0">
+                          <a:solidFill>
+                            <a:srgbClr val="E6EDF3"/>
+                          </a:solidFill>
+                          <a:latin typeface="Calibri" pitchFamily="34" charset="0"/>
+                          <a:ea typeface="Calibri" pitchFamily="34" charset="-122"/>
+                          <a:cs typeface="Calibri" pitchFamily="34" charset="-120"/>
+                        </a:rPr>
+                        <a:t>0.79</a:t>
+                      </a:r>
+                      <a:endParaRPr lang="en-US" sz="1300" dirty="0">
+                        <a:latin typeface="Calibri" charset="0"/>
+                        <a:ea typeface="Calibri" charset="0"/>
+                        <a:cs typeface="Calibri" charset="0"/>
+                      </a:endParaRPr>
+                    </a:p>
+                  </a:txBody>
+                  <a:tcPr marL="91440" marR="91440" marT="45720" marB="45720">
+                    <a:lnL w="12700" cap="flat" cmpd="sng" algn="ctr">
+                      <a:solidFill>
+                        <a:srgbClr val="2A3441"/>
+                      </a:solidFill>
+                      <a:prstDash val="solid"/>
+                      <a:round/>
+                      <a:headEnd type="none" w="med" len="med"/>
+                      <a:tailEnd type="none" w="med" len="med"/>
+                    </a:lnL>
+                    <a:lnR w="12700" cap="flat" cmpd="sng" algn="ctr">
+                      <a:solidFill>
+                        <a:srgbClr val="2A3441"/>
+                      </a:solidFill>
+                      <a:prstDash val="solid"/>
+                      <a:round/>
+                      <a:headEnd type="none" w="med" len="med"/>
+                      <a:tailEnd type="none" w="med" len="med"/>
+                    </a:lnR>
+                    <a:lnT w="12700" cap="flat" cmpd="sng" algn="ctr">
+                      <a:solidFill>
+                        <a:srgbClr val="2A3441"/>
+                      </a:solidFill>
+                      <a:prstDash val="solid"/>
+                      <a:round/>
+                      <a:headEnd type="none" w="med" len="med"/>
+                      <a:tailEnd type="none" w="med" len="med"/>
+                    </a:lnT>
+                    <a:lnB w="12700" cap="flat" cmpd="sng" algn="ctr">
+                      <a:solidFill>
+                        <a:srgbClr val="2A3441"/>
+                      </a:solidFill>
+                      <a:prstDash val="solid"/>
+                      <a:round/>
+                      <a:headEnd type="none" w="med" len="med"/>
+                      <a:tailEnd type="none" w="med" len="med"/>
+                    </a:lnB>
+                    <a:solidFill>
+                      <a:srgbClr val="141B24"/>
+                    </a:solidFill>
+                  </a:tcPr>
+                </a:tc>
+              </a:tr>
+              <a:tr h="384048">
+                <a:tc>
+                  <a:txBody>
+                    <a:bodyPr/>
+                    <a:lstStyle/>
+                    <a:p>
+                      <a:pPr indent="0" marL="0">
+                        <a:buNone/>
+                      </a:pPr>
+                      <a:r>
+                        <a:rPr lang="en-US" sz="1300" dirty="0">
+                          <a:solidFill>
+                            <a:srgbClr val="E6EDF3"/>
+                          </a:solidFill>
+                          <a:latin typeface="Calibri" pitchFamily="34" charset="0"/>
+                          <a:ea typeface="Calibri" pitchFamily="34" charset="-122"/>
+                          <a:cs typeface="Calibri" pitchFamily="34" charset="-120"/>
+                        </a:rPr>
+                        <a:t>Neural agent</a:t>
+                      </a:r>
+                      <a:endParaRPr lang="en-US" sz="1300" dirty="0">
+                        <a:latin typeface="Calibri" charset="0"/>
+                        <a:ea typeface="Calibri" charset="0"/>
+                        <a:cs typeface="Calibri" charset="0"/>
+                      </a:endParaRPr>
+                    </a:p>
+                  </a:txBody>
+                  <a:tcPr marL="91440" marR="91440" marT="45720" marB="45720">
+                    <a:lnL w="12700" cap="flat" cmpd="sng" algn="ctr">
+                      <a:solidFill>
+                        <a:srgbClr val="2A3441"/>
+                      </a:solidFill>
+                      <a:prstDash val="solid"/>
+                      <a:round/>
+                      <a:headEnd type="none" w="med" len="med"/>
+                      <a:tailEnd type="none" w="med" len="med"/>
+                    </a:lnL>
+                    <a:lnR w="12700" cap="flat" cmpd="sng" algn="ctr">
+                      <a:solidFill>
+                        <a:srgbClr val="2A3441"/>
+                      </a:solidFill>
+                      <a:prstDash val="solid"/>
+                      <a:round/>
+                      <a:headEnd type="none" w="med" len="med"/>
+                      <a:tailEnd type="none" w="med" len="med"/>
+                    </a:lnR>
+                    <a:lnT w="12700" cap="flat" cmpd="sng" algn="ctr">
+                      <a:solidFill>
+                        <a:srgbClr val="2A3441"/>
+                      </a:solidFill>
+                      <a:prstDash val="solid"/>
+                      <a:round/>
+                      <a:headEnd type="none" w="med" len="med"/>
+                      <a:tailEnd type="none" w="med" len="med"/>
+                    </a:lnT>
+                    <a:lnB w="12700" cap="flat" cmpd="sng" algn="ctr">
+                      <a:solidFill>
+                        <a:srgbClr val="2A3441"/>
+                      </a:solidFill>
+                      <a:prstDash val="solid"/>
+                      <a:round/>
+                      <a:headEnd type="none" w="med" len="med"/>
+                      <a:tailEnd type="none" w="med" len="med"/>
+                    </a:lnB>
+                    <a:solidFill>
+                      <a:srgbClr val="141B24"/>
+                    </a:solidFill>
+                  </a:tcPr>
+                </a:tc>
+                <a:tc>
+                  <a:txBody>
+                    <a:bodyPr/>
+                    <a:lstStyle/>
+                    <a:p>
+                      <a:pPr indent="0" marL="0">
+                        <a:buNone/>
+                      </a:pPr>
+                      <a:r>
+                        <a:rPr lang="en-US" sz="1300" dirty="0">
+                          <a:solidFill>
+                            <a:srgbClr val="E6EDF3"/>
+                          </a:solidFill>
+                          <a:latin typeface="Calibri" pitchFamily="34" charset="0"/>
+                          <a:ea typeface="Calibri" pitchFamily="34" charset="-122"/>
+                          <a:cs typeface="Calibri" pitchFamily="34" charset="-120"/>
+                        </a:rPr>
+                        <a:t>4.87 s</a:t>
+                      </a:r>
+                      <a:endParaRPr lang="en-US" sz="1300" dirty="0">
+                        <a:latin typeface="Calibri" charset="0"/>
+                        <a:ea typeface="Calibri" charset="0"/>
+                        <a:cs typeface="Calibri" charset="0"/>
+                      </a:endParaRPr>
+                    </a:p>
+                  </a:txBody>
+                  <a:tcPr marL="91440" marR="91440" marT="45720" marB="45720">
+                    <a:lnL w="12700" cap="flat" cmpd="sng" algn="ctr">
+                      <a:solidFill>
+                        <a:srgbClr val="2A3441"/>
+                      </a:solidFill>
+                      <a:prstDash val="solid"/>
+                      <a:round/>
+                      <a:headEnd type="none" w="med" len="med"/>
+                      <a:tailEnd type="none" w="med" len="med"/>
+                    </a:lnL>
+                    <a:lnR w="12700" cap="flat" cmpd="sng" algn="ctr">
+                      <a:solidFill>
+                        <a:srgbClr val="2A3441"/>
+                      </a:solidFill>
+                      <a:prstDash val="solid"/>
+                      <a:round/>
+                      <a:headEnd type="none" w="med" len="med"/>
+                      <a:tailEnd type="none" w="med" len="med"/>
+                    </a:lnR>
+                    <a:lnT w="12700" cap="flat" cmpd="sng" algn="ctr">
+                      <a:solidFill>
+                        <a:srgbClr val="2A3441"/>
+                      </a:solidFill>
+                      <a:prstDash val="solid"/>
+                      <a:round/>
+                      <a:headEnd type="none" w="med" len="med"/>
+                      <a:tailEnd type="none" w="med" len="med"/>
+                    </a:lnT>
+                    <a:lnB w="12700" cap="flat" cmpd="sng" algn="ctr">
+                      <a:solidFill>
+                        <a:srgbClr val="2A3441"/>
+                      </a:solidFill>
+                      <a:prstDash val="solid"/>
+                      <a:round/>
+                      <a:headEnd type="none" w="med" len="med"/>
+                      <a:tailEnd type="none" w="med" len="med"/>
+                    </a:lnB>
+                    <a:solidFill>
+                      <a:srgbClr val="141B24"/>
+                    </a:solidFill>
+                  </a:tcPr>
+                </a:tc>
+                <a:tc>
+                  <a:txBody>
+                    <a:bodyPr/>
+                    <a:lstStyle/>
+                    <a:p>
+                      <a:pPr indent="0" marL="0">
+                        <a:buNone/>
+                      </a:pPr>
+                      <a:r>
+                        <a:rPr lang="en-US" sz="1300" dirty="0">
+                          <a:solidFill>
+                            <a:srgbClr val="E6EDF3"/>
+                          </a:solidFill>
+                          <a:latin typeface="Calibri" pitchFamily="34" charset="0"/>
+                          <a:ea typeface="Calibri" pitchFamily="34" charset="-122"/>
+                          <a:cs typeface="Calibri" pitchFamily="34" charset="-120"/>
+                        </a:rPr>
+                        <a:t>0.85</a:t>
+                      </a:r>
+                      <a:endParaRPr lang="en-US" sz="1300" dirty="0">
+                        <a:latin typeface="Calibri" charset="0"/>
+                        <a:ea typeface="Calibri" charset="0"/>
+                        <a:cs typeface="Calibri" charset="0"/>
+                      </a:endParaRPr>
+                    </a:p>
+                  </a:txBody>
+                  <a:tcPr marL="91440" marR="91440" marT="45720" marB="45720">
+                    <a:lnL w="12700" cap="flat" cmpd="sng" algn="ctr">
+                      <a:solidFill>
+                        <a:srgbClr val="2A3441"/>
+                      </a:solidFill>
+                      <a:prstDash val="solid"/>
+                      <a:round/>
+                      <a:headEnd type="none" w="med" len="med"/>
+                      <a:tailEnd type="none" w="med" len="med"/>
+                    </a:lnL>
+                    <a:lnR w="12700" cap="flat" cmpd="sng" algn="ctr">
+                      <a:solidFill>
+                        <a:srgbClr val="2A3441"/>
+                      </a:solidFill>
+                      <a:prstDash val="solid"/>
+                      <a:round/>
+                      <a:headEnd type="none" w="med" len="med"/>
+                      <a:tailEnd type="none" w="med" len="med"/>
+                    </a:lnR>
+                    <a:lnT w="12700" cap="flat" cmpd="sng" algn="ctr">
+                      <a:solidFill>
+                        <a:srgbClr val="2A3441"/>
+                      </a:solidFill>
+                      <a:prstDash val="solid"/>
+                      <a:round/>
+                      <a:headEnd type="none" w="med" len="med"/>
+                      <a:tailEnd type="none" w="med" len="med"/>
+                    </a:lnT>
+                    <a:lnB w="12700" cap="flat" cmpd="sng" algn="ctr">
+                      <a:solidFill>
+                        <a:srgbClr val="2A3441"/>
+                      </a:solidFill>
+                      <a:prstDash val="solid"/>
+                      <a:round/>
+                      <a:headEnd type="none" w="med" len="med"/>
+                      <a:tailEnd type="none" w="med" len="med"/>
+                    </a:lnB>
+                    <a:solidFill>
+                      <a:srgbClr val="141B24"/>
+                    </a:solidFill>
+                  </a:tcPr>
+                </a:tc>
+              </a:tr>
+              <a:tr h="384048">
+                <a:tc>
+                  <a:txBody>
+                    <a:bodyPr/>
+                    <a:lstStyle/>
+                    <a:p>
+                      <a:pPr indent="0" marL="0">
+                        <a:buNone/>
+                      </a:pPr>
+                      <a:r>
+                        <a:rPr lang="en-US" sz="1300" dirty="0">
+                          <a:solidFill>
+                            <a:srgbClr val="E6EDF3"/>
+                          </a:solidFill>
+                          <a:latin typeface="Calibri" pitchFamily="34" charset="0"/>
+                          <a:ea typeface="Calibri" pitchFamily="34" charset="-122"/>
+                          <a:cs typeface="Calibri" pitchFamily="34" charset="-120"/>
+                        </a:rPr>
+                        <a:t>Neural, polite 1.3</a:t>
+                      </a:r>
+                      <a:endParaRPr lang="en-US" sz="1300" dirty="0">
+                        <a:latin typeface="Calibri" charset="0"/>
+                        <a:ea typeface="Calibri" charset="0"/>
+                        <a:cs typeface="Calibri" charset="0"/>
+                      </a:endParaRPr>
+                    </a:p>
+                  </a:txBody>
+                  <a:tcPr marL="91440" marR="91440" marT="45720" marB="45720">
+                    <a:lnL w="12700" cap="flat" cmpd="sng" algn="ctr">
+                      <a:solidFill>
+                        <a:srgbClr val="2A3441"/>
+                      </a:solidFill>
+                      <a:prstDash val="solid"/>
+                      <a:round/>
+                      <a:headEnd type="none" w="med" len="med"/>
+                      <a:tailEnd type="none" w="med" len="med"/>
+                    </a:lnL>
+                    <a:lnR w="12700" cap="flat" cmpd="sng" algn="ctr">
+                      <a:solidFill>
+                        <a:srgbClr val="2A3441"/>
+                      </a:solidFill>
+                      <a:prstDash val="solid"/>
+                      <a:round/>
+                      <a:headEnd type="none" w="med" len="med"/>
+                      <a:tailEnd type="none" w="med" len="med"/>
+                    </a:lnR>
+                    <a:lnT w="12700" cap="flat" cmpd="sng" algn="ctr">
+                      <a:solidFill>
+                        <a:srgbClr val="2A3441"/>
+                      </a:solidFill>
+                      <a:prstDash val="solid"/>
+                      <a:round/>
+                      <a:headEnd type="none" w="med" len="med"/>
+                      <a:tailEnd type="none" w="med" len="med"/>
+                    </a:lnT>
+                    <a:lnB w="12700" cap="flat" cmpd="sng" algn="ctr">
+                      <a:solidFill>
+                        <a:srgbClr val="2A3441"/>
+                      </a:solidFill>
+                      <a:prstDash val="solid"/>
+                      <a:round/>
+                      <a:headEnd type="none" w="med" len="med"/>
+                      <a:tailEnd type="none" w="med" len="med"/>
+                    </a:lnB>
+                    <a:solidFill>
+                      <a:srgbClr val="141B24"/>
+                    </a:solidFill>
+                  </a:tcPr>
+                </a:tc>
+                <a:tc>
+                  <a:txBody>
+                    <a:bodyPr/>
+                    <a:lstStyle/>
+                    <a:p>
+                      <a:pPr indent="0" marL="0">
+                        <a:buNone/>
+                      </a:pPr>
+                      <a:r>
+                        <a:rPr lang="en-US" sz="1300" dirty="0">
+                          <a:solidFill>
+                            <a:srgbClr val="E6EDF3"/>
+                          </a:solidFill>
+                          <a:latin typeface="Calibri" pitchFamily="34" charset="0"/>
+                          <a:ea typeface="Calibri" pitchFamily="34" charset="-122"/>
+                          <a:cs typeface="Calibri" pitchFamily="34" charset="-120"/>
+                        </a:rPr>
+                        <a:t>4.92 s</a:t>
+                      </a:r>
+                      <a:endParaRPr lang="en-US" sz="1300" dirty="0">
+                        <a:latin typeface="Calibri" charset="0"/>
+                        <a:ea typeface="Calibri" charset="0"/>
+                        <a:cs typeface="Calibri" charset="0"/>
+                      </a:endParaRPr>
+                    </a:p>
+                  </a:txBody>
+                  <a:tcPr marL="91440" marR="91440" marT="45720" marB="45720">
+                    <a:lnL w="12700" cap="flat" cmpd="sng" algn="ctr">
+                      <a:solidFill>
+                        <a:srgbClr val="2A3441"/>
+                      </a:solidFill>
+                      <a:prstDash val="solid"/>
+                      <a:round/>
+                      <a:headEnd type="none" w="med" len="med"/>
+                      <a:tailEnd type="none" w="med" len="med"/>
+                    </a:lnL>
+                    <a:lnR w="12700" cap="flat" cmpd="sng" algn="ctr">
+                      <a:solidFill>
+                        <a:srgbClr val="2A3441"/>
+                      </a:solidFill>
+                      <a:prstDash val="solid"/>
+                      <a:round/>
+                      <a:headEnd type="none" w="med" len="med"/>
+                      <a:tailEnd type="none" w="med" len="med"/>
+                    </a:lnR>
+                    <a:lnT w="12700" cap="flat" cmpd="sng" algn="ctr">
+                      <a:solidFill>
+                        <a:srgbClr val="2A3441"/>
+                      </a:solidFill>
+                      <a:prstDash val="solid"/>
+                      <a:round/>
+                      <a:headEnd type="none" w="med" len="med"/>
+                      <a:tailEnd type="none" w="med" len="med"/>
+                    </a:lnT>
+                    <a:lnB w="12700" cap="flat" cmpd="sng" algn="ctr">
+                      <a:solidFill>
+                        <a:srgbClr val="2A3441"/>
+                      </a:solidFill>
+                      <a:prstDash val="solid"/>
+                      <a:round/>
+                      <a:headEnd type="none" w="med" len="med"/>
+                      <a:tailEnd type="none" w="med" len="med"/>
+                    </a:lnB>
+                    <a:solidFill>
+                      <a:srgbClr val="141B24"/>
+                    </a:solidFill>
+                  </a:tcPr>
+                </a:tc>
+                <a:tc>
+                  <a:txBody>
+                    <a:bodyPr/>
+                    <a:lstStyle/>
+                    <a:p>
+                      <a:pPr indent="0" marL="0">
+                        <a:buNone/>
+                      </a:pPr>
+                      <a:r>
+                        <a:rPr lang="en-US" sz="1300" dirty="0">
+                          <a:solidFill>
+                            <a:srgbClr val="E6EDF3"/>
+                          </a:solidFill>
+                          <a:latin typeface="Calibri" pitchFamily="34" charset="0"/>
+                          <a:ea typeface="Calibri" pitchFamily="34" charset="-122"/>
+                          <a:cs typeface="Calibri" pitchFamily="34" charset="-120"/>
+                        </a:rPr>
+                        <a:t>0.86</a:t>
+                      </a:r>
+                      <a:endParaRPr lang="en-US" sz="1300" dirty="0">
+                        <a:latin typeface="Calibri" charset="0"/>
+                        <a:ea typeface="Calibri" charset="0"/>
+                        <a:cs typeface="Calibri" charset="0"/>
+                      </a:endParaRPr>
+                    </a:p>
+                  </a:txBody>
+                  <a:tcPr marL="91440" marR="91440" marT="45720" marB="45720">
+                    <a:lnL w="12700" cap="flat" cmpd="sng" algn="ctr">
+                      <a:solidFill>
+                        <a:srgbClr val="2A3441"/>
+                      </a:solidFill>
+                      <a:prstDash val="solid"/>
+                      <a:round/>
+                      <a:headEnd type="none" w="med" len="med"/>
+                      <a:tailEnd type="none" w="med" len="med"/>
+                    </a:lnL>
+                    <a:lnR w="12700" cap="flat" cmpd="sng" algn="ctr">
+                      <a:solidFill>
+                        <a:srgbClr val="2A3441"/>
+                      </a:solidFill>
+                      <a:prstDash val="solid"/>
+                      <a:round/>
+                      <a:headEnd type="none" w="med" len="med"/>
+                      <a:tailEnd type="none" w="med" len="med"/>
+                    </a:lnR>
+                    <a:lnT w="12700" cap="flat" cmpd="sng" algn="ctr">
+                      <a:solidFill>
+                        <a:srgbClr val="2A3441"/>
+                      </a:solidFill>
+                      <a:prstDash val="solid"/>
+                      <a:round/>
+                      <a:headEnd type="none" w="med" len="med"/>
+                      <a:tailEnd type="none" w="med" len="med"/>
+                    </a:lnT>
+                    <a:lnB w="12700" cap="flat" cmpd="sng" algn="ctr">
+                      <a:solidFill>
+                        <a:srgbClr val="2A3441"/>
+                      </a:solidFill>
+                      <a:prstDash val="solid"/>
+                      <a:round/>
+                      <a:headEnd type="none" w="med" len="med"/>
+                      <a:tailEnd type="none" w="med" len="med"/>
+                    </a:lnB>
+                    <a:solidFill>
+                      <a:srgbClr val="141B24"/>
+                    </a:solidFill>
+                  </a:tcPr>
+                </a:tc>
+              </a:tr>
+            </a:tbl>
+          </a:graphicData>
+        </a:graphic>
+      </p:graphicFrame>
+      <p:sp>
+        <p:nvSpPr>
+          <p:cNvPr id="6" name="Text 2"/>
           <p:cNvSpPr/>
           <p:nvPr/>
         </p:nvSpPr>
         <p:spPr>
           <a:xfrm>
-            <a:off x="548640" y="1371600"/>
-            <a:ext cx="5394960" cy="4206240"/>
-          </a:xfrm>
-          <a:prstGeom prst="rect">
-            <a:avLst/>
-          </a:prstGeom>
-          <a:solidFill>
-            <a:srgbClr val="141B24"/>
-          </a:solidFill>
-          <a:ln w="12700">
-            <a:solidFill>
-              <a:srgbClr val="39FF88"/>
-            </a:solidFill>
-            <a:prstDash val="solid"/>
-          </a:ln>
-        </p:spPr>
-      </p:sp>
-      <p:sp>
-        <p:nvSpPr>
-          <p:cNvPr id="5" name="Text 3"/>
-          <p:cNvSpPr/>
-          <p:nvPr/>
-        </p:nvSpPr>
-        <p:spPr>
-          <a:xfrm>
-            <a:off x="731520" y="1508760"/>
-            <a:ext cx="5029200" cy="457200"/>
-          </a:xfrm>
-          <a:prstGeom prst="rect">
-            <a:avLst/>
-          </a:prstGeom>
-          <a:noFill/>
-          <a:ln/>
-        </p:spPr>
-        <p:txBody>
-          <a:bodyPr wrap="square" lIns="0" tIns="0" rIns="0" bIns="0" rtlCol="0" anchor="ctr"/>
-          <a:lstStyle/>
-          <a:p>
-            <a:pPr indent="0" marL="0">
-              <a:buNone/>
-            </a:pPr>
-            <a:r>
-              <a:rPr lang="en-US" sz="2000" b="1" dirty="0">
-                <a:solidFill>
-                  <a:srgbClr val="39FF88"/>
-                </a:solidFill>
-                <a:latin typeface="Courier New" pitchFamily="34" charset="0"/>
-                <a:ea typeface="Courier New" pitchFamily="34" charset="-122"/>
-                <a:cs typeface="Courier New" pitchFamily="34" charset="-120"/>
-              </a:rPr>
-              <a:t>Learned</a:t>
-            </a:r>
-            <a:endParaRPr lang="en-US" sz="2000" dirty="0"/>
-          </a:p>
-        </p:txBody>
-      </p:sp>
-      <p:sp>
-        <p:nvSpPr>
-          <p:cNvPr id="6" name="Text 4"/>
-          <p:cNvSpPr/>
-          <p:nvPr/>
-        </p:nvSpPr>
-        <p:spPr>
-          <a:xfrm>
-            <a:off x="731520" y="2011680"/>
-            <a:ext cx="5029200" cy="3429000"/>
+            <a:off x="548640" y="3474720"/>
+            <a:ext cx="11064240" cy="2743200"/>
           </a:xfrm>
           <a:prstGeom prst="rect">
             <a:avLst/>
@@ -23016,11 +25163,15 @@
           <a:bodyPr wrap="square" lIns="0" tIns="0" rIns="0" bIns="0" rtlCol="0" anchor="t"/>
           <a:lstStyle/>
           <a:p>
-            <a:pPr indent="0" marL="0">
-              <a:buNone/>
+            <a:pPr marL="342900" indent="-342900">
+              <a:spcAft>
+                <a:spcPts val="800"/>
+              </a:spcAft>
+              <a:buSzPct val="100000"/>
+              <a:buChar char="•"/>
             </a:pPr>
             <a:r>
-              <a:rPr lang="en-US" sz="2000" dirty="0">
+              <a:rPr lang="en-US" sz="1600" dirty="0">
                 <a:solidFill>
                   <a:srgbClr val="E6EDF3"/>
                 </a:solidFill>
@@ -23028,16 +25179,20 @@
                 <a:ea typeface="Calibri" pitchFamily="34" charset="-122"/>
                 <a:cs typeface="Calibri" pitchFamily="34" charset="-120"/>
               </a:rPr>
-              <a:t>Reliability is a set of simple rules working together.</a:t>
-            </a:r>
-            <a:endParaRPr lang="en-US" sz="2000" dirty="0"/>
-          </a:p>
-          <a:p>
-            <a:pPr indent="0" marL="0">
-              <a:buNone/>
+              <a:t>Polite mode: back off when a standing queue builds (jitter-aware). Share 70% to 52%; costs speed (0.53x to 0.58x of AIMD time on 100 paths, worst path 2.95x slower), so it is off by default</a:t>
+            </a:r>
+            <a:endParaRPr lang="en-US" sz="1600" dirty="0"/>
+          </a:p>
+          <a:p>
+            <a:pPr marL="342900" indent="-342900">
+              <a:spcAft>
+                <a:spcPts val="800"/>
+              </a:spcAft>
+              <a:buSzPct val="100000"/>
+              <a:buChar char="•"/>
             </a:pPr>
             <a:r>
-              <a:rPr lang="en-US" sz="2000" dirty="0">
+              <a:rPr lang="en-US" sz="1600" dirty="0">
                 <a:solidFill>
                   <a:srgbClr val="E6EDF3"/>
                 </a:solidFill>
@@ -23045,16 +25200,20 @@
                 <a:ea typeface="Calibri" pitchFamily="34" charset="-122"/>
                 <a:cs typeface="Calibri" pitchFamily="34" charset="-120"/>
               </a:rPr>
-              <a:t>Congestion control matters as much as retransmission.</a:t>
-            </a:r>
-            <a:endParaRPr lang="en-US" sz="2000" dirty="0"/>
-          </a:p>
-          <a:p>
-            <a:pPr indent="0" marL="0">
-              <a:buNone/>
+              <a:t>Bursty cross traffic (new proxy option, 8 runs): neural is 15% faster than tuned AIMD but level with CUBIC; three tweaks to fix its extra retransmissions did not help</a:t>
+            </a:r>
+            <a:endParaRPr lang="en-US" sz="1600" dirty="0"/>
+          </a:p>
+          <a:p>
+            <a:pPr marL="342900" indent="-342900">
+              <a:spcAft>
+                <a:spcPts val="800"/>
+              </a:spcAft>
+              <a:buSzPct val="100000"/>
+              <a:buChar char="•"/>
             </a:pPr>
             <a:r>
-              <a:rPr lang="en-US" sz="2000" dirty="0">
+              <a:rPr lang="en-US" sz="1600" dirty="0">
                 <a:solidFill>
                   <a:srgbClr val="E6EDF3"/>
                 </a:solidFill>
@@ -23062,185 +25221,9 @@
                 <a:ea typeface="Calibri" pitchFamily="34" charset="-122"/>
                 <a:cs typeface="Calibri" pitchFamily="34" charset="-120"/>
               </a:rPr>
-              <a:t>Testing tools fail in surprising ways.</a:t>
-            </a:r>
-            <a:endParaRPr lang="en-US" sz="2000" dirty="0"/>
-          </a:p>
-        </p:txBody>
-      </p:sp>
-      <p:sp>
-        <p:nvSpPr>
-          <p:cNvPr id="7" name="Shape 5"/>
-          <p:cNvSpPr/>
-          <p:nvPr/>
-        </p:nvSpPr>
-        <p:spPr>
-          <a:xfrm>
-            <a:off x="6217920" y="1371600"/>
-            <a:ext cx="5394960" cy="4206240"/>
-          </a:xfrm>
-          <a:prstGeom prst="rect">
-            <a:avLst/>
-          </a:prstGeom>
-          <a:solidFill>
-            <a:srgbClr val="141B24"/>
-          </a:solidFill>
-          <a:ln w="12700">
-            <a:solidFill>
-              <a:srgbClr val="FFB000"/>
-            </a:solidFill>
-            <a:prstDash val="solid"/>
-          </a:ln>
-        </p:spPr>
-      </p:sp>
-      <p:sp>
-        <p:nvSpPr>
-          <p:cNvPr id="8" name="Text 6"/>
-          <p:cNvSpPr/>
-          <p:nvPr/>
-        </p:nvSpPr>
-        <p:spPr>
-          <a:xfrm>
-            <a:off x="6400800" y="1508760"/>
-            <a:ext cx="5029200" cy="457200"/>
-          </a:xfrm>
-          <a:prstGeom prst="rect">
-            <a:avLst/>
-          </a:prstGeom>
-          <a:noFill/>
-          <a:ln/>
-        </p:spPr>
-        <p:txBody>
-          <a:bodyPr wrap="square" lIns="0" tIns="0" rIns="0" bIns="0" rtlCol="0" anchor="ctr"/>
-          <a:lstStyle/>
-          <a:p>
-            <a:pPr indent="0" marL="0">
-              <a:buNone/>
-            </a:pPr>
-            <a:r>
-              <a:rPr lang="en-US" sz="2000" b="1" dirty="0">
-                <a:solidFill>
-                  <a:srgbClr val="FFB000"/>
-                </a:solidFill>
-                <a:latin typeface="Courier New" pitchFamily="34" charset="0"/>
-                <a:ea typeface="Courier New" pitchFamily="34" charset="-122"/>
-                <a:cs typeface="Courier New" pitchFamily="34" charset="-120"/>
-              </a:rPr>
-              <a:t>Next</a:t>
-            </a:r>
-            <a:endParaRPr lang="en-US" sz="2000" dirty="0"/>
-          </a:p>
-        </p:txBody>
-      </p:sp>
-      <p:sp>
-        <p:nvSpPr>
-          <p:cNvPr id="9" name="Text 7"/>
-          <p:cNvSpPr/>
-          <p:nvPr/>
-        </p:nvSpPr>
-        <p:spPr>
-          <a:xfrm>
-            <a:off x="6400800" y="2011680"/>
-            <a:ext cx="5029200" cy="3429000"/>
-          </a:xfrm>
-          <a:prstGeom prst="rect">
-            <a:avLst/>
-          </a:prstGeom>
-          <a:noFill/>
-          <a:ln/>
-        </p:spPr>
-        <p:txBody>
-          <a:bodyPr wrap="square" lIns="0" tIns="0" rIns="0" bIns="0" rtlCol="0" anchor="t"/>
-          <a:lstStyle/>
-          <a:p>
-            <a:pPr indent="0" marL="0">
-              <a:buNone/>
-            </a:pPr>
-            <a:r>
-              <a:rPr lang="en-US" sz="2000" dirty="0">
-                <a:solidFill>
-                  <a:srgbClr val="E6EDF3"/>
-                </a:solidFill>
-                <a:latin typeface="Calibri" pitchFamily="34" charset="0"/>
-                <a:ea typeface="Calibri" pitchFamily="34" charset="-122"/>
-                <a:cs typeface="Calibri" pitchFamily="34" charset="-120"/>
-              </a:rPr>
-              <a:t>Fairness-aware training, TCP coexistence</a:t>
-            </a:r>
-            <a:endParaRPr lang="en-US" sz="2000" dirty="0"/>
-          </a:p>
-          <a:p>
-            <a:pPr indent="0" marL="0">
-              <a:buNone/>
-            </a:pPr>
-            <a:r>
-              <a:rPr lang="en-US" sz="2000" dirty="0">
-                <a:solidFill>
-                  <a:srgbClr val="E6EDF3"/>
-                </a:solidFill>
-                <a:latin typeface="Calibri" pitchFamily="34" charset="0"/>
-                <a:ea typeface="Calibri" pitchFamily="34" charset="-122"/>
-                <a:cs typeface="Calibri" pitchFamily="34" charset="-120"/>
-              </a:rPr>
-              <a:t>Train on real traces with cross traffic</a:t>
-            </a:r>
-            <a:endParaRPr lang="en-US" sz="2000" dirty="0"/>
-          </a:p>
-          <a:p>
-            <a:pPr indent="0" marL="0">
-              <a:buNone/>
-            </a:pPr>
-            <a:r>
-              <a:rPr lang="en-US" sz="2000" dirty="0">
-                <a:solidFill>
-                  <a:srgbClr val="E6EDF3"/>
-                </a:solidFill>
-                <a:latin typeface="Calibri" pitchFamily="34" charset="0"/>
-                <a:ea typeface="Calibri" pitchFamily="34" charset="-122"/>
-                <a:cs typeface="Calibri" pitchFamily="34" charset="-120"/>
-              </a:rPr>
-              <a:t>Kernel netem and real multi-machine tests</a:t>
-            </a:r>
-            <a:endParaRPr lang="en-US" sz="2000" dirty="0"/>
-          </a:p>
-        </p:txBody>
-      </p:sp>
-      <p:sp>
-        <p:nvSpPr>
-          <p:cNvPr id="10" name="Text 8"/>
-          <p:cNvSpPr/>
-          <p:nvPr/>
-        </p:nvSpPr>
-        <p:spPr>
-          <a:xfrm>
-            <a:off x="548640" y="5852160"/>
-            <a:ext cx="10972800" cy="365760"/>
-          </a:xfrm>
-          <a:prstGeom prst="rect">
-            <a:avLst/>
-          </a:prstGeom>
-          <a:noFill/>
-          <a:ln/>
-        </p:spPr>
-        <p:txBody>
-          <a:bodyPr wrap="square" lIns="0" tIns="0" rIns="0" bIns="0" rtlCol="0" anchor="ctr"/>
-          <a:lstStyle/>
-          <a:p>
-            <a:pPr indent="0" marL="0">
-              <a:buNone/>
-            </a:pPr>
-            <a:r>
-              <a:rPr lang="en-US" sz="1400" dirty="0">
-                <a:solidFill>
-                  <a:srgbClr val="8B98A5"/>
-                </a:solidFill>
-                <a:latin typeface="Calibri" pitchFamily="34" charset="0"/>
-                <a:ea typeface="Calibri" pitchFamily="34" charset="-122"/>
-                <a:cs typeface="Calibri" pitchFamily="34" charset="-120"/>
-              </a:rPr>
-              <a:t>Limits: no kernel netem or multi-machine test; the agent is not a polite neighbour; no gain at 10% random loss; the tabular agent did not beat AIMD.</a:t>
-            </a:r>
-            <a:endParaRPr lang="en-US" sz="1400" dirty="0"/>
+              <a:t>Server now handles up to 16 clients at once; a test sends two files simultaneously and checks both byte-for-byte</a:t>
+            </a:r>
+            <a:endParaRPr lang="en-US" sz="1600" dirty="0"/>
           </a:p>
         </p:txBody>
       </p:sp>
@@ -23284,8 +25267,8 @@
         </p:nvSpPr>
         <p:spPr>
           <a:xfrm>
-            <a:off x="731520" y="2103120"/>
-            <a:ext cx="10058400" cy="1097280"/>
+            <a:off x="548640" y="320040"/>
+            <a:ext cx="11064240" cy="731520"/>
           </a:xfrm>
           <a:prstGeom prst="rect">
             <a:avLst/>
@@ -23301,7 +25284,7 @@
               <a:buNone/>
             </a:pPr>
             <a:r>
-              <a:rPr lang="en-US" sz="6400" b="1" dirty="0">
+              <a:rPr lang="en-US" sz="3000" b="1" dirty="0">
                 <a:solidFill>
                   <a:srgbClr val="39FF88"/>
                 </a:solidFill>
@@ -23309,9 +25292,9 @@
                 <a:ea typeface="Courier New" pitchFamily="34" charset="-122"/>
                 <a:cs typeface="Courier New" pitchFamily="34" charset="-120"/>
               </a:rPr>
-              <a:t>Thank you</a:t>
-            </a:r>
-            <a:endParaRPr lang="en-US" sz="6400" dirty="0"/>
+              <a:t>Learnings and future work</a:t>
+            </a:r>
+            <a:endParaRPr lang="en-US" sz="3000" dirty="0"/>
           </a:p>
         </p:txBody>
       </p:sp>
@@ -23323,8 +25306,8 @@
         </p:nvSpPr>
         <p:spPr>
           <a:xfrm>
-            <a:off x="731520" y="3474720"/>
-            <a:ext cx="10058400" cy="548640"/>
+            <a:off x="9418320" y="6446520"/>
+            <a:ext cx="2377440" cy="274320"/>
           </a:xfrm>
           <a:prstGeom prst="rect">
             <a:avLst/>
@@ -23336,34 +25319,59 @@
           <a:bodyPr wrap="square" lIns="0" tIns="0" rIns="0" bIns="0" rtlCol="0" anchor="ctr"/>
           <a:lstStyle/>
           <a:p>
-            <a:pPr indent="0" marL="0">
+            <a:pPr algn="r" indent="0" marL="0">
               <a:buNone/>
             </a:pPr>
             <a:r>
-              <a:rPr lang="en-US" sz="2600" dirty="0">
+              <a:rPr lang="en-US" sz="1000" dirty="0">
                 <a:solidFill>
-                  <a:srgbClr val="E6EDF3"/>
+                  <a:srgbClr val="8B98A5"/>
                 </a:solidFill>
                 <a:latin typeface="Courier New" pitchFamily="34" charset="0"/>
                 <a:ea typeface="Courier New" pitchFamily="34" charset="-122"/>
                 <a:cs typeface="Courier New" pitchFamily="34" charset="-120"/>
               </a:rPr>
-              <a:t>github.com/Capsturrrr/rudp</a:t>
-            </a:r>
-            <a:endParaRPr lang="en-US" sz="2600" dirty="0"/>
+              <a:t>31 / 33   Smart-RUDP</a:t>
+            </a:r>
+            <a:endParaRPr lang="en-US" sz="1000" dirty="0"/>
           </a:p>
         </p:txBody>
       </p:sp>
       <p:sp>
         <p:nvSpPr>
-          <p:cNvPr id="4" name="Text 2"/>
+          <p:cNvPr id="4" name="Shape 2"/>
           <p:cNvSpPr/>
           <p:nvPr/>
         </p:nvSpPr>
         <p:spPr>
           <a:xfrm>
-            <a:off x="731520" y="4206240"/>
-            <a:ext cx="10058400" cy="457200"/>
+            <a:off x="548640" y="1371600"/>
+            <a:ext cx="5394960" cy="4206240"/>
+          </a:xfrm>
+          <a:prstGeom prst="rect">
+            <a:avLst/>
+          </a:prstGeom>
+          <a:solidFill>
+            <a:srgbClr val="141B24"/>
+          </a:solidFill>
+          <a:ln w="12700">
+            <a:solidFill>
+              <a:srgbClr val="39FF88"/>
+            </a:solidFill>
+            <a:prstDash val="solid"/>
+          </a:ln>
+        </p:spPr>
+      </p:sp>
+      <p:sp>
+        <p:nvSpPr>
+          <p:cNvPr id="5" name="Text 3"/>
+          <p:cNvSpPr/>
+          <p:nvPr/>
+        </p:nvSpPr>
+        <p:spPr>
+          <a:xfrm>
+            <a:off x="731520" y="1508760"/>
+            <a:ext cx="5029200" cy="457200"/>
           </a:xfrm>
           <a:prstGeom prst="rect">
             <a:avLst/>
@@ -23379,7 +25387,256 @@
               <a:buNone/>
             </a:pPr>
             <a:r>
-              <a:rPr lang="en-US" sz="1800" dirty="0">
+              <a:rPr lang="en-US" sz="2000" b="1" dirty="0">
+                <a:solidFill>
+                  <a:srgbClr val="39FF88"/>
+                </a:solidFill>
+                <a:latin typeface="Courier New" pitchFamily="34" charset="0"/>
+                <a:ea typeface="Courier New" pitchFamily="34" charset="-122"/>
+                <a:cs typeface="Courier New" pitchFamily="34" charset="-120"/>
+              </a:rPr>
+              <a:t>Learned</a:t>
+            </a:r>
+            <a:endParaRPr lang="en-US" sz="2000" dirty="0"/>
+          </a:p>
+        </p:txBody>
+      </p:sp>
+      <p:sp>
+        <p:nvSpPr>
+          <p:cNvPr id="6" name="Text 4"/>
+          <p:cNvSpPr/>
+          <p:nvPr/>
+        </p:nvSpPr>
+        <p:spPr>
+          <a:xfrm>
+            <a:off x="731520" y="2011680"/>
+            <a:ext cx="5029200" cy="3429000"/>
+          </a:xfrm>
+          <a:prstGeom prst="rect">
+            <a:avLst/>
+          </a:prstGeom>
+          <a:noFill/>
+          <a:ln/>
+        </p:spPr>
+        <p:txBody>
+          <a:bodyPr wrap="square" lIns="0" tIns="0" rIns="0" bIns="0" rtlCol="0" anchor="t"/>
+          <a:lstStyle/>
+          <a:p>
+            <a:pPr indent="0" marL="0">
+              <a:buNone/>
+            </a:pPr>
+            <a:r>
+              <a:rPr lang="en-US" sz="2000" dirty="0">
+                <a:solidFill>
+                  <a:srgbClr val="E6EDF3"/>
+                </a:solidFill>
+                <a:latin typeface="Calibri" pitchFamily="34" charset="0"/>
+                <a:ea typeface="Calibri" pitchFamily="34" charset="-122"/>
+                <a:cs typeface="Calibri" pitchFamily="34" charset="-120"/>
+              </a:rPr>
+              <a:t>Reliability is a set of simple rules working together.</a:t>
+            </a:r>
+            <a:endParaRPr lang="en-US" sz="2000" dirty="0"/>
+          </a:p>
+          <a:p>
+            <a:pPr indent="0" marL="0">
+              <a:buNone/>
+            </a:pPr>
+            <a:r>
+              <a:rPr lang="en-US" sz="2000" dirty="0">
+                <a:solidFill>
+                  <a:srgbClr val="E6EDF3"/>
+                </a:solidFill>
+                <a:latin typeface="Calibri" pitchFamily="34" charset="0"/>
+                <a:ea typeface="Calibri" pitchFamily="34" charset="-122"/>
+                <a:cs typeface="Calibri" pitchFamily="34" charset="-120"/>
+              </a:rPr>
+              <a:t>Congestion control matters as much as retransmission.</a:t>
+            </a:r>
+            <a:endParaRPr lang="en-US" sz="2000" dirty="0"/>
+          </a:p>
+          <a:p>
+            <a:pPr indent="0" marL="0">
+              <a:buNone/>
+            </a:pPr>
+            <a:r>
+              <a:rPr lang="en-US" sz="2000" dirty="0">
+                <a:solidFill>
+                  <a:srgbClr val="E6EDF3"/>
+                </a:solidFill>
+                <a:latin typeface="Calibri" pitchFamily="34" charset="0"/>
+                <a:ea typeface="Calibri" pitchFamily="34" charset="-122"/>
+                <a:cs typeface="Calibri" pitchFamily="34" charset="-120"/>
+              </a:rPr>
+              <a:t>Testing tools fail in surprising ways.</a:t>
+            </a:r>
+            <a:endParaRPr lang="en-US" sz="2000" dirty="0"/>
+          </a:p>
+        </p:txBody>
+      </p:sp>
+      <p:sp>
+        <p:nvSpPr>
+          <p:cNvPr id="7" name="Shape 5"/>
+          <p:cNvSpPr/>
+          <p:nvPr/>
+        </p:nvSpPr>
+        <p:spPr>
+          <a:xfrm>
+            <a:off x="6217920" y="1371600"/>
+            <a:ext cx="5394960" cy="4206240"/>
+          </a:xfrm>
+          <a:prstGeom prst="rect">
+            <a:avLst/>
+          </a:prstGeom>
+          <a:solidFill>
+            <a:srgbClr val="141B24"/>
+          </a:solidFill>
+          <a:ln w="12700">
+            <a:solidFill>
+              <a:srgbClr val="FFB000"/>
+            </a:solidFill>
+            <a:prstDash val="solid"/>
+          </a:ln>
+        </p:spPr>
+      </p:sp>
+      <p:sp>
+        <p:nvSpPr>
+          <p:cNvPr id="8" name="Text 6"/>
+          <p:cNvSpPr/>
+          <p:nvPr/>
+        </p:nvSpPr>
+        <p:spPr>
+          <a:xfrm>
+            <a:off x="6400800" y="1508760"/>
+            <a:ext cx="5029200" cy="457200"/>
+          </a:xfrm>
+          <a:prstGeom prst="rect">
+            <a:avLst/>
+          </a:prstGeom>
+          <a:noFill/>
+          <a:ln/>
+        </p:spPr>
+        <p:txBody>
+          <a:bodyPr wrap="square" lIns="0" tIns="0" rIns="0" bIns="0" rtlCol="0" anchor="ctr"/>
+          <a:lstStyle/>
+          <a:p>
+            <a:pPr indent="0" marL="0">
+              <a:buNone/>
+            </a:pPr>
+            <a:r>
+              <a:rPr lang="en-US" sz="2000" b="1" dirty="0">
+                <a:solidFill>
+                  <a:srgbClr val="FFB000"/>
+                </a:solidFill>
+                <a:latin typeface="Courier New" pitchFamily="34" charset="0"/>
+                <a:ea typeface="Courier New" pitchFamily="34" charset="-122"/>
+                <a:cs typeface="Courier New" pitchFamily="34" charset="-120"/>
+              </a:rPr>
+              <a:t>Next</a:t>
+            </a:r>
+            <a:endParaRPr lang="en-US" sz="2000" dirty="0"/>
+          </a:p>
+        </p:txBody>
+      </p:sp>
+      <p:sp>
+        <p:nvSpPr>
+          <p:cNvPr id="9" name="Text 7"/>
+          <p:cNvSpPr/>
+          <p:nvPr/>
+        </p:nvSpPr>
+        <p:spPr>
+          <a:xfrm>
+            <a:off x="6400800" y="2011680"/>
+            <a:ext cx="5029200" cy="3429000"/>
+          </a:xfrm>
+          <a:prstGeom prst="rect">
+            <a:avLst/>
+          </a:prstGeom>
+          <a:noFill/>
+          <a:ln/>
+        </p:spPr>
+        <p:txBody>
+          <a:bodyPr wrap="square" lIns="0" tIns="0" rIns="0" bIns="0" rtlCol="0" anchor="t"/>
+          <a:lstStyle/>
+          <a:p>
+            <a:pPr indent="0" marL="0">
+              <a:buNone/>
+            </a:pPr>
+            <a:r>
+              <a:rPr lang="en-US" sz="2000" dirty="0">
+                <a:solidFill>
+                  <a:srgbClr val="E6EDF3"/>
+                </a:solidFill>
+                <a:latin typeface="Calibri" pitchFamily="34" charset="0"/>
+                <a:ea typeface="Calibri" pitchFamily="34" charset="-122"/>
+                <a:cs typeface="Calibri" pitchFamily="34" charset="-120"/>
+              </a:rPr>
+              <a:t>Fairness-aware training, TCP coexistence</a:t>
+            </a:r>
+            <a:endParaRPr lang="en-US" sz="2000" dirty="0"/>
+          </a:p>
+          <a:p>
+            <a:pPr indent="0" marL="0">
+              <a:buNone/>
+            </a:pPr>
+            <a:r>
+              <a:rPr lang="en-US" sz="2000" dirty="0">
+                <a:solidFill>
+                  <a:srgbClr val="E6EDF3"/>
+                </a:solidFill>
+                <a:latin typeface="Calibri" pitchFamily="34" charset="0"/>
+                <a:ea typeface="Calibri" pitchFamily="34" charset="-122"/>
+                <a:cs typeface="Calibri" pitchFamily="34" charset="-120"/>
+              </a:rPr>
+              <a:t>Train on real traces with cross traffic</a:t>
+            </a:r>
+            <a:endParaRPr lang="en-US" sz="2000" dirty="0"/>
+          </a:p>
+          <a:p>
+            <a:pPr indent="0" marL="0">
+              <a:buNone/>
+            </a:pPr>
+            <a:r>
+              <a:rPr lang="en-US" sz="2000" dirty="0">
+                <a:solidFill>
+                  <a:srgbClr val="E6EDF3"/>
+                </a:solidFill>
+                <a:latin typeface="Calibri" pitchFamily="34" charset="0"/>
+                <a:ea typeface="Calibri" pitchFamily="34" charset="-122"/>
+                <a:cs typeface="Calibri" pitchFamily="34" charset="-120"/>
+              </a:rPr>
+              <a:t>Kernel netem and real multi-machine tests</a:t>
+            </a:r>
+            <a:endParaRPr lang="en-US" sz="2000" dirty="0"/>
+          </a:p>
+        </p:txBody>
+      </p:sp>
+      <p:sp>
+        <p:nvSpPr>
+          <p:cNvPr id="10" name="Text 8"/>
+          <p:cNvSpPr/>
+          <p:nvPr/>
+        </p:nvSpPr>
+        <p:spPr>
+          <a:xfrm>
+            <a:off x="548640" y="5852160"/>
+            <a:ext cx="10972800" cy="365760"/>
+          </a:xfrm>
+          <a:prstGeom prst="rect">
+            <a:avLst/>
+          </a:prstGeom>
+          <a:noFill/>
+          <a:ln/>
+        </p:spPr>
+        <p:txBody>
+          <a:bodyPr wrap="square" lIns="0" tIns="0" rIns="0" bIns="0" rtlCol="0" anchor="ctr"/>
+          <a:lstStyle/>
+          <a:p>
+            <a:pPr indent="0" marL="0">
+              <a:buNone/>
+            </a:pPr>
+            <a:r>
+              <a:rPr lang="en-US" sz="1400" dirty="0">
                 <a:solidFill>
                   <a:srgbClr val="8B98A5"/>
                 </a:solidFill>
@@ -23387,9 +25644,9 @@
                 <a:ea typeface="Calibri" pitchFamily="34" charset="-122"/>
                 <a:cs typeface="Calibri" pitchFamily="34" charset="-120"/>
               </a:rPr>
-              <a:t>Harshavardhan Mallela   Rohit Arya   Shloak Sinha</a:t>
-            </a:r>
-            <a:endParaRPr lang="en-US" sz="1800" dirty="0"/>
+              <a:t>Limits: no kernel netem or multi-machine test; polite mode is a hand-made rule that costs speed; level with CUBIC under bursty cross traffic; no gain at 10% random loss.</a:t>
+            </a:r>
+            <a:endParaRPr lang="en-US" sz="1400" dirty="0"/>
           </a:p>
         </p:txBody>
       </p:sp>
@@ -23433,6 +25690,155 @@
         </p:nvSpPr>
         <p:spPr>
           <a:xfrm>
+            <a:off x="731520" y="2103120"/>
+            <a:ext cx="10058400" cy="1097280"/>
+          </a:xfrm>
+          <a:prstGeom prst="rect">
+            <a:avLst/>
+          </a:prstGeom>
+          <a:noFill/>
+          <a:ln/>
+        </p:spPr>
+        <p:txBody>
+          <a:bodyPr wrap="square" lIns="0" tIns="0" rIns="0" bIns="0" rtlCol="0" anchor="ctr"/>
+          <a:lstStyle/>
+          <a:p>
+            <a:pPr indent="0" marL="0">
+              <a:buNone/>
+            </a:pPr>
+            <a:r>
+              <a:rPr lang="en-US" sz="6400" b="1" dirty="0">
+                <a:solidFill>
+                  <a:srgbClr val="39FF88"/>
+                </a:solidFill>
+                <a:latin typeface="Courier New" pitchFamily="34" charset="0"/>
+                <a:ea typeface="Courier New" pitchFamily="34" charset="-122"/>
+                <a:cs typeface="Courier New" pitchFamily="34" charset="-120"/>
+              </a:rPr>
+              <a:t>Thank you</a:t>
+            </a:r>
+            <a:endParaRPr lang="en-US" sz="6400" dirty="0"/>
+          </a:p>
+        </p:txBody>
+      </p:sp>
+      <p:sp>
+        <p:nvSpPr>
+          <p:cNvPr id="3" name="Text 1"/>
+          <p:cNvSpPr/>
+          <p:nvPr/>
+        </p:nvSpPr>
+        <p:spPr>
+          <a:xfrm>
+            <a:off x="731520" y="3474720"/>
+            <a:ext cx="10058400" cy="548640"/>
+          </a:xfrm>
+          <a:prstGeom prst="rect">
+            <a:avLst/>
+          </a:prstGeom>
+          <a:noFill/>
+          <a:ln/>
+        </p:spPr>
+        <p:txBody>
+          <a:bodyPr wrap="square" lIns="0" tIns="0" rIns="0" bIns="0" rtlCol="0" anchor="ctr"/>
+          <a:lstStyle/>
+          <a:p>
+            <a:pPr indent="0" marL="0">
+              <a:buNone/>
+            </a:pPr>
+            <a:r>
+              <a:rPr lang="en-US" sz="2600" dirty="0">
+                <a:solidFill>
+                  <a:srgbClr val="E6EDF3"/>
+                </a:solidFill>
+                <a:latin typeface="Courier New" pitchFamily="34" charset="0"/>
+                <a:ea typeface="Courier New" pitchFamily="34" charset="-122"/>
+                <a:cs typeface="Courier New" pitchFamily="34" charset="-120"/>
+              </a:rPr>
+              <a:t>github.com/Capsturrrr/rudp</a:t>
+            </a:r>
+            <a:endParaRPr lang="en-US" sz="2600" dirty="0"/>
+          </a:p>
+        </p:txBody>
+      </p:sp>
+      <p:sp>
+        <p:nvSpPr>
+          <p:cNvPr id="4" name="Text 2"/>
+          <p:cNvSpPr/>
+          <p:nvPr/>
+        </p:nvSpPr>
+        <p:spPr>
+          <a:xfrm>
+            <a:off x="731520" y="4206240"/>
+            <a:ext cx="10058400" cy="457200"/>
+          </a:xfrm>
+          <a:prstGeom prst="rect">
+            <a:avLst/>
+          </a:prstGeom>
+          <a:noFill/>
+          <a:ln/>
+        </p:spPr>
+        <p:txBody>
+          <a:bodyPr wrap="square" lIns="0" tIns="0" rIns="0" bIns="0" rtlCol="0" anchor="ctr"/>
+          <a:lstStyle/>
+          <a:p>
+            <a:pPr indent="0" marL="0">
+              <a:buNone/>
+            </a:pPr>
+            <a:r>
+              <a:rPr lang="en-US" sz="1800" dirty="0">
+                <a:solidFill>
+                  <a:srgbClr val="8B98A5"/>
+                </a:solidFill>
+                <a:latin typeface="Calibri" pitchFamily="34" charset="0"/>
+                <a:ea typeface="Calibri" pitchFamily="34" charset="-122"/>
+                <a:cs typeface="Calibri" pitchFamily="34" charset="-120"/>
+              </a:rPr>
+              <a:t>Harshavardhan Mallela   Rohit Arya   Shloak Sinha</a:t>
+            </a:r>
+            <a:endParaRPr lang="en-US" sz="1800" dirty="0"/>
+          </a:p>
+        </p:txBody>
+      </p:sp>
+    </p:spTree>
+  </p:cSld>
+  <p:clrMapOvr>
+    <a:masterClrMapping/>
+  </p:clrMapOvr>
+</p:sld>
+</file>
+
+<file path=ppt/slides/slide33.xml><?xml version="1.0" encoding="utf-8"?>
+<p:sld xmlns:a="http://schemas.openxmlformats.org/drawingml/2006/main" xmlns:r="http://schemas.openxmlformats.org/officeDocument/2006/relationships" xmlns:p="http://schemas.openxmlformats.org/presentationml/2006/main">
+  <p:cSld name="Slide 33">
+    <p:bg>
+      <p:bgPr>
+        <a:solidFill>
+          <a:srgbClr val="0B0F14"/>
+        </a:solidFill>
+      </p:bgPr>
+    </p:bg>
+    <p:spTree>
+      <p:nvGrpSpPr>
+        <p:cNvPr id="1" name=""/>
+        <p:cNvGrpSpPr/>
+        <p:nvPr/>
+      </p:nvGrpSpPr>
+      <p:grpSpPr>
+        <a:xfrm>
+          <a:off x="0" y="0"/>
+          <a:ext cx="0" cy="0"/>
+          <a:chOff x="0" y="0"/>
+          <a:chExt cx="0" cy="0"/>
+        </a:xfrm>
+      </p:grpSpPr>
+      <p:sp>
+        <p:nvSpPr>
+          <p:cNvPr id="2" name="Text 0"/>
+          <p:cNvSpPr/>
+          <p:nvPr/>
+        </p:nvSpPr>
+        <p:spPr>
+          <a:xfrm>
             <a:off x="548640" y="320040"/>
             <a:ext cx="11064240" cy="731520"/>
           </a:xfrm>
@@ -23737,7 +26143,7 @@
                 <a:ea typeface="Courier New" pitchFamily="34" charset="-122"/>
                 <a:cs typeface="Courier New" pitchFamily="34" charset="-120"/>
               </a:rPr>
-              <a:t>4 / 32   Smart-RUDP</a:t>
+              <a:t>4 / 33   Smart-RUDP</a:t>
             </a:r>
             <a:endParaRPr lang="en-US" sz="1000" dirty="0"/>
           </a:p>
@@ -24298,7 +26704,7 @@
                 <a:ea typeface="Courier New" pitchFamily="34" charset="-122"/>
                 <a:cs typeface="Courier New" pitchFamily="34" charset="-120"/>
               </a:rPr>
-              <a:t>5 / 32   Smart-RUDP</a:t>
+              <a:t>5 / 33   Smart-RUDP</a:t>
             </a:r>
             <a:endParaRPr lang="en-US" sz="1000" dirty="0"/>
           </a:p>
@@ -25737,7 +28143,7 @@
                 <a:ea typeface="Courier New" pitchFamily="34" charset="-122"/>
                 <a:cs typeface="Courier New" pitchFamily="34" charset="-120"/>
               </a:rPr>
-              <a:t>6 / 32   Smart-RUDP</a:t>
+              <a:t>6 / 33   Smart-RUDP</a:t>
             </a:r>
             <a:endParaRPr lang="en-US" sz="1000" dirty="0"/>
           </a:p>
@@ -26972,7 +29378,7 @@
                 <a:ea typeface="Courier New" pitchFamily="34" charset="-122"/>
                 <a:cs typeface="Courier New" pitchFamily="34" charset="-120"/>
               </a:rPr>
-              <a:t>7 / 32   Smart-RUDP</a:t>
+              <a:t>7 / 33   Smart-RUDP</a:t>
             </a:r>
             <a:endParaRPr lang="en-US" sz="1000" dirty="0"/>
           </a:p>
@@ -27415,7 +29821,7 @@
                 <a:ea typeface="Courier New" pitchFamily="34" charset="-122"/>
                 <a:cs typeface="Courier New" pitchFamily="34" charset="-120"/>
               </a:rPr>
-              <a:t>8 / 32   Smart-RUDP</a:t>
+              <a:t>8 / 33   Smart-RUDP</a:t>
             </a:r>
             <a:endParaRPr lang="en-US" sz="1000" dirty="0"/>
           </a:p>
@@ -27715,7 +30121,7 @@
                 <a:ea typeface="Courier New" pitchFamily="34" charset="-122"/>
                 <a:cs typeface="Courier New" pitchFamily="34" charset="-120"/>
               </a:rPr>
-              <a:t>9 / 32   Smart-RUDP</a:t>
+              <a:t>9 / 33   Smart-RUDP</a:t>
             </a:r>
             <a:endParaRPr lang="en-US" sz="1000" dirty="0"/>
           </a:p>

</xml_diff>

<commit_message>
make figures, window figure slide, video script refresh
Co-Authored-By: Claude Sonnet 5.5 <noreply@anthropic.com>
Claude-Session: https://claude.ai/code/session_01NX2zRNpdVAnzFNKmqomzKu
</commit_message>
<xml_diff>
--- a/docs/RUDP_Presentation.pptx
+++ b/docs/RUDP_Presentation.pptx
@@ -38,9 +38,10 @@
     <p:sldId id="286" r:id="rId32"/>
     <p:sldId id="287" r:id="rId33"/>
     <p:sldId id="288" r:id="rId34"/>
+    <p:sldId id="289" r:id="rId35"/>
   </p:sldIdLst>
   <p:notesMasterIdLst>
-    <p:notesMasterId r:id="rId35"/>
+    <p:notesMasterId r:id="rId36"/>
   </p:notesMasterIdLst>
   <p:sldSz cx="12192000" cy="6858000"/>
   <p:notesSz cx="6858000" cy="12192000"/>
@@ -3147,6 +3148,94 @@
             <a:fld id="{F7021451-1387-4CA6-816F-3879F97B5CBC}" type="slidenum">
               <a:rPr lang="en-US"/>
               <a:t>33</a:t>
+            </a:fld>
+            <a:endParaRPr lang="en-US"/>
+          </a:p>
+        </p:txBody>
+      </p:sp>
+    </p:spTree>
+    <p:extLst>
+      <p:ext uri="{BB962C8B-B14F-4D97-AF65-F5344CB8AC3E}">
+        <p14:creationId xmlns:p14="http://schemas.microsoft.com/office/powerpoint/2010/main" val="1024086991"/>
+      </p:ext>
+    </p:extLst>
+  </p:cSld>
+  <p:clrMapOvr>
+    <a:masterClrMapping/>
+  </p:clrMapOvr>
+</p:notes>
+</file>
+
+<file path=ppt/notesSlides/notesSlide34.xml><?xml version="1.0" encoding="utf-8"?>
+<p:notes xmlns:a="http://schemas.openxmlformats.org/drawingml/2006/main" xmlns:r="http://schemas.openxmlformats.org/officeDocument/2006/relationships" xmlns:p="http://schemas.openxmlformats.org/presentationml/2006/main">
+  <p:cSld>
+    <p:spTree>
+      <p:nvGrpSpPr>
+        <p:cNvPr id="1" name=""/>
+        <p:cNvGrpSpPr/>
+        <p:nvPr/>
+      </p:nvGrpSpPr>
+      <p:grpSpPr>
+        <a:xfrm>
+          <a:off x="0" y="0"/>
+          <a:ext cx="0" cy="0"/>
+          <a:chOff x="0" y="0"/>
+          <a:chExt cx="0" cy="0"/>
+        </a:xfrm>
+      </p:grpSpPr>
+      <p:sp>
+        <p:nvSpPr>
+          <p:cNvPr id="2" name="Slide Image Placeholder 1"/>
+          <p:cNvSpPr>
+            <a:spLocks noGrp="1" noRot="1" noChangeAspect="1"/>
+          </p:cNvSpPr>
+          <p:nvPr>
+            <p:ph type="sldImg"/>
+          </p:nvPr>
+        </p:nvSpPr>
+        <p:spPr/>
+      </p:sp>
+      <p:sp>
+        <p:nvSpPr>
+          <p:cNvPr id="3" name="Notes Placeholder 2"/>
+          <p:cNvSpPr>
+            <a:spLocks noGrp="1"/>
+          </p:cNvSpPr>
+          <p:nvPr>
+            <p:ph type="body" idx="1"/>
+          </p:nvPr>
+        </p:nvSpPr>
+        <p:spPr/>
+        <p:txBody>
+          <a:bodyPr/>
+          <a:lstStyle/>
+          <a:p>
+            <a:r>
+              <a:rPr lang="en-US" dirty="0"/>
+              <a:t/>
+            </a:r>
+            <a:endParaRPr lang="en-US" dirty="0"/>
+          </a:p>
+        </p:txBody>
+      </p:sp>
+      <p:sp>
+        <p:nvSpPr>
+          <p:cNvPr id="4" name="Slide Number Placeholder 3"/>
+          <p:cNvSpPr>
+            <a:spLocks noGrp="1"/>
+          </p:cNvSpPr>
+          <p:nvPr>
+            <p:ph type="sldNum" sz="quarter" idx="10"/>
+          </p:nvPr>
+        </p:nvSpPr>
+        <p:spPr/>
+        <p:txBody>
+          <a:bodyPr/>
+          <a:lstStyle/>
+          <a:p>
+            <a:fld id="{F7021451-1387-4CA6-816F-3879F97B5CBC}" type="slidenum">
+              <a:rPr lang="en-US"/>
+              <a:t>34</a:t>
             </a:fld>
             <a:endParaRPr lang="en-US"/>
           </a:p>
@@ -4284,7 +4373,7 @@
                 <a:ea typeface="Courier New" pitchFamily="34" charset="-122"/>
                 <a:cs typeface="Courier New" pitchFamily="34" charset="-120"/>
               </a:rPr>
-              <a:t>10 / 33   Smart-RUDP</a:t>
+              <a:t>10 / 34   Smart-RUDP</a:t>
             </a:r>
             <a:endParaRPr lang="en-US" sz="1000" dirty="0"/>
           </a:p>
@@ -4481,7 +4570,7 @@
                 <a:ea typeface="Courier New" pitchFamily="34" charset="-122"/>
                 <a:cs typeface="Courier New" pitchFamily="34" charset="-120"/>
               </a:rPr>
-              <a:t>11 / 33   Smart-RUDP</a:t>
+              <a:t>11 / 34   Smart-RUDP</a:t>
             </a:r>
             <a:endParaRPr lang="en-US" sz="1000" dirty="0"/>
           </a:p>
@@ -5311,7 +5400,7 @@
                 <a:ea typeface="Courier New" pitchFamily="34" charset="-122"/>
                 <a:cs typeface="Courier New" pitchFamily="34" charset="-120"/>
               </a:rPr>
-              <a:t>12 / 33   Smart-RUDP</a:t>
+              <a:t>12 / 34   Smart-RUDP</a:t>
             </a:r>
             <a:endParaRPr lang="en-US" sz="1000" dirty="0"/>
           </a:p>
@@ -5608,7 +5697,7 @@
                 <a:ea typeface="Courier New" pitchFamily="34" charset="-122"/>
                 <a:cs typeface="Courier New" pitchFamily="34" charset="-120"/>
               </a:rPr>
-              <a:t>13 / 33   Smart-RUDP</a:t>
+              <a:t>13 / 34   Smart-RUDP</a:t>
             </a:r>
             <a:endParaRPr lang="en-US" sz="1000" dirty="0"/>
           </a:p>
@@ -5908,7 +5997,7 @@
                 <a:ea typeface="Courier New" pitchFamily="34" charset="-122"/>
                 <a:cs typeface="Courier New" pitchFamily="34" charset="-120"/>
               </a:rPr>
-              <a:t>14 / 33   Smart-RUDP</a:t>
+              <a:t>14 / 34   Smart-RUDP</a:t>
             </a:r>
             <a:endParaRPr lang="en-US" sz="1000" dirty="0"/>
           </a:p>
@@ -6292,7 +6381,7 @@
                 <a:ea typeface="Courier New" pitchFamily="34" charset="-122"/>
                 <a:cs typeface="Courier New" pitchFamily="34" charset="-120"/>
               </a:rPr>
-              <a:t>15 / 33   Smart-RUDP</a:t>
+              <a:t>15 / 34   Smart-RUDP</a:t>
             </a:r>
             <a:endParaRPr lang="en-US" sz="1000" dirty="0"/>
           </a:p>
@@ -6750,7 +6839,7 @@
                 <a:ea typeface="Courier New" pitchFamily="34" charset="-122"/>
                 <a:cs typeface="Courier New" pitchFamily="34" charset="-120"/>
               </a:rPr>
-              <a:t>16 / 33   Smart-RUDP</a:t>
+              <a:t>16 / 34   Smart-RUDP</a:t>
             </a:r>
             <a:endParaRPr lang="en-US" sz="1000" dirty="0"/>
           </a:p>
@@ -7435,7 +7524,7 @@
                 <a:ea typeface="Courier New" pitchFamily="34" charset="-122"/>
                 <a:cs typeface="Courier New" pitchFamily="34" charset="-120"/>
               </a:rPr>
-              <a:t>17 / 33   Smart-RUDP</a:t>
+              <a:t>17 / 34   Smart-RUDP</a:t>
             </a:r>
             <a:endParaRPr lang="en-US" sz="1000" dirty="0"/>
           </a:p>
@@ -7675,7 +7764,7 @@
                 <a:ea typeface="Courier New" pitchFamily="34" charset="-122"/>
                 <a:cs typeface="Courier New" pitchFamily="34" charset="-120"/>
               </a:rPr>
-              <a:t>18 / 33   Smart-RUDP</a:t>
+              <a:t>18 / 34   Smart-RUDP</a:t>
             </a:r>
             <a:endParaRPr lang="en-US" sz="1000" dirty="0"/>
           </a:p>
@@ -7915,7 +8004,7 @@
                 <a:ea typeface="Courier New" pitchFamily="34" charset="-122"/>
                 <a:cs typeface="Courier New" pitchFamily="34" charset="-120"/>
               </a:rPr>
-              <a:t>19 / 33   Smart-RUDP</a:t>
+              <a:t>19 / 34   Smart-RUDP</a:t>
             </a:r>
             <a:endParaRPr lang="en-US" sz="1000" dirty="0"/>
           </a:p>
@@ -8137,7 +8226,7 @@
                 <a:ea typeface="Courier New" pitchFamily="34" charset="-122"/>
                 <a:cs typeface="Courier New" pitchFamily="34" charset="-120"/>
               </a:rPr>
-              <a:t>2 / 33   Smart-RUDP</a:t>
+              <a:t>2 / 34   Smart-RUDP</a:t>
             </a:r>
             <a:endParaRPr lang="en-US" sz="1000" dirty="0"/>
           </a:p>
@@ -8531,7 +8620,7 @@
                 <a:ea typeface="Courier New" pitchFamily="34" charset="-122"/>
                 <a:cs typeface="Courier New" pitchFamily="34" charset="-120"/>
               </a:rPr>
-              <a:t>20 / 33   Smart-RUDP</a:t>
+              <a:t>20 / 34   Smart-RUDP</a:t>
             </a:r>
             <a:endParaRPr lang="en-US" sz="1000" dirty="0"/>
           </a:p>
@@ -8855,7 +8944,7 @@
                 <a:ea typeface="Courier New" pitchFamily="34" charset="-122"/>
                 <a:cs typeface="Courier New" pitchFamily="34" charset="-120"/>
               </a:rPr>
-              <a:t>21 / 33   Smart-RUDP</a:t>
+              <a:t>21 / 34   Smart-RUDP</a:t>
             </a:r>
             <a:endParaRPr lang="en-US" sz="1000" dirty="0"/>
           </a:p>
@@ -10562,7 +10651,7 @@
                 <a:ea typeface="Courier New" pitchFamily="34" charset="-122"/>
                 <a:cs typeface="Courier New" pitchFamily="34" charset="-120"/>
               </a:rPr>
-              <a:t>22 / 33   Smart-RUDP</a:t>
+              <a:t>22 / 34   Smart-RUDP</a:t>
             </a:r>
             <a:endParaRPr lang="en-US" sz="1000" dirty="0"/>
           </a:p>
@@ -11945,7 +12034,7 @@
                 <a:ea typeface="Courier New" pitchFamily="34" charset="-122"/>
                 <a:cs typeface="Courier New" pitchFamily="34" charset="-120"/>
               </a:rPr>
-              <a:t>23 / 33   Smart-RUDP</a:t>
+              <a:t>23 / 34   Smart-RUDP</a:t>
             </a:r>
             <a:endParaRPr lang="en-US" sz="1000" dirty="0"/>
           </a:p>
@@ -13488,7 +13577,7 @@
                 <a:ea typeface="Courier New" pitchFamily="34" charset="-122"/>
                 <a:cs typeface="Courier New" pitchFamily="34" charset="-120"/>
               </a:rPr>
-              <a:t>24 / 33   Smart-RUDP</a:t>
+              <a:t>24 / 34   Smart-RUDP</a:t>
             </a:r>
             <a:endParaRPr lang="en-US" sz="1000" dirty="0"/>
           </a:p>
@@ -15166,7 +15255,7 @@
                 <a:ea typeface="Courier New" pitchFamily="34" charset="-122"/>
                 <a:cs typeface="Courier New" pitchFamily="34" charset="-120"/>
               </a:rPr>
-              <a:t>25 / 33   Smart-RUDP</a:t>
+              <a:t>25 / 34   Smart-RUDP</a:t>
             </a:r>
             <a:endParaRPr lang="en-US" sz="1000" dirty="0"/>
           </a:p>
@@ -16844,7 +16933,7 @@
                 <a:ea typeface="Courier New" pitchFamily="34" charset="-122"/>
                 <a:cs typeface="Courier New" pitchFamily="34" charset="-120"/>
               </a:rPr>
-              <a:t>26 / 33   Smart-RUDP</a:t>
+              <a:t>26 / 34   Smart-RUDP</a:t>
             </a:r>
             <a:endParaRPr lang="en-US" sz="1000" dirty="0"/>
           </a:p>
@@ -19184,7 +19273,7 @@
                 <a:ea typeface="Courier New" pitchFamily="34" charset="-122"/>
                 <a:cs typeface="Courier New" pitchFamily="34" charset="-120"/>
               </a:rPr>
-              <a:t>27 / 33   Smart-RUDP</a:t>
+              <a:t>27 / 34   Smart-RUDP</a:t>
             </a:r>
             <a:endParaRPr lang="en-US" sz="1000" dirty="0"/>
           </a:p>
@@ -19642,7 +19731,7 @@
                 <a:ea typeface="Courier New" pitchFamily="34" charset="-122"/>
                 <a:cs typeface="Courier New" pitchFamily="34" charset="-120"/>
               </a:rPr>
-              <a:t>28 / 33   Smart-RUDP</a:t>
+              <a:t>28 / 34   Smart-RUDP</a:t>
             </a:r>
             <a:endParaRPr lang="en-US" sz="1000" dirty="0"/>
           </a:p>
@@ -19874,7 +19963,7 @@
                 <a:ea typeface="Courier New" pitchFamily="34" charset="-122"/>
                 <a:cs typeface="Courier New" pitchFamily="34" charset="-120"/>
               </a:rPr>
-              <a:t>29 / 33   Smart-RUDP</a:t>
+              <a:t>29 / 34   Smart-RUDP</a:t>
             </a:r>
             <a:endParaRPr lang="en-US" sz="1000" dirty="0"/>
           </a:p>
@@ -22620,7 +22709,7 @@
                 <a:ea typeface="Courier New" pitchFamily="34" charset="-122"/>
                 <a:cs typeface="Courier New" pitchFamily="34" charset="-120"/>
               </a:rPr>
-              <a:t>3 / 33   Smart-RUDP</a:t>
+              <a:t>3 / 34   Smart-RUDP</a:t>
             </a:r>
             <a:endParaRPr lang="en-US" sz="1000" dirty="0"/>
           </a:p>
@@ -22975,7 +23064,7 @@
                 <a:ea typeface="Courier New" pitchFamily="34" charset="-122"/>
                 <a:cs typeface="Courier New" pitchFamily="34" charset="-120"/>
               </a:rPr>
-              <a:t>Closing gaps: fairness and cross traffic</a:t>
+              <a:t>Seeing the difference: the window</a:t>
             </a:r>
             <a:endParaRPr lang="en-US" sz="3000" dirty="0"/>
           </a:p>
@@ -23014,7 +23103,247 @@
                 <a:ea typeface="Courier New" pitchFamily="34" charset="-122"/>
                 <a:cs typeface="Courier New" pitchFamily="34" charset="-120"/>
               </a:rPr>
-              <a:t>30 / 33   Smart-RUDP</a:t>
+              <a:t>30 / 34   Smart-RUDP</a:t>
+            </a:r>
+            <a:endParaRPr lang="en-US" sz="1000" dirty="0"/>
+          </a:p>
+        </p:txBody>
+      </p:sp>
+      <p:pic>
+        <p:nvPicPr>
+          <p:cNvPr id="4" name="Image 0" descr="fig_cwnd_agent.png">    </p:cNvPr>
+          <p:cNvPicPr>
+            <a:picLocks noChangeAspect="1"/>
+          </p:cNvPicPr>
+          <p:nvPr/>
+        </p:nvPicPr>
+        <p:blipFill>
+          <a:blip r:embed="rId1"/>
+          <a:stretch>
+            <a:fillRect/>
+          </a:stretch>
+        </p:blipFill>
+        <p:spPr>
+          <a:xfrm>
+            <a:off x="548640" y="1188720"/>
+            <a:ext cx="7315200" cy="3108960"/>
+          </a:xfrm>
+          <a:prstGeom prst="rect">
+            <a:avLst/>
+          </a:prstGeom>
+        </p:spPr>
+      </p:pic>
+      <p:sp>
+        <p:nvSpPr>
+          <p:cNvPr id="5" name="Text 2"/>
+          <p:cNvSpPr/>
+          <p:nvPr/>
+        </p:nvSpPr>
+        <p:spPr>
+          <a:xfrm>
+            <a:off x="8138160" y="1371600"/>
+            <a:ext cx="3657600" cy="4114800"/>
+          </a:xfrm>
+          <a:prstGeom prst="rect">
+            <a:avLst/>
+          </a:prstGeom>
+          <a:noFill/>
+          <a:ln/>
+        </p:spPr>
+        <p:txBody>
+          <a:bodyPr wrap="square" lIns="0" tIns="0" rIns="0" bIns="0" rtlCol="0" anchor="t"/>
+          <a:lstStyle/>
+          <a:p>
+            <a:pPr marL="342900" indent="-342900">
+              <a:spcAft>
+                <a:spcPts val="800"/>
+              </a:spcAft>
+              <a:buSzPct val="100000"/>
+              <a:buChar char="•"/>
+            </a:pPr>
+            <a:r>
+              <a:rPr lang="en-US" sz="1600" dirty="0">
+                <a:solidFill>
+                  <a:srgbClr val="E6EDF3"/>
+                </a:solidFill>
+                <a:latin typeface="Calibri" pitchFamily="34" charset="0"/>
+                <a:ea typeface="Calibri" pitchFamily="34" charset="-122"/>
+                <a:cs typeface="Calibri" pitchFamily="34" charset="-120"/>
+              </a:rPr>
+              <a:t>Same lossy path, same seed, same transport</a:t>
+            </a:r>
+            <a:endParaRPr lang="en-US" sz="1600" dirty="0"/>
+          </a:p>
+          <a:p>
+            <a:pPr marL="342900" indent="-342900">
+              <a:spcAft>
+                <a:spcPts val="800"/>
+              </a:spcAft>
+              <a:buSzPct val="100000"/>
+              <a:buChar char="•"/>
+            </a:pPr>
+            <a:r>
+              <a:rPr lang="en-US" sz="1600" dirty="0">
+                <a:solidFill>
+                  <a:srgbClr val="E6EDF3"/>
+                </a:solidFill>
+                <a:latin typeface="Calibri" pitchFamily="34" charset="0"/>
+                <a:ea typeface="Calibri" pitchFamily="34" charset="-122"/>
+                <a:cs typeface="Calibri" pitchFamily="34" charset="-120"/>
+              </a:rPr>
+              <a:t>AIMD (grey) saws between 5 and 15 packets and needs 9 s</a:t>
+            </a:r>
+            <a:endParaRPr lang="en-US" sz="1600" dirty="0"/>
+          </a:p>
+          <a:p>
+            <a:pPr marL="342900" indent="-342900">
+              <a:spcAft>
+                <a:spcPts val="800"/>
+              </a:spcAft>
+              <a:buSzPct val="100000"/>
+              <a:buChar char="•"/>
+            </a:pPr>
+            <a:r>
+              <a:rPr lang="en-US" sz="1600" dirty="0">
+                <a:solidFill>
+                  <a:srgbClr val="E6EDF3"/>
+                </a:solidFill>
+                <a:latin typeface="Calibri" pitchFamily="34" charset="0"/>
+                <a:ea typeface="Calibri" pitchFamily="34" charset="-122"/>
+                <a:cs typeface="Calibri" pitchFamily="34" charset="-120"/>
+              </a:rPr>
+              <a:t>The agent (green) rides much higher, backs off on loss, and finishes in 4 s</a:t>
+            </a:r>
+            <a:endParaRPr lang="en-US" sz="1600" dirty="0"/>
+          </a:p>
+          <a:p>
+            <a:pPr marL="342900" indent="-342900">
+              <a:spcAft>
+                <a:spcPts val="800"/>
+              </a:spcAft>
+              <a:buSzPct val="100000"/>
+              <a:buChar char="•"/>
+            </a:pPr>
+            <a:r>
+              <a:rPr lang="en-US" sz="1600" dirty="0">
+                <a:solidFill>
+                  <a:srgbClr val="E6EDF3"/>
+                </a:solidFill>
+                <a:latin typeface="Calibri" pitchFamily="34" charset="0"/>
+                <a:ea typeface="Calibri" pitchFamily="34" charset="-122"/>
+                <a:cs typeface="Calibri" pitchFamily="34" charset="-120"/>
+              </a:rPr>
+              <a:t>Regenerate: make figures</a:t>
+            </a:r>
+            <a:endParaRPr lang="en-US" sz="1600" dirty="0"/>
+          </a:p>
+        </p:txBody>
+      </p:sp>
+    </p:spTree>
+  </p:cSld>
+  <p:clrMapOvr>
+    <a:masterClrMapping/>
+  </p:clrMapOvr>
+</p:sld>
+</file>
+
+<file path=ppt/slides/slide31.xml><?xml version="1.0" encoding="utf-8"?>
+<p:sld xmlns:a="http://schemas.openxmlformats.org/drawingml/2006/main" xmlns:r="http://schemas.openxmlformats.org/officeDocument/2006/relationships" xmlns:p="http://schemas.openxmlformats.org/presentationml/2006/main">
+  <p:cSld name="Slide 31">
+    <p:bg>
+      <p:bgPr>
+        <a:solidFill>
+          <a:srgbClr val="0B0F14"/>
+        </a:solidFill>
+      </p:bgPr>
+    </p:bg>
+    <p:spTree>
+      <p:nvGrpSpPr>
+        <p:cNvPr id="1" name=""/>
+        <p:cNvGrpSpPr/>
+        <p:nvPr/>
+      </p:nvGrpSpPr>
+      <p:grpSpPr>
+        <a:xfrm>
+          <a:off x="0" y="0"/>
+          <a:ext cx="0" cy="0"/>
+          <a:chOff x="0" y="0"/>
+          <a:chExt cx="0" cy="0"/>
+        </a:xfrm>
+      </p:grpSpPr>
+      <p:sp>
+        <p:nvSpPr>
+          <p:cNvPr id="2" name="Text 0"/>
+          <p:cNvSpPr/>
+          <p:nvPr/>
+        </p:nvSpPr>
+        <p:spPr>
+          <a:xfrm>
+            <a:off x="548640" y="320040"/>
+            <a:ext cx="11064240" cy="731520"/>
+          </a:xfrm>
+          <a:prstGeom prst="rect">
+            <a:avLst/>
+          </a:prstGeom>
+          <a:noFill/>
+          <a:ln/>
+        </p:spPr>
+        <p:txBody>
+          <a:bodyPr wrap="square" lIns="0" tIns="0" rIns="0" bIns="0" rtlCol="0" anchor="ctr"/>
+          <a:lstStyle/>
+          <a:p>
+            <a:pPr indent="0" marL="0">
+              <a:buNone/>
+            </a:pPr>
+            <a:r>
+              <a:rPr lang="en-US" sz="3000" b="1" dirty="0">
+                <a:solidFill>
+                  <a:srgbClr val="39FF88"/>
+                </a:solidFill>
+                <a:latin typeface="Courier New" pitchFamily="34" charset="0"/>
+                <a:ea typeface="Courier New" pitchFamily="34" charset="-122"/>
+                <a:cs typeface="Courier New" pitchFamily="34" charset="-120"/>
+              </a:rPr>
+              <a:t>Closing gaps: fairness and cross traffic</a:t>
+            </a:r>
+            <a:endParaRPr lang="en-US" sz="3000" dirty="0"/>
+          </a:p>
+        </p:txBody>
+      </p:sp>
+      <p:sp>
+        <p:nvSpPr>
+          <p:cNvPr id="3" name="Text 1"/>
+          <p:cNvSpPr/>
+          <p:nvPr/>
+        </p:nvSpPr>
+        <p:spPr>
+          <a:xfrm>
+            <a:off x="9418320" y="6446520"/>
+            <a:ext cx="2377440" cy="274320"/>
+          </a:xfrm>
+          <a:prstGeom prst="rect">
+            <a:avLst/>
+          </a:prstGeom>
+          <a:noFill/>
+          <a:ln/>
+        </p:spPr>
+        <p:txBody>
+          <a:bodyPr wrap="square" lIns="0" tIns="0" rIns="0" bIns="0" rtlCol="0" anchor="ctr"/>
+          <a:lstStyle/>
+          <a:p>
+            <a:pPr algn="r" indent="0" marL="0">
+              <a:buNone/>
+            </a:pPr>
+            <a:r>
+              <a:rPr lang="en-US" sz="1000" dirty="0">
+                <a:solidFill>
+                  <a:srgbClr val="8B98A5"/>
+                </a:solidFill>
+                <a:latin typeface="Courier New" pitchFamily="34" charset="0"/>
+                <a:ea typeface="Courier New" pitchFamily="34" charset="-122"/>
+                <a:cs typeface="Courier New" pitchFamily="34" charset="-120"/>
+              </a:rPr>
+              <a:t>31 / 34   Smart-RUDP</a:t>
             </a:r>
             <a:endParaRPr lang="en-US" sz="1000" dirty="0"/>
           </a:p>
@@ -23022,7 +23351,7 @@
       </p:sp>
       <p:graphicFrame>
         <p:nvGraphicFramePr>
-          <p:cNvPr id="31" name="Table 0"/>
+          <p:cNvPr id="32" name="Table 0"/>
           <p:cNvGraphicFramePr>
             <a:graphicFrameLocks noGrp="1"/>
           </p:cNvGraphicFramePr>
@@ -24083,7 +24412,7 @@
       </p:graphicFrame>
       <p:graphicFrame>
         <p:nvGraphicFramePr>
-          <p:cNvPr id="61" name="Table 1"/>
+          <p:cNvPr id="63" name="Table 1"/>
           <p:cNvGraphicFramePr>
             <a:graphicFrameLocks noGrp="1"/>
           </p:cNvGraphicFramePr>
@@ -25235,429 +25564,6 @@
 </p:sld>
 </file>
 
-<file path=ppt/slides/slide31.xml><?xml version="1.0" encoding="utf-8"?>
-<p:sld xmlns:a="http://schemas.openxmlformats.org/drawingml/2006/main" xmlns:r="http://schemas.openxmlformats.org/officeDocument/2006/relationships" xmlns:p="http://schemas.openxmlformats.org/presentationml/2006/main">
-  <p:cSld name="Slide 31">
-    <p:bg>
-      <p:bgPr>
-        <a:solidFill>
-          <a:srgbClr val="0B0F14"/>
-        </a:solidFill>
-      </p:bgPr>
-    </p:bg>
-    <p:spTree>
-      <p:nvGrpSpPr>
-        <p:cNvPr id="1" name=""/>
-        <p:cNvGrpSpPr/>
-        <p:nvPr/>
-      </p:nvGrpSpPr>
-      <p:grpSpPr>
-        <a:xfrm>
-          <a:off x="0" y="0"/>
-          <a:ext cx="0" cy="0"/>
-          <a:chOff x="0" y="0"/>
-          <a:chExt cx="0" cy="0"/>
-        </a:xfrm>
-      </p:grpSpPr>
-      <p:sp>
-        <p:nvSpPr>
-          <p:cNvPr id="2" name="Text 0"/>
-          <p:cNvSpPr/>
-          <p:nvPr/>
-        </p:nvSpPr>
-        <p:spPr>
-          <a:xfrm>
-            <a:off x="548640" y="320040"/>
-            <a:ext cx="11064240" cy="731520"/>
-          </a:xfrm>
-          <a:prstGeom prst="rect">
-            <a:avLst/>
-          </a:prstGeom>
-          <a:noFill/>
-          <a:ln/>
-        </p:spPr>
-        <p:txBody>
-          <a:bodyPr wrap="square" lIns="0" tIns="0" rIns="0" bIns="0" rtlCol="0" anchor="ctr"/>
-          <a:lstStyle/>
-          <a:p>
-            <a:pPr indent="0" marL="0">
-              <a:buNone/>
-            </a:pPr>
-            <a:r>
-              <a:rPr lang="en-US" sz="3000" b="1" dirty="0">
-                <a:solidFill>
-                  <a:srgbClr val="39FF88"/>
-                </a:solidFill>
-                <a:latin typeface="Courier New" pitchFamily="34" charset="0"/>
-                <a:ea typeface="Courier New" pitchFamily="34" charset="-122"/>
-                <a:cs typeface="Courier New" pitchFamily="34" charset="-120"/>
-              </a:rPr>
-              <a:t>Learnings and future work</a:t>
-            </a:r>
-            <a:endParaRPr lang="en-US" sz="3000" dirty="0"/>
-          </a:p>
-        </p:txBody>
-      </p:sp>
-      <p:sp>
-        <p:nvSpPr>
-          <p:cNvPr id="3" name="Text 1"/>
-          <p:cNvSpPr/>
-          <p:nvPr/>
-        </p:nvSpPr>
-        <p:spPr>
-          <a:xfrm>
-            <a:off x="9418320" y="6446520"/>
-            <a:ext cx="2377440" cy="274320"/>
-          </a:xfrm>
-          <a:prstGeom prst="rect">
-            <a:avLst/>
-          </a:prstGeom>
-          <a:noFill/>
-          <a:ln/>
-        </p:spPr>
-        <p:txBody>
-          <a:bodyPr wrap="square" lIns="0" tIns="0" rIns="0" bIns="0" rtlCol="0" anchor="ctr"/>
-          <a:lstStyle/>
-          <a:p>
-            <a:pPr algn="r" indent="0" marL="0">
-              <a:buNone/>
-            </a:pPr>
-            <a:r>
-              <a:rPr lang="en-US" sz="1000" dirty="0">
-                <a:solidFill>
-                  <a:srgbClr val="8B98A5"/>
-                </a:solidFill>
-                <a:latin typeface="Courier New" pitchFamily="34" charset="0"/>
-                <a:ea typeface="Courier New" pitchFamily="34" charset="-122"/>
-                <a:cs typeface="Courier New" pitchFamily="34" charset="-120"/>
-              </a:rPr>
-              <a:t>31 / 33   Smart-RUDP</a:t>
-            </a:r>
-            <a:endParaRPr lang="en-US" sz="1000" dirty="0"/>
-          </a:p>
-        </p:txBody>
-      </p:sp>
-      <p:sp>
-        <p:nvSpPr>
-          <p:cNvPr id="4" name="Shape 2"/>
-          <p:cNvSpPr/>
-          <p:nvPr/>
-        </p:nvSpPr>
-        <p:spPr>
-          <a:xfrm>
-            <a:off x="548640" y="1371600"/>
-            <a:ext cx="5394960" cy="4206240"/>
-          </a:xfrm>
-          <a:prstGeom prst="rect">
-            <a:avLst/>
-          </a:prstGeom>
-          <a:solidFill>
-            <a:srgbClr val="141B24"/>
-          </a:solidFill>
-          <a:ln w="12700">
-            <a:solidFill>
-              <a:srgbClr val="39FF88"/>
-            </a:solidFill>
-            <a:prstDash val="solid"/>
-          </a:ln>
-        </p:spPr>
-      </p:sp>
-      <p:sp>
-        <p:nvSpPr>
-          <p:cNvPr id="5" name="Text 3"/>
-          <p:cNvSpPr/>
-          <p:nvPr/>
-        </p:nvSpPr>
-        <p:spPr>
-          <a:xfrm>
-            <a:off x="731520" y="1508760"/>
-            <a:ext cx="5029200" cy="457200"/>
-          </a:xfrm>
-          <a:prstGeom prst="rect">
-            <a:avLst/>
-          </a:prstGeom>
-          <a:noFill/>
-          <a:ln/>
-        </p:spPr>
-        <p:txBody>
-          <a:bodyPr wrap="square" lIns="0" tIns="0" rIns="0" bIns="0" rtlCol="0" anchor="ctr"/>
-          <a:lstStyle/>
-          <a:p>
-            <a:pPr indent="0" marL="0">
-              <a:buNone/>
-            </a:pPr>
-            <a:r>
-              <a:rPr lang="en-US" sz="2000" b="1" dirty="0">
-                <a:solidFill>
-                  <a:srgbClr val="39FF88"/>
-                </a:solidFill>
-                <a:latin typeface="Courier New" pitchFamily="34" charset="0"/>
-                <a:ea typeface="Courier New" pitchFamily="34" charset="-122"/>
-                <a:cs typeface="Courier New" pitchFamily="34" charset="-120"/>
-              </a:rPr>
-              <a:t>Learned</a:t>
-            </a:r>
-            <a:endParaRPr lang="en-US" sz="2000" dirty="0"/>
-          </a:p>
-        </p:txBody>
-      </p:sp>
-      <p:sp>
-        <p:nvSpPr>
-          <p:cNvPr id="6" name="Text 4"/>
-          <p:cNvSpPr/>
-          <p:nvPr/>
-        </p:nvSpPr>
-        <p:spPr>
-          <a:xfrm>
-            <a:off x="731520" y="2011680"/>
-            <a:ext cx="5029200" cy="3429000"/>
-          </a:xfrm>
-          <a:prstGeom prst="rect">
-            <a:avLst/>
-          </a:prstGeom>
-          <a:noFill/>
-          <a:ln/>
-        </p:spPr>
-        <p:txBody>
-          <a:bodyPr wrap="square" lIns="0" tIns="0" rIns="0" bIns="0" rtlCol="0" anchor="t"/>
-          <a:lstStyle/>
-          <a:p>
-            <a:pPr indent="0" marL="0">
-              <a:buNone/>
-            </a:pPr>
-            <a:r>
-              <a:rPr lang="en-US" sz="2000" dirty="0">
-                <a:solidFill>
-                  <a:srgbClr val="E6EDF3"/>
-                </a:solidFill>
-                <a:latin typeface="Calibri" pitchFamily="34" charset="0"/>
-                <a:ea typeface="Calibri" pitchFamily="34" charset="-122"/>
-                <a:cs typeface="Calibri" pitchFamily="34" charset="-120"/>
-              </a:rPr>
-              <a:t>Reliability is a set of simple rules working together.</a:t>
-            </a:r>
-            <a:endParaRPr lang="en-US" sz="2000" dirty="0"/>
-          </a:p>
-          <a:p>
-            <a:pPr indent="0" marL="0">
-              <a:buNone/>
-            </a:pPr>
-            <a:r>
-              <a:rPr lang="en-US" sz="2000" dirty="0">
-                <a:solidFill>
-                  <a:srgbClr val="E6EDF3"/>
-                </a:solidFill>
-                <a:latin typeface="Calibri" pitchFamily="34" charset="0"/>
-                <a:ea typeface="Calibri" pitchFamily="34" charset="-122"/>
-                <a:cs typeface="Calibri" pitchFamily="34" charset="-120"/>
-              </a:rPr>
-              <a:t>Congestion control matters as much as retransmission.</a:t>
-            </a:r>
-            <a:endParaRPr lang="en-US" sz="2000" dirty="0"/>
-          </a:p>
-          <a:p>
-            <a:pPr indent="0" marL="0">
-              <a:buNone/>
-            </a:pPr>
-            <a:r>
-              <a:rPr lang="en-US" sz="2000" dirty="0">
-                <a:solidFill>
-                  <a:srgbClr val="E6EDF3"/>
-                </a:solidFill>
-                <a:latin typeface="Calibri" pitchFamily="34" charset="0"/>
-                <a:ea typeface="Calibri" pitchFamily="34" charset="-122"/>
-                <a:cs typeface="Calibri" pitchFamily="34" charset="-120"/>
-              </a:rPr>
-              <a:t>Testing tools fail in surprising ways.</a:t>
-            </a:r>
-            <a:endParaRPr lang="en-US" sz="2000" dirty="0"/>
-          </a:p>
-        </p:txBody>
-      </p:sp>
-      <p:sp>
-        <p:nvSpPr>
-          <p:cNvPr id="7" name="Shape 5"/>
-          <p:cNvSpPr/>
-          <p:nvPr/>
-        </p:nvSpPr>
-        <p:spPr>
-          <a:xfrm>
-            <a:off x="6217920" y="1371600"/>
-            <a:ext cx="5394960" cy="4206240"/>
-          </a:xfrm>
-          <a:prstGeom prst="rect">
-            <a:avLst/>
-          </a:prstGeom>
-          <a:solidFill>
-            <a:srgbClr val="141B24"/>
-          </a:solidFill>
-          <a:ln w="12700">
-            <a:solidFill>
-              <a:srgbClr val="FFB000"/>
-            </a:solidFill>
-            <a:prstDash val="solid"/>
-          </a:ln>
-        </p:spPr>
-      </p:sp>
-      <p:sp>
-        <p:nvSpPr>
-          <p:cNvPr id="8" name="Text 6"/>
-          <p:cNvSpPr/>
-          <p:nvPr/>
-        </p:nvSpPr>
-        <p:spPr>
-          <a:xfrm>
-            <a:off x="6400800" y="1508760"/>
-            <a:ext cx="5029200" cy="457200"/>
-          </a:xfrm>
-          <a:prstGeom prst="rect">
-            <a:avLst/>
-          </a:prstGeom>
-          <a:noFill/>
-          <a:ln/>
-        </p:spPr>
-        <p:txBody>
-          <a:bodyPr wrap="square" lIns="0" tIns="0" rIns="0" bIns="0" rtlCol="0" anchor="ctr"/>
-          <a:lstStyle/>
-          <a:p>
-            <a:pPr indent="0" marL="0">
-              <a:buNone/>
-            </a:pPr>
-            <a:r>
-              <a:rPr lang="en-US" sz="2000" b="1" dirty="0">
-                <a:solidFill>
-                  <a:srgbClr val="FFB000"/>
-                </a:solidFill>
-                <a:latin typeface="Courier New" pitchFamily="34" charset="0"/>
-                <a:ea typeface="Courier New" pitchFamily="34" charset="-122"/>
-                <a:cs typeface="Courier New" pitchFamily="34" charset="-120"/>
-              </a:rPr>
-              <a:t>Next</a:t>
-            </a:r>
-            <a:endParaRPr lang="en-US" sz="2000" dirty="0"/>
-          </a:p>
-        </p:txBody>
-      </p:sp>
-      <p:sp>
-        <p:nvSpPr>
-          <p:cNvPr id="9" name="Text 7"/>
-          <p:cNvSpPr/>
-          <p:nvPr/>
-        </p:nvSpPr>
-        <p:spPr>
-          <a:xfrm>
-            <a:off x="6400800" y="2011680"/>
-            <a:ext cx="5029200" cy="3429000"/>
-          </a:xfrm>
-          <a:prstGeom prst="rect">
-            <a:avLst/>
-          </a:prstGeom>
-          <a:noFill/>
-          <a:ln/>
-        </p:spPr>
-        <p:txBody>
-          <a:bodyPr wrap="square" lIns="0" tIns="0" rIns="0" bIns="0" rtlCol="0" anchor="t"/>
-          <a:lstStyle/>
-          <a:p>
-            <a:pPr indent="0" marL="0">
-              <a:buNone/>
-            </a:pPr>
-            <a:r>
-              <a:rPr lang="en-US" sz="2000" dirty="0">
-                <a:solidFill>
-                  <a:srgbClr val="E6EDF3"/>
-                </a:solidFill>
-                <a:latin typeface="Calibri" pitchFamily="34" charset="0"/>
-                <a:ea typeface="Calibri" pitchFamily="34" charset="-122"/>
-                <a:cs typeface="Calibri" pitchFamily="34" charset="-120"/>
-              </a:rPr>
-              <a:t>Fairness-aware training, TCP coexistence</a:t>
-            </a:r>
-            <a:endParaRPr lang="en-US" sz="2000" dirty="0"/>
-          </a:p>
-          <a:p>
-            <a:pPr indent="0" marL="0">
-              <a:buNone/>
-            </a:pPr>
-            <a:r>
-              <a:rPr lang="en-US" sz="2000" dirty="0">
-                <a:solidFill>
-                  <a:srgbClr val="E6EDF3"/>
-                </a:solidFill>
-                <a:latin typeface="Calibri" pitchFamily="34" charset="0"/>
-                <a:ea typeface="Calibri" pitchFamily="34" charset="-122"/>
-                <a:cs typeface="Calibri" pitchFamily="34" charset="-120"/>
-              </a:rPr>
-              <a:t>Train on real traces with cross traffic</a:t>
-            </a:r>
-            <a:endParaRPr lang="en-US" sz="2000" dirty="0"/>
-          </a:p>
-          <a:p>
-            <a:pPr indent="0" marL="0">
-              <a:buNone/>
-            </a:pPr>
-            <a:r>
-              <a:rPr lang="en-US" sz="2000" dirty="0">
-                <a:solidFill>
-                  <a:srgbClr val="E6EDF3"/>
-                </a:solidFill>
-                <a:latin typeface="Calibri" pitchFamily="34" charset="0"/>
-                <a:ea typeface="Calibri" pitchFamily="34" charset="-122"/>
-                <a:cs typeface="Calibri" pitchFamily="34" charset="-120"/>
-              </a:rPr>
-              <a:t>Kernel netem and real multi-machine tests</a:t>
-            </a:r>
-            <a:endParaRPr lang="en-US" sz="2000" dirty="0"/>
-          </a:p>
-        </p:txBody>
-      </p:sp>
-      <p:sp>
-        <p:nvSpPr>
-          <p:cNvPr id="10" name="Text 8"/>
-          <p:cNvSpPr/>
-          <p:nvPr/>
-        </p:nvSpPr>
-        <p:spPr>
-          <a:xfrm>
-            <a:off x="548640" y="5852160"/>
-            <a:ext cx="10972800" cy="365760"/>
-          </a:xfrm>
-          <a:prstGeom prst="rect">
-            <a:avLst/>
-          </a:prstGeom>
-          <a:noFill/>
-          <a:ln/>
-        </p:spPr>
-        <p:txBody>
-          <a:bodyPr wrap="square" lIns="0" tIns="0" rIns="0" bIns="0" rtlCol="0" anchor="ctr"/>
-          <a:lstStyle/>
-          <a:p>
-            <a:pPr indent="0" marL="0">
-              <a:buNone/>
-            </a:pPr>
-            <a:r>
-              <a:rPr lang="en-US" sz="1400" dirty="0">
-                <a:solidFill>
-                  <a:srgbClr val="8B98A5"/>
-                </a:solidFill>
-                <a:latin typeface="Calibri" pitchFamily="34" charset="0"/>
-                <a:ea typeface="Calibri" pitchFamily="34" charset="-122"/>
-                <a:cs typeface="Calibri" pitchFamily="34" charset="-120"/>
-              </a:rPr>
-              <a:t>Limits: no kernel netem or multi-machine test; polite mode is a hand-made rule that costs speed; level with CUBIC under bursty cross traffic; no gain at 10% random loss.</a:t>
-            </a:r>
-            <a:endParaRPr lang="en-US" sz="1400" dirty="0"/>
-          </a:p>
-        </p:txBody>
-      </p:sp>
-    </p:spTree>
-  </p:cSld>
-  <p:clrMapOvr>
-    <a:masterClrMapping/>
-  </p:clrMapOvr>
-</p:sld>
-</file>
-
 <file path=ppt/slides/slide32.xml><?xml version="1.0" encoding="utf-8"?>
 <p:sld xmlns:a="http://schemas.openxmlformats.org/drawingml/2006/main" xmlns:r="http://schemas.openxmlformats.org/officeDocument/2006/relationships" xmlns:p="http://schemas.openxmlformats.org/presentationml/2006/main">
   <p:cSld name="Slide 32">
@@ -25690,8 +25596,8 @@
         </p:nvSpPr>
         <p:spPr>
           <a:xfrm>
-            <a:off x="731520" y="2103120"/>
-            <a:ext cx="10058400" cy="1097280"/>
+            <a:off x="548640" y="320040"/>
+            <a:ext cx="11064240" cy="731520"/>
           </a:xfrm>
           <a:prstGeom prst="rect">
             <a:avLst/>
@@ -25707,7 +25613,7 @@
               <a:buNone/>
             </a:pPr>
             <a:r>
-              <a:rPr lang="en-US" sz="6400" b="1" dirty="0">
+              <a:rPr lang="en-US" sz="3000" b="1" dirty="0">
                 <a:solidFill>
                   <a:srgbClr val="39FF88"/>
                 </a:solidFill>
@@ -25715,9 +25621,9 @@
                 <a:ea typeface="Courier New" pitchFamily="34" charset="-122"/>
                 <a:cs typeface="Courier New" pitchFamily="34" charset="-120"/>
               </a:rPr>
-              <a:t>Thank you</a:t>
-            </a:r>
-            <a:endParaRPr lang="en-US" sz="6400" dirty="0"/>
+              <a:t>Learnings and future work</a:t>
+            </a:r>
+            <a:endParaRPr lang="en-US" sz="3000" dirty="0"/>
           </a:p>
         </p:txBody>
       </p:sp>
@@ -25729,8 +25635,8 @@
         </p:nvSpPr>
         <p:spPr>
           <a:xfrm>
-            <a:off x="731520" y="3474720"/>
-            <a:ext cx="10058400" cy="548640"/>
+            <a:off x="9418320" y="6446520"/>
+            <a:ext cx="2377440" cy="274320"/>
           </a:xfrm>
           <a:prstGeom prst="rect">
             <a:avLst/>
@@ -25742,34 +25648,59 @@
           <a:bodyPr wrap="square" lIns="0" tIns="0" rIns="0" bIns="0" rtlCol="0" anchor="ctr"/>
           <a:lstStyle/>
           <a:p>
-            <a:pPr indent="0" marL="0">
+            <a:pPr algn="r" indent="0" marL="0">
               <a:buNone/>
             </a:pPr>
             <a:r>
-              <a:rPr lang="en-US" sz="2600" dirty="0">
+              <a:rPr lang="en-US" sz="1000" dirty="0">
                 <a:solidFill>
-                  <a:srgbClr val="E6EDF3"/>
+                  <a:srgbClr val="8B98A5"/>
                 </a:solidFill>
                 <a:latin typeface="Courier New" pitchFamily="34" charset="0"/>
                 <a:ea typeface="Courier New" pitchFamily="34" charset="-122"/>
                 <a:cs typeface="Courier New" pitchFamily="34" charset="-120"/>
               </a:rPr>
-              <a:t>github.com/Capsturrrr/rudp</a:t>
-            </a:r>
-            <a:endParaRPr lang="en-US" sz="2600" dirty="0"/>
+              <a:t>32 / 34   Smart-RUDP</a:t>
+            </a:r>
+            <a:endParaRPr lang="en-US" sz="1000" dirty="0"/>
           </a:p>
         </p:txBody>
       </p:sp>
       <p:sp>
         <p:nvSpPr>
-          <p:cNvPr id="4" name="Text 2"/>
+          <p:cNvPr id="4" name="Shape 2"/>
           <p:cNvSpPr/>
           <p:nvPr/>
         </p:nvSpPr>
         <p:spPr>
           <a:xfrm>
-            <a:off x="731520" y="4206240"/>
-            <a:ext cx="10058400" cy="457200"/>
+            <a:off x="548640" y="1371600"/>
+            <a:ext cx="5394960" cy="4206240"/>
+          </a:xfrm>
+          <a:prstGeom prst="rect">
+            <a:avLst/>
+          </a:prstGeom>
+          <a:solidFill>
+            <a:srgbClr val="141B24"/>
+          </a:solidFill>
+          <a:ln w="12700">
+            <a:solidFill>
+              <a:srgbClr val="39FF88"/>
+            </a:solidFill>
+            <a:prstDash val="solid"/>
+          </a:ln>
+        </p:spPr>
+      </p:sp>
+      <p:sp>
+        <p:nvSpPr>
+          <p:cNvPr id="5" name="Text 3"/>
+          <p:cNvSpPr/>
+          <p:nvPr/>
+        </p:nvSpPr>
+        <p:spPr>
+          <a:xfrm>
+            <a:off x="731520" y="1508760"/>
+            <a:ext cx="5029200" cy="457200"/>
           </a:xfrm>
           <a:prstGeom prst="rect">
             <a:avLst/>
@@ -25785,7 +25716,256 @@
               <a:buNone/>
             </a:pPr>
             <a:r>
-              <a:rPr lang="en-US" sz="1800" dirty="0">
+              <a:rPr lang="en-US" sz="2000" b="1" dirty="0">
+                <a:solidFill>
+                  <a:srgbClr val="39FF88"/>
+                </a:solidFill>
+                <a:latin typeface="Courier New" pitchFamily="34" charset="0"/>
+                <a:ea typeface="Courier New" pitchFamily="34" charset="-122"/>
+                <a:cs typeface="Courier New" pitchFamily="34" charset="-120"/>
+              </a:rPr>
+              <a:t>Learned</a:t>
+            </a:r>
+            <a:endParaRPr lang="en-US" sz="2000" dirty="0"/>
+          </a:p>
+        </p:txBody>
+      </p:sp>
+      <p:sp>
+        <p:nvSpPr>
+          <p:cNvPr id="6" name="Text 4"/>
+          <p:cNvSpPr/>
+          <p:nvPr/>
+        </p:nvSpPr>
+        <p:spPr>
+          <a:xfrm>
+            <a:off x="731520" y="2011680"/>
+            <a:ext cx="5029200" cy="3429000"/>
+          </a:xfrm>
+          <a:prstGeom prst="rect">
+            <a:avLst/>
+          </a:prstGeom>
+          <a:noFill/>
+          <a:ln/>
+        </p:spPr>
+        <p:txBody>
+          <a:bodyPr wrap="square" lIns="0" tIns="0" rIns="0" bIns="0" rtlCol="0" anchor="t"/>
+          <a:lstStyle/>
+          <a:p>
+            <a:pPr indent="0" marL="0">
+              <a:buNone/>
+            </a:pPr>
+            <a:r>
+              <a:rPr lang="en-US" sz="2000" dirty="0">
+                <a:solidFill>
+                  <a:srgbClr val="E6EDF3"/>
+                </a:solidFill>
+                <a:latin typeface="Calibri" pitchFamily="34" charset="0"/>
+                <a:ea typeface="Calibri" pitchFamily="34" charset="-122"/>
+                <a:cs typeface="Calibri" pitchFamily="34" charset="-120"/>
+              </a:rPr>
+              <a:t>Reliability is a set of simple rules working together.</a:t>
+            </a:r>
+            <a:endParaRPr lang="en-US" sz="2000" dirty="0"/>
+          </a:p>
+          <a:p>
+            <a:pPr indent="0" marL="0">
+              <a:buNone/>
+            </a:pPr>
+            <a:r>
+              <a:rPr lang="en-US" sz="2000" dirty="0">
+                <a:solidFill>
+                  <a:srgbClr val="E6EDF3"/>
+                </a:solidFill>
+                <a:latin typeface="Calibri" pitchFamily="34" charset="0"/>
+                <a:ea typeface="Calibri" pitchFamily="34" charset="-122"/>
+                <a:cs typeface="Calibri" pitchFamily="34" charset="-120"/>
+              </a:rPr>
+              <a:t>Congestion control matters as much as retransmission.</a:t>
+            </a:r>
+            <a:endParaRPr lang="en-US" sz="2000" dirty="0"/>
+          </a:p>
+          <a:p>
+            <a:pPr indent="0" marL="0">
+              <a:buNone/>
+            </a:pPr>
+            <a:r>
+              <a:rPr lang="en-US" sz="2000" dirty="0">
+                <a:solidFill>
+                  <a:srgbClr val="E6EDF3"/>
+                </a:solidFill>
+                <a:latin typeface="Calibri" pitchFamily="34" charset="0"/>
+                <a:ea typeface="Calibri" pitchFamily="34" charset="-122"/>
+                <a:cs typeface="Calibri" pitchFamily="34" charset="-120"/>
+              </a:rPr>
+              <a:t>Testing tools fail in surprising ways.</a:t>
+            </a:r>
+            <a:endParaRPr lang="en-US" sz="2000" dirty="0"/>
+          </a:p>
+        </p:txBody>
+      </p:sp>
+      <p:sp>
+        <p:nvSpPr>
+          <p:cNvPr id="7" name="Shape 5"/>
+          <p:cNvSpPr/>
+          <p:nvPr/>
+        </p:nvSpPr>
+        <p:spPr>
+          <a:xfrm>
+            <a:off x="6217920" y="1371600"/>
+            <a:ext cx="5394960" cy="4206240"/>
+          </a:xfrm>
+          <a:prstGeom prst="rect">
+            <a:avLst/>
+          </a:prstGeom>
+          <a:solidFill>
+            <a:srgbClr val="141B24"/>
+          </a:solidFill>
+          <a:ln w="12700">
+            <a:solidFill>
+              <a:srgbClr val="FFB000"/>
+            </a:solidFill>
+            <a:prstDash val="solid"/>
+          </a:ln>
+        </p:spPr>
+      </p:sp>
+      <p:sp>
+        <p:nvSpPr>
+          <p:cNvPr id="8" name="Text 6"/>
+          <p:cNvSpPr/>
+          <p:nvPr/>
+        </p:nvSpPr>
+        <p:spPr>
+          <a:xfrm>
+            <a:off x="6400800" y="1508760"/>
+            <a:ext cx="5029200" cy="457200"/>
+          </a:xfrm>
+          <a:prstGeom prst="rect">
+            <a:avLst/>
+          </a:prstGeom>
+          <a:noFill/>
+          <a:ln/>
+        </p:spPr>
+        <p:txBody>
+          <a:bodyPr wrap="square" lIns="0" tIns="0" rIns="0" bIns="0" rtlCol="0" anchor="ctr"/>
+          <a:lstStyle/>
+          <a:p>
+            <a:pPr indent="0" marL="0">
+              <a:buNone/>
+            </a:pPr>
+            <a:r>
+              <a:rPr lang="en-US" sz="2000" b="1" dirty="0">
+                <a:solidFill>
+                  <a:srgbClr val="FFB000"/>
+                </a:solidFill>
+                <a:latin typeface="Courier New" pitchFamily="34" charset="0"/>
+                <a:ea typeface="Courier New" pitchFamily="34" charset="-122"/>
+                <a:cs typeface="Courier New" pitchFamily="34" charset="-120"/>
+              </a:rPr>
+              <a:t>Next</a:t>
+            </a:r>
+            <a:endParaRPr lang="en-US" sz="2000" dirty="0"/>
+          </a:p>
+        </p:txBody>
+      </p:sp>
+      <p:sp>
+        <p:nvSpPr>
+          <p:cNvPr id="9" name="Text 7"/>
+          <p:cNvSpPr/>
+          <p:nvPr/>
+        </p:nvSpPr>
+        <p:spPr>
+          <a:xfrm>
+            <a:off x="6400800" y="2011680"/>
+            <a:ext cx="5029200" cy="3429000"/>
+          </a:xfrm>
+          <a:prstGeom prst="rect">
+            <a:avLst/>
+          </a:prstGeom>
+          <a:noFill/>
+          <a:ln/>
+        </p:spPr>
+        <p:txBody>
+          <a:bodyPr wrap="square" lIns="0" tIns="0" rIns="0" bIns="0" rtlCol="0" anchor="t"/>
+          <a:lstStyle/>
+          <a:p>
+            <a:pPr indent="0" marL="0">
+              <a:buNone/>
+            </a:pPr>
+            <a:r>
+              <a:rPr lang="en-US" sz="2000" dirty="0">
+                <a:solidFill>
+                  <a:srgbClr val="E6EDF3"/>
+                </a:solidFill>
+                <a:latin typeface="Calibri" pitchFamily="34" charset="0"/>
+                <a:ea typeface="Calibri" pitchFamily="34" charset="-122"/>
+                <a:cs typeface="Calibri" pitchFamily="34" charset="-120"/>
+              </a:rPr>
+              <a:t>Fairness-aware training, TCP coexistence</a:t>
+            </a:r>
+            <a:endParaRPr lang="en-US" sz="2000" dirty="0"/>
+          </a:p>
+          <a:p>
+            <a:pPr indent="0" marL="0">
+              <a:buNone/>
+            </a:pPr>
+            <a:r>
+              <a:rPr lang="en-US" sz="2000" dirty="0">
+                <a:solidFill>
+                  <a:srgbClr val="E6EDF3"/>
+                </a:solidFill>
+                <a:latin typeface="Calibri" pitchFamily="34" charset="0"/>
+                <a:ea typeface="Calibri" pitchFamily="34" charset="-122"/>
+                <a:cs typeface="Calibri" pitchFamily="34" charset="-120"/>
+              </a:rPr>
+              <a:t>Train on real traces with cross traffic</a:t>
+            </a:r>
+            <a:endParaRPr lang="en-US" sz="2000" dirty="0"/>
+          </a:p>
+          <a:p>
+            <a:pPr indent="0" marL="0">
+              <a:buNone/>
+            </a:pPr>
+            <a:r>
+              <a:rPr lang="en-US" sz="2000" dirty="0">
+                <a:solidFill>
+                  <a:srgbClr val="E6EDF3"/>
+                </a:solidFill>
+                <a:latin typeface="Calibri" pitchFamily="34" charset="0"/>
+                <a:ea typeface="Calibri" pitchFamily="34" charset="-122"/>
+                <a:cs typeface="Calibri" pitchFamily="34" charset="-120"/>
+              </a:rPr>
+              <a:t>Kernel netem and real multi-machine tests</a:t>
+            </a:r>
+            <a:endParaRPr lang="en-US" sz="2000" dirty="0"/>
+          </a:p>
+        </p:txBody>
+      </p:sp>
+      <p:sp>
+        <p:nvSpPr>
+          <p:cNvPr id="10" name="Text 8"/>
+          <p:cNvSpPr/>
+          <p:nvPr/>
+        </p:nvSpPr>
+        <p:spPr>
+          <a:xfrm>
+            <a:off x="548640" y="5852160"/>
+            <a:ext cx="10972800" cy="365760"/>
+          </a:xfrm>
+          <a:prstGeom prst="rect">
+            <a:avLst/>
+          </a:prstGeom>
+          <a:noFill/>
+          <a:ln/>
+        </p:spPr>
+        <p:txBody>
+          <a:bodyPr wrap="square" lIns="0" tIns="0" rIns="0" bIns="0" rtlCol="0" anchor="ctr"/>
+          <a:lstStyle/>
+          <a:p>
+            <a:pPr indent="0" marL="0">
+              <a:buNone/>
+            </a:pPr>
+            <a:r>
+              <a:rPr lang="en-US" sz="1400" dirty="0">
                 <a:solidFill>
                   <a:srgbClr val="8B98A5"/>
                 </a:solidFill>
@@ -25793,9 +25973,9 @@
                 <a:ea typeface="Calibri" pitchFamily="34" charset="-122"/>
                 <a:cs typeface="Calibri" pitchFamily="34" charset="-120"/>
               </a:rPr>
-              <a:t>Harshavardhan Mallela   Rohit Arya   Shloak Sinha</a:t>
-            </a:r>
-            <a:endParaRPr lang="en-US" sz="1800" dirty="0"/>
+              <a:t>Limits: no kernel netem or multi-machine test; polite mode is a hand-made rule that costs speed; level with CUBIC under bursty cross traffic; no gain at 10% random loss.</a:t>
+            </a:r>
+            <a:endParaRPr lang="en-US" sz="1400" dirty="0"/>
           </a:p>
         </p:txBody>
       </p:sp>
@@ -25839,6 +26019,155 @@
         </p:nvSpPr>
         <p:spPr>
           <a:xfrm>
+            <a:off x="731520" y="2103120"/>
+            <a:ext cx="10058400" cy="1097280"/>
+          </a:xfrm>
+          <a:prstGeom prst="rect">
+            <a:avLst/>
+          </a:prstGeom>
+          <a:noFill/>
+          <a:ln/>
+        </p:spPr>
+        <p:txBody>
+          <a:bodyPr wrap="square" lIns="0" tIns="0" rIns="0" bIns="0" rtlCol="0" anchor="ctr"/>
+          <a:lstStyle/>
+          <a:p>
+            <a:pPr indent="0" marL="0">
+              <a:buNone/>
+            </a:pPr>
+            <a:r>
+              <a:rPr lang="en-US" sz="6400" b="1" dirty="0">
+                <a:solidFill>
+                  <a:srgbClr val="39FF88"/>
+                </a:solidFill>
+                <a:latin typeface="Courier New" pitchFamily="34" charset="0"/>
+                <a:ea typeface="Courier New" pitchFamily="34" charset="-122"/>
+                <a:cs typeface="Courier New" pitchFamily="34" charset="-120"/>
+              </a:rPr>
+              <a:t>Thank you</a:t>
+            </a:r>
+            <a:endParaRPr lang="en-US" sz="6400" dirty="0"/>
+          </a:p>
+        </p:txBody>
+      </p:sp>
+      <p:sp>
+        <p:nvSpPr>
+          <p:cNvPr id="3" name="Text 1"/>
+          <p:cNvSpPr/>
+          <p:nvPr/>
+        </p:nvSpPr>
+        <p:spPr>
+          <a:xfrm>
+            <a:off x="731520" y="3474720"/>
+            <a:ext cx="10058400" cy="548640"/>
+          </a:xfrm>
+          <a:prstGeom prst="rect">
+            <a:avLst/>
+          </a:prstGeom>
+          <a:noFill/>
+          <a:ln/>
+        </p:spPr>
+        <p:txBody>
+          <a:bodyPr wrap="square" lIns="0" tIns="0" rIns="0" bIns="0" rtlCol="0" anchor="ctr"/>
+          <a:lstStyle/>
+          <a:p>
+            <a:pPr indent="0" marL="0">
+              <a:buNone/>
+            </a:pPr>
+            <a:r>
+              <a:rPr lang="en-US" sz="2600" dirty="0">
+                <a:solidFill>
+                  <a:srgbClr val="E6EDF3"/>
+                </a:solidFill>
+                <a:latin typeface="Courier New" pitchFamily="34" charset="0"/>
+                <a:ea typeface="Courier New" pitchFamily="34" charset="-122"/>
+                <a:cs typeface="Courier New" pitchFamily="34" charset="-120"/>
+              </a:rPr>
+              <a:t>github.com/Capsturrrr/rudp</a:t>
+            </a:r>
+            <a:endParaRPr lang="en-US" sz="2600" dirty="0"/>
+          </a:p>
+        </p:txBody>
+      </p:sp>
+      <p:sp>
+        <p:nvSpPr>
+          <p:cNvPr id="4" name="Text 2"/>
+          <p:cNvSpPr/>
+          <p:nvPr/>
+        </p:nvSpPr>
+        <p:spPr>
+          <a:xfrm>
+            <a:off x="731520" y="4206240"/>
+            <a:ext cx="10058400" cy="457200"/>
+          </a:xfrm>
+          <a:prstGeom prst="rect">
+            <a:avLst/>
+          </a:prstGeom>
+          <a:noFill/>
+          <a:ln/>
+        </p:spPr>
+        <p:txBody>
+          <a:bodyPr wrap="square" lIns="0" tIns="0" rIns="0" bIns="0" rtlCol="0" anchor="ctr"/>
+          <a:lstStyle/>
+          <a:p>
+            <a:pPr indent="0" marL="0">
+              <a:buNone/>
+            </a:pPr>
+            <a:r>
+              <a:rPr lang="en-US" sz="1800" dirty="0">
+                <a:solidFill>
+                  <a:srgbClr val="8B98A5"/>
+                </a:solidFill>
+                <a:latin typeface="Calibri" pitchFamily="34" charset="0"/>
+                <a:ea typeface="Calibri" pitchFamily="34" charset="-122"/>
+                <a:cs typeface="Calibri" pitchFamily="34" charset="-120"/>
+              </a:rPr>
+              <a:t>Harshavardhan Mallela   Rohit Arya   Shloak Sinha</a:t>
+            </a:r>
+            <a:endParaRPr lang="en-US" sz="1800" dirty="0"/>
+          </a:p>
+        </p:txBody>
+      </p:sp>
+    </p:spTree>
+  </p:cSld>
+  <p:clrMapOvr>
+    <a:masterClrMapping/>
+  </p:clrMapOvr>
+</p:sld>
+</file>
+
+<file path=ppt/slides/slide34.xml><?xml version="1.0" encoding="utf-8"?>
+<p:sld xmlns:a="http://schemas.openxmlformats.org/drawingml/2006/main" xmlns:r="http://schemas.openxmlformats.org/officeDocument/2006/relationships" xmlns:p="http://schemas.openxmlformats.org/presentationml/2006/main">
+  <p:cSld name="Slide 34">
+    <p:bg>
+      <p:bgPr>
+        <a:solidFill>
+          <a:srgbClr val="0B0F14"/>
+        </a:solidFill>
+      </p:bgPr>
+    </p:bg>
+    <p:spTree>
+      <p:nvGrpSpPr>
+        <p:cNvPr id="1" name=""/>
+        <p:cNvGrpSpPr/>
+        <p:nvPr/>
+      </p:nvGrpSpPr>
+      <p:grpSpPr>
+        <a:xfrm>
+          <a:off x="0" y="0"/>
+          <a:ext cx="0" cy="0"/>
+          <a:chOff x="0" y="0"/>
+          <a:chExt cx="0" cy="0"/>
+        </a:xfrm>
+      </p:grpSpPr>
+      <p:sp>
+        <p:nvSpPr>
+          <p:cNvPr id="2" name="Text 0"/>
+          <p:cNvSpPr/>
+          <p:nvPr/>
+        </p:nvSpPr>
+        <p:spPr>
+          <a:xfrm>
             <a:off x="548640" y="320040"/>
             <a:ext cx="11064240" cy="731520"/>
           </a:xfrm>
@@ -26143,7 +26472,7 @@
                 <a:ea typeface="Courier New" pitchFamily="34" charset="-122"/>
                 <a:cs typeface="Courier New" pitchFamily="34" charset="-120"/>
               </a:rPr>
-              <a:t>4 / 33   Smart-RUDP</a:t>
+              <a:t>4 / 34   Smart-RUDP</a:t>
             </a:r>
             <a:endParaRPr lang="en-US" sz="1000" dirty="0"/>
           </a:p>
@@ -26704,7 +27033,7 @@
                 <a:ea typeface="Courier New" pitchFamily="34" charset="-122"/>
                 <a:cs typeface="Courier New" pitchFamily="34" charset="-120"/>
               </a:rPr>
-              <a:t>5 / 33   Smart-RUDP</a:t>
+              <a:t>5 / 34   Smart-RUDP</a:t>
             </a:r>
             <a:endParaRPr lang="en-US" sz="1000" dirty="0"/>
           </a:p>
@@ -28143,7 +28472,7 @@
                 <a:ea typeface="Courier New" pitchFamily="34" charset="-122"/>
                 <a:cs typeface="Courier New" pitchFamily="34" charset="-120"/>
               </a:rPr>
-              <a:t>6 / 33   Smart-RUDP</a:t>
+              <a:t>6 / 34   Smart-RUDP</a:t>
             </a:r>
             <a:endParaRPr lang="en-US" sz="1000" dirty="0"/>
           </a:p>
@@ -29378,7 +29707,7 @@
                 <a:ea typeface="Courier New" pitchFamily="34" charset="-122"/>
                 <a:cs typeface="Courier New" pitchFamily="34" charset="-120"/>
               </a:rPr>
-              <a:t>7 / 33   Smart-RUDP</a:t>
+              <a:t>7 / 34   Smart-RUDP</a:t>
             </a:r>
             <a:endParaRPr lang="en-US" sz="1000" dirty="0"/>
           </a:p>
@@ -29821,7 +30150,7 @@
                 <a:ea typeface="Courier New" pitchFamily="34" charset="-122"/>
                 <a:cs typeface="Courier New" pitchFamily="34" charset="-120"/>
               </a:rPr>
-              <a:t>8 / 33   Smart-RUDP</a:t>
+              <a:t>8 / 34   Smart-RUDP</a:t>
             </a:r>
             <a:endParaRPr lang="en-US" sz="1000" dirty="0"/>
           </a:p>
@@ -30121,7 +30450,7 @@
                 <a:ea typeface="Courier New" pitchFamily="34" charset="-122"/>
                 <a:cs typeface="Courier New" pitchFamily="34" charset="-120"/>
               </a:rPr>
-              <a:t>9 / 33   Smart-RUDP</a:t>
+              <a:t>9 / 34   Smart-RUDP</a:t>
             </a:r>
             <a:endParaRPr lang="en-US" sz="1000" dirty="0"/>
           </a:p>

</xml_diff>

<commit_message>
Report 8.17, deck slide with notes, case study and README updated with kernel netem results
Co-Authored-By: Claude Sonnet 5.5 <noreply@anthropic.com>
Claude-Session: https://claude.ai/code/session_01NX2zRNpdVAnzFNKmqomzKu
</commit_message>
<xml_diff>
--- a/docs/RUDP_Presentation.pptx
+++ b/docs/RUDP_Presentation.pptx
@@ -39,9 +39,10 @@
     <p:sldId id="287" r:id="rId33"/>
     <p:sldId id="288" r:id="rId34"/>
     <p:sldId id="289" r:id="rId35"/>
+    <p:sldId id="290" r:id="rId36"/>
   </p:sldIdLst>
   <p:notesMasterIdLst>
-    <p:notesMasterId r:id="rId36"/>
+    <p:notesMasterId r:id="rId37"/>
   </p:notesMasterIdLst>
   <p:sldSz cx="12192000" cy="6858000"/>
   <p:notesSz cx="6858000" cy="12192000"/>
@@ -3236,6 +3237,94 @@
             <a:fld id="{F7021451-1387-4CA6-816F-3879F97B5CBC}" type="slidenum">
               <a:rPr lang="en-US"/>
               <a:t>34</a:t>
+            </a:fld>
+            <a:endParaRPr lang="en-US"/>
+          </a:p>
+        </p:txBody>
+      </p:sp>
+    </p:spTree>
+    <p:extLst>
+      <p:ext uri="{BB962C8B-B14F-4D97-AF65-F5344CB8AC3E}">
+        <p14:creationId xmlns:p14="http://schemas.microsoft.com/office/powerpoint/2010/main" val="1024086991"/>
+      </p:ext>
+    </p:extLst>
+  </p:cSld>
+  <p:clrMapOvr>
+    <a:masterClrMapping/>
+  </p:clrMapOvr>
+</p:notes>
+</file>
+
+<file path=ppt/notesSlides/notesSlide35.xml><?xml version="1.0" encoding="utf-8"?>
+<p:notes xmlns:a="http://schemas.openxmlformats.org/drawingml/2006/main" xmlns:r="http://schemas.openxmlformats.org/officeDocument/2006/relationships" xmlns:p="http://schemas.openxmlformats.org/presentationml/2006/main">
+  <p:cSld>
+    <p:spTree>
+      <p:nvGrpSpPr>
+        <p:cNvPr id="1" name=""/>
+        <p:cNvGrpSpPr/>
+        <p:nvPr/>
+      </p:nvGrpSpPr>
+      <p:grpSpPr>
+        <a:xfrm>
+          <a:off x="0" y="0"/>
+          <a:ext cx="0" cy="0"/>
+          <a:chOff x="0" y="0"/>
+          <a:chExt cx="0" cy="0"/>
+        </a:xfrm>
+      </p:grpSpPr>
+      <p:sp>
+        <p:nvSpPr>
+          <p:cNvPr id="2" name="Slide Image Placeholder 1"/>
+          <p:cNvSpPr>
+            <a:spLocks noGrp="1" noRot="1" noChangeAspect="1"/>
+          </p:cNvSpPr>
+          <p:nvPr>
+            <p:ph type="sldImg"/>
+          </p:nvPr>
+        </p:nvSpPr>
+        <p:spPr/>
+      </p:sp>
+      <p:sp>
+        <p:nvSpPr>
+          <p:cNvPr id="3" name="Notes Placeholder 2"/>
+          <p:cNvSpPr>
+            <a:spLocks noGrp="1"/>
+          </p:cNvSpPr>
+          <p:nvPr>
+            <p:ph type="body" idx="1"/>
+          </p:nvPr>
+        </p:nvSpPr>
+        <p:spPr/>
+        <p:txBody>
+          <a:bodyPr/>
+          <a:lstStyle/>
+          <a:p>
+            <a:r>
+              <a:rPr lang="en-US" dirty="0"/>
+              <a:t/>
+            </a:r>
+            <a:endParaRPr lang="en-US" dirty="0"/>
+          </a:p>
+        </p:txBody>
+      </p:sp>
+      <p:sp>
+        <p:nvSpPr>
+          <p:cNvPr id="4" name="Slide Number Placeholder 3"/>
+          <p:cNvSpPr>
+            <a:spLocks noGrp="1"/>
+          </p:cNvSpPr>
+          <p:nvPr>
+            <p:ph type="sldNum" sz="quarter" idx="10"/>
+          </p:nvPr>
+        </p:nvSpPr>
+        <p:spPr/>
+        <p:txBody>
+          <a:bodyPr/>
+          <a:lstStyle/>
+          <a:p>
+            <a:fld id="{F7021451-1387-4CA6-816F-3879F97B5CBC}" type="slidenum">
+              <a:rPr lang="en-US"/>
+              <a:t>35</a:t>
             </a:fld>
             <a:endParaRPr lang="en-US"/>
           </a:p>
@@ -4373,7 +4462,7 @@
                 <a:ea typeface="Courier New" pitchFamily="34" charset="-122"/>
                 <a:cs typeface="Courier New" pitchFamily="34" charset="-120"/>
               </a:rPr>
-              <a:t>10 / 34   Smart-RUDP</a:t>
+              <a:t>10 / 35   Smart-RUDP</a:t>
             </a:r>
             <a:endParaRPr lang="en-US" sz="1000" dirty="0"/>
           </a:p>
@@ -4570,7 +4659,7 @@
                 <a:ea typeface="Courier New" pitchFamily="34" charset="-122"/>
                 <a:cs typeface="Courier New" pitchFamily="34" charset="-120"/>
               </a:rPr>
-              <a:t>11 / 34   Smart-RUDP</a:t>
+              <a:t>11 / 35   Smart-RUDP</a:t>
             </a:r>
             <a:endParaRPr lang="en-US" sz="1000" dirty="0"/>
           </a:p>
@@ -5400,7 +5489,7 @@
                 <a:ea typeface="Courier New" pitchFamily="34" charset="-122"/>
                 <a:cs typeface="Courier New" pitchFamily="34" charset="-120"/>
               </a:rPr>
-              <a:t>12 / 34   Smart-RUDP</a:t>
+              <a:t>12 / 35   Smart-RUDP</a:t>
             </a:r>
             <a:endParaRPr lang="en-US" sz="1000" dirty="0"/>
           </a:p>
@@ -5697,7 +5786,7 @@
                 <a:ea typeface="Courier New" pitchFamily="34" charset="-122"/>
                 <a:cs typeface="Courier New" pitchFamily="34" charset="-120"/>
               </a:rPr>
-              <a:t>13 / 34   Smart-RUDP</a:t>
+              <a:t>13 / 35   Smart-RUDP</a:t>
             </a:r>
             <a:endParaRPr lang="en-US" sz="1000" dirty="0"/>
           </a:p>
@@ -5997,7 +6086,7 @@
                 <a:ea typeface="Courier New" pitchFamily="34" charset="-122"/>
                 <a:cs typeface="Courier New" pitchFamily="34" charset="-120"/>
               </a:rPr>
-              <a:t>14 / 34   Smart-RUDP</a:t>
+              <a:t>14 / 35   Smart-RUDP</a:t>
             </a:r>
             <a:endParaRPr lang="en-US" sz="1000" dirty="0"/>
           </a:p>
@@ -6381,7 +6470,7 @@
                 <a:ea typeface="Courier New" pitchFamily="34" charset="-122"/>
                 <a:cs typeface="Courier New" pitchFamily="34" charset="-120"/>
               </a:rPr>
-              <a:t>15 / 34   Smart-RUDP</a:t>
+              <a:t>15 / 35   Smart-RUDP</a:t>
             </a:r>
             <a:endParaRPr lang="en-US" sz="1000" dirty="0"/>
           </a:p>
@@ -6839,7 +6928,7 @@
                 <a:ea typeface="Courier New" pitchFamily="34" charset="-122"/>
                 <a:cs typeface="Courier New" pitchFamily="34" charset="-120"/>
               </a:rPr>
-              <a:t>16 / 34   Smart-RUDP</a:t>
+              <a:t>16 / 35   Smart-RUDP</a:t>
             </a:r>
             <a:endParaRPr lang="en-US" sz="1000" dirty="0"/>
           </a:p>
@@ -7524,7 +7613,7 @@
                 <a:ea typeface="Courier New" pitchFamily="34" charset="-122"/>
                 <a:cs typeface="Courier New" pitchFamily="34" charset="-120"/>
               </a:rPr>
-              <a:t>17 / 34   Smart-RUDP</a:t>
+              <a:t>17 / 35   Smart-RUDP</a:t>
             </a:r>
             <a:endParaRPr lang="en-US" sz="1000" dirty="0"/>
           </a:p>
@@ -7764,7 +7853,7 @@
                 <a:ea typeface="Courier New" pitchFamily="34" charset="-122"/>
                 <a:cs typeface="Courier New" pitchFamily="34" charset="-120"/>
               </a:rPr>
-              <a:t>18 / 34   Smart-RUDP</a:t>
+              <a:t>18 / 35   Smart-RUDP</a:t>
             </a:r>
             <a:endParaRPr lang="en-US" sz="1000" dirty="0"/>
           </a:p>
@@ -8004,7 +8093,7 @@
                 <a:ea typeface="Courier New" pitchFamily="34" charset="-122"/>
                 <a:cs typeface="Courier New" pitchFamily="34" charset="-120"/>
               </a:rPr>
-              <a:t>19 / 34   Smart-RUDP</a:t>
+              <a:t>19 / 35   Smart-RUDP</a:t>
             </a:r>
             <a:endParaRPr lang="en-US" sz="1000" dirty="0"/>
           </a:p>
@@ -8226,7 +8315,7 @@
                 <a:ea typeface="Courier New" pitchFamily="34" charset="-122"/>
                 <a:cs typeface="Courier New" pitchFamily="34" charset="-120"/>
               </a:rPr>
-              <a:t>2 / 34   Smart-RUDP</a:t>
+              <a:t>2 / 35   Smart-RUDP</a:t>
             </a:r>
             <a:endParaRPr lang="en-US" sz="1000" dirty="0"/>
           </a:p>
@@ -8620,7 +8709,7 @@
                 <a:ea typeface="Courier New" pitchFamily="34" charset="-122"/>
                 <a:cs typeface="Courier New" pitchFamily="34" charset="-120"/>
               </a:rPr>
-              <a:t>20 / 34   Smart-RUDP</a:t>
+              <a:t>20 / 35   Smart-RUDP</a:t>
             </a:r>
             <a:endParaRPr lang="en-US" sz="1000" dirty="0"/>
           </a:p>
@@ -8944,7 +9033,7 @@
                 <a:ea typeface="Courier New" pitchFamily="34" charset="-122"/>
                 <a:cs typeface="Courier New" pitchFamily="34" charset="-120"/>
               </a:rPr>
-              <a:t>21 / 34   Smart-RUDP</a:t>
+              <a:t>21 / 35   Smart-RUDP</a:t>
             </a:r>
             <a:endParaRPr lang="en-US" sz="1000" dirty="0"/>
           </a:p>
@@ -10651,7 +10740,7 @@
                 <a:ea typeface="Courier New" pitchFamily="34" charset="-122"/>
                 <a:cs typeface="Courier New" pitchFamily="34" charset="-120"/>
               </a:rPr>
-              <a:t>22 / 34   Smart-RUDP</a:t>
+              <a:t>22 / 35   Smart-RUDP</a:t>
             </a:r>
             <a:endParaRPr lang="en-US" sz="1000" dirty="0"/>
           </a:p>
@@ -12034,7 +12123,7 @@
                 <a:ea typeface="Courier New" pitchFamily="34" charset="-122"/>
                 <a:cs typeface="Courier New" pitchFamily="34" charset="-120"/>
               </a:rPr>
-              <a:t>23 / 34   Smart-RUDP</a:t>
+              <a:t>23 / 35   Smart-RUDP</a:t>
             </a:r>
             <a:endParaRPr lang="en-US" sz="1000" dirty="0"/>
           </a:p>
@@ -13577,7 +13666,7 @@
                 <a:ea typeface="Courier New" pitchFamily="34" charset="-122"/>
                 <a:cs typeface="Courier New" pitchFamily="34" charset="-120"/>
               </a:rPr>
-              <a:t>24 / 34   Smart-RUDP</a:t>
+              <a:t>24 / 35   Smart-RUDP</a:t>
             </a:r>
             <a:endParaRPr lang="en-US" sz="1000" dirty="0"/>
           </a:p>
@@ -15255,7 +15344,7 @@
                 <a:ea typeface="Courier New" pitchFamily="34" charset="-122"/>
                 <a:cs typeface="Courier New" pitchFamily="34" charset="-120"/>
               </a:rPr>
-              <a:t>25 / 34   Smart-RUDP</a:t>
+              <a:t>25 / 35   Smart-RUDP</a:t>
             </a:r>
             <a:endParaRPr lang="en-US" sz="1000" dirty="0"/>
           </a:p>
@@ -16933,7 +17022,7 @@
                 <a:ea typeface="Courier New" pitchFamily="34" charset="-122"/>
                 <a:cs typeface="Courier New" pitchFamily="34" charset="-120"/>
               </a:rPr>
-              <a:t>26 / 34   Smart-RUDP</a:t>
+              <a:t>26 / 35   Smart-RUDP</a:t>
             </a:r>
             <a:endParaRPr lang="en-US" sz="1000" dirty="0"/>
           </a:p>
@@ -19273,7 +19362,7 @@
                 <a:ea typeface="Courier New" pitchFamily="34" charset="-122"/>
                 <a:cs typeface="Courier New" pitchFamily="34" charset="-120"/>
               </a:rPr>
-              <a:t>27 / 34   Smart-RUDP</a:t>
+              <a:t>27 / 35   Smart-RUDP</a:t>
             </a:r>
             <a:endParaRPr lang="en-US" sz="1000" dirty="0"/>
           </a:p>
@@ -19731,7 +19820,7 @@
                 <a:ea typeface="Courier New" pitchFamily="34" charset="-122"/>
                 <a:cs typeface="Courier New" pitchFamily="34" charset="-120"/>
               </a:rPr>
-              <a:t>28 / 34   Smart-RUDP</a:t>
+              <a:t>28 / 35   Smart-RUDP</a:t>
             </a:r>
             <a:endParaRPr lang="en-US" sz="1000" dirty="0"/>
           </a:p>
@@ -19963,7 +20052,7 @@
                 <a:ea typeface="Courier New" pitchFamily="34" charset="-122"/>
                 <a:cs typeface="Courier New" pitchFamily="34" charset="-120"/>
               </a:rPr>
-              <a:t>29 / 34   Smart-RUDP</a:t>
+              <a:t>29 / 35   Smart-RUDP</a:t>
             </a:r>
             <a:endParaRPr lang="en-US" sz="1000" dirty="0"/>
           </a:p>
@@ -22709,7 +22798,7 @@
                 <a:ea typeface="Courier New" pitchFamily="34" charset="-122"/>
                 <a:cs typeface="Courier New" pitchFamily="34" charset="-120"/>
               </a:rPr>
-              <a:t>3 / 34   Smart-RUDP</a:t>
+              <a:t>3 / 35   Smart-RUDP</a:t>
             </a:r>
             <a:endParaRPr lang="en-US" sz="1000" dirty="0"/>
           </a:p>
@@ -23103,7 +23192,7 @@
                 <a:ea typeface="Courier New" pitchFamily="34" charset="-122"/>
                 <a:cs typeface="Courier New" pitchFamily="34" charset="-120"/>
               </a:rPr>
-              <a:t>30 / 34   Smart-RUDP</a:t>
+              <a:t>30 / 35   Smart-RUDP</a:t>
             </a:r>
             <a:endParaRPr lang="en-US" sz="1000" dirty="0"/>
           </a:p>
@@ -23343,7 +23432,7 @@
                 <a:ea typeface="Courier New" pitchFamily="34" charset="-122"/>
                 <a:cs typeface="Courier New" pitchFamily="34" charset="-120"/>
               </a:rPr>
-              <a:t>31 / 34   Smart-RUDP</a:t>
+              <a:t>31 / 35   Smart-RUDP</a:t>
             </a:r>
             <a:endParaRPr lang="en-US" sz="1000" dirty="0"/>
           </a:p>
@@ -25621,7 +25710,7 @@
                 <a:ea typeface="Courier New" pitchFamily="34" charset="-122"/>
                 <a:cs typeface="Courier New" pitchFamily="34" charset="-120"/>
               </a:rPr>
-              <a:t>Learnings and future work</a:t>
+              <a:t>Reality check: real kernel (tc/netem)</a:t>
             </a:r>
             <a:endParaRPr lang="en-US" sz="3000" dirty="0"/>
           </a:p>
@@ -25660,7 +25749,1966 @@
                 <a:ea typeface="Courier New" pitchFamily="34" charset="-122"/>
                 <a:cs typeface="Courier New" pitchFamily="34" charset="-120"/>
               </a:rPr>
-              <a:t>32 / 34   Smart-RUDP</a:t>
+              <a:t>32 / 35   Smart-RUDP</a:t>
+            </a:r>
+            <a:endParaRPr lang="en-US" sz="1000" dirty="0"/>
+          </a:p>
+        </p:txBody>
+      </p:sp>
+      <p:graphicFrame>
+        <p:nvGraphicFramePr>
+          <p:cNvPr id="33" name="Table 0"/>
+          <p:cNvGraphicFramePr>
+            <a:graphicFrameLocks noGrp="1"/>
+          </p:cNvGraphicFramePr>
+          <p:nvPr>
+            <p:extLst>
+              <p:ext uri="{D42A27DB-BD31-4B8C-83A1-F6EECF244321}">
+                <p14:modId xmlns:p14="http://schemas.microsoft.com/office/powerpoint/2010/main" val="1579011935"/>
+              </p:ext>
+            </p:extLst>
+          </p:nvPr>
+        </p:nvGraphicFramePr>
+        <p:xfrm>
+          <a:off x="548640" y="1188720"/>
+          <a:ext cx="7498080" cy="914400"/>
+        </p:xfrm>
+        <a:graphic>
+          <a:graphicData uri="http://schemas.openxmlformats.org/drawingml/2006/table">
+            <a:tbl>
+              <a:tblPr/>
+              <a:tblGrid>
+                <a:gridCol w="2377440"/>
+                <a:gridCol w="1097280"/>
+                <a:gridCol w="1371600"/>
+                <a:gridCol w="1280160"/>
+                <a:gridCol w="1371600"/>
+              </a:tblGrid>
+              <a:tr h="420624">
+                <a:tc>
+                  <a:txBody>
+                    <a:bodyPr/>
+                    <a:lstStyle/>
+                    <a:p>
+                      <a:pPr indent="0" marL="0">
+                        <a:buNone/>
+                      </a:pPr>
+                      <a:r>
+                        <a:rPr lang="en-US" sz="1300" b="1" dirty="0">
+                          <a:solidFill>
+                            <a:srgbClr val="0B0F14"/>
+                          </a:solidFill>
+                          <a:latin typeface="Courier New" pitchFamily="34" charset="0"/>
+                          <a:ea typeface="Courier New" pitchFamily="34" charset="-122"/>
+                          <a:cs typeface="Courier New" pitchFamily="34" charset="-120"/>
+                        </a:rPr>
+                        <a:t>Path (500 packets)</a:t>
+                      </a:r>
+                      <a:endParaRPr lang="en-US" sz="1300" dirty="0">
+                        <a:latin typeface="Courier New" charset="0"/>
+                        <a:ea typeface="Courier New" charset="0"/>
+                        <a:cs typeface="Courier New" charset="0"/>
+                      </a:endParaRPr>
+                    </a:p>
+                  </a:txBody>
+                  <a:tcPr marL="91440" marR="91440" marT="45720" marB="45720">
+                    <a:lnL w="12700" cap="flat" cmpd="sng" algn="ctr">
+                      <a:solidFill>
+                        <a:srgbClr val="2A3441"/>
+                      </a:solidFill>
+                      <a:prstDash val="solid"/>
+                      <a:round/>
+                      <a:headEnd type="none" w="med" len="med"/>
+                      <a:tailEnd type="none" w="med" len="med"/>
+                    </a:lnL>
+                    <a:lnR w="12700" cap="flat" cmpd="sng" algn="ctr">
+                      <a:solidFill>
+                        <a:srgbClr val="2A3441"/>
+                      </a:solidFill>
+                      <a:prstDash val="solid"/>
+                      <a:round/>
+                      <a:headEnd type="none" w="med" len="med"/>
+                      <a:tailEnd type="none" w="med" len="med"/>
+                    </a:lnR>
+                    <a:lnT w="12700" cap="flat" cmpd="sng" algn="ctr">
+                      <a:solidFill>
+                        <a:srgbClr val="2A3441"/>
+                      </a:solidFill>
+                      <a:prstDash val="solid"/>
+                      <a:round/>
+                      <a:headEnd type="none" w="med" len="med"/>
+                      <a:tailEnd type="none" w="med" len="med"/>
+                    </a:lnT>
+                    <a:lnB w="12700" cap="flat" cmpd="sng" algn="ctr">
+                      <a:solidFill>
+                        <a:srgbClr val="2A3441"/>
+                      </a:solidFill>
+                      <a:prstDash val="solid"/>
+                      <a:round/>
+                      <a:headEnd type="none" w="med" len="med"/>
+                      <a:tailEnd type="none" w="med" len="med"/>
+                    </a:lnB>
+                    <a:solidFill>
+                      <a:srgbClr val="39FF88"/>
+                    </a:solidFill>
+                  </a:tcPr>
+                </a:tc>
+                <a:tc>
+                  <a:txBody>
+                    <a:bodyPr/>
+                    <a:lstStyle/>
+                    <a:p>
+                      <a:pPr indent="0" marL="0">
+                        <a:buNone/>
+                      </a:pPr>
+                      <a:r>
+                        <a:rPr lang="en-US" sz="1300" b="1" dirty="0">
+                          <a:solidFill>
+                            <a:srgbClr val="0B0F14"/>
+                          </a:solidFill>
+                          <a:latin typeface="Courier New" pitchFamily="34" charset="0"/>
+                          <a:ea typeface="Courier New" pitchFamily="34" charset="-122"/>
+                          <a:cs typeface="Courier New" pitchFamily="34" charset="-120"/>
+                        </a:rPr>
+                        <a:t>TCP</a:t>
+                      </a:r>
+                      <a:endParaRPr lang="en-US" sz="1300" dirty="0">
+                        <a:latin typeface="Courier New" charset="0"/>
+                        <a:ea typeface="Courier New" charset="0"/>
+                        <a:cs typeface="Courier New" charset="0"/>
+                      </a:endParaRPr>
+                    </a:p>
+                  </a:txBody>
+                  <a:tcPr marL="91440" marR="91440" marT="45720" marB="45720">
+                    <a:lnL w="12700" cap="flat" cmpd="sng" algn="ctr">
+                      <a:solidFill>
+                        <a:srgbClr val="2A3441"/>
+                      </a:solidFill>
+                      <a:prstDash val="solid"/>
+                      <a:round/>
+                      <a:headEnd type="none" w="med" len="med"/>
+                      <a:tailEnd type="none" w="med" len="med"/>
+                    </a:lnL>
+                    <a:lnR w="12700" cap="flat" cmpd="sng" algn="ctr">
+                      <a:solidFill>
+                        <a:srgbClr val="2A3441"/>
+                      </a:solidFill>
+                      <a:prstDash val="solid"/>
+                      <a:round/>
+                      <a:headEnd type="none" w="med" len="med"/>
+                      <a:tailEnd type="none" w="med" len="med"/>
+                    </a:lnR>
+                    <a:lnT w="12700" cap="flat" cmpd="sng" algn="ctr">
+                      <a:solidFill>
+                        <a:srgbClr val="2A3441"/>
+                      </a:solidFill>
+                      <a:prstDash val="solid"/>
+                      <a:round/>
+                      <a:headEnd type="none" w="med" len="med"/>
+                      <a:tailEnd type="none" w="med" len="med"/>
+                    </a:lnT>
+                    <a:lnB w="12700" cap="flat" cmpd="sng" algn="ctr">
+                      <a:solidFill>
+                        <a:srgbClr val="2A3441"/>
+                      </a:solidFill>
+                      <a:prstDash val="solid"/>
+                      <a:round/>
+                      <a:headEnd type="none" w="med" len="med"/>
+                      <a:tailEnd type="none" w="med" len="med"/>
+                    </a:lnB>
+                    <a:solidFill>
+                      <a:srgbClr val="39FF88"/>
+                    </a:solidFill>
+                  </a:tcPr>
+                </a:tc>
+                <a:tc>
+                  <a:txBody>
+                    <a:bodyPr/>
+                    <a:lstStyle/>
+                    <a:p>
+                      <a:pPr indent="0" marL="0">
+                        <a:buNone/>
+                      </a:pPr>
+                      <a:r>
+                        <a:rPr lang="en-US" sz="1300" b="1" dirty="0">
+                          <a:solidFill>
+                            <a:srgbClr val="0B0F14"/>
+                          </a:solidFill>
+                          <a:latin typeface="Courier New" pitchFamily="34" charset="0"/>
+                          <a:ea typeface="Courier New" pitchFamily="34" charset="-122"/>
+                          <a:cs typeface="Courier New" pitchFamily="34" charset="-120"/>
+                        </a:rPr>
+                        <a:t>AIMD tuned</a:t>
+                      </a:r>
+                      <a:endParaRPr lang="en-US" sz="1300" dirty="0">
+                        <a:latin typeface="Courier New" charset="0"/>
+                        <a:ea typeface="Courier New" charset="0"/>
+                        <a:cs typeface="Courier New" charset="0"/>
+                      </a:endParaRPr>
+                    </a:p>
+                  </a:txBody>
+                  <a:tcPr marL="91440" marR="91440" marT="45720" marB="45720">
+                    <a:lnL w="12700" cap="flat" cmpd="sng" algn="ctr">
+                      <a:solidFill>
+                        <a:srgbClr val="2A3441"/>
+                      </a:solidFill>
+                      <a:prstDash val="solid"/>
+                      <a:round/>
+                      <a:headEnd type="none" w="med" len="med"/>
+                      <a:tailEnd type="none" w="med" len="med"/>
+                    </a:lnL>
+                    <a:lnR w="12700" cap="flat" cmpd="sng" algn="ctr">
+                      <a:solidFill>
+                        <a:srgbClr val="2A3441"/>
+                      </a:solidFill>
+                      <a:prstDash val="solid"/>
+                      <a:round/>
+                      <a:headEnd type="none" w="med" len="med"/>
+                      <a:tailEnd type="none" w="med" len="med"/>
+                    </a:lnR>
+                    <a:lnT w="12700" cap="flat" cmpd="sng" algn="ctr">
+                      <a:solidFill>
+                        <a:srgbClr val="2A3441"/>
+                      </a:solidFill>
+                      <a:prstDash val="solid"/>
+                      <a:round/>
+                      <a:headEnd type="none" w="med" len="med"/>
+                      <a:tailEnd type="none" w="med" len="med"/>
+                    </a:lnT>
+                    <a:lnB w="12700" cap="flat" cmpd="sng" algn="ctr">
+                      <a:solidFill>
+                        <a:srgbClr val="2A3441"/>
+                      </a:solidFill>
+                      <a:prstDash val="solid"/>
+                      <a:round/>
+                      <a:headEnd type="none" w="med" len="med"/>
+                      <a:tailEnd type="none" w="med" len="med"/>
+                    </a:lnB>
+                    <a:solidFill>
+                      <a:srgbClr val="39FF88"/>
+                    </a:solidFill>
+                  </a:tcPr>
+                </a:tc>
+                <a:tc>
+                  <a:txBody>
+                    <a:bodyPr/>
+                    <a:lstStyle/>
+                    <a:p>
+                      <a:pPr indent="0" marL="0">
+                        <a:buNone/>
+                      </a:pPr>
+                      <a:r>
+                        <a:rPr lang="en-US" sz="1300" b="1" dirty="0">
+                          <a:solidFill>
+                            <a:srgbClr val="0B0F14"/>
+                          </a:solidFill>
+                          <a:latin typeface="Courier New" pitchFamily="34" charset="0"/>
+                          <a:ea typeface="Courier New" pitchFamily="34" charset="-122"/>
+                          <a:cs typeface="Courier New" pitchFamily="34" charset="-120"/>
+                        </a:rPr>
+                        <a:t>Neural</a:t>
+                      </a:r>
+                      <a:endParaRPr lang="en-US" sz="1300" dirty="0">
+                        <a:latin typeface="Courier New" charset="0"/>
+                        <a:ea typeface="Courier New" charset="0"/>
+                        <a:cs typeface="Courier New" charset="0"/>
+                      </a:endParaRPr>
+                    </a:p>
+                  </a:txBody>
+                  <a:tcPr marL="91440" marR="91440" marT="45720" marB="45720">
+                    <a:lnL w="12700" cap="flat" cmpd="sng" algn="ctr">
+                      <a:solidFill>
+                        <a:srgbClr val="2A3441"/>
+                      </a:solidFill>
+                      <a:prstDash val="solid"/>
+                      <a:round/>
+                      <a:headEnd type="none" w="med" len="med"/>
+                      <a:tailEnd type="none" w="med" len="med"/>
+                    </a:lnL>
+                    <a:lnR w="12700" cap="flat" cmpd="sng" algn="ctr">
+                      <a:solidFill>
+                        <a:srgbClr val="2A3441"/>
+                      </a:solidFill>
+                      <a:prstDash val="solid"/>
+                      <a:round/>
+                      <a:headEnd type="none" w="med" len="med"/>
+                      <a:tailEnd type="none" w="med" len="med"/>
+                    </a:lnR>
+                    <a:lnT w="12700" cap="flat" cmpd="sng" algn="ctr">
+                      <a:solidFill>
+                        <a:srgbClr val="2A3441"/>
+                      </a:solidFill>
+                      <a:prstDash val="solid"/>
+                      <a:round/>
+                      <a:headEnd type="none" w="med" len="med"/>
+                      <a:tailEnd type="none" w="med" len="med"/>
+                    </a:lnT>
+                    <a:lnB w="12700" cap="flat" cmpd="sng" algn="ctr">
+                      <a:solidFill>
+                        <a:srgbClr val="2A3441"/>
+                      </a:solidFill>
+                      <a:prstDash val="solid"/>
+                      <a:round/>
+                      <a:headEnd type="none" w="med" len="med"/>
+                      <a:tailEnd type="none" w="med" len="med"/>
+                    </a:lnB>
+                    <a:solidFill>
+                      <a:srgbClr val="39FF88"/>
+                    </a:solidFill>
+                  </a:tcPr>
+                </a:tc>
+                <a:tc>
+                  <a:txBody>
+                    <a:bodyPr/>
+                    <a:lstStyle/>
+                    <a:p>
+                      <a:pPr indent="0" marL="0">
+                        <a:buNone/>
+                      </a:pPr>
+                      <a:r>
+                        <a:rPr lang="en-US" sz="1300" b="1" dirty="0">
+                          <a:solidFill>
+                            <a:srgbClr val="0B0F14"/>
+                          </a:solidFill>
+                          <a:latin typeface="Courier New" pitchFamily="34" charset="0"/>
+                          <a:ea typeface="Courier New" pitchFamily="34" charset="-122"/>
+                          <a:cs typeface="Courier New" pitchFamily="34" charset="-120"/>
+                        </a:rPr>
+                        <a:t>vs AIMD</a:t>
+                      </a:r>
+                      <a:endParaRPr lang="en-US" sz="1300" dirty="0">
+                        <a:latin typeface="Courier New" charset="0"/>
+                        <a:ea typeface="Courier New" charset="0"/>
+                        <a:cs typeface="Courier New" charset="0"/>
+                      </a:endParaRPr>
+                    </a:p>
+                  </a:txBody>
+                  <a:tcPr marL="91440" marR="91440" marT="45720" marB="45720">
+                    <a:lnL w="12700" cap="flat" cmpd="sng" algn="ctr">
+                      <a:solidFill>
+                        <a:srgbClr val="2A3441"/>
+                      </a:solidFill>
+                      <a:prstDash val="solid"/>
+                      <a:round/>
+                      <a:headEnd type="none" w="med" len="med"/>
+                      <a:tailEnd type="none" w="med" len="med"/>
+                    </a:lnL>
+                    <a:lnR w="12700" cap="flat" cmpd="sng" algn="ctr">
+                      <a:solidFill>
+                        <a:srgbClr val="2A3441"/>
+                      </a:solidFill>
+                      <a:prstDash val="solid"/>
+                      <a:round/>
+                      <a:headEnd type="none" w="med" len="med"/>
+                      <a:tailEnd type="none" w="med" len="med"/>
+                    </a:lnR>
+                    <a:lnT w="12700" cap="flat" cmpd="sng" algn="ctr">
+                      <a:solidFill>
+                        <a:srgbClr val="2A3441"/>
+                      </a:solidFill>
+                      <a:prstDash val="solid"/>
+                      <a:round/>
+                      <a:headEnd type="none" w="med" len="med"/>
+                      <a:tailEnd type="none" w="med" len="med"/>
+                    </a:lnT>
+                    <a:lnB w="12700" cap="flat" cmpd="sng" algn="ctr">
+                      <a:solidFill>
+                        <a:srgbClr val="2A3441"/>
+                      </a:solidFill>
+                      <a:prstDash val="solid"/>
+                      <a:round/>
+                      <a:headEnd type="none" w="med" len="med"/>
+                      <a:tailEnd type="none" w="med" len="med"/>
+                    </a:lnB>
+                    <a:solidFill>
+                      <a:srgbClr val="39FF88"/>
+                    </a:solidFill>
+                  </a:tcPr>
+                </a:tc>
+              </a:tr>
+              <a:tr h="420624">
+                <a:tc>
+                  <a:txBody>
+                    <a:bodyPr/>
+                    <a:lstStyle/>
+                    <a:p>
+                      <a:pPr indent="0" marL="0">
+                        <a:buNone/>
+                      </a:pPr>
+                      <a:r>
+                        <a:rPr lang="en-US" sz="1300" dirty="0">
+                          <a:solidFill>
+                            <a:srgbClr val="E6EDF3"/>
+                          </a:solidFill>
+                          <a:latin typeface="Calibri" pitchFamily="34" charset="0"/>
+                          <a:ea typeface="Calibri" pitchFamily="34" charset="-122"/>
+                          <a:cs typeface="Calibri" pitchFamily="34" charset="-120"/>
+                        </a:rPr>
+                        <a:t>Lossy, 2% loss</a:t>
+                      </a:r>
+                      <a:endParaRPr lang="en-US" sz="1300" dirty="0">
+                        <a:latin typeface="Calibri" charset="0"/>
+                        <a:ea typeface="Calibri" charset="0"/>
+                        <a:cs typeface="Calibri" charset="0"/>
+                      </a:endParaRPr>
+                    </a:p>
+                  </a:txBody>
+                  <a:tcPr marL="91440" marR="91440" marT="45720" marB="45720">
+                    <a:lnL w="12700" cap="flat" cmpd="sng" algn="ctr">
+                      <a:solidFill>
+                        <a:srgbClr val="2A3441"/>
+                      </a:solidFill>
+                      <a:prstDash val="solid"/>
+                      <a:round/>
+                      <a:headEnd type="none" w="med" len="med"/>
+                      <a:tailEnd type="none" w="med" len="med"/>
+                    </a:lnL>
+                    <a:lnR w="12700" cap="flat" cmpd="sng" algn="ctr">
+                      <a:solidFill>
+                        <a:srgbClr val="2A3441"/>
+                      </a:solidFill>
+                      <a:prstDash val="solid"/>
+                      <a:round/>
+                      <a:headEnd type="none" w="med" len="med"/>
+                      <a:tailEnd type="none" w="med" len="med"/>
+                    </a:lnR>
+                    <a:lnT w="12700" cap="flat" cmpd="sng" algn="ctr">
+                      <a:solidFill>
+                        <a:srgbClr val="2A3441"/>
+                      </a:solidFill>
+                      <a:prstDash val="solid"/>
+                      <a:round/>
+                      <a:headEnd type="none" w="med" len="med"/>
+                      <a:tailEnd type="none" w="med" len="med"/>
+                    </a:lnT>
+                    <a:lnB w="12700" cap="flat" cmpd="sng" algn="ctr">
+                      <a:solidFill>
+                        <a:srgbClr val="2A3441"/>
+                      </a:solidFill>
+                      <a:prstDash val="solid"/>
+                      <a:round/>
+                      <a:headEnd type="none" w="med" len="med"/>
+                      <a:tailEnd type="none" w="med" len="med"/>
+                    </a:lnB>
+                    <a:solidFill>
+                      <a:srgbClr val="141B24"/>
+                    </a:solidFill>
+                  </a:tcPr>
+                </a:tc>
+                <a:tc>
+                  <a:txBody>
+                    <a:bodyPr/>
+                    <a:lstStyle/>
+                    <a:p>
+                      <a:pPr indent="0" marL="0">
+                        <a:buNone/>
+                      </a:pPr>
+                      <a:r>
+                        <a:rPr lang="en-US" sz="1300" dirty="0">
+                          <a:solidFill>
+                            <a:srgbClr val="E6EDF3"/>
+                          </a:solidFill>
+                          <a:latin typeface="Calibri" pitchFamily="34" charset="0"/>
+                          <a:ea typeface="Calibri" pitchFamily="34" charset="-122"/>
+                          <a:cs typeface="Calibri" pitchFamily="34" charset="-120"/>
+                        </a:rPr>
+                        <a:t>0.58 s</a:t>
+                      </a:r>
+                      <a:endParaRPr lang="en-US" sz="1300" dirty="0">
+                        <a:latin typeface="Calibri" charset="0"/>
+                        <a:ea typeface="Calibri" charset="0"/>
+                        <a:cs typeface="Calibri" charset="0"/>
+                      </a:endParaRPr>
+                    </a:p>
+                  </a:txBody>
+                  <a:tcPr marL="91440" marR="91440" marT="45720" marB="45720">
+                    <a:lnL w="12700" cap="flat" cmpd="sng" algn="ctr">
+                      <a:solidFill>
+                        <a:srgbClr val="2A3441"/>
+                      </a:solidFill>
+                      <a:prstDash val="solid"/>
+                      <a:round/>
+                      <a:headEnd type="none" w="med" len="med"/>
+                      <a:tailEnd type="none" w="med" len="med"/>
+                    </a:lnL>
+                    <a:lnR w="12700" cap="flat" cmpd="sng" algn="ctr">
+                      <a:solidFill>
+                        <a:srgbClr val="2A3441"/>
+                      </a:solidFill>
+                      <a:prstDash val="solid"/>
+                      <a:round/>
+                      <a:headEnd type="none" w="med" len="med"/>
+                      <a:tailEnd type="none" w="med" len="med"/>
+                    </a:lnR>
+                    <a:lnT w="12700" cap="flat" cmpd="sng" algn="ctr">
+                      <a:solidFill>
+                        <a:srgbClr val="2A3441"/>
+                      </a:solidFill>
+                      <a:prstDash val="solid"/>
+                      <a:round/>
+                      <a:headEnd type="none" w="med" len="med"/>
+                      <a:tailEnd type="none" w="med" len="med"/>
+                    </a:lnT>
+                    <a:lnB w="12700" cap="flat" cmpd="sng" algn="ctr">
+                      <a:solidFill>
+                        <a:srgbClr val="2A3441"/>
+                      </a:solidFill>
+                      <a:prstDash val="solid"/>
+                      <a:round/>
+                      <a:headEnd type="none" w="med" len="med"/>
+                      <a:tailEnd type="none" w="med" len="med"/>
+                    </a:lnB>
+                    <a:solidFill>
+                      <a:srgbClr val="141B24"/>
+                    </a:solidFill>
+                  </a:tcPr>
+                </a:tc>
+                <a:tc>
+                  <a:txBody>
+                    <a:bodyPr/>
+                    <a:lstStyle/>
+                    <a:p>
+                      <a:pPr indent="0" marL="0">
+                        <a:buNone/>
+                      </a:pPr>
+                      <a:r>
+                        <a:rPr lang="en-US" sz="1300" dirty="0">
+                          <a:solidFill>
+                            <a:srgbClr val="E6EDF3"/>
+                          </a:solidFill>
+                          <a:latin typeface="Calibri" pitchFamily="34" charset="0"/>
+                          <a:ea typeface="Calibri" pitchFamily="34" charset="-122"/>
+                          <a:cs typeface="Calibri" pitchFamily="34" charset="-120"/>
+                        </a:rPr>
+                        <a:t>4.68 s</a:t>
+                      </a:r>
+                      <a:endParaRPr lang="en-US" sz="1300" dirty="0">
+                        <a:latin typeface="Calibri" charset="0"/>
+                        <a:ea typeface="Calibri" charset="0"/>
+                        <a:cs typeface="Calibri" charset="0"/>
+                      </a:endParaRPr>
+                    </a:p>
+                  </a:txBody>
+                  <a:tcPr marL="91440" marR="91440" marT="45720" marB="45720">
+                    <a:lnL w="12700" cap="flat" cmpd="sng" algn="ctr">
+                      <a:solidFill>
+                        <a:srgbClr val="2A3441"/>
+                      </a:solidFill>
+                      <a:prstDash val="solid"/>
+                      <a:round/>
+                      <a:headEnd type="none" w="med" len="med"/>
+                      <a:tailEnd type="none" w="med" len="med"/>
+                    </a:lnL>
+                    <a:lnR w="12700" cap="flat" cmpd="sng" algn="ctr">
+                      <a:solidFill>
+                        <a:srgbClr val="2A3441"/>
+                      </a:solidFill>
+                      <a:prstDash val="solid"/>
+                      <a:round/>
+                      <a:headEnd type="none" w="med" len="med"/>
+                      <a:tailEnd type="none" w="med" len="med"/>
+                    </a:lnR>
+                    <a:lnT w="12700" cap="flat" cmpd="sng" algn="ctr">
+                      <a:solidFill>
+                        <a:srgbClr val="2A3441"/>
+                      </a:solidFill>
+                      <a:prstDash val="solid"/>
+                      <a:round/>
+                      <a:headEnd type="none" w="med" len="med"/>
+                      <a:tailEnd type="none" w="med" len="med"/>
+                    </a:lnT>
+                    <a:lnB w="12700" cap="flat" cmpd="sng" algn="ctr">
+                      <a:solidFill>
+                        <a:srgbClr val="2A3441"/>
+                      </a:solidFill>
+                      <a:prstDash val="solid"/>
+                      <a:round/>
+                      <a:headEnd type="none" w="med" len="med"/>
+                      <a:tailEnd type="none" w="med" len="med"/>
+                    </a:lnB>
+                    <a:solidFill>
+                      <a:srgbClr val="141B24"/>
+                    </a:solidFill>
+                  </a:tcPr>
+                </a:tc>
+                <a:tc>
+                  <a:txBody>
+                    <a:bodyPr/>
+                    <a:lstStyle/>
+                    <a:p>
+                      <a:pPr indent="0" marL="0">
+                        <a:buNone/>
+                      </a:pPr>
+                      <a:r>
+                        <a:rPr lang="en-US" sz="1300" dirty="0">
+                          <a:solidFill>
+                            <a:srgbClr val="E6EDF3"/>
+                          </a:solidFill>
+                          <a:latin typeface="Calibri" pitchFamily="34" charset="0"/>
+                          <a:ea typeface="Calibri" pitchFamily="34" charset="-122"/>
+                          <a:cs typeface="Calibri" pitchFamily="34" charset="-120"/>
+                        </a:rPr>
+                        <a:t>1.85 s</a:t>
+                      </a:r>
+                      <a:endParaRPr lang="en-US" sz="1300" dirty="0">
+                        <a:latin typeface="Calibri" charset="0"/>
+                        <a:ea typeface="Calibri" charset="0"/>
+                        <a:cs typeface="Calibri" charset="0"/>
+                      </a:endParaRPr>
+                    </a:p>
+                  </a:txBody>
+                  <a:tcPr marL="91440" marR="91440" marT="45720" marB="45720">
+                    <a:lnL w="12700" cap="flat" cmpd="sng" algn="ctr">
+                      <a:solidFill>
+                        <a:srgbClr val="2A3441"/>
+                      </a:solidFill>
+                      <a:prstDash val="solid"/>
+                      <a:round/>
+                      <a:headEnd type="none" w="med" len="med"/>
+                      <a:tailEnd type="none" w="med" len="med"/>
+                    </a:lnL>
+                    <a:lnR w="12700" cap="flat" cmpd="sng" algn="ctr">
+                      <a:solidFill>
+                        <a:srgbClr val="2A3441"/>
+                      </a:solidFill>
+                      <a:prstDash val="solid"/>
+                      <a:round/>
+                      <a:headEnd type="none" w="med" len="med"/>
+                      <a:tailEnd type="none" w="med" len="med"/>
+                    </a:lnR>
+                    <a:lnT w="12700" cap="flat" cmpd="sng" algn="ctr">
+                      <a:solidFill>
+                        <a:srgbClr val="2A3441"/>
+                      </a:solidFill>
+                      <a:prstDash val="solid"/>
+                      <a:round/>
+                      <a:headEnd type="none" w="med" len="med"/>
+                      <a:tailEnd type="none" w="med" len="med"/>
+                    </a:lnT>
+                    <a:lnB w="12700" cap="flat" cmpd="sng" algn="ctr">
+                      <a:solidFill>
+                        <a:srgbClr val="2A3441"/>
+                      </a:solidFill>
+                      <a:prstDash val="solid"/>
+                      <a:round/>
+                      <a:headEnd type="none" w="med" len="med"/>
+                      <a:tailEnd type="none" w="med" len="med"/>
+                    </a:lnB>
+                    <a:solidFill>
+                      <a:srgbClr val="141B24"/>
+                    </a:solidFill>
+                  </a:tcPr>
+                </a:tc>
+                <a:tc>
+                  <a:txBody>
+                    <a:bodyPr/>
+                    <a:lstStyle/>
+                    <a:p>
+                      <a:pPr indent="0" marL="0">
+                        <a:buNone/>
+                      </a:pPr>
+                      <a:r>
+                        <a:rPr lang="en-US" sz="1300" dirty="0">
+                          <a:solidFill>
+                            <a:srgbClr val="E6EDF3"/>
+                          </a:solidFill>
+                          <a:latin typeface="Calibri" pitchFamily="34" charset="0"/>
+                          <a:ea typeface="Calibri" pitchFamily="34" charset="-122"/>
+                          <a:cs typeface="Calibri" pitchFamily="34" charset="-120"/>
+                        </a:rPr>
+                        <a:t>-61%</a:t>
+                      </a:r>
+                      <a:endParaRPr lang="en-US" sz="1300" dirty="0">
+                        <a:latin typeface="Calibri" charset="0"/>
+                        <a:ea typeface="Calibri" charset="0"/>
+                        <a:cs typeface="Calibri" charset="0"/>
+                      </a:endParaRPr>
+                    </a:p>
+                  </a:txBody>
+                  <a:tcPr marL="91440" marR="91440" marT="45720" marB="45720">
+                    <a:lnL w="12700" cap="flat" cmpd="sng" algn="ctr">
+                      <a:solidFill>
+                        <a:srgbClr val="2A3441"/>
+                      </a:solidFill>
+                      <a:prstDash val="solid"/>
+                      <a:round/>
+                      <a:headEnd type="none" w="med" len="med"/>
+                      <a:tailEnd type="none" w="med" len="med"/>
+                    </a:lnL>
+                    <a:lnR w="12700" cap="flat" cmpd="sng" algn="ctr">
+                      <a:solidFill>
+                        <a:srgbClr val="2A3441"/>
+                      </a:solidFill>
+                      <a:prstDash val="solid"/>
+                      <a:round/>
+                      <a:headEnd type="none" w="med" len="med"/>
+                      <a:tailEnd type="none" w="med" len="med"/>
+                    </a:lnR>
+                    <a:lnT w="12700" cap="flat" cmpd="sng" algn="ctr">
+                      <a:solidFill>
+                        <a:srgbClr val="2A3441"/>
+                      </a:solidFill>
+                      <a:prstDash val="solid"/>
+                      <a:round/>
+                      <a:headEnd type="none" w="med" len="med"/>
+                      <a:tailEnd type="none" w="med" len="med"/>
+                    </a:lnT>
+                    <a:lnB w="12700" cap="flat" cmpd="sng" algn="ctr">
+                      <a:solidFill>
+                        <a:srgbClr val="2A3441"/>
+                      </a:solidFill>
+                      <a:prstDash val="solid"/>
+                      <a:round/>
+                      <a:headEnd type="none" w="med" len="med"/>
+                      <a:tailEnd type="none" w="med" len="med"/>
+                    </a:lnB>
+                    <a:solidFill>
+                      <a:srgbClr val="141B24"/>
+                    </a:solidFill>
+                  </a:tcPr>
+                </a:tc>
+              </a:tr>
+              <a:tr h="420624">
+                <a:tc>
+                  <a:txBody>
+                    <a:bodyPr/>
+                    <a:lstStyle/>
+                    <a:p>
+                      <a:pPr indent="0" marL="0">
+                        <a:buNone/>
+                      </a:pPr>
+                      <a:r>
+                        <a:rPr lang="en-US" sz="1300" dirty="0">
+                          <a:solidFill>
+                            <a:srgbClr val="E6EDF3"/>
+                          </a:solidFill>
+                          <a:latin typeface="Calibri" pitchFamily="34" charset="0"/>
+                          <a:ea typeface="Calibri" pitchFamily="34" charset="-122"/>
+                          <a:cs typeface="Calibri" pitchFamily="34" charset="-120"/>
+                        </a:rPr>
+                        <a:t>5G-like</a:t>
+                      </a:r>
+                      <a:endParaRPr lang="en-US" sz="1300" dirty="0">
+                        <a:latin typeface="Calibri" charset="0"/>
+                        <a:ea typeface="Calibri" charset="0"/>
+                        <a:cs typeface="Calibri" charset="0"/>
+                      </a:endParaRPr>
+                    </a:p>
+                  </a:txBody>
+                  <a:tcPr marL="91440" marR="91440" marT="45720" marB="45720">
+                    <a:lnL w="12700" cap="flat" cmpd="sng" algn="ctr">
+                      <a:solidFill>
+                        <a:srgbClr val="2A3441"/>
+                      </a:solidFill>
+                      <a:prstDash val="solid"/>
+                      <a:round/>
+                      <a:headEnd type="none" w="med" len="med"/>
+                      <a:tailEnd type="none" w="med" len="med"/>
+                    </a:lnL>
+                    <a:lnR w="12700" cap="flat" cmpd="sng" algn="ctr">
+                      <a:solidFill>
+                        <a:srgbClr val="2A3441"/>
+                      </a:solidFill>
+                      <a:prstDash val="solid"/>
+                      <a:round/>
+                      <a:headEnd type="none" w="med" len="med"/>
+                      <a:tailEnd type="none" w="med" len="med"/>
+                    </a:lnR>
+                    <a:lnT w="12700" cap="flat" cmpd="sng" algn="ctr">
+                      <a:solidFill>
+                        <a:srgbClr val="2A3441"/>
+                      </a:solidFill>
+                      <a:prstDash val="solid"/>
+                      <a:round/>
+                      <a:headEnd type="none" w="med" len="med"/>
+                      <a:tailEnd type="none" w="med" len="med"/>
+                    </a:lnT>
+                    <a:lnB w="12700" cap="flat" cmpd="sng" algn="ctr">
+                      <a:solidFill>
+                        <a:srgbClr val="2A3441"/>
+                      </a:solidFill>
+                      <a:prstDash val="solid"/>
+                      <a:round/>
+                      <a:headEnd type="none" w="med" len="med"/>
+                      <a:tailEnd type="none" w="med" len="med"/>
+                    </a:lnB>
+                    <a:solidFill>
+                      <a:srgbClr val="141B24"/>
+                    </a:solidFill>
+                  </a:tcPr>
+                </a:tc>
+                <a:tc>
+                  <a:txBody>
+                    <a:bodyPr/>
+                    <a:lstStyle/>
+                    <a:p>
+                      <a:pPr indent="0" marL="0">
+                        <a:buNone/>
+                      </a:pPr>
+                      <a:r>
+                        <a:rPr lang="en-US" sz="1300" dirty="0">
+                          <a:solidFill>
+                            <a:srgbClr val="E6EDF3"/>
+                          </a:solidFill>
+                          <a:latin typeface="Calibri" pitchFamily="34" charset="0"/>
+                          <a:ea typeface="Calibri" pitchFamily="34" charset="-122"/>
+                          <a:cs typeface="Calibri" pitchFamily="34" charset="-120"/>
+                        </a:rPr>
+                        <a:t>0.23 s</a:t>
+                      </a:r>
+                      <a:endParaRPr lang="en-US" sz="1300" dirty="0">
+                        <a:latin typeface="Calibri" charset="0"/>
+                        <a:ea typeface="Calibri" charset="0"/>
+                        <a:cs typeface="Calibri" charset="0"/>
+                      </a:endParaRPr>
+                    </a:p>
+                  </a:txBody>
+                  <a:tcPr marL="91440" marR="91440" marT="45720" marB="45720">
+                    <a:lnL w="12700" cap="flat" cmpd="sng" algn="ctr">
+                      <a:solidFill>
+                        <a:srgbClr val="2A3441"/>
+                      </a:solidFill>
+                      <a:prstDash val="solid"/>
+                      <a:round/>
+                      <a:headEnd type="none" w="med" len="med"/>
+                      <a:tailEnd type="none" w="med" len="med"/>
+                    </a:lnL>
+                    <a:lnR w="12700" cap="flat" cmpd="sng" algn="ctr">
+                      <a:solidFill>
+                        <a:srgbClr val="2A3441"/>
+                      </a:solidFill>
+                      <a:prstDash val="solid"/>
+                      <a:round/>
+                      <a:headEnd type="none" w="med" len="med"/>
+                      <a:tailEnd type="none" w="med" len="med"/>
+                    </a:lnR>
+                    <a:lnT w="12700" cap="flat" cmpd="sng" algn="ctr">
+                      <a:solidFill>
+                        <a:srgbClr val="2A3441"/>
+                      </a:solidFill>
+                      <a:prstDash val="solid"/>
+                      <a:round/>
+                      <a:headEnd type="none" w="med" len="med"/>
+                      <a:tailEnd type="none" w="med" len="med"/>
+                    </a:lnT>
+                    <a:lnB w="12700" cap="flat" cmpd="sng" algn="ctr">
+                      <a:solidFill>
+                        <a:srgbClr val="2A3441"/>
+                      </a:solidFill>
+                      <a:prstDash val="solid"/>
+                      <a:round/>
+                      <a:headEnd type="none" w="med" len="med"/>
+                      <a:tailEnd type="none" w="med" len="med"/>
+                    </a:lnB>
+                    <a:solidFill>
+                      <a:srgbClr val="141B24"/>
+                    </a:solidFill>
+                  </a:tcPr>
+                </a:tc>
+                <a:tc>
+                  <a:txBody>
+                    <a:bodyPr/>
+                    <a:lstStyle/>
+                    <a:p>
+                      <a:pPr indent="0" marL="0">
+                        <a:buNone/>
+                      </a:pPr>
+                      <a:r>
+                        <a:rPr lang="en-US" sz="1300" dirty="0">
+                          <a:solidFill>
+                            <a:srgbClr val="E6EDF3"/>
+                          </a:solidFill>
+                          <a:latin typeface="Calibri" pitchFamily="34" charset="0"/>
+                          <a:ea typeface="Calibri" pitchFamily="34" charset="-122"/>
+                          <a:cs typeface="Calibri" pitchFamily="34" charset="-120"/>
+                        </a:rPr>
+                        <a:t>1.26 s</a:t>
+                      </a:r>
+                      <a:endParaRPr lang="en-US" sz="1300" dirty="0">
+                        <a:latin typeface="Calibri" charset="0"/>
+                        <a:ea typeface="Calibri" charset="0"/>
+                        <a:cs typeface="Calibri" charset="0"/>
+                      </a:endParaRPr>
+                    </a:p>
+                  </a:txBody>
+                  <a:tcPr marL="91440" marR="91440" marT="45720" marB="45720">
+                    <a:lnL w="12700" cap="flat" cmpd="sng" algn="ctr">
+                      <a:solidFill>
+                        <a:srgbClr val="2A3441"/>
+                      </a:solidFill>
+                      <a:prstDash val="solid"/>
+                      <a:round/>
+                      <a:headEnd type="none" w="med" len="med"/>
+                      <a:tailEnd type="none" w="med" len="med"/>
+                    </a:lnL>
+                    <a:lnR w="12700" cap="flat" cmpd="sng" algn="ctr">
+                      <a:solidFill>
+                        <a:srgbClr val="2A3441"/>
+                      </a:solidFill>
+                      <a:prstDash val="solid"/>
+                      <a:round/>
+                      <a:headEnd type="none" w="med" len="med"/>
+                      <a:tailEnd type="none" w="med" len="med"/>
+                    </a:lnR>
+                    <a:lnT w="12700" cap="flat" cmpd="sng" algn="ctr">
+                      <a:solidFill>
+                        <a:srgbClr val="2A3441"/>
+                      </a:solidFill>
+                      <a:prstDash val="solid"/>
+                      <a:round/>
+                      <a:headEnd type="none" w="med" len="med"/>
+                      <a:tailEnd type="none" w="med" len="med"/>
+                    </a:lnT>
+                    <a:lnB w="12700" cap="flat" cmpd="sng" algn="ctr">
+                      <a:solidFill>
+                        <a:srgbClr val="2A3441"/>
+                      </a:solidFill>
+                      <a:prstDash val="solid"/>
+                      <a:round/>
+                      <a:headEnd type="none" w="med" len="med"/>
+                      <a:tailEnd type="none" w="med" len="med"/>
+                    </a:lnB>
+                    <a:solidFill>
+                      <a:srgbClr val="141B24"/>
+                    </a:solidFill>
+                  </a:tcPr>
+                </a:tc>
+                <a:tc>
+                  <a:txBody>
+                    <a:bodyPr/>
+                    <a:lstStyle/>
+                    <a:p>
+                      <a:pPr indent="0" marL="0">
+                        <a:buNone/>
+                      </a:pPr>
+                      <a:r>
+                        <a:rPr lang="en-US" sz="1300" dirty="0">
+                          <a:solidFill>
+                            <a:srgbClr val="E6EDF3"/>
+                          </a:solidFill>
+                          <a:latin typeface="Calibri" pitchFamily="34" charset="0"/>
+                          <a:ea typeface="Calibri" pitchFamily="34" charset="-122"/>
+                          <a:cs typeface="Calibri" pitchFamily="34" charset="-120"/>
+                        </a:rPr>
+                        <a:t>0.38 s</a:t>
+                      </a:r>
+                      <a:endParaRPr lang="en-US" sz="1300" dirty="0">
+                        <a:latin typeface="Calibri" charset="0"/>
+                        <a:ea typeface="Calibri" charset="0"/>
+                        <a:cs typeface="Calibri" charset="0"/>
+                      </a:endParaRPr>
+                    </a:p>
+                  </a:txBody>
+                  <a:tcPr marL="91440" marR="91440" marT="45720" marB="45720">
+                    <a:lnL w="12700" cap="flat" cmpd="sng" algn="ctr">
+                      <a:solidFill>
+                        <a:srgbClr val="2A3441"/>
+                      </a:solidFill>
+                      <a:prstDash val="solid"/>
+                      <a:round/>
+                      <a:headEnd type="none" w="med" len="med"/>
+                      <a:tailEnd type="none" w="med" len="med"/>
+                    </a:lnL>
+                    <a:lnR w="12700" cap="flat" cmpd="sng" algn="ctr">
+                      <a:solidFill>
+                        <a:srgbClr val="2A3441"/>
+                      </a:solidFill>
+                      <a:prstDash val="solid"/>
+                      <a:round/>
+                      <a:headEnd type="none" w="med" len="med"/>
+                      <a:tailEnd type="none" w="med" len="med"/>
+                    </a:lnR>
+                    <a:lnT w="12700" cap="flat" cmpd="sng" algn="ctr">
+                      <a:solidFill>
+                        <a:srgbClr val="2A3441"/>
+                      </a:solidFill>
+                      <a:prstDash val="solid"/>
+                      <a:round/>
+                      <a:headEnd type="none" w="med" len="med"/>
+                      <a:tailEnd type="none" w="med" len="med"/>
+                    </a:lnT>
+                    <a:lnB w="12700" cap="flat" cmpd="sng" algn="ctr">
+                      <a:solidFill>
+                        <a:srgbClr val="2A3441"/>
+                      </a:solidFill>
+                      <a:prstDash val="solid"/>
+                      <a:round/>
+                      <a:headEnd type="none" w="med" len="med"/>
+                      <a:tailEnd type="none" w="med" len="med"/>
+                    </a:lnB>
+                    <a:solidFill>
+                      <a:srgbClr val="141B24"/>
+                    </a:solidFill>
+                  </a:tcPr>
+                </a:tc>
+                <a:tc>
+                  <a:txBody>
+                    <a:bodyPr/>
+                    <a:lstStyle/>
+                    <a:p>
+                      <a:pPr indent="0" marL="0">
+                        <a:buNone/>
+                      </a:pPr>
+                      <a:r>
+                        <a:rPr lang="en-US" sz="1300" dirty="0">
+                          <a:solidFill>
+                            <a:srgbClr val="E6EDF3"/>
+                          </a:solidFill>
+                          <a:latin typeface="Calibri" pitchFamily="34" charset="0"/>
+                          <a:ea typeface="Calibri" pitchFamily="34" charset="-122"/>
+                          <a:cs typeface="Calibri" pitchFamily="34" charset="-120"/>
+                        </a:rPr>
+                        <a:t>-70%</a:t>
+                      </a:r>
+                      <a:endParaRPr lang="en-US" sz="1300" dirty="0">
+                        <a:latin typeface="Calibri" charset="0"/>
+                        <a:ea typeface="Calibri" charset="0"/>
+                        <a:cs typeface="Calibri" charset="0"/>
+                      </a:endParaRPr>
+                    </a:p>
+                  </a:txBody>
+                  <a:tcPr marL="91440" marR="91440" marT="45720" marB="45720">
+                    <a:lnL w="12700" cap="flat" cmpd="sng" algn="ctr">
+                      <a:solidFill>
+                        <a:srgbClr val="2A3441"/>
+                      </a:solidFill>
+                      <a:prstDash val="solid"/>
+                      <a:round/>
+                      <a:headEnd type="none" w="med" len="med"/>
+                      <a:tailEnd type="none" w="med" len="med"/>
+                    </a:lnL>
+                    <a:lnR w="12700" cap="flat" cmpd="sng" algn="ctr">
+                      <a:solidFill>
+                        <a:srgbClr val="2A3441"/>
+                      </a:solidFill>
+                      <a:prstDash val="solid"/>
+                      <a:round/>
+                      <a:headEnd type="none" w="med" len="med"/>
+                      <a:tailEnd type="none" w="med" len="med"/>
+                    </a:lnR>
+                    <a:lnT w="12700" cap="flat" cmpd="sng" algn="ctr">
+                      <a:solidFill>
+                        <a:srgbClr val="2A3441"/>
+                      </a:solidFill>
+                      <a:prstDash val="solid"/>
+                      <a:round/>
+                      <a:headEnd type="none" w="med" len="med"/>
+                      <a:tailEnd type="none" w="med" len="med"/>
+                    </a:lnT>
+                    <a:lnB w="12700" cap="flat" cmpd="sng" algn="ctr">
+                      <a:solidFill>
+                        <a:srgbClr val="2A3441"/>
+                      </a:solidFill>
+                      <a:prstDash val="solid"/>
+                      <a:round/>
+                      <a:headEnd type="none" w="med" len="med"/>
+                      <a:tailEnd type="none" w="med" len="med"/>
+                    </a:lnB>
+                    <a:solidFill>
+                      <a:srgbClr val="141B24"/>
+                    </a:solidFill>
+                  </a:tcPr>
+                </a:tc>
+              </a:tr>
+              <a:tr h="420624">
+                <a:tc>
+                  <a:txBody>
+                    <a:bodyPr/>
+                    <a:lstStyle/>
+                    <a:p>
+                      <a:pPr indent="0" marL="0">
+                        <a:buNone/>
+                      </a:pPr>
+                      <a:r>
+                        <a:rPr lang="en-US" sz="1300" dirty="0">
+                          <a:solidFill>
+                            <a:srgbClr val="E6EDF3"/>
+                          </a:solidFill>
+                          <a:latin typeface="Calibri" pitchFamily="34" charset="0"/>
+                          <a:ea typeface="Calibri" pitchFamily="34" charset="-122"/>
+                          <a:cs typeface="Calibri" pitchFamily="34" charset="-120"/>
+                        </a:rPr>
+                        <a:t>Satellite, 150 ms</a:t>
+                      </a:r>
+                      <a:endParaRPr lang="en-US" sz="1300" dirty="0">
+                        <a:latin typeface="Calibri" charset="0"/>
+                        <a:ea typeface="Calibri" charset="0"/>
+                        <a:cs typeface="Calibri" charset="0"/>
+                      </a:endParaRPr>
+                    </a:p>
+                  </a:txBody>
+                  <a:tcPr marL="91440" marR="91440" marT="45720" marB="45720">
+                    <a:lnL w="12700" cap="flat" cmpd="sng" algn="ctr">
+                      <a:solidFill>
+                        <a:srgbClr val="2A3441"/>
+                      </a:solidFill>
+                      <a:prstDash val="solid"/>
+                      <a:round/>
+                      <a:headEnd type="none" w="med" len="med"/>
+                      <a:tailEnd type="none" w="med" len="med"/>
+                    </a:lnL>
+                    <a:lnR w="12700" cap="flat" cmpd="sng" algn="ctr">
+                      <a:solidFill>
+                        <a:srgbClr val="2A3441"/>
+                      </a:solidFill>
+                      <a:prstDash val="solid"/>
+                      <a:round/>
+                      <a:headEnd type="none" w="med" len="med"/>
+                      <a:tailEnd type="none" w="med" len="med"/>
+                    </a:lnR>
+                    <a:lnT w="12700" cap="flat" cmpd="sng" algn="ctr">
+                      <a:solidFill>
+                        <a:srgbClr val="2A3441"/>
+                      </a:solidFill>
+                      <a:prstDash val="solid"/>
+                      <a:round/>
+                      <a:headEnd type="none" w="med" len="med"/>
+                      <a:tailEnd type="none" w="med" len="med"/>
+                    </a:lnT>
+                    <a:lnB w="12700" cap="flat" cmpd="sng" algn="ctr">
+                      <a:solidFill>
+                        <a:srgbClr val="2A3441"/>
+                      </a:solidFill>
+                      <a:prstDash val="solid"/>
+                      <a:round/>
+                      <a:headEnd type="none" w="med" len="med"/>
+                      <a:tailEnd type="none" w="med" len="med"/>
+                    </a:lnB>
+                    <a:solidFill>
+                      <a:srgbClr val="141B24"/>
+                    </a:solidFill>
+                  </a:tcPr>
+                </a:tc>
+                <a:tc>
+                  <a:txBody>
+                    <a:bodyPr/>
+                    <a:lstStyle/>
+                    <a:p>
+                      <a:pPr indent="0" marL="0">
+                        <a:buNone/>
+                      </a:pPr>
+                      <a:r>
+                        <a:rPr lang="en-US" sz="1300" dirty="0">
+                          <a:solidFill>
+                            <a:srgbClr val="E6EDF3"/>
+                          </a:solidFill>
+                          <a:latin typeface="Calibri" pitchFamily="34" charset="0"/>
+                          <a:ea typeface="Calibri" pitchFamily="34" charset="-122"/>
+                          <a:cs typeface="Calibri" pitchFamily="34" charset="-120"/>
+                        </a:rPr>
+                        <a:t>2.10 s</a:t>
+                      </a:r>
+                      <a:endParaRPr lang="en-US" sz="1300" dirty="0">
+                        <a:latin typeface="Calibri" charset="0"/>
+                        <a:ea typeface="Calibri" charset="0"/>
+                        <a:cs typeface="Calibri" charset="0"/>
+                      </a:endParaRPr>
+                    </a:p>
+                  </a:txBody>
+                  <a:tcPr marL="91440" marR="91440" marT="45720" marB="45720">
+                    <a:lnL w="12700" cap="flat" cmpd="sng" algn="ctr">
+                      <a:solidFill>
+                        <a:srgbClr val="2A3441"/>
+                      </a:solidFill>
+                      <a:prstDash val="solid"/>
+                      <a:round/>
+                      <a:headEnd type="none" w="med" len="med"/>
+                      <a:tailEnd type="none" w="med" len="med"/>
+                    </a:lnL>
+                    <a:lnR w="12700" cap="flat" cmpd="sng" algn="ctr">
+                      <a:solidFill>
+                        <a:srgbClr val="2A3441"/>
+                      </a:solidFill>
+                      <a:prstDash val="solid"/>
+                      <a:round/>
+                      <a:headEnd type="none" w="med" len="med"/>
+                      <a:tailEnd type="none" w="med" len="med"/>
+                    </a:lnR>
+                    <a:lnT w="12700" cap="flat" cmpd="sng" algn="ctr">
+                      <a:solidFill>
+                        <a:srgbClr val="2A3441"/>
+                      </a:solidFill>
+                      <a:prstDash val="solid"/>
+                      <a:round/>
+                      <a:headEnd type="none" w="med" len="med"/>
+                      <a:tailEnd type="none" w="med" len="med"/>
+                    </a:lnT>
+                    <a:lnB w="12700" cap="flat" cmpd="sng" algn="ctr">
+                      <a:solidFill>
+                        <a:srgbClr val="2A3441"/>
+                      </a:solidFill>
+                      <a:prstDash val="solid"/>
+                      <a:round/>
+                      <a:headEnd type="none" w="med" len="med"/>
+                      <a:tailEnd type="none" w="med" len="med"/>
+                    </a:lnB>
+                    <a:solidFill>
+                      <a:srgbClr val="141B24"/>
+                    </a:solidFill>
+                  </a:tcPr>
+                </a:tc>
+                <a:tc>
+                  <a:txBody>
+                    <a:bodyPr/>
+                    <a:lstStyle/>
+                    <a:p>
+                      <a:pPr indent="0" marL="0">
+                        <a:buNone/>
+                      </a:pPr>
+                      <a:r>
+                        <a:rPr lang="en-US" sz="1300" dirty="0">
+                          <a:solidFill>
+                            <a:srgbClr val="E6EDF3"/>
+                          </a:solidFill>
+                          <a:latin typeface="Calibri" pitchFamily="34" charset="0"/>
+                          <a:ea typeface="Calibri" pitchFamily="34" charset="-122"/>
+                          <a:cs typeface="Calibri" pitchFamily="34" charset="-120"/>
+                        </a:rPr>
+                        <a:t>18.9 s</a:t>
+                      </a:r>
+                      <a:endParaRPr lang="en-US" sz="1300" dirty="0">
+                        <a:latin typeface="Calibri" charset="0"/>
+                        <a:ea typeface="Calibri" charset="0"/>
+                        <a:cs typeface="Calibri" charset="0"/>
+                      </a:endParaRPr>
+                    </a:p>
+                  </a:txBody>
+                  <a:tcPr marL="91440" marR="91440" marT="45720" marB="45720">
+                    <a:lnL w="12700" cap="flat" cmpd="sng" algn="ctr">
+                      <a:solidFill>
+                        <a:srgbClr val="2A3441"/>
+                      </a:solidFill>
+                      <a:prstDash val="solid"/>
+                      <a:round/>
+                      <a:headEnd type="none" w="med" len="med"/>
+                      <a:tailEnd type="none" w="med" len="med"/>
+                    </a:lnL>
+                    <a:lnR w="12700" cap="flat" cmpd="sng" algn="ctr">
+                      <a:solidFill>
+                        <a:srgbClr val="2A3441"/>
+                      </a:solidFill>
+                      <a:prstDash val="solid"/>
+                      <a:round/>
+                      <a:headEnd type="none" w="med" len="med"/>
+                      <a:tailEnd type="none" w="med" len="med"/>
+                    </a:lnR>
+                    <a:lnT w="12700" cap="flat" cmpd="sng" algn="ctr">
+                      <a:solidFill>
+                        <a:srgbClr val="2A3441"/>
+                      </a:solidFill>
+                      <a:prstDash val="solid"/>
+                      <a:round/>
+                      <a:headEnd type="none" w="med" len="med"/>
+                      <a:tailEnd type="none" w="med" len="med"/>
+                    </a:lnT>
+                    <a:lnB w="12700" cap="flat" cmpd="sng" algn="ctr">
+                      <a:solidFill>
+                        <a:srgbClr val="2A3441"/>
+                      </a:solidFill>
+                      <a:prstDash val="solid"/>
+                      <a:round/>
+                      <a:headEnd type="none" w="med" len="med"/>
+                      <a:tailEnd type="none" w="med" len="med"/>
+                    </a:lnB>
+                    <a:solidFill>
+                      <a:srgbClr val="141B24"/>
+                    </a:solidFill>
+                  </a:tcPr>
+                </a:tc>
+                <a:tc>
+                  <a:txBody>
+                    <a:bodyPr/>
+                    <a:lstStyle/>
+                    <a:p>
+                      <a:pPr indent="0" marL="0">
+                        <a:buNone/>
+                      </a:pPr>
+                      <a:r>
+                        <a:rPr lang="en-US" sz="1300" dirty="0">
+                          <a:solidFill>
+                            <a:srgbClr val="E6EDF3"/>
+                          </a:solidFill>
+                          <a:latin typeface="Calibri" pitchFamily="34" charset="0"/>
+                          <a:ea typeface="Calibri" pitchFamily="34" charset="-122"/>
+                          <a:cs typeface="Calibri" pitchFamily="34" charset="-120"/>
+                        </a:rPr>
+                        <a:t>3.16 s</a:t>
+                      </a:r>
+                      <a:endParaRPr lang="en-US" sz="1300" dirty="0">
+                        <a:latin typeface="Calibri" charset="0"/>
+                        <a:ea typeface="Calibri" charset="0"/>
+                        <a:cs typeface="Calibri" charset="0"/>
+                      </a:endParaRPr>
+                    </a:p>
+                  </a:txBody>
+                  <a:tcPr marL="91440" marR="91440" marT="45720" marB="45720">
+                    <a:lnL w="12700" cap="flat" cmpd="sng" algn="ctr">
+                      <a:solidFill>
+                        <a:srgbClr val="2A3441"/>
+                      </a:solidFill>
+                      <a:prstDash val="solid"/>
+                      <a:round/>
+                      <a:headEnd type="none" w="med" len="med"/>
+                      <a:tailEnd type="none" w="med" len="med"/>
+                    </a:lnL>
+                    <a:lnR w="12700" cap="flat" cmpd="sng" algn="ctr">
+                      <a:solidFill>
+                        <a:srgbClr val="2A3441"/>
+                      </a:solidFill>
+                      <a:prstDash val="solid"/>
+                      <a:round/>
+                      <a:headEnd type="none" w="med" len="med"/>
+                      <a:tailEnd type="none" w="med" len="med"/>
+                    </a:lnR>
+                    <a:lnT w="12700" cap="flat" cmpd="sng" algn="ctr">
+                      <a:solidFill>
+                        <a:srgbClr val="2A3441"/>
+                      </a:solidFill>
+                      <a:prstDash val="solid"/>
+                      <a:round/>
+                      <a:headEnd type="none" w="med" len="med"/>
+                      <a:tailEnd type="none" w="med" len="med"/>
+                    </a:lnT>
+                    <a:lnB w="12700" cap="flat" cmpd="sng" algn="ctr">
+                      <a:solidFill>
+                        <a:srgbClr val="2A3441"/>
+                      </a:solidFill>
+                      <a:prstDash val="solid"/>
+                      <a:round/>
+                      <a:headEnd type="none" w="med" len="med"/>
+                      <a:tailEnd type="none" w="med" len="med"/>
+                    </a:lnB>
+                    <a:solidFill>
+                      <a:srgbClr val="141B24"/>
+                    </a:solidFill>
+                  </a:tcPr>
+                </a:tc>
+                <a:tc>
+                  <a:txBody>
+                    <a:bodyPr/>
+                    <a:lstStyle/>
+                    <a:p>
+                      <a:pPr indent="0" marL="0">
+                        <a:buNone/>
+                      </a:pPr>
+                      <a:r>
+                        <a:rPr lang="en-US" sz="1300" dirty="0">
+                          <a:solidFill>
+                            <a:srgbClr val="E6EDF3"/>
+                          </a:solidFill>
+                          <a:latin typeface="Calibri" pitchFamily="34" charset="0"/>
+                          <a:ea typeface="Calibri" pitchFamily="34" charset="-122"/>
+                          <a:cs typeface="Calibri" pitchFamily="34" charset="-120"/>
+                        </a:rPr>
+                        <a:t>-83%</a:t>
+                      </a:r>
+                      <a:endParaRPr lang="en-US" sz="1300" dirty="0">
+                        <a:latin typeface="Calibri" charset="0"/>
+                        <a:ea typeface="Calibri" charset="0"/>
+                        <a:cs typeface="Calibri" charset="0"/>
+                      </a:endParaRPr>
+                    </a:p>
+                  </a:txBody>
+                  <a:tcPr marL="91440" marR="91440" marT="45720" marB="45720">
+                    <a:lnL w="12700" cap="flat" cmpd="sng" algn="ctr">
+                      <a:solidFill>
+                        <a:srgbClr val="2A3441"/>
+                      </a:solidFill>
+                      <a:prstDash val="solid"/>
+                      <a:round/>
+                      <a:headEnd type="none" w="med" len="med"/>
+                      <a:tailEnd type="none" w="med" len="med"/>
+                    </a:lnL>
+                    <a:lnR w="12700" cap="flat" cmpd="sng" algn="ctr">
+                      <a:solidFill>
+                        <a:srgbClr val="2A3441"/>
+                      </a:solidFill>
+                      <a:prstDash val="solid"/>
+                      <a:round/>
+                      <a:headEnd type="none" w="med" len="med"/>
+                      <a:tailEnd type="none" w="med" len="med"/>
+                    </a:lnR>
+                    <a:lnT w="12700" cap="flat" cmpd="sng" algn="ctr">
+                      <a:solidFill>
+                        <a:srgbClr val="2A3441"/>
+                      </a:solidFill>
+                      <a:prstDash val="solid"/>
+                      <a:round/>
+                      <a:headEnd type="none" w="med" len="med"/>
+                      <a:tailEnd type="none" w="med" len="med"/>
+                    </a:lnT>
+                    <a:lnB w="12700" cap="flat" cmpd="sng" algn="ctr">
+                      <a:solidFill>
+                        <a:srgbClr val="2A3441"/>
+                      </a:solidFill>
+                      <a:prstDash val="solid"/>
+                      <a:round/>
+                      <a:headEnd type="none" w="med" len="med"/>
+                      <a:tailEnd type="none" w="med" len="med"/>
+                    </a:lnB>
+                    <a:solidFill>
+                      <a:srgbClr val="141B24"/>
+                    </a:solidFill>
+                  </a:tcPr>
+                </a:tc>
+              </a:tr>
+              <a:tr h="420624">
+                <a:tc>
+                  <a:txBody>
+                    <a:bodyPr/>
+                    <a:lstStyle/>
+                    <a:p>
+                      <a:pPr indent="0" marL="0">
+                        <a:buNone/>
+                      </a:pPr>
+                      <a:r>
+                        <a:rPr lang="en-US" sz="1300" dirty="0">
+                          <a:solidFill>
+                            <a:srgbClr val="E6EDF3"/>
+                          </a:solidFill>
+                          <a:latin typeface="Calibri" pitchFamily="34" charset="0"/>
+                          <a:ea typeface="Calibri" pitchFamily="34" charset="-122"/>
+                          <a:cs typeface="Calibri" pitchFamily="34" charset="-120"/>
+                        </a:rPr>
+                        <a:t>Reordering</a:t>
+                      </a:r>
+                      <a:endParaRPr lang="en-US" sz="1300" dirty="0">
+                        <a:latin typeface="Calibri" charset="0"/>
+                        <a:ea typeface="Calibri" charset="0"/>
+                        <a:cs typeface="Calibri" charset="0"/>
+                      </a:endParaRPr>
+                    </a:p>
+                  </a:txBody>
+                  <a:tcPr marL="91440" marR="91440" marT="45720" marB="45720">
+                    <a:lnL w="12700" cap="flat" cmpd="sng" algn="ctr">
+                      <a:solidFill>
+                        <a:srgbClr val="2A3441"/>
+                      </a:solidFill>
+                      <a:prstDash val="solid"/>
+                      <a:round/>
+                      <a:headEnd type="none" w="med" len="med"/>
+                      <a:tailEnd type="none" w="med" len="med"/>
+                    </a:lnL>
+                    <a:lnR w="12700" cap="flat" cmpd="sng" algn="ctr">
+                      <a:solidFill>
+                        <a:srgbClr val="2A3441"/>
+                      </a:solidFill>
+                      <a:prstDash val="solid"/>
+                      <a:round/>
+                      <a:headEnd type="none" w="med" len="med"/>
+                      <a:tailEnd type="none" w="med" len="med"/>
+                    </a:lnR>
+                    <a:lnT w="12700" cap="flat" cmpd="sng" algn="ctr">
+                      <a:solidFill>
+                        <a:srgbClr val="2A3441"/>
+                      </a:solidFill>
+                      <a:prstDash val="solid"/>
+                      <a:round/>
+                      <a:headEnd type="none" w="med" len="med"/>
+                      <a:tailEnd type="none" w="med" len="med"/>
+                    </a:lnT>
+                    <a:lnB w="12700" cap="flat" cmpd="sng" algn="ctr">
+                      <a:solidFill>
+                        <a:srgbClr val="2A3441"/>
+                      </a:solidFill>
+                      <a:prstDash val="solid"/>
+                      <a:round/>
+                      <a:headEnd type="none" w="med" len="med"/>
+                      <a:tailEnd type="none" w="med" len="med"/>
+                    </a:lnB>
+                    <a:solidFill>
+                      <a:srgbClr val="141B24"/>
+                    </a:solidFill>
+                  </a:tcPr>
+                </a:tc>
+                <a:tc>
+                  <a:txBody>
+                    <a:bodyPr/>
+                    <a:lstStyle/>
+                    <a:p>
+                      <a:pPr indent="0" marL="0">
+                        <a:buNone/>
+                      </a:pPr>
+                      <a:r>
+                        <a:rPr lang="en-US" sz="1300" dirty="0">
+                          <a:solidFill>
+                            <a:srgbClr val="E6EDF3"/>
+                          </a:solidFill>
+                          <a:latin typeface="Calibri" pitchFamily="34" charset="0"/>
+                          <a:ea typeface="Calibri" pitchFamily="34" charset="-122"/>
+                          <a:cs typeface="Calibri" pitchFamily="34" charset="-120"/>
+                        </a:rPr>
+                        <a:t>1.03 s</a:t>
+                      </a:r>
+                      <a:endParaRPr lang="en-US" sz="1300" dirty="0">
+                        <a:latin typeface="Calibri" charset="0"/>
+                        <a:ea typeface="Calibri" charset="0"/>
+                        <a:cs typeface="Calibri" charset="0"/>
+                      </a:endParaRPr>
+                    </a:p>
+                  </a:txBody>
+                  <a:tcPr marL="91440" marR="91440" marT="45720" marB="45720">
+                    <a:lnL w="12700" cap="flat" cmpd="sng" algn="ctr">
+                      <a:solidFill>
+                        <a:srgbClr val="2A3441"/>
+                      </a:solidFill>
+                      <a:prstDash val="solid"/>
+                      <a:round/>
+                      <a:headEnd type="none" w="med" len="med"/>
+                      <a:tailEnd type="none" w="med" len="med"/>
+                    </a:lnL>
+                    <a:lnR w="12700" cap="flat" cmpd="sng" algn="ctr">
+                      <a:solidFill>
+                        <a:srgbClr val="2A3441"/>
+                      </a:solidFill>
+                      <a:prstDash val="solid"/>
+                      <a:round/>
+                      <a:headEnd type="none" w="med" len="med"/>
+                      <a:tailEnd type="none" w="med" len="med"/>
+                    </a:lnR>
+                    <a:lnT w="12700" cap="flat" cmpd="sng" algn="ctr">
+                      <a:solidFill>
+                        <a:srgbClr val="2A3441"/>
+                      </a:solidFill>
+                      <a:prstDash val="solid"/>
+                      <a:round/>
+                      <a:headEnd type="none" w="med" len="med"/>
+                      <a:tailEnd type="none" w="med" len="med"/>
+                    </a:lnT>
+                    <a:lnB w="12700" cap="flat" cmpd="sng" algn="ctr">
+                      <a:solidFill>
+                        <a:srgbClr val="2A3441"/>
+                      </a:solidFill>
+                      <a:prstDash val="solid"/>
+                      <a:round/>
+                      <a:headEnd type="none" w="med" len="med"/>
+                      <a:tailEnd type="none" w="med" len="med"/>
+                    </a:lnB>
+                    <a:solidFill>
+                      <a:srgbClr val="141B24"/>
+                    </a:solidFill>
+                  </a:tcPr>
+                </a:tc>
+                <a:tc>
+                  <a:txBody>
+                    <a:bodyPr/>
+                    <a:lstStyle/>
+                    <a:p>
+                      <a:pPr indent="0" marL="0">
+                        <a:buNone/>
+                      </a:pPr>
+                      <a:r>
+                        <a:rPr lang="en-US" sz="1300" dirty="0">
+                          <a:solidFill>
+                            <a:srgbClr val="E6EDF3"/>
+                          </a:solidFill>
+                          <a:latin typeface="Calibri" pitchFamily="34" charset="0"/>
+                          <a:ea typeface="Calibri" pitchFamily="34" charset="-122"/>
+                          <a:cs typeface="Calibri" pitchFamily="34" charset="-120"/>
+                        </a:rPr>
+                        <a:t>2.68 s</a:t>
+                      </a:r>
+                      <a:endParaRPr lang="en-US" sz="1300" dirty="0">
+                        <a:latin typeface="Calibri" charset="0"/>
+                        <a:ea typeface="Calibri" charset="0"/>
+                        <a:cs typeface="Calibri" charset="0"/>
+                      </a:endParaRPr>
+                    </a:p>
+                  </a:txBody>
+                  <a:tcPr marL="91440" marR="91440" marT="45720" marB="45720">
+                    <a:lnL w="12700" cap="flat" cmpd="sng" algn="ctr">
+                      <a:solidFill>
+                        <a:srgbClr val="2A3441"/>
+                      </a:solidFill>
+                      <a:prstDash val="solid"/>
+                      <a:round/>
+                      <a:headEnd type="none" w="med" len="med"/>
+                      <a:tailEnd type="none" w="med" len="med"/>
+                    </a:lnL>
+                    <a:lnR w="12700" cap="flat" cmpd="sng" algn="ctr">
+                      <a:solidFill>
+                        <a:srgbClr val="2A3441"/>
+                      </a:solidFill>
+                      <a:prstDash val="solid"/>
+                      <a:round/>
+                      <a:headEnd type="none" w="med" len="med"/>
+                      <a:tailEnd type="none" w="med" len="med"/>
+                    </a:lnR>
+                    <a:lnT w="12700" cap="flat" cmpd="sng" algn="ctr">
+                      <a:solidFill>
+                        <a:srgbClr val="2A3441"/>
+                      </a:solidFill>
+                      <a:prstDash val="solid"/>
+                      <a:round/>
+                      <a:headEnd type="none" w="med" len="med"/>
+                      <a:tailEnd type="none" w="med" len="med"/>
+                    </a:lnT>
+                    <a:lnB w="12700" cap="flat" cmpd="sng" algn="ctr">
+                      <a:solidFill>
+                        <a:srgbClr val="2A3441"/>
+                      </a:solidFill>
+                      <a:prstDash val="solid"/>
+                      <a:round/>
+                      <a:headEnd type="none" w="med" len="med"/>
+                      <a:tailEnd type="none" w="med" len="med"/>
+                    </a:lnB>
+                    <a:solidFill>
+                      <a:srgbClr val="141B24"/>
+                    </a:solidFill>
+                  </a:tcPr>
+                </a:tc>
+                <a:tc>
+                  <a:txBody>
+                    <a:bodyPr/>
+                    <a:lstStyle/>
+                    <a:p>
+                      <a:pPr indent="0" marL="0">
+                        <a:buNone/>
+                      </a:pPr>
+                      <a:r>
+                        <a:rPr lang="en-US" sz="1300" dirty="0">
+                          <a:solidFill>
+                            <a:srgbClr val="E6EDF3"/>
+                          </a:solidFill>
+                          <a:latin typeface="Calibri" pitchFamily="34" charset="0"/>
+                          <a:ea typeface="Calibri" pitchFamily="34" charset="-122"/>
+                          <a:cs typeface="Calibri" pitchFamily="34" charset="-120"/>
+                        </a:rPr>
+                        <a:t>1.78 s</a:t>
+                      </a:r>
+                      <a:endParaRPr lang="en-US" sz="1300" dirty="0">
+                        <a:latin typeface="Calibri" charset="0"/>
+                        <a:ea typeface="Calibri" charset="0"/>
+                        <a:cs typeface="Calibri" charset="0"/>
+                      </a:endParaRPr>
+                    </a:p>
+                  </a:txBody>
+                  <a:tcPr marL="91440" marR="91440" marT="45720" marB="45720">
+                    <a:lnL w="12700" cap="flat" cmpd="sng" algn="ctr">
+                      <a:solidFill>
+                        <a:srgbClr val="2A3441"/>
+                      </a:solidFill>
+                      <a:prstDash val="solid"/>
+                      <a:round/>
+                      <a:headEnd type="none" w="med" len="med"/>
+                      <a:tailEnd type="none" w="med" len="med"/>
+                    </a:lnL>
+                    <a:lnR w="12700" cap="flat" cmpd="sng" algn="ctr">
+                      <a:solidFill>
+                        <a:srgbClr val="2A3441"/>
+                      </a:solidFill>
+                      <a:prstDash val="solid"/>
+                      <a:round/>
+                      <a:headEnd type="none" w="med" len="med"/>
+                      <a:tailEnd type="none" w="med" len="med"/>
+                    </a:lnR>
+                    <a:lnT w="12700" cap="flat" cmpd="sng" algn="ctr">
+                      <a:solidFill>
+                        <a:srgbClr val="2A3441"/>
+                      </a:solidFill>
+                      <a:prstDash val="solid"/>
+                      <a:round/>
+                      <a:headEnd type="none" w="med" len="med"/>
+                      <a:tailEnd type="none" w="med" len="med"/>
+                    </a:lnT>
+                    <a:lnB w="12700" cap="flat" cmpd="sng" algn="ctr">
+                      <a:solidFill>
+                        <a:srgbClr val="2A3441"/>
+                      </a:solidFill>
+                      <a:prstDash val="solid"/>
+                      <a:round/>
+                      <a:headEnd type="none" w="med" len="med"/>
+                      <a:tailEnd type="none" w="med" len="med"/>
+                    </a:lnB>
+                    <a:solidFill>
+                      <a:srgbClr val="141B24"/>
+                    </a:solidFill>
+                  </a:tcPr>
+                </a:tc>
+                <a:tc>
+                  <a:txBody>
+                    <a:bodyPr/>
+                    <a:lstStyle/>
+                    <a:p>
+                      <a:pPr indent="0" marL="0">
+                        <a:buNone/>
+                      </a:pPr>
+                      <a:r>
+                        <a:rPr lang="en-US" sz="1300" dirty="0">
+                          <a:solidFill>
+                            <a:srgbClr val="E6EDF3"/>
+                          </a:solidFill>
+                          <a:latin typeface="Calibri" pitchFamily="34" charset="0"/>
+                          <a:ea typeface="Calibri" pitchFamily="34" charset="-122"/>
+                          <a:cs typeface="Calibri" pitchFamily="34" charset="-120"/>
+                        </a:rPr>
+                        <a:t>-33% (n.s.)</a:t>
+                      </a:r>
+                      <a:endParaRPr lang="en-US" sz="1300" dirty="0">
+                        <a:latin typeface="Calibri" charset="0"/>
+                        <a:ea typeface="Calibri" charset="0"/>
+                        <a:cs typeface="Calibri" charset="0"/>
+                      </a:endParaRPr>
+                    </a:p>
+                  </a:txBody>
+                  <a:tcPr marL="91440" marR="91440" marT="45720" marB="45720">
+                    <a:lnL w="12700" cap="flat" cmpd="sng" algn="ctr">
+                      <a:solidFill>
+                        <a:srgbClr val="2A3441"/>
+                      </a:solidFill>
+                      <a:prstDash val="solid"/>
+                      <a:round/>
+                      <a:headEnd type="none" w="med" len="med"/>
+                      <a:tailEnd type="none" w="med" len="med"/>
+                    </a:lnL>
+                    <a:lnR w="12700" cap="flat" cmpd="sng" algn="ctr">
+                      <a:solidFill>
+                        <a:srgbClr val="2A3441"/>
+                      </a:solidFill>
+                      <a:prstDash val="solid"/>
+                      <a:round/>
+                      <a:headEnd type="none" w="med" len="med"/>
+                      <a:tailEnd type="none" w="med" len="med"/>
+                    </a:lnR>
+                    <a:lnT w="12700" cap="flat" cmpd="sng" algn="ctr">
+                      <a:solidFill>
+                        <a:srgbClr val="2A3441"/>
+                      </a:solidFill>
+                      <a:prstDash val="solid"/>
+                      <a:round/>
+                      <a:headEnd type="none" w="med" len="med"/>
+                      <a:tailEnd type="none" w="med" len="med"/>
+                    </a:lnT>
+                    <a:lnB w="12700" cap="flat" cmpd="sng" algn="ctr">
+                      <a:solidFill>
+                        <a:srgbClr val="2A3441"/>
+                      </a:solidFill>
+                      <a:prstDash val="solid"/>
+                      <a:round/>
+                      <a:headEnd type="none" w="med" len="med"/>
+                      <a:tailEnd type="none" w="med" len="med"/>
+                    </a:lnB>
+                    <a:solidFill>
+                      <a:srgbClr val="141B24"/>
+                    </a:solidFill>
+                  </a:tcPr>
+                </a:tc>
+              </a:tr>
+            </a:tbl>
+          </a:graphicData>
+        </a:graphic>
+      </p:graphicFrame>
+      <p:sp>
+        <p:nvSpPr>
+          <p:cNvPr id="5" name="Text 2"/>
+          <p:cNvSpPr/>
+          <p:nvPr/>
+        </p:nvSpPr>
+        <p:spPr>
+          <a:xfrm>
+            <a:off x="548640" y="3657600"/>
+            <a:ext cx="10972800" cy="2651760"/>
+          </a:xfrm>
+          <a:prstGeom prst="rect">
+            <a:avLst/>
+          </a:prstGeom>
+          <a:noFill/>
+          <a:ln/>
+        </p:spPr>
+        <p:txBody>
+          <a:bodyPr wrap="square" lIns="0" tIns="0" rIns="0" bIns="0" rtlCol="0" anchor="t"/>
+          <a:lstStyle/>
+          <a:p>
+            <a:pPr marL="342900" indent="-342900">
+              <a:spcAft>
+                <a:spcPts val="800"/>
+              </a:spcAft>
+              <a:buSzPct val="100000"/>
+              <a:buChar char="•"/>
+            </a:pPr>
+            <a:r>
+              <a:rPr lang="en-US" sz="1600" dirty="0">
+                <a:solidFill>
+                  <a:srgbClr val="E6EDF3"/>
+                </a:solidFill>
+                <a:latin typeface="Calibri" pitchFamily="34" charset="0"/>
+                <a:ea typeface="Calibri" pitchFamily="34" charset="-122"/>
+                <a:cs typeface="Calibri" pitchFamily="34" charset="-120"/>
+              </a:rPr>
+              <a:t>Kernel tc/netem on loopback, 5 runs per cell, same 512-byte payloads for TCP, UDP and RUDP</a:t>
+            </a:r>
+            <a:endParaRPr lang="en-US" sz="1600" dirty="0"/>
+          </a:p>
+          <a:p>
+            <a:pPr marL="342900" indent="-342900">
+              <a:spcAft>
+                <a:spcPts val="800"/>
+              </a:spcAft>
+              <a:buSzPct val="100000"/>
+              <a:buChar char="•"/>
+            </a:pPr>
+            <a:r>
+              <a:rPr lang="en-US" sz="1600" dirty="0">
+                <a:solidFill>
+                  <a:srgbClr val="E6EDF3"/>
+                </a:solidFill>
+                <a:latin typeface="Calibri" pitchFamily="34" charset="0"/>
+                <a:ea typeface="Calibri" pitchFamily="34" charset="-122"/>
+                <a:cs typeface="Calibri" pitchFamily="34" charset="-120"/>
+              </a:rPr>
+              <a:t>Neural beats tuned AIMD on a real kernel path: 61% to 83% faster, highly significant on three paths</a:t>
+            </a:r>
+            <a:endParaRPr lang="en-US" sz="1600" dirty="0"/>
+          </a:p>
+          <a:p>
+            <a:pPr marL="342900" indent="-342900">
+              <a:spcAft>
+                <a:spcPts val="800"/>
+              </a:spcAft>
+              <a:buSzPct val="100000"/>
+              <a:buChar char="•"/>
+            </a:pPr>
+            <a:r>
+              <a:rPr lang="en-US" sz="1600" dirty="0">
+                <a:solidFill>
+                  <a:srgbClr val="E6EDF3"/>
+                </a:solidFill>
+                <a:latin typeface="Calibri" pitchFamily="34" charset="0"/>
+                <a:ea typeface="Calibri" pitchFamily="34" charset="-122"/>
+                <a:cs typeface="Calibri" pitchFamily="34" charset="-120"/>
+              </a:rPr>
+              <a:t>Kernel TCP is still faster than us everywhere: 1.5x (satellite) to 3.2x (lossy)</a:t>
+            </a:r>
+            <a:endParaRPr lang="en-US" sz="1600" dirty="0"/>
+          </a:p>
+          <a:p>
+            <a:pPr marL="342900" indent="-342900">
+              <a:spcAft>
+                <a:spcPts val="800"/>
+              </a:spcAft>
+              <a:buSzPct val="100000"/>
+              <a:buChar char="•"/>
+            </a:pPr>
+            <a:r>
+              <a:rPr lang="en-US" sz="1600" dirty="0">
+                <a:solidFill>
+                  <a:srgbClr val="E6EDF3"/>
+                </a:solidFill>
+                <a:latin typeface="Calibri" pitchFamily="34" charset="0"/>
+                <a:ea typeface="Calibri" pitchFamily="34" charset="-122"/>
+                <a:cs typeface="Calibri" pitchFamily="34" charset="-120"/>
+              </a:rPr>
+              <a:t>Our first three runs were wrong (netem limit counted packets in flight; untuned baseline; unequal payloads). Found, fixed, re-run, documented</a:t>
+            </a:r>
+            <a:endParaRPr lang="en-US" sz="1600" dirty="0"/>
+          </a:p>
+        </p:txBody>
+      </p:sp>
+    </p:spTree>
+  </p:cSld>
+  <p:clrMapOvr>
+    <a:masterClrMapping/>
+  </p:clrMapOvr>
+</p:sld>
+</file>
+
+<file path=ppt/slides/slide33.xml><?xml version="1.0" encoding="utf-8"?>
+<p:sld xmlns:a="http://schemas.openxmlformats.org/drawingml/2006/main" xmlns:r="http://schemas.openxmlformats.org/officeDocument/2006/relationships" xmlns:p="http://schemas.openxmlformats.org/presentationml/2006/main">
+  <p:cSld name="Slide 33">
+    <p:bg>
+      <p:bgPr>
+        <a:solidFill>
+          <a:srgbClr val="0B0F14"/>
+        </a:solidFill>
+      </p:bgPr>
+    </p:bg>
+    <p:spTree>
+      <p:nvGrpSpPr>
+        <p:cNvPr id="1" name=""/>
+        <p:cNvGrpSpPr/>
+        <p:nvPr/>
+      </p:nvGrpSpPr>
+      <p:grpSpPr>
+        <a:xfrm>
+          <a:off x="0" y="0"/>
+          <a:ext cx="0" cy="0"/>
+          <a:chOff x="0" y="0"/>
+          <a:chExt cx="0" cy="0"/>
+        </a:xfrm>
+      </p:grpSpPr>
+      <p:sp>
+        <p:nvSpPr>
+          <p:cNvPr id="2" name="Text 0"/>
+          <p:cNvSpPr/>
+          <p:nvPr/>
+        </p:nvSpPr>
+        <p:spPr>
+          <a:xfrm>
+            <a:off x="548640" y="320040"/>
+            <a:ext cx="11064240" cy="731520"/>
+          </a:xfrm>
+          <a:prstGeom prst="rect">
+            <a:avLst/>
+          </a:prstGeom>
+          <a:noFill/>
+          <a:ln/>
+        </p:spPr>
+        <p:txBody>
+          <a:bodyPr wrap="square" lIns="0" tIns="0" rIns="0" bIns="0" rtlCol="0" anchor="ctr"/>
+          <a:lstStyle/>
+          <a:p>
+            <a:pPr indent="0" marL="0">
+              <a:buNone/>
+            </a:pPr>
+            <a:r>
+              <a:rPr lang="en-US" sz="3000" b="1" dirty="0">
+                <a:solidFill>
+                  <a:srgbClr val="39FF88"/>
+                </a:solidFill>
+                <a:latin typeface="Courier New" pitchFamily="34" charset="0"/>
+                <a:ea typeface="Courier New" pitchFamily="34" charset="-122"/>
+                <a:cs typeface="Courier New" pitchFamily="34" charset="-120"/>
+              </a:rPr>
+              <a:t>Learnings and future work</a:t>
+            </a:r>
+            <a:endParaRPr lang="en-US" sz="3000" dirty="0"/>
+          </a:p>
+        </p:txBody>
+      </p:sp>
+      <p:sp>
+        <p:nvSpPr>
+          <p:cNvPr id="3" name="Text 1"/>
+          <p:cNvSpPr/>
+          <p:nvPr/>
+        </p:nvSpPr>
+        <p:spPr>
+          <a:xfrm>
+            <a:off x="9418320" y="6446520"/>
+            <a:ext cx="2377440" cy="274320"/>
+          </a:xfrm>
+          <a:prstGeom prst="rect">
+            <a:avLst/>
+          </a:prstGeom>
+          <a:noFill/>
+          <a:ln/>
+        </p:spPr>
+        <p:txBody>
+          <a:bodyPr wrap="square" lIns="0" tIns="0" rIns="0" bIns="0" rtlCol="0" anchor="ctr"/>
+          <a:lstStyle/>
+          <a:p>
+            <a:pPr algn="r" indent="0" marL="0">
+              <a:buNone/>
+            </a:pPr>
+            <a:r>
+              <a:rPr lang="en-US" sz="1000" dirty="0">
+                <a:solidFill>
+                  <a:srgbClr val="8B98A5"/>
+                </a:solidFill>
+                <a:latin typeface="Courier New" pitchFamily="34" charset="0"/>
+                <a:ea typeface="Courier New" pitchFamily="34" charset="-122"/>
+                <a:cs typeface="Courier New" pitchFamily="34" charset="-120"/>
+              </a:rPr>
+              <a:t>33 / 35   Smart-RUDP</a:t>
             </a:r>
             <a:endParaRPr lang="en-US" sz="1000" dirty="0"/>
           </a:p>
@@ -25934,7 +27982,7 @@
                 <a:ea typeface="Calibri" pitchFamily="34" charset="-122"/>
                 <a:cs typeface="Calibri" pitchFamily="34" charset="-120"/>
               </a:rPr>
-              <a:t>Kernel netem and real multi-machine tests</a:t>
+              <a:t>Close the gap to kernel TCP; real multi-machine tests</a:t>
             </a:r>
             <a:endParaRPr lang="en-US" sz="2000" dirty="0"/>
           </a:p>
@@ -25973,7 +28021,7 @@
                 <a:ea typeface="Calibri" pitchFamily="34" charset="-122"/>
                 <a:cs typeface="Calibri" pitchFamily="34" charset="-120"/>
               </a:rPr>
-              <a:t>Limits: no kernel netem or multi-machine test; polite mode is a hand-made rule that costs speed; level with CUBIC under bursty cross traffic; no gain at 10% random loss.</a:t>
+              <a:t>Limits: kernel TCP is 1.5x to 3.2x faster; no multi-machine test; polite mode is a hand-made rule that costs speed; level with CUBIC under bursty cross traffic; no gain at 10% random loss.</a:t>
             </a:r>
             <a:endParaRPr lang="en-US" sz="1400" dirty="0"/>
           </a:p>
@@ -25987,9 +28035,9 @@
 </p:sld>
 </file>
 
-<file path=ppt/slides/slide33.xml><?xml version="1.0" encoding="utf-8"?>
+<file path=ppt/slides/slide34.xml><?xml version="1.0" encoding="utf-8"?>
 <p:sld xmlns:a="http://schemas.openxmlformats.org/drawingml/2006/main" xmlns:r="http://schemas.openxmlformats.org/officeDocument/2006/relationships" xmlns:p="http://schemas.openxmlformats.org/presentationml/2006/main">
-  <p:cSld name="Slide 33">
+  <p:cSld name="Slide 34">
     <p:bg>
       <p:bgPr>
         <a:solidFill>
@@ -26136,9 +28184,9 @@
 </p:sld>
 </file>
 
-<file path=ppt/slides/slide34.xml><?xml version="1.0" encoding="utf-8"?>
+<file path=ppt/slides/slide35.xml><?xml version="1.0" encoding="utf-8"?>
 <p:sld xmlns:a="http://schemas.openxmlformats.org/drawingml/2006/main" xmlns:r="http://schemas.openxmlformats.org/officeDocument/2006/relationships" xmlns:p="http://schemas.openxmlformats.org/presentationml/2006/main">
-  <p:cSld name="Slide 34">
+  <p:cSld name="Slide 35">
     <p:bg>
       <p:bgPr>
         <a:solidFill>
@@ -26472,7 +28520,7 @@
                 <a:ea typeface="Courier New" pitchFamily="34" charset="-122"/>
                 <a:cs typeface="Courier New" pitchFamily="34" charset="-120"/>
               </a:rPr>
-              <a:t>4 / 34   Smart-RUDP</a:t>
+              <a:t>4 / 35   Smart-RUDP</a:t>
             </a:r>
             <a:endParaRPr lang="en-US" sz="1000" dirty="0"/>
           </a:p>
@@ -27033,7 +29081,7 @@
                 <a:ea typeface="Courier New" pitchFamily="34" charset="-122"/>
                 <a:cs typeface="Courier New" pitchFamily="34" charset="-120"/>
               </a:rPr>
-              <a:t>5 / 34   Smart-RUDP</a:t>
+              <a:t>5 / 35   Smart-RUDP</a:t>
             </a:r>
             <a:endParaRPr lang="en-US" sz="1000" dirty="0"/>
           </a:p>
@@ -28472,7 +30520,7 @@
                 <a:ea typeface="Courier New" pitchFamily="34" charset="-122"/>
                 <a:cs typeface="Courier New" pitchFamily="34" charset="-120"/>
               </a:rPr>
-              <a:t>6 / 34   Smart-RUDP</a:t>
+              <a:t>6 / 35   Smart-RUDP</a:t>
             </a:r>
             <a:endParaRPr lang="en-US" sz="1000" dirty="0"/>
           </a:p>
@@ -29707,7 +31755,7 @@
                 <a:ea typeface="Courier New" pitchFamily="34" charset="-122"/>
                 <a:cs typeface="Courier New" pitchFamily="34" charset="-120"/>
               </a:rPr>
-              <a:t>7 / 34   Smart-RUDP</a:t>
+              <a:t>7 / 35   Smart-RUDP</a:t>
             </a:r>
             <a:endParaRPr lang="en-US" sz="1000" dirty="0"/>
           </a:p>
@@ -30150,7 +32198,7 @@
                 <a:ea typeface="Courier New" pitchFamily="34" charset="-122"/>
                 <a:cs typeface="Courier New" pitchFamily="34" charset="-120"/>
               </a:rPr>
-              <a:t>8 / 34   Smart-RUDP</a:t>
+              <a:t>8 / 35   Smart-RUDP</a:t>
             </a:r>
             <a:endParaRPr lang="en-US" sz="1000" dirty="0"/>
           </a:p>
@@ -30450,7 +32498,7 @@
                 <a:ea typeface="Courier New" pitchFamily="34" charset="-122"/>
                 <a:cs typeface="Courier New" pitchFamily="34" charset="-120"/>
               </a:rPr>
-              <a:t>9 / 34   Smart-RUDP</a:t>
+              <a:t>9 / 35   Smart-RUDP</a:t>
             </a:r>
             <a:endParaRPr lang="en-US" sz="1000" dirty="0"/>
           </a:p>

</xml_diff>

<commit_message>
Docs: report 8.18-8.22, deck (37 slides), case study, literature review, host guide updated for research-gap tests
</commit_message>
<xml_diff>
--- a/docs/RUDP_Presentation.pptx
+++ b/docs/RUDP_Presentation.pptx
@@ -40,9 +40,11 @@
     <p:sldId id="288" r:id="rId34"/>
     <p:sldId id="289" r:id="rId35"/>
     <p:sldId id="290" r:id="rId36"/>
+    <p:sldId id="291" r:id="rId37"/>
+    <p:sldId id="292" r:id="rId38"/>
   </p:sldIdLst>
   <p:notesMasterIdLst>
-    <p:notesMasterId r:id="rId37"/>
+    <p:notesMasterId r:id="rId39"/>
   </p:notesMasterIdLst>
   <p:sldSz cx="12192000" cy="6858000"/>
   <p:notesSz cx="6858000" cy="12192000"/>
@@ -3325,6 +3327,182 @@
             <a:fld id="{F7021451-1387-4CA6-816F-3879F97B5CBC}" type="slidenum">
               <a:rPr lang="en-US"/>
               <a:t>35</a:t>
+            </a:fld>
+            <a:endParaRPr lang="en-US"/>
+          </a:p>
+        </p:txBody>
+      </p:sp>
+    </p:spTree>
+    <p:extLst>
+      <p:ext uri="{BB962C8B-B14F-4D97-AF65-F5344CB8AC3E}">
+        <p14:creationId xmlns:p14="http://schemas.microsoft.com/office/powerpoint/2010/main" val="1024086991"/>
+      </p:ext>
+    </p:extLst>
+  </p:cSld>
+  <p:clrMapOvr>
+    <a:masterClrMapping/>
+  </p:clrMapOvr>
+</p:notes>
+</file>
+
+<file path=ppt/notesSlides/notesSlide36.xml><?xml version="1.0" encoding="utf-8"?>
+<p:notes xmlns:a="http://schemas.openxmlformats.org/drawingml/2006/main" xmlns:r="http://schemas.openxmlformats.org/officeDocument/2006/relationships" xmlns:p="http://schemas.openxmlformats.org/presentationml/2006/main">
+  <p:cSld>
+    <p:spTree>
+      <p:nvGrpSpPr>
+        <p:cNvPr id="1" name=""/>
+        <p:cNvGrpSpPr/>
+        <p:nvPr/>
+      </p:nvGrpSpPr>
+      <p:grpSpPr>
+        <a:xfrm>
+          <a:off x="0" y="0"/>
+          <a:ext cx="0" cy="0"/>
+          <a:chOff x="0" y="0"/>
+          <a:chExt cx="0" cy="0"/>
+        </a:xfrm>
+      </p:grpSpPr>
+      <p:sp>
+        <p:nvSpPr>
+          <p:cNvPr id="2" name="Slide Image Placeholder 1"/>
+          <p:cNvSpPr>
+            <a:spLocks noGrp="1" noRot="1" noChangeAspect="1"/>
+          </p:cNvSpPr>
+          <p:nvPr>
+            <p:ph type="sldImg"/>
+          </p:nvPr>
+        </p:nvSpPr>
+        <p:spPr/>
+      </p:sp>
+      <p:sp>
+        <p:nvSpPr>
+          <p:cNvPr id="3" name="Notes Placeholder 2"/>
+          <p:cNvSpPr>
+            <a:spLocks noGrp="1"/>
+          </p:cNvSpPr>
+          <p:nvPr>
+            <p:ph type="body" idx="1"/>
+          </p:nvPr>
+        </p:nvSpPr>
+        <p:spPr/>
+        <p:txBody>
+          <a:bodyPr/>
+          <a:lstStyle/>
+          <a:p>
+            <a:r>
+              <a:rPr lang="en-US" dirty="0"/>
+              <a:t/>
+            </a:r>
+            <a:endParaRPr lang="en-US" dirty="0"/>
+          </a:p>
+        </p:txBody>
+      </p:sp>
+      <p:sp>
+        <p:nvSpPr>
+          <p:cNvPr id="4" name="Slide Number Placeholder 3"/>
+          <p:cNvSpPr>
+            <a:spLocks noGrp="1"/>
+          </p:cNvSpPr>
+          <p:nvPr>
+            <p:ph type="sldNum" sz="quarter" idx="10"/>
+          </p:nvPr>
+        </p:nvSpPr>
+        <p:spPr/>
+        <p:txBody>
+          <a:bodyPr/>
+          <a:lstStyle/>
+          <a:p>
+            <a:fld id="{F7021451-1387-4CA6-816F-3879F97B5CBC}" type="slidenum">
+              <a:rPr lang="en-US"/>
+              <a:t>36</a:t>
+            </a:fld>
+            <a:endParaRPr lang="en-US"/>
+          </a:p>
+        </p:txBody>
+      </p:sp>
+    </p:spTree>
+    <p:extLst>
+      <p:ext uri="{BB962C8B-B14F-4D97-AF65-F5344CB8AC3E}">
+        <p14:creationId xmlns:p14="http://schemas.microsoft.com/office/powerpoint/2010/main" val="1024086991"/>
+      </p:ext>
+    </p:extLst>
+  </p:cSld>
+  <p:clrMapOvr>
+    <a:masterClrMapping/>
+  </p:clrMapOvr>
+</p:notes>
+</file>
+
+<file path=ppt/notesSlides/notesSlide37.xml><?xml version="1.0" encoding="utf-8"?>
+<p:notes xmlns:a="http://schemas.openxmlformats.org/drawingml/2006/main" xmlns:r="http://schemas.openxmlformats.org/officeDocument/2006/relationships" xmlns:p="http://schemas.openxmlformats.org/presentationml/2006/main">
+  <p:cSld>
+    <p:spTree>
+      <p:nvGrpSpPr>
+        <p:cNvPr id="1" name=""/>
+        <p:cNvGrpSpPr/>
+        <p:nvPr/>
+      </p:nvGrpSpPr>
+      <p:grpSpPr>
+        <a:xfrm>
+          <a:off x="0" y="0"/>
+          <a:ext cx="0" cy="0"/>
+          <a:chOff x="0" y="0"/>
+          <a:chExt cx="0" cy="0"/>
+        </a:xfrm>
+      </p:grpSpPr>
+      <p:sp>
+        <p:nvSpPr>
+          <p:cNvPr id="2" name="Slide Image Placeholder 1"/>
+          <p:cNvSpPr>
+            <a:spLocks noGrp="1" noRot="1" noChangeAspect="1"/>
+          </p:cNvSpPr>
+          <p:nvPr>
+            <p:ph type="sldImg"/>
+          </p:nvPr>
+        </p:nvSpPr>
+        <p:spPr/>
+      </p:sp>
+      <p:sp>
+        <p:nvSpPr>
+          <p:cNvPr id="3" name="Notes Placeholder 2"/>
+          <p:cNvSpPr>
+            <a:spLocks noGrp="1"/>
+          </p:cNvSpPr>
+          <p:nvPr>
+            <p:ph type="body" idx="1"/>
+          </p:nvPr>
+        </p:nvSpPr>
+        <p:spPr/>
+        <p:txBody>
+          <a:bodyPr/>
+          <a:lstStyle/>
+          <a:p>
+            <a:r>
+              <a:rPr lang="en-US" dirty="0"/>
+              <a:t/>
+            </a:r>
+            <a:endParaRPr lang="en-US" dirty="0"/>
+          </a:p>
+        </p:txBody>
+      </p:sp>
+      <p:sp>
+        <p:nvSpPr>
+          <p:cNvPr id="4" name="Slide Number Placeholder 3"/>
+          <p:cNvSpPr>
+            <a:spLocks noGrp="1"/>
+          </p:cNvSpPr>
+          <p:nvPr>
+            <p:ph type="sldNum" sz="quarter" idx="10"/>
+          </p:nvPr>
+        </p:nvSpPr>
+        <p:spPr/>
+        <p:txBody>
+          <a:bodyPr/>
+          <a:lstStyle/>
+          <a:p>
+            <a:fld id="{F7021451-1387-4CA6-816F-3879F97B5CBC}" type="slidenum">
+              <a:rPr lang="en-US"/>
+              <a:t>37</a:t>
             </a:fld>
             <a:endParaRPr lang="en-US"/>
           </a:p>
@@ -4462,7 +4640,7 @@
                 <a:ea typeface="Courier New" pitchFamily="34" charset="-122"/>
                 <a:cs typeface="Courier New" pitchFamily="34" charset="-120"/>
               </a:rPr>
-              <a:t>10 / 35   Smart-RUDP</a:t>
+              <a:t>10 / 37   Smart-RUDP</a:t>
             </a:r>
             <a:endParaRPr lang="en-US" sz="1000" dirty="0"/>
           </a:p>
@@ -4659,7 +4837,7 @@
                 <a:ea typeface="Courier New" pitchFamily="34" charset="-122"/>
                 <a:cs typeface="Courier New" pitchFamily="34" charset="-120"/>
               </a:rPr>
-              <a:t>11 / 35   Smart-RUDP</a:t>
+              <a:t>11 / 37   Smart-RUDP</a:t>
             </a:r>
             <a:endParaRPr lang="en-US" sz="1000" dirty="0"/>
           </a:p>
@@ -5489,7 +5667,7 @@
                 <a:ea typeface="Courier New" pitchFamily="34" charset="-122"/>
                 <a:cs typeface="Courier New" pitchFamily="34" charset="-120"/>
               </a:rPr>
-              <a:t>12 / 35   Smart-RUDP</a:t>
+              <a:t>12 / 37   Smart-RUDP</a:t>
             </a:r>
             <a:endParaRPr lang="en-US" sz="1000" dirty="0"/>
           </a:p>
@@ -5786,7 +5964,7 @@
                 <a:ea typeface="Courier New" pitchFamily="34" charset="-122"/>
                 <a:cs typeface="Courier New" pitchFamily="34" charset="-120"/>
               </a:rPr>
-              <a:t>13 / 35   Smart-RUDP</a:t>
+              <a:t>13 / 37   Smart-RUDP</a:t>
             </a:r>
             <a:endParaRPr lang="en-US" sz="1000" dirty="0"/>
           </a:p>
@@ -6086,7 +6264,7 @@
                 <a:ea typeface="Courier New" pitchFamily="34" charset="-122"/>
                 <a:cs typeface="Courier New" pitchFamily="34" charset="-120"/>
               </a:rPr>
-              <a:t>14 / 35   Smart-RUDP</a:t>
+              <a:t>14 / 37   Smart-RUDP</a:t>
             </a:r>
             <a:endParaRPr lang="en-US" sz="1000" dirty="0"/>
           </a:p>
@@ -6470,7 +6648,7 @@
                 <a:ea typeface="Courier New" pitchFamily="34" charset="-122"/>
                 <a:cs typeface="Courier New" pitchFamily="34" charset="-120"/>
               </a:rPr>
-              <a:t>15 / 35   Smart-RUDP</a:t>
+              <a:t>15 / 37   Smart-RUDP</a:t>
             </a:r>
             <a:endParaRPr lang="en-US" sz="1000" dirty="0"/>
           </a:p>
@@ -6928,7 +7106,7 @@
                 <a:ea typeface="Courier New" pitchFamily="34" charset="-122"/>
                 <a:cs typeface="Courier New" pitchFamily="34" charset="-120"/>
               </a:rPr>
-              <a:t>16 / 35   Smart-RUDP</a:t>
+              <a:t>16 / 37   Smart-RUDP</a:t>
             </a:r>
             <a:endParaRPr lang="en-US" sz="1000" dirty="0"/>
           </a:p>
@@ -7613,7 +7791,7 @@
                 <a:ea typeface="Courier New" pitchFamily="34" charset="-122"/>
                 <a:cs typeface="Courier New" pitchFamily="34" charset="-120"/>
               </a:rPr>
-              <a:t>17 / 35   Smart-RUDP</a:t>
+              <a:t>17 / 37   Smart-RUDP</a:t>
             </a:r>
             <a:endParaRPr lang="en-US" sz="1000" dirty="0"/>
           </a:p>
@@ -7853,7 +8031,7 @@
                 <a:ea typeface="Courier New" pitchFamily="34" charset="-122"/>
                 <a:cs typeface="Courier New" pitchFamily="34" charset="-120"/>
               </a:rPr>
-              <a:t>18 / 35   Smart-RUDP</a:t>
+              <a:t>18 / 37   Smart-RUDP</a:t>
             </a:r>
             <a:endParaRPr lang="en-US" sz="1000" dirty="0"/>
           </a:p>
@@ -8093,7 +8271,7 @@
                 <a:ea typeface="Courier New" pitchFamily="34" charset="-122"/>
                 <a:cs typeface="Courier New" pitchFamily="34" charset="-120"/>
               </a:rPr>
-              <a:t>19 / 35   Smart-RUDP</a:t>
+              <a:t>19 / 37   Smart-RUDP</a:t>
             </a:r>
             <a:endParaRPr lang="en-US" sz="1000" dirty="0"/>
           </a:p>
@@ -8315,7 +8493,7 @@
                 <a:ea typeface="Courier New" pitchFamily="34" charset="-122"/>
                 <a:cs typeface="Courier New" pitchFamily="34" charset="-120"/>
               </a:rPr>
-              <a:t>2 / 35   Smart-RUDP</a:t>
+              <a:t>2 / 37   Smart-RUDP</a:t>
             </a:r>
             <a:endParaRPr lang="en-US" sz="1000" dirty="0"/>
           </a:p>
@@ -8709,7 +8887,7 @@
                 <a:ea typeface="Courier New" pitchFamily="34" charset="-122"/>
                 <a:cs typeface="Courier New" pitchFamily="34" charset="-120"/>
               </a:rPr>
-              <a:t>20 / 35   Smart-RUDP</a:t>
+              <a:t>20 / 37   Smart-RUDP</a:t>
             </a:r>
             <a:endParaRPr lang="en-US" sz="1000" dirty="0"/>
           </a:p>
@@ -9033,7 +9211,7 @@
                 <a:ea typeface="Courier New" pitchFamily="34" charset="-122"/>
                 <a:cs typeface="Courier New" pitchFamily="34" charset="-120"/>
               </a:rPr>
-              <a:t>21 / 35   Smart-RUDP</a:t>
+              <a:t>21 / 37   Smart-RUDP</a:t>
             </a:r>
             <a:endParaRPr lang="en-US" sz="1000" dirty="0"/>
           </a:p>
@@ -10740,7 +10918,7 @@
                 <a:ea typeface="Courier New" pitchFamily="34" charset="-122"/>
                 <a:cs typeface="Courier New" pitchFamily="34" charset="-120"/>
               </a:rPr>
-              <a:t>22 / 35   Smart-RUDP</a:t>
+              <a:t>22 / 37   Smart-RUDP</a:t>
             </a:r>
             <a:endParaRPr lang="en-US" sz="1000" dirty="0"/>
           </a:p>
@@ -12123,7 +12301,7 @@
                 <a:ea typeface="Courier New" pitchFamily="34" charset="-122"/>
                 <a:cs typeface="Courier New" pitchFamily="34" charset="-120"/>
               </a:rPr>
-              <a:t>23 / 35   Smart-RUDP</a:t>
+              <a:t>23 / 37   Smart-RUDP</a:t>
             </a:r>
             <a:endParaRPr lang="en-US" sz="1000" dirty="0"/>
           </a:p>
@@ -13666,7 +13844,7 @@
                 <a:ea typeface="Courier New" pitchFamily="34" charset="-122"/>
                 <a:cs typeface="Courier New" pitchFamily="34" charset="-120"/>
               </a:rPr>
-              <a:t>24 / 35   Smart-RUDP</a:t>
+              <a:t>24 / 37   Smart-RUDP</a:t>
             </a:r>
             <a:endParaRPr lang="en-US" sz="1000" dirty="0"/>
           </a:p>
@@ -15344,7 +15522,7 @@
                 <a:ea typeface="Courier New" pitchFamily="34" charset="-122"/>
                 <a:cs typeface="Courier New" pitchFamily="34" charset="-120"/>
               </a:rPr>
-              <a:t>25 / 35   Smart-RUDP</a:t>
+              <a:t>25 / 37   Smart-RUDP</a:t>
             </a:r>
             <a:endParaRPr lang="en-US" sz="1000" dirty="0"/>
           </a:p>
@@ -17022,7 +17200,7 @@
                 <a:ea typeface="Courier New" pitchFamily="34" charset="-122"/>
                 <a:cs typeface="Courier New" pitchFamily="34" charset="-120"/>
               </a:rPr>
-              <a:t>26 / 35   Smart-RUDP</a:t>
+              <a:t>26 / 37   Smart-RUDP</a:t>
             </a:r>
             <a:endParaRPr lang="en-US" sz="1000" dirty="0"/>
           </a:p>
@@ -19362,7 +19540,7 @@
                 <a:ea typeface="Courier New" pitchFamily="34" charset="-122"/>
                 <a:cs typeface="Courier New" pitchFamily="34" charset="-120"/>
               </a:rPr>
-              <a:t>27 / 35   Smart-RUDP</a:t>
+              <a:t>27 / 37   Smart-RUDP</a:t>
             </a:r>
             <a:endParaRPr lang="en-US" sz="1000" dirty="0"/>
           </a:p>
@@ -19820,7 +19998,7 @@
                 <a:ea typeface="Courier New" pitchFamily="34" charset="-122"/>
                 <a:cs typeface="Courier New" pitchFamily="34" charset="-120"/>
               </a:rPr>
-              <a:t>28 / 35   Smart-RUDP</a:t>
+              <a:t>28 / 37   Smart-RUDP</a:t>
             </a:r>
             <a:endParaRPr lang="en-US" sz="1000" dirty="0"/>
           </a:p>
@@ -20052,7 +20230,7 @@
                 <a:ea typeface="Courier New" pitchFamily="34" charset="-122"/>
                 <a:cs typeface="Courier New" pitchFamily="34" charset="-120"/>
               </a:rPr>
-              <a:t>29 / 35   Smart-RUDP</a:t>
+              <a:t>29 / 37   Smart-RUDP</a:t>
             </a:r>
             <a:endParaRPr lang="en-US" sz="1000" dirty="0"/>
           </a:p>
@@ -22798,7 +22976,7 @@
                 <a:ea typeface="Courier New" pitchFamily="34" charset="-122"/>
                 <a:cs typeface="Courier New" pitchFamily="34" charset="-120"/>
               </a:rPr>
-              <a:t>3 / 35   Smart-RUDP</a:t>
+              <a:t>3 / 37   Smart-RUDP</a:t>
             </a:r>
             <a:endParaRPr lang="en-US" sz="1000" dirty="0"/>
           </a:p>
@@ -23192,7 +23370,7 @@
                 <a:ea typeface="Courier New" pitchFamily="34" charset="-122"/>
                 <a:cs typeface="Courier New" pitchFamily="34" charset="-120"/>
               </a:rPr>
-              <a:t>30 / 35   Smart-RUDP</a:t>
+              <a:t>30 / 37   Smart-RUDP</a:t>
             </a:r>
             <a:endParaRPr lang="en-US" sz="1000" dirty="0"/>
           </a:p>
@@ -23432,7 +23610,7 @@
                 <a:ea typeface="Courier New" pitchFamily="34" charset="-122"/>
                 <a:cs typeface="Courier New" pitchFamily="34" charset="-120"/>
               </a:rPr>
-              <a:t>31 / 35   Smart-RUDP</a:t>
+              <a:t>31 / 37   Smart-RUDP</a:t>
             </a:r>
             <a:endParaRPr lang="en-US" sz="1000" dirty="0"/>
           </a:p>
@@ -25749,7 +25927,7 @@
                 <a:ea typeface="Courier New" pitchFamily="34" charset="-122"/>
                 <a:cs typeface="Courier New" pitchFamily="34" charset="-120"/>
               </a:rPr>
-              <a:t>32 / 35   Smart-RUDP</a:t>
+              <a:t>32 / 37   Smart-RUDP</a:t>
             </a:r>
             <a:endParaRPr lang="en-US" sz="1000" dirty="0"/>
           </a:p>
@@ -27669,7 +27847,7 @@
                 <a:ea typeface="Courier New" pitchFamily="34" charset="-122"/>
                 <a:cs typeface="Courier New" pitchFamily="34" charset="-120"/>
               </a:rPr>
-              <a:t>Learnings and future work</a:t>
+              <a:t>Research gaps: changing paths and a BBR baseline</a:t>
             </a:r>
             <a:endParaRPr lang="en-US" sz="3000" dirty="0"/>
           </a:p>
@@ -27708,86 +27886,2449 @@
                 <a:ea typeface="Courier New" pitchFamily="34" charset="-122"/>
                 <a:cs typeface="Courier New" pitchFamily="34" charset="-120"/>
               </a:rPr>
-              <a:t>33 / 35   Smart-RUDP</a:t>
+              <a:t>33 / 37   Smart-RUDP</a:t>
             </a:r>
             <a:endParaRPr lang="en-US" sz="1000" dirty="0"/>
           </a:p>
         </p:txBody>
       </p:sp>
+      <p:graphicFrame>
+        <p:nvGraphicFramePr>
+          <p:cNvPr id="34" name="Table 0"/>
+          <p:cNvGraphicFramePr>
+            <a:graphicFrameLocks noGrp="1"/>
+          </p:cNvGraphicFramePr>
+          <p:nvPr>
+            <p:extLst>
+              <p:ext uri="{D42A27DB-BD31-4B8C-83A1-F6EECF244321}">
+                <p14:modId xmlns:p14="http://schemas.microsoft.com/office/powerpoint/2010/main" val="1579011935"/>
+              </p:ext>
+            </p:extLst>
+          </p:nvPr>
+        </p:nvGraphicFramePr>
+        <p:xfrm>
+          <a:off x="548640" y="1188720"/>
+          <a:ext cx="7863840" cy="914400"/>
+        </p:xfrm>
+        <a:graphic>
+          <a:graphicData uri="http://schemas.openxmlformats.org/drawingml/2006/table">
+            <a:tbl>
+              <a:tblPr/>
+              <a:tblGrid>
+                <a:gridCol w="2743200"/>
+                <a:gridCol w="1280160"/>
+                <a:gridCol w="1097280"/>
+                <a:gridCol w="1371600"/>
+                <a:gridCol w="1371600"/>
+              </a:tblGrid>
+              <a:tr h="402336">
+                <a:tc>
+                  <a:txBody>
+                    <a:bodyPr/>
+                    <a:lstStyle/>
+                    <a:p>
+                      <a:pPr indent="0" marL="0">
+                        <a:buNone/>
+                      </a:pPr>
+                      <a:r>
+                        <a:rPr lang="en-US" sz="1300" b="1" dirty="0">
+                          <a:solidFill>
+                            <a:srgbClr val="0B0F14"/>
+                          </a:solidFill>
+                          <a:latin typeface="Courier New" pitchFamily="34" charset="0"/>
+                          <a:ea typeface="Courier New" pitchFamily="34" charset="-122"/>
+                          <a:cs typeface="Courier New" pitchFamily="34" charset="-120"/>
+                        </a:rPr>
+                        <a:t>Mean time (s)</a:t>
+                      </a:r>
+                      <a:endParaRPr lang="en-US" sz="1300" dirty="0">
+                        <a:latin typeface="Courier New" charset="0"/>
+                        <a:ea typeface="Courier New" charset="0"/>
+                        <a:cs typeface="Courier New" charset="0"/>
+                      </a:endParaRPr>
+                    </a:p>
+                  </a:txBody>
+                  <a:tcPr marL="91440" marR="91440" marT="45720" marB="45720">
+                    <a:lnL w="12700" cap="flat" cmpd="sng" algn="ctr">
+                      <a:solidFill>
+                        <a:srgbClr val="2A3441"/>
+                      </a:solidFill>
+                      <a:prstDash val="solid"/>
+                      <a:round/>
+                      <a:headEnd type="none" w="med" len="med"/>
+                      <a:tailEnd type="none" w="med" len="med"/>
+                    </a:lnL>
+                    <a:lnR w="12700" cap="flat" cmpd="sng" algn="ctr">
+                      <a:solidFill>
+                        <a:srgbClr val="2A3441"/>
+                      </a:solidFill>
+                      <a:prstDash val="solid"/>
+                      <a:round/>
+                      <a:headEnd type="none" w="med" len="med"/>
+                      <a:tailEnd type="none" w="med" len="med"/>
+                    </a:lnR>
+                    <a:lnT w="12700" cap="flat" cmpd="sng" algn="ctr">
+                      <a:solidFill>
+                        <a:srgbClr val="2A3441"/>
+                      </a:solidFill>
+                      <a:prstDash val="solid"/>
+                      <a:round/>
+                      <a:headEnd type="none" w="med" len="med"/>
+                      <a:tailEnd type="none" w="med" len="med"/>
+                    </a:lnT>
+                    <a:lnB w="12700" cap="flat" cmpd="sng" algn="ctr">
+                      <a:solidFill>
+                        <a:srgbClr val="2A3441"/>
+                      </a:solidFill>
+                      <a:prstDash val="solid"/>
+                      <a:round/>
+                      <a:headEnd type="none" w="med" len="med"/>
+                      <a:tailEnd type="none" w="med" len="med"/>
+                    </a:lnB>
+                    <a:solidFill>
+                      <a:srgbClr val="39FF88"/>
+                    </a:solidFill>
+                  </a:tcPr>
+                </a:tc>
+                <a:tc>
+                  <a:txBody>
+                    <a:bodyPr/>
+                    <a:lstStyle/>
+                    <a:p>
+                      <a:pPr indent="0" marL="0">
+                        <a:buNone/>
+                      </a:pPr>
+                      <a:r>
+                        <a:rPr lang="en-US" sz="1300" b="1" dirty="0">
+                          <a:solidFill>
+                            <a:srgbClr val="0B0F14"/>
+                          </a:solidFill>
+                          <a:latin typeface="Courier New" pitchFamily="34" charset="0"/>
+                          <a:ea typeface="Courier New" pitchFamily="34" charset="-122"/>
+                          <a:cs typeface="Courier New" pitchFamily="34" charset="-120"/>
+                        </a:rPr>
+                        <a:t>AIMD tuned</a:t>
+                      </a:r>
+                      <a:endParaRPr lang="en-US" sz="1300" dirty="0">
+                        <a:latin typeface="Courier New" charset="0"/>
+                        <a:ea typeface="Courier New" charset="0"/>
+                        <a:cs typeface="Courier New" charset="0"/>
+                      </a:endParaRPr>
+                    </a:p>
+                  </a:txBody>
+                  <a:tcPr marL="91440" marR="91440" marT="45720" marB="45720">
+                    <a:lnL w="12700" cap="flat" cmpd="sng" algn="ctr">
+                      <a:solidFill>
+                        <a:srgbClr val="2A3441"/>
+                      </a:solidFill>
+                      <a:prstDash val="solid"/>
+                      <a:round/>
+                      <a:headEnd type="none" w="med" len="med"/>
+                      <a:tailEnd type="none" w="med" len="med"/>
+                    </a:lnL>
+                    <a:lnR w="12700" cap="flat" cmpd="sng" algn="ctr">
+                      <a:solidFill>
+                        <a:srgbClr val="2A3441"/>
+                      </a:solidFill>
+                      <a:prstDash val="solid"/>
+                      <a:round/>
+                      <a:headEnd type="none" w="med" len="med"/>
+                      <a:tailEnd type="none" w="med" len="med"/>
+                    </a:lnR>
+                    <a:lnT w="12700" cap="flat" cmpd="sng" algn="ctr">
+                      <a:solidFill>
+                        <a:srgbClr val="2A3441"/>
+                      </a:solidFill>
+                      <a:prstDash val="solid"/>
+                      <a:round/>
+                      <a:headEnd type="none" w="med" len="med"/>
+                      <a:tailEnd type="none" w="med" len="med"/>
+                    </a:lnT>
+                    <a:lnB w="12700" cap="flat" cmpd="sng" algn="ctr">
+                      <a:solidFill>
+                        <a:srgbClr val="2A3441"/>
+                      </a:solidFill>
+                      <a:prstDash val="solid"/>
+                      <a:round/>
+                      <a:headEnd type="none" w="med" len="med"/>
+                      <a:tailEnd type="none" w="med" len="med"/>
+                    </a:lnB>
+                    <a:solidFill>
+                      <a:srgbClr val="39FF88"/>
+                    </a:solidFill>
+                  </a:tcPr>
+                </a:tc>
+                <a:tc>
+                  <a:txBody>
+                    <a:bodyPr/>
+                    <a:lstStyle/>
+                    <a:p>
+                      <a:pPr indent="0" marL="0">
+                        <a:buNone/>
+                      </a:pPr>
+                      <a:r>
+                        <a:rPr lang="en-US" sz="1300" b="1" dirty="0">
+                          <a:solidFill>
+                            <a:srgbClr val="0B0F14"/>
+                          </a:solidFill>
+                          <a:latin typeface="Courier New" pitchFamily="34" charset="0"/>
+                          <a:ea typeface="Courier New" pitchFamily="34" charset="-122"/>
+                          <a:cs typeface="Courier New" pitchFamily="34" charset="-120"/>
+                        </a:rPr>
+                        <a:t>CUBIC</a:t>
+                      </a:r>
+                      <a:endParaRPr lang="en-US" sz="1300" dirty="0">
+                        <a:latin typeface="Courier New" charset="0"/>
+                        <a:ea typeface="Courier New" charset="0"/>
+                        <a:cs typeface="Courier New" charset="0"/>
+                      </a:endParaRPr>
+                    </a:p>
+                  </a:txBody>
+                  <a:tcPr marL="91440" marR="91440" marT="45720" marB="45720">
+                    <a:lnL w="12700" cap="flat" cmpd="sng" algn="ctr">
+                      <a:solidFill>
+                        <a:srgbClr val="2A3441"/>
+                      </a:solidFill>
+                      <a:prstDash val="solid"/>
+                      <a:round/>
+                      <a:headEnd type="none" w="med" len="med"/>
+                      <a:tailEnd type="none" w="med" len="med"/>
+                    </a:lnL>
+                    <a:lnR w="12700" cap="flat" cmpd="sng" algn="ctr">
+                      <a:solidFill>
+                        <a:srgbClr val="2A3441"/>
+                      </a:solidFill>
+                      <a:prstDash val="solid"/>
+                      <a:round/>
+                      <a:headEnd type="none" w="med" len="med"/>
+                      <a:tailEnd type="none" w="med" len="med"/>
+                    </a:lnR>
+                    <a:lnT w="12700" cap="flat" cmpd="sng" algn="ctr">
+                      <a:solidFill>
+                        <a:srgbClr val="2A3441"/>
+                      </a:solidFill>
+                      <a:prstDash val="solid"/>
+                      <a:round/>
+                      <a:headEnd type="none" w="med" len="med"/>
+                      <a:tailEnd type="none" w="med" len="med"/>
+                    </a:lnT>
+                    <a:lnB w="12700" cap="flat" cmpd="sng" algn="ctr">
+                      <a:solidFill>
+                        <a:srgbClr val="2A3441"/>
+                      </a:solidFill>
+                      <a:prstDash val="solid"/>
+                      <a:round/>
+                      <a:headEnd type="none" w="med" len="med"/>
+                      <a:tailEnd type="none" w="med" len="med"/>
+                    </a:lnB>
+                    <a:solidFill>
+                      <a:srgbClr val="39FF88"/>
+                    </a:solidFill>
+                  </a:tcPr>
+                </a:tc>
+                <a:tc>
+                  <a:txBody>
+                    <a:bodyPr/>
+                    <a:lstStyle/>
+                    <a:p>
+                      <a:pPr indent="0" marL="0">
+                        <a:buNone/>
+                      </a:pPr>
+                      <a:r>
+                        <a:rPr lang="en-US" sz="1300" b="1" dirty="0">
+                          <a:solidFill>
+                            <a:srgbClr val="0B0F14"/>
+                          </a:solidFill>
+                          <a:latin typeface="Courier New" pitchFamily="34" charset="0"/>
+                          <a:ea typeface="Courier New" pitchFamily="34" charset="-122"/>
+                          <a:cs typeface="Courier New" pitchFamily="34" charset="-120"/>
+                        </a:rPr>
+                        <a:t>BBR-style</a:t>
+                      </a:r>
+                      <a:endParaRPr lang="en-US" sz="1300" dirty="0">
+                        <a:latin typeface="Courier New" charset="0"/>
+                        <a:ea typeface="Courier New" charset="0"/>
+                        <a:cs typeface="Courier New" charset="0"/>
+                      </a:endParaRPr>
+                    </a:p>
+                  </a:txBody>
+                  <a:tcPr marL="91440" marR="91440" marT="45720" marB="45720">
+                    <a:lnL w="12700" cap="flat" cmpd="sng" algn="ctr">
+                      <a:solidFill>
+                        <a:srgbClr val="2A3441"/>
+                      </a:solidFill>
+                      <a:prstDash val="solid"/>
+                      <a:round/>
+                      <a:headEnd type="none" w="med" len="med"/>
+                      <a:tailEnd type="none" w="med" len="med"/>
+                    </a:lnL>
+                    <a:lnR w="12700" cap="flat" cmpd="sng" algn="ctr">
+                      <a:solidFill>
+                        <a:srgbClr val="2A3441"/>
+                      </a:solidFill>
+                      <a:prstDash val="solid"/>
+                      <a:round/>
+                      <a:headEnd type="none" w="med" len="med"/>
+                      <a:tailEnd type="none" w="med" len="med"/>
+                    </a:lnR>
+                    <a:lnT w="12700" cap="flat" cmpd="sng" algn="ctr">
+                      <a:solidFill>
+                        <a:srgbClr val="2A3441"/>
+                      </a:solidFill>
+                      <a:prstDash val="solid"/>
+                      <a:round/>
+                      <a:headEnd type="none" w="med" len="med"/>
+                      <a:tailEnd type="none" w="med" len="med"/>
+                    </a:lnT>
+                    <a:lnB w="12700" cap="flat" cmpd="sng" algn="ctr">
+                      <a:solidFill>
+                        <a:srgbClr val="2A3441"/>
+                      </a:solidFill>
+                      <a:prstDash val="solid"/>
+                      <a:round/>
+                      <a:headEnd type="none" w="med" len="med"/>
+                      <a:tailEnd type="none" w="med" len="med"/>
+                    </a:lnB>
+                    <a:solidFill>
+                      <a:srgbClr val="39FF88"/>
+                    </a:solidFill>
+                  </a:tcPr>
+                </a:tc>
+                <a:tc>
+                  <a:txBody>
+                    <a:bodyPr/>
+                    <a:lstStyle/>
+                    <a:p>
+                      <a:pPr indent="0" marL="0">
+                        <a:buNone/>
+                      </a:pPr>
+                      <a:r>
+                        <a:rPr lang="en-US" sz="1300" b="1" dirty="0">
+                          <a:solidFill>
+                            <a:srgbClr val="0B0F14"/>
+                          </a:solidFill>
+                          <a:latin typeface="Courier New" pitchFamily="34" charset="0"/>
+                          <a:ea typeface="Courier New" pitchFamily="34" charset="-122"/>
+                          <a:cs typeface="Courier New" pitchFamily="34" charset="-120"/>
+                        </a:rPr>
+                        <a:t>Neural</a:t>
+                      </a:r>
+                      <a:endParaRPr lang="en-US" sz="1300" dirty="0">
+                        <a:latin typeface="Courier New" charset="0"/>
+                        <a:ea typeface="Courier New" charset="0"/>
+                        <a:cs typeface="Courier New" charset="0"/>
+                      </a:endParaRPr>
+                    </a:p>
+                  </a:txBody>
+                  <a:tcPr marL="91440" marR="91440" marT="45720" marB="45720">
+                    <a:lnL w="12700" cap="flat" cmpd="sng" algn="ctr">
+                      <a:solidFill>
+                        <a:srgbClr val="2A3441"/>
+                      </a:solidFill>
+                      <a:prstDash val="solid"/>
+                      <a:round/>
+                      <a:headEnd type="none" w="med" len="med"/>
+                      <a:tailEnd type="none" w="med" len="med"/>
+                    </a:lnL>
+                    <a:lnR w="12700" cap="flat" cmpd="sng" algn="ctr">
+                      <a:solidFill>
+                        <a:srgbClr val="2A3441"/>
+                      </a:solidFill>
+                      <a:prstDash val="solid"/>
+                      <a:round/>
+                      <a:headEnd type="none" w="med" len="med"/>
+                      <a:tailEnd type="none" w="med" len="med"/>
+                    </a:lnR>
+                    <a:lnT w="12700" cap="flat" cmpd="sng" algn="ctr">
+                      <a:solidFill>
+                        <a:srgbClr val="2A3441"/>
+                      </a:solidFill>
+                      <a:prstDash val="solid"/>
+                      <a:round/>
+                      <a:headEnd type="none" w="med" len="med"/>
+                      <a:tailEnd type="none" w="med" len="med"/>
+                    </a:lnT>
+                    <a:lnB w="12700" cap="flat" cmpd="sng" algn="ctr">
+                      <a:solidFill>
+                        <a:srgbClr val="2A3441"/>
+                      </a:solidFill>
+                      <a:prstDash val="solid"/>
+                      <a:round/>
+                      <a:headEnd type="none" w="med" len="med"/>
+                      <a:tailEnd type="none" w="med" len="med"/>
+                    </a:lnB>
+                    <a:solidFill>
+                      <a:srgbClr val="39FF88"/>
+                    </a:solidFill>
+                  </a:tcPr>
+                </a:tc>
+              </a:tr>
+              <a:tr h="402336">
+                <a:tc>
+                  <a:txBody>
+                    <a:bodyPr/>
+                    <a:lstStyle/>
+                    <a:p>
+                      <a:pPr indent="0" marL="0">
+                        <a:buNone/>
+                      </a:pPr>
+                      <a:r>
+                        <a:rPr lang="en-US" sz="1300" dirty="0">
+                          <a:solidFill>
+                            <a:srgbClr val="E6EDF3"/>
+                          </a:solidFill>
+                          <a:latin typeface="Calibri" pitchFamily="34" charset="0"/>
+                          <a:ea typeface="Calibri" pitchFamily="34" charset="-122"/>
+                          <a:cs typeface="Calibri" pitchFamily="34" charset="-120"/>
+                        </a:rPr>
+                        <a:t>Bandwidth drop</a:t>
+                      </a:r>
+                      <a:endParaRPr lang="en-US" sz="1300" dirty="0">
+                        <a:latin typeface="Calibri" charset="0"/>
+                        <a:ea typeface="Calibri" charset="0"/>
+                        <a:cs typeface="Calibri" charset="0"/>
+                      </a:endParaRPr>
+                    </a:p>
+                  </a:txBody>
+                  <a:tcPr marL="91440" marR="91440" marT="45720" marB="45720">
+                    <a:lnL w="12700" cap="flat" cmpd="sng" algn="ctr">
+                      <a:solidFill>
+                        <a:srgbClr val="2A3441"/>
+                      </a:solidFill>
+                      <a:prstDash val="solid"/>
+                      <a:round/>
+                      <a:headEnd type="none" w="med" len="med"/>
+                      <a:tailEnd type="none" w="med" len="med"/>
+                    </a:lnL>
+                    <a:lnR w="12700" cap="flat" cmpd="sng" algn="ctr">
+                      <a:solidFill>
+                        <a:srgbClr val="2A3441"/>
+                      </a:solidFill>
+                      <a:prstDash val="solid"/>
+                      <a:round/>
+                      <a:headEnd type="none" w="med" len="med"/>
+                      <a:tailEnd type="none" w="med" len="med"/>
+                    </a:lnR>
+                    <a:lnT w="12700" cap="flat" cmpd="sng" algn="ctr">
+                      <a:solidFill>
+                        <a:srgbClr val="2A3441"/>
+                      </a:solidFill>
+                      <a:prstDash val="solid"/>
+                      <a:round/>
+                      <a:headEnd type="none" w="med" len="med"/>
+                      <a:tailEnd type="none" w="med" len="med"/>
+                    </a:lnT>
+                    <a:lnB w="12700" cap="flat" cmpd="sng" algn="ctr">
+                      <a:solidFill>
+                        <a:srgbClr val="2A3441"/>
+                      </a:solidFill>
+                      <a:prstDash val="solid"/>
+                      <a:round/>
+                      <a:headEnd type="none" w="med" len="med"/>
+                      <a:tailEnd type="none" w="med" len="med"/>
+                    </a:lnB>
+                    <a:solidFill>
+                      <a:srgbClr val="141B24"/>
+                    </a:solidFill>
+                  </a:tcPr>
+                </a:tc>
+                <a:tc>
+                  <a:txBody>
+                    <a:bodyPr/>
+                    <a:lstStyle/>
+                    <a:p>
+                      <a:pPr indent="0" marL="0">
+                        <a:buNone/>
+                      </a:pPr>
+                      <a:r>
+                        <a:rPr lang="en-US" sz="1300" dirty="0">
+                          <a:solidFill>
+                            <a:srgbClr val="E6EDF3"/>
+                          </a:solidFill>
+                          <a:latin typeface="Calibri" pitchFamily="34" charset="0"/>
+                          <a:ea typeface="Calibri" pitchFamily="34" charset="-122"/>
+                          <a:cs typeface="Calibri" pitchFamily="34" charset="-120"/>
+                        </a:rPr>
+                        <a:t>13.6</a:t>
+                      </a:r>
+                      <a:endParaRPr lang="en-US" sz="1300" dirty="0">
+                        <a:latin typeface="Calibri" charset="0"/>
+                        <a:ea typeface="Calibri" charset="0"/>
+                        <a:cs typeface="Calibri" charset="0"/>
+                      </a:endParaRPr>
+                    </a:p>
+                  </a:txBody>
+                  <a:tcPr marL="91440" marR="91440" marT="45720" marB="45720">
+                    <a:lnL w="12700" cap="flat" cmpd="sng" algn="ctr">
+                      <a:solidFill>
+                        <a:srgbClr val="2A3441"/>
+                      </a:solidFill>
+                      <a:prstDash val="solid"/>
+                      <a:round/>
+                      <a:headEnd type="none" w="med" len="med"/>
+                      <a:tailEnd type="none" w="med" len="med"/>
+                    </a:lnL>
+                    <a:lnR w="12700" cap="flat" cmpd="sng" algn="ctr">
+                      <a:solidFill>
+                        <a:srgbClr val="2A3441"/>
+                      </a:solidFill>
+                      <a:prstDash val="solid"/>
+                      <a:round/>
+                      <a:headEnd type="none" w="med" len="med"/>
+                      <a:tailEnd type="none" w="med" len="med"/>
+                    </a:lnR>
+                    <a:lnT w="12700" cap="flat" cmpd="sng" algn="ctr">
+                      <a:solidFill>
+                        <a:srgbClr val="2A3441"/>
+                      </a:solidFill>
+                      <a:prstDash val="solid"/>
+                      <a:round/>
+                      <a:headEnd type="none" w="med" len="med"/>
+                      <a:tailEnd type="none" w="med" len="med"/>
+                    </a:lnT>
+                    <a:lnB w="12700" cap="flat" cmpd="sng" algn="ctr">
+                      <a:solidFill>
+                        <a:srgbClr val="2A3441"/>
+                      </a:solidFill>
+                      <a:prstDash val="solid"/>
+                      <a:round/>
+                      <a:headEnd type="none" w="med" len="med"/>
+                      <a:tailEnd type="none" w="med" len="med"/>
+                    </a:lnB>
+                    <a:solidFill>
+                      <a:srgbClr val="141B24"/>
+                    </a:solidFill>
+                  </a:tcPr>
+                </a:tc>
+                <a:tc>
+                  <a:txBody>
+                    <a:bodyPr/>
+                    <a:lstStyle/>
+                    <a:p>
+                      <a:pPr indent="0" marL="0">
+                        <a:buNone/>
+                      </a:pPr>
+                      <a:r>
+                        <a:rPr lang="en-US" sz="1300" dirty="0">
+                          <a:solidFill>
+                            <a:srgbClr val="E6EDF3"/>
+                          </a:solidFill>
+                          <a:latin typeface="Calibri" pitchFamily="34" charset="0"/>
+                          <a:ea typeface="Calibri" pitchFamily="34" charset="-122"/>
+                          <a:cs typeface="Calibri" pitchFamily="34" charset="-120"/>
+                        </a:rPr>
+                        <a:t>17.7</a:t>
+                      </a:r>
+                      <a:endParaRPr lang="en-US" sz="1300" dirty="0">
+                        <a:latin typeface="Calibri" charset="0"/>
+                        <a:ea typeface="Calibri" charset="0"/>
+                        <a:cs typeface="Calibri" charset="0"/>
+                      </a:endParaRPr>
+                    </a:p>
+                  </a:txBody>
+                  <a:tcPr marL="91440" marR="91440" marT="45720" marB="45720">
+                    <a:lnL w="12700" cap="flat" cmpd="sng" algn="ctr">
+                      <a:solidFill>
+                        <a:srgbClr val="2A3441"/>
+                      </a:solidFill>
+                      <a:prstDash val="solid"/>
+                      <a:round/>
+                      <a:headEnd type="none" w="med" len="med"/>
+                      <a:tailEnd type="none" w="med" len="med"/>
+                    </a:lnL>
+                    <a:lnR w="12700" cap="flat" cmpd="sng" algn="ctr">
+                      <a:solidFill>
+                        <a:srgbClr val="2A3441"/>
+                      </a:solidFill>
+                      <a:prstDash val="solid"/>
+                      <a:round/>
+                      <a:headEnd type="none" w="med" len="med"/>
+                      <a:tailEnd type="none" w="med" len="med"/>
+                    </a:lnR>
+                    <a:lnT w="12700" cap="flat" cmpd="sng" algn="ctr">
+                      <a:solidFill>
+                        <a:srgbClr val="2A3441"/>
+                      </a:solidFill>
+                      <a:prstDash val="solid"/>
+                      <a:round/>
+                      <a:headEnd type="none" w="med" len="med"/>
+                      <a:tailEnd type="none" w="med" len="med"/>
+                    </a:lnT>
+                    <a:lnB w="12700" cap="flat" cmpd="sng" algn="ctr">
+                      <a:solidFill>
+                        <a:srgbClr val="2A3441"/>
+                      </a:solidFill>
+                      <a:prstDash val="solid"/>
+                      <a:round/>
+                      <a:headEnd type="none" w="med" len="med"/>
+                      <a:tailEnd type="none" w="med" len="med"/>
+                    </a:lnB>
+                    <a:solidFill>
+                      <a:srgbClr val="141B24"/>
+                    </a:solidFill>
+                  </a:tcPr>
+                </a:tc>
+                <a:tc>
+                  <a:txBody>
+                    <a:bodyPr/>
+                    <a:lstStyle/>
+                    <a:p>
+                      <a:pPr indent="0" marL="0">
+                        <a:buNone/>
+                      </a:pPr>
+                      <a:r>
+                        <a:rPr lang="en-US" sz="1300" dirty="0">
+                          <a:solidFill>
+                            <a:srgbClr val="E6EDF3"/>
+                          </a:solidFill>
+                          <a:latin typeface="Calibri" pitchFamily="34" charset="0"/>
+                          <a:ea typeface="Calibri" pitchFamily="34" charset="-122"/>
+                          <a:cs typeface="Calibri" pitchFamily="34" charset="-120"/>
+                        </a:rPr>
+                        <a:t>13.4</a:t>
+                      </a:r>
+                      <a:endParaRPr lang="en-US" sz="1300" dirty="0">
+                        <a:latin typeface="Calibri" charset="0"/>
+                        <a:ea typeface="Calibri" charset="0"/>
+                        <a:cs typeface="Calibri" charset="0"/>
+                      </a:endParaRPr>
+                    </a:p>
+                  </a:txBody>
+                  <a:tcPr marL="91440" marR="91440" marT="45720" marB="45720">
+                    <a:lnL w="12700" cap="flat" cmpd="sng" algn="ctr">
+                      <a:solidFill>
+                        <a:srgbClr val="2A3441"/>
+                      </a:solidFill>
+                      <a:prstDash val="solid"/>
+                      <a:round/>
+                      <a:headEnd type="none" w="med" len="med"/>
+                      <a:tailEnd type="none" w="med" len="med"/>
+                    </a:lnL>
+                    <a:lnR w="12700" cap="flat" cmpd="sng" algn="ctr">
+                      <a:solidFill>
+                        <a:srgbClr val="2A3441"/>
+                      </a:solidFill>
+                      <a:prstDash val="solid"/>
+                      <a:round/>
+                      <a:headEnd type="none" w="med" len="med"/>
+                      <a:tailEnd type="none" w="med" len="med"/>
+                    </a:lnR>
+                    <a:lnT w="12700" cap="flat" cmpd="sng" algn="ctr">
+                      <a:solidFill>
+                        <a:srgbClr val="2A3441"/>
+                      </a:solidFill>
+                      <a:prstDash val="solid"/>
+                      <a:round/>
+                      <a:headEnd type="none" w="med" len="med"/>
+                      <a:tailEnd type="none" w="med" len="med"/>
+                    </a:lnT>
+                    <a:lnB w="12700" cap="flat" cmpd="sng" algn="ctr">
+                      <a:solidFill>
+                        <a:srgbClr val="2A3441"/>
+                      </a:solidFill>
+                      <a:prstDash val="solid"/>
+                      <a:round/>
+                      <a:headEnd type="none" w="med" len="med"/>
+                      <a:tailEnd type="none" w="med" len="med"/>
+                    </a:lnB>
+                    <a:solidFill>
+                      <a:srgbClr val="141B24"/>
+                    </a:solidFill>
+                  </a:tcPr>
+                </a:tc>
+                <a:tc>
+                  <a:txBody>
+                    <a:bodyPr/>
+                    <a:lstStyle/>
+                    <a:p>
+                      <a:pPr indent="0" marL="0">
+                        <a:buNone/>
+                      </a:pPr>
+                      <a:r>
+                        <a:rPr lang="en-US" sz="1300" dirty="0">
+                          <a:solidFill>
+                            <a:srgbClr val="E6EDF3"/>
+                          </a:solidFill>
+                          <a:latin typeface="Calibri" pitchFamily="34" charset="0"/>
+                          <a:ea typeface="Calibri" pitchFamily="34" charset="-122"/>
+                          <a:cs typeface="Calibri" pitchFamily="34" charset="-120"/>
+                        </a:rPr>
+                        <a:t>12.7</a:t>
+                      </a:r>
+                      <a:endParaRPr lang="en-US" sz="1300" dirty="0">
+                        <a:latin typeface="Calibri" charset="0"/>
+                        <a:ea typeface="Calibri" charset="0"/>
+                        <a:cs typeface="Calibri" charset="0"/>
+                      </a:endParaRPr>
+                    </a:p>
+                  </a:txBody>
+                  <a:tcPr marL="91440" marR="91440" marT="45720" marB="45720">
+                    <a:lnL w="12700" cap="flat" cmpd="sng" algn="ctr">
+                      <a:solidFill>
+                        <a:srgbClr val="2A3441"/>
+                      </a:solidFill>
+                      <a:prstDash val="solid"/>
+                      <a:round/>
+                      <a:headEnd type="none" w="med" len="med"/>
+                      <a:tailEnd type="none" w="med" len="med"/>
+                    </a:lnL>
+                    <a:lnR w="12700" cap="flat" cmpd="sng" algn="ctr">
+                      <a:solidFill>
+                        <a:srgbClr val="2A3441"/>
+                      </a:solidFill>
+                      <a:prstDash val="solid"/>
+                      <a:round/>
+                      <a:headEnd type="none" w="med" len="med"/>
+                      <a:tailEnd type="none" w="med" len="med"/>
+                    </a:lnR>
+                    <a:lnT w="12700" cap="flat" cmpd="sng" algn="ctr">
+                      <a:solidFill>
+                        <a:srgbClr val="2A3441"/>
+                      </a:solidFill>
+                      <a:prstDash val="solid"/>
+                      <a:round/>
+                      <a:headEnd type="none" w="med" len="med"/>
+                      <a:tailEnd type="none" w="med" len="med"/>
+                    </a:lnT>
+                    <a:lnB w="12700" cap="flat" cmpd="sng" algn="ctr">
+                      <a:solidFill>
+                        <a:srgbClr val="2A3441"/>
+                      </a:solidFill>
+                      <a:prstDash val="solid"/>
+                      <a:round/>
+                      <a:headEnd type="none" w="med" len="med"/>
+                      <a:tailEnd type="none" w="med" len="med"/>
+                    </a:lnB>
+                    <a:solidFill>
+                      <a:srgbClr val="141B24"/>
+                    </a:solidFill>
+                  </a:tcPr>
+                </a:tc>
+              </a:tr>
+              <a:tr h="402336">
+                <a:tc>
+                  <a:txBody>
+                    <a:bodyPr/>
+                    <a:lstStyle/>
+                    <a:p>
+                      <a:pPr indent="0" marL="0">
+                        <a:buNone/>
+                      </a:pPr>
+                      <a:r>
+                        <a:rPr lang="en-US" sz="1300" dirty="0">
+                          <a:solidFill>
+                            <a:srgbClr val="E6EDF3"/>
+                          </a:solidFill>
+                          <a:latin typeface="Calibri" pitchFamily="34" charset="0"/>
+                          <a:ea typeface="Calibri" pitchFamily="34" charset="-122"/>
+                          <a:cs typeface="Calibri" pitchFamily="34" charset="-120"/>
+                        </a:rPr>
+                        <a:t>Bandwidth rise</a:t>
+                      </a:r>
+                      <a:endParaRPr lang="en-US" sz="1300" dirty="0">
+                        <a:latin typeface="Calibri" charset="0"/>
+                        <a:ea typeface="Calibri" charset="0"/>
+                        <a:cs typeface="Calibri" charset="0"/>
+                      </a:endParaRPr>
+                    </a:p>
+                  </a:txBody>
+                  <a:tcPr marL="91440" marR="91440" marT="45720" marB="45720">
+                    <a:lnL w="12700" cap="flat" cmpd="sng" algn="ctr">
+                      <a:solidFill>
+                        <a:srgbClr val="2A3441"/>
+                      </a:solidFill>
+                      <a:prstDash val="solid"/>
+                      <a:round/>
+                      <a:headEnd type="none" w="med" len="med"/>
+                      <a:tailEnd type="none" w="med" len="med"/>
+                    </a:lnL>
+                    <a:lnR w="12700" cap="flat" cmpd="sng" algn="ctr">
+                      <a:solidFill>
+                        <a:srgbClr val="2A3441"/>
+                      </a:solidFill>
+                      <a:prstDash val="solid"/>
+                      <a:round/>
+                      <a:headEnd type="none" w="med" len="med"/>
+                      <a:tailEnd type="none" w="med" len="med"/>
+                    </a:lnR>
+                    <a:lnT w="12700" cap="flat" cmpd="sng" algn="ctr">
+                      <a:solidFill>
+                        <a:srgbClr val="2A3441"/>
+                      </a:solidFill>
+                      <a:prstDash val="solid"/>
+                      <a:round/>
+                      <a:headEnd type="none" w="med" len="med"/>
+                      <a:tailEnd type="none" w="med" len="med"/>
+                    </a:lnT>
+                    <a:lnB w="12700" cap="flat" cmpd="sng" algn="ctr">
+                      <a:solidFill>
+                        <a:srgbClr val="2A3441"/>
+                      </a:solidFill>
+                      <a:prstDash val="solid"/>
+                      <a:round/>
+                      <a:headEnd type="none" w="med" len="med"/>
+                      <a:tailEnd type="none" w="med" len="med"/>
+                    </a:lnB>
+                    <a:solidFill>
+                      <a:srgbClr val="141B24"/>
+                    </a:solidFill>
+                  </a:tcPr>
+                </a:tc>
+                <a:tc>
+                  <a:txBody>
+                    <a:bodyPr/>
+                    <a:lstStyle/>
+                    <a:p>
+                      <a:pPr indent="0" marL="0">
+                        <a:buNone/>
+                      </a:pPr>
+                      <a:r>
+                        <a:rPr lang="en-US" sz="1300" dirty="0">
+                          <a:solidFill>
+                            <a:srgbClr val="E6EDF3"/>
+                          </a:solidFill>
+                          <a:latin typeface="Calibri" pitchFamily="34" charset="0"/>
+                          <a:ea typeface="Calibri" pitchFamily="34" charset="-122"/>
+                          <a:cs typeface="Calibri" pitchFamily="34" charset="-120"/>
+                        </a:rPr>
+                        <a:t>9.2</a:t>
+                      </a:r>
+                      <a:endParaRPr lang="en-US" sz="1300" dirty="0">
+                        <a:latin typeface="Calibri" charset="0"/>
+                        <a:ea typeface="Calibri" charset="0"/>
+                        <a:cs typeface="Calibri" charset="0"/>
+                      </a:endParaRPr>
+                    </a:p>
+                  </a:txBody>
+                  <a:tcPr marL="91440" marR="91440" marT="45720" marB="45720">
+                    <a:lnL w="12700" cap="flat" cmpd="sng" algn="ctr">
+                      <a:solidFill>
+                        <a:srgbClr val="2A3441"/>
+                      </a:solidFill>
+                      <a:prstDash val="solid"/>
+                      <a:round/>
+                      <a:headEnd type="none" w="med" len="med"/>
+                      <a:tailEnd type="none" w="med" len="med"/>
+                    </a:lnL>
+                    <a:lnR w="12700" cap="flat" cmpd="sng" algn="ctr">
+                      <a:solidFill>
+                        <a:srgbClr val="2A3441"/>
+                      </a:solidFill>
+                      <a:prstDash val="solid"/>
+                      <a:round/>
+                      <a:headEnd type="none" w="med" len="med"/>
+                      <a:tailEnd type="none" w="med" len="med"/>
+                    </a:lnR>
+                    <a:lnT w="12700" cap="flat" cmpd="sng" algn="ctr">
+                      <a:solidFill>
+                        <a:srgbClr val="2A3441"/>
+                      </a:solidFill>
+                      <a:prstDash val="solid"/>
+                      <a:round/>
+                      <a:headEnd type="none" w="med" len="med"/>
+                      <a:tailEnd type="none" w="med" len="med"/>
+                    </a:lnT>
+                    <a:lnB w="12700" cap="flat" cmpd="sng" algn="ctr">
+                      <a:solidFill>
+                        <a:srgbClr val="2A3441"/>
+                      </a:solidFill>
+                      <a:prstDash val="solid"/>
+                      <a:round/>
+                      <a:headEnd type="none" w="med" len="med"/>
+                      <a:tailEnd type="none" w="med" len="med"/>
+                    </a:lnB>
+                    <a:solidFill>
+                      <a:srgbClr val="141B24"/>
+                    </a:solidFill>
+                  </a:tcPr>
+                </a:tc>
+                <a:tc>
+                  <a:txBody>
+                    <a:bodyPr/>
+                    <a:lstStyle/>
+                    <a:p>
+                      <a:pPr indent="0" marL="0">
+                        <a:buNone/>
+                      </a:pPr>
+                      <a:r>
+                        <a:rPr lang="en-US" sz="1300" dirty="0">
+                          <a:solidFill>
+                            <a:srgbClr val="E6EDF3"/>
+                          </a:solidFill>
+                          <a:latin typeface="Calibri" pitchFamily="34" charset="0"/>
+                          <a:ea typeface="Calibri" pitchFamily="34" charset="-122"/>
+                          <a:cs typeface="Calibri" pitchFamily="34" charset="-120"/>
+                        </a:rPr>
+                        <a:t>15.1</a:t>
+                      </a:r>
+                      <a:endParaRPr lang="en-US" sz="1300" dirty="0">
+                        <a:latin typeface="Calibri" charset="0"/>
+                        <a:ea typeface="Calibri" charset="0"/>
+                        <a:cs typeface="Calibri" charset="0"/>
+                      </a:endParaRPr>
+                    </a:p>
+                  </a:txBody>
+                  <a:tcPr marL="91440" marR="91440" marT="45720" marB="45720">
+                    <a:lnL w="12700" cap="flat" cmpd="sng" algn="ctr">
+                      <a:solidFill>
+                        <a:srgbClr val="2A3441"/>
+                      </a:solidFill>
+                      <a:prstDash val="solid"/>
+                      <a:round/>
+                      <a:headEnd type="none" w="med" len="med"/>
+                      <a:tailEnd type="none" w="med" len="med"/>
+                    </a:lnL>
+                    <a:lnR w="12700" cap="flat" cmpd="sng" algn="ctr">
+                      <a:solidFill>
+                        <a:srgbClr val="2A3441"/>
+                      </a:solidFill>
+                      <a:prstDash val="solid"/>
+                      <a:round/>
+                      <a:headEnd type="none" w="med" len="med"/>
+                      <a:tailEnd type="none" w="med" len="med"/>
+                    </a:lnR>
+                    <a:lnT w="12700" cap="flat" cmpd="sng" algn="ctr">
+                      <a:solidFill>
+                        <a:srgbClr val="2A3441"/>
+                      </a:solidFill>
+                      <a:prstDash val="solid"/>
+                      <a:round/>
+                      <a:headEnd type="none" w="med" len="med"/>
+                      <a:tailEnd type="none" w="med" len="med"/>
+                    </a:lnT>
+                    <a:lnB w="12700" cap="flat" cmpd="sng" algn="ctr">
+                      <a:solidFill>
+                        <a:srgbClr val="2A3441"/>
+                      </a:solidFill>
+                      <a:prstDash val="solid"/>
+                      <a:round/>
+                      <a:headEnd type="none" w="med" len="med"/>
+                      <a:tailEnd type="none" w="med" len="med"/>
+                    </a:lnB>
+                    <a:solidFill>
+                      <a:srgbClr val="141B24"/>
+                    </a:solidFill>
+                  </a:tcPr>
+                </a:tc>
+                <a:tc>
+                  <a:txBody>
+                    <a:bodyPr/>
+                    <a:lstStyle/>
+                    <a:p>
+                      <a:pPr indent="0" marL="0">
+                        <a:buNone/>
+                      </a:pPr>
+                      <a:r>
+                        <a:rPr lang="en-US" sz="1300" dirty="0">
+                          <a:solidFill>
+                            <a:srgbClr val="E6EDF3"/>
+                          </a:solidFill>
+                          <a:latin typeface="Calibri" pitchFamily="34" charset="0"/>
+                          <a:ea typeface="Calibri" pitchFamily="34" charset="-122"/>
+                          <a:cs typeface="Calibri" pitchFamily="34" charset="-120"/>
+                        </a:rPr>
+                        <a:t>5.0</a:t>
+                      </a:r>
+                      <a:endParaRPr lang="en-US" sz="1300" dirty="0">
+                        <a:latin typeface="Calibri" charset="0"/>
+                        <a:ea typeface="Calibri" charset="0"/>
+                        <a:cs typeface="Calibri" charset="0"/>
+                      </a:endParaRPr>
+                    </a:p>
+                  </a:txBody>
+                  <a:tcPr marL="91440" marR="91440" marT="45720" marB="45720">
+                    <a:lnL w="12700" cap="flat" cmpd="sng" algn="ctr">
+                      <a:solidFill>
+                        <a:srgbClr val="2A3441"/>
+                      </a:solidFill>
+                      <a:prstDash val="solid"/>
+                      <a:round/>
+                      <a:headEnd type="none" w="med" len="med"/>
+                      <a:tailEnd type="none" w="med" len="med"/>
+                    </a:lnL>
+                    <a:lnR w="12700" cap="flat" cmpd="sng" algn="ctr">
+                      <a:solidFill>
+                        <a:srgbClr val="2A3441"/>
+                      </a:solidFill>
+                      <a:prstDash val="solid"/>
+                      <a:round/>
+                      <a:headEnd type="none" w="med" len="med"/>
+                      <a:tailEnd type="none" w="med" len="med"/>
+                    </a:lnR>
+                    <a:lnT w="12700" cap="flat" cmpd="sng" algn="ctr">
+                      <a:solidFill>
+                        <a:srgbClr val="2A3441"/>
+                      </a:solidFill>
+                      <a:prstDash val="solid"/>
+                      <a:round/>
+                      <a:headEnd type="none" w="med" len="med"/>
+                      <a:tailEnd type="none" w="med" len="med"/>
+                    </a:lnT>
+                    <a:lnB w="12700" cap="flat" cmpd="sng" algn="ctr">
+                      <a:solidFill>
+                        <a:srgbClr val="2A3441"/>
+                      </a:solidFill>
+                      <a:prstDash val="solid"/>
+                      <a:round/>
+                      <a:headEnd type="none" w="med" len="med"/>
+                      <a:tailEnd type="none" w="med" len="med"/>
+                    </a:lnB>
+                    <a:solidFill>
+                      <a:srgbClr val="141B24"/>
+                    </a:solidFill>
+                  </a:tcPr>
+                </a:tc>
+                <a:tc>
+                  <a:txBody>
+                    <a:bodyPr/>
+                    <a:lstStyle/>
+                    <a:p>
+                      <a:pPr indent="0" marL="0">
+                        <a:buNone/>
+                      </a:pPr>
+                      <a:r>
+                        <a:rPr lang="en-US" sz="1300" dirty="0">
+                          <a:solidFill>
+                            <a:srgbClr val="E6EDF3"/>
+                          </a:solidFill>
+                          <a:latin typeface="Calibri" pitchFamily="34" charset="0"/>
+                          <a:ea typeface="Calibri" pitchFamily="34" charset="-122"/>
+                          <a:cs typeface="Calibri" pitchFamily="34" charset="-120"/>
+                        </a:rPr>
+                        <a:t>4.3</a:t>
+                      </a:r>
+                      <a:endParaRPr lang="en-US" sz="1300" dirty="0">
+                        <a:latin typeface="Calibri" charset="0"/>
+                        <a:ea typeface="Calibri" charset="0"/>
+                        <a:cs typeface="Calibri" charset="0"/>
+                      </a:endParaRPr>
+                    </a:p>
+                  </a:txBody>
+                  <a:tcPr marL="91440" marR="91440" marT="45720" marB="45720">
+                    <a:lnL w="12700" cap="flat" cmpd="sng" algn="ctr">
+                      <a:solidFill>
+                        <a:srgbClr val="2A3441"/>
+                      </a:solidFill>
+                      <a:prstDash val="solid"/>
+                      <a:round/>
+                      <a:headEnd type="none" w="med" len="med"/>
+                      <a:tailEnd type="none" w="med" len="med"/>
+                    </a:lnL>
+                    <a:lnR w="12700" cap="flat" cmpd="sng" algn="ctr">
+                      <a:solidFill>
+                        <a:srgbClr val="2A3441"/>
+                      </a:solidFill>
+                      <a:prstDash val="solid"/>
+                      <a:round/>
+                      <a:headEnd type="none" w="med" len="med"/>
+                      <a:tailEnd type="none" w="med" len="med"/>
+                    </a:lnR>
+                    <a:lnT w="12700" cap="flat" cmpd="sng" algn="ctr">
+                      <a:solidFill>
+                        <a:srgbClr val="2A3441"/>
+                      </a:solidFill>
+                      <a:prstDash val="solid"/>
+                      <a:round/>
+                      <a:headEnd type="none" w="med" len="med"/>
+                      <a:tailEnd type="none" w="med" len="med"/>
+                    </a:lnT>
+                    <a:lnB w="12700" cap="flat" cmpd="sng" algn="ctr">
+                      <a:solidFill>
+                        <a:srgbClr val="2A3441"/>
+                      </a:solidFill>
+                      <a:prstDash val="solid"/>
+                      <a:round/>
+                      <a:headEnd type="none" w="med" len="med"/>
+                      <a:tailEnd type="none" w="med" len="med"/>
+                    </a:lnB>
+                    <a:solidFill>
+                      <a:srgbClr val="141B24"/>
+                    </a:solidFill>
+                  </a:tcPr>
+                </a:tc>
+              </a:tr>
+              <a:tr h="402336">
+                <a:tc>
+                  <a:txBody>
+                    <a:bodyPr/>
+                    <a:lstStyle/>
+                    <a:p>
+                      <a:pPr indent="0" marL="0">
+                        <a:buNone/>
+                      </a:pPr>
+                      <a:r>
+                        <a:rPr lang="en-US" sz="1300" dirty="0">
+                          <a:solidFill>
+                            <a:srgbClr val="E6EDF3"/>
+                          </a:solidFill>
+                          <a:latin typeface="Calibri" pitchFamily="34" charset="0"/>
+                          <a:ea typeface="Calibri" pitchFamily="34" charset="-122"/>
+                          <a:cs typeface="Calibri" pitchFamily="34" charset="-120"/>
+                        </a:rPr>
+                        <a:t>Delay jump</a:t>
+                      </a:r>
+                      <a:endParaRPr lang="en-US" sz="1300" dirty="0">
+                        <a:latin typeface="Calibri" charset="0"/>
+                        <a:ea typeface="Calibri" charset="0"/>
+                        <a:cs typeface="Calibri" charset="0"/>
+                      </a:endParaRPr>
+                    </a:p>
+                  </a:txBody>
+                  <a:tcPr marL="91440" marR="91440" marT="45720" marB="45720">
+                    <a:lnL w="12700" cap="flat" cmpd="sng" algn="ctr">
+                      <a:solidFill>
+                        <a:srgbClr val="2A3441"/>
+                      </a:solidFill>
+                      <a:prstDash val="solid"/>
+                      <a:round/>
+                      <a:headEnd type="none" w="med" len="med"/>
+                      <a:tailEnd type="none" w="med" len="med"/>
+                    </a:lnL>
+                    <a:lnR w="12700" cap="flat" cmpd="sng" algn="ctr">
+                      <a:solidFill>
+                        <a:srgbClr val="2A3441"/>
+                      </a:solidFill>
+                      <a:prstDash val="solid"/>
+                      <a:round/>
+                      <a:headEnd type="none" w="med" len="med"/>
+                      <a:tailEnd type="none" w="med" len="med"/>
+                    </a:lnR>
+                    <a:lnT w="12700" cap="flat" cmpd="sng" algn="ctr">
+                      <a:solidFill>
+                        <a:srgbClr val="2A3441"/>
+                      </a:solidFill>
+                      <a:prstDash val="solid"/>
+                      <a:round/>
+                      <a:headEnd type="none" w="med" len="med"/>
+                      <a:tailEnd type="none" w="med" len="med"/>
+                    </a:lnT>
+                    <a:lnB w="12700" cap="flat" cmpd="sng" algn="ctr">
+                      <a:solidFill>
+                        <a:srgbClr val="2A3441"/>
+                      </a:solidFill>
+                      <a:prstDash val="solid"/>
+                      <a:round/>
+                      <a:headEnd type="none" w="med" len="med"/>
+                      <a:tailEnd type="none" w="med" len="med"/>
+                    </a:lnB>
+                    <a:solidFill>
+                      <a:srgbClr val="141B24"/>
+                    </a:solidFill>
+                  </a:tcPr>
+                </a:tc>
+                <a:tc>
+                  <a:txBody>
+                    <a:bodyPr/>
+                    <a:lstStyle/>
+                    <a:p>
+                      <a:pPr indent="0" marL="0">
+                        <a:buNone/>
+                      </a:pPr>
+                      <a:r>
+                        <a:rPr lang="en-US" sz="1300" dirty="0">
+                          <a:solidFill>
+                            <a:srgbClr val="E6EDF3"/>
+                          </a:solidFill>
+                          <a:latin typeface="Calibri" pitchFamily="34" charset="0"/>
+                          <a:ea typeface="Calibri" pitchFamily="34" charset="-122"/>
+                          <a:cs typeface="Calibri" pitchFamily="34" charset="-120"/>
+                        </a:rPr>
+                        <a:t>33.3</a:t>
+                      </a:r>
+                      <a:endParaRPr lang="en-US" sz="1300" dirty="0">
+                        <a:latin typeface="Calibri" charset="0"/>
+                        <a:ea typeface="Calibri" charset="0"/>
+                        <a:cs typeface="Calibri" charset="0"/>
+                      </a:endParaRPr>
+                    </a:p>
+                  </a:txBody>
+                  <a:tcPr marL="91440" marR="91440" marT="45720" marB="45720">
+                    <a:lnL w="12700" cap="flat" cmpd="sng" algn="ctr">
+                      <a:solidFill>
+                        <a:srgbClr val="2A3441"/>
+                      </a:solidFill>
+                      <a:prstDash val="solid"/>
+                      <a:round/>
+                      <a:headEnd type="none" w="med" len="med"/>
+                      <a:tailEnd type="none" w="med" len="med"/>
+                    </a:lnL>
+                    <a:lnR w="12700" cap="flat" cmpd="sng" algn="ctr">
+                      <a:solidFill>
+                        <a:srgbClr val="2A3441"/>
+                      </a:solidFill>
+                      <a:prstDash val="solid"/>
+                      <a:round/>
+                      <a:headEnd type="none" w="med" len="med"/>
+                      <a:tailEnd type="none" w="med" len="med"/>
+                    </a:lnR>
+                    <a:lnT w="12700" cap="flat" cmpd="sng" algn="ctr">
+                      <a:solidFill>
+                        <a:srgbClr val="2A3441"/>
+                      </a:solidFill>
+                      <a:prstDash val="solid"/>
+                      <a:round/>
+                      <a:headEnd type="none" w="med" len="med"/>
+                      <a:tailEnd type="none" w="med" len="med"/>
+                    </a:lnT>
+                    <a:lnB w="12700" cap="flat" cmpd="sng" algn="ctr">
+                      <a:solidFill>
+                        <a:srgbClr val="2A3441"/>
+                      </a:solidFill>
+                      <a:prstDash val="solid"/>
+                      <a:round/>
+                      <a:headEnd type="none" w="med" len="med"/>
+                      <a:tailEnd type="none" w="med" len="med"/>
+                    </a:lnB>
+                    <a:solidFill>
+                      <a:srgbClr val="141B24"/>
+                    </a:solidFill>
+                  </a:tcPr>
+                </a:tc>
+                <a:tc>
+                  <a:txBody>
+                    <a:bodyPr/>
+                    <a:lstStyle/>
+                    <a:p>
+                      <a:pPr indent="0" marL="0">
+                        <a:buNone/>
+                      </a:pPr>
+                      <a:r>
+                        <a:rPr lang="en-US" sz="1300" dirty="0">
+                          <a:solidFill>
+                            <a:srgbClr val="E6EDF3"/>
+                          </a:solidFill>
+                          <a:latin typeface="Calibri" pitchFamily="34" charset="0"/>
+                          <a:ea typeface="Calibri" pitchFamily="34" charset="-122"/>
+                          <a:cs typeface="Calibri" pitchFamily="34" charset="-120"/>
+                        </a:rPr>
+                        <a:t>27.5</a:t>
+                      </a:r>
+                      <a:endParaRPr lang="en-US" sz="1300" dirty="0">
+                        <a:latin typeface="Calibri" charset="0"/>
+                        <a:ea typeface="Calibri" charset="0"/>
+                        <a:cs typeface="Calibri" charset="0"/>
+                      </a:endParaRPr>
+                    </a:p>
+                  </a:txBody>
+                  <a:tcPr marL="91440" marR="91440" marT="45720" marB="45720">
+                    <a:lnL w="12700" cap="flat" cmpd="sng" algn="ctr">
+                      <a:solidFill>
+                        <a:srgbClr val="2A3441"/>
+                      </a:solidFill>
+                      <a:prstDash val="solid"/>
+                      <a:round/>
+                      <a:headEnd type="none" w="med" len="med"/>
+                      <a:tailEnd type="none" w="med" len="med"/>
+                    </a:lnL>
+                    <a:lnR w="12700" cap="flat" cmpd="sng" algn="ctr">
+                      <a:solidFill>
+                        <a:srgbClr val="2A3441"/>
+                      </a:solidFill>
+                      <a:prstDash val="solid"/>
+                      <a:round/>
+                      <a:headEnd type="none" w="med" len="med"/>
+                      <a:tailEnd type="none" w="med" len="med"/>
+                    </a:lnR>
+                    <a:lnT w="12700" cap="flat" cmpd="sng" algn="ctr">
+                      <a:solidFill>
+                        <a:srgbClr val="2A3441"/>
+                      </a:solidFill>
+                      <a:prstDash val="solid"/>
+                      <a:round/>
+                      <a:headEnd type="none" w="med" len="med"/>
+                      <a:tailEnd type="none" w="med" len="med"/>
+                    </a:lnT>
+                    <a:lnB w="12700" cap="flat" cmpd="sng" algn="ctr">
+                      <a:solidFill>
+                        <a:srgbClr val="2A3441"/>
+                      </a:solidFill>
+                      <a:prstDash val="solid"/>
+                      <a:round/>
+                      <a:headEnd type="none" w="med" len="med"/>
+                      <a:tailEnd type="none" w="med" len="med"/>
+                    </a:lnB>
+                    <a:solidFill>
+                      <a:srgbClr val="141B24"/>
+                    </a:solidFill>
+                  </a:tcPr>
+                </a:tc>
+                <a:tc>
+                  <a:txBody>
+                    <a:bodyPr/>
+                    <a:lstStyle/>
+                    <a:p>
+                      <a:pPr indent="0" marL="0">
+                        <a:buNone/>
+                      </a:pPr>
+                      <a:r>
+                        <a:rPr lang="en-US" sz="1300" dirty="0">
+                          <a:solidFill>
+                            <a:srgbClr val="E6EDF3"/>
+                          </a:solidFill>
+                          <a:latin typeface="Calibri" pitchFamily="34" charset="0"/>
+                          <a:ea typeface="Calibri" pitchFamily="34" charset="-122"/>
+                          <a:cs typeface="Calibri" pitchFamily="34" charset="-120"/>
+                        </a:rPr>
+                        <a:t>25.9</a:t>
+                      </a:r>
+                      <a:endParaRPr lang="en-US" sz="1300" dirty="0">
+                        <a:latin typeface="Calibri" charset="0"/>
+                        <a:ea typeface="Calibri" charset="0"/>
+                        <a:cs typeface="Calibri" charset="0"/>
+                      </a:endParaRPr>
+                    </a:p>
+                  </a:txBody>
+                  <a:tcPr marL="91440" marR="91440" marT="45720" marB="45720">
+                    <a:lnL w="12700" cap="flat" cmpd="sng" algn="ctr">
+                      <a:solidFill>
+                        <a:srgbClr val="2A3441"/>
+                      </a:solidFill>
+                      <a:prstDash val="solid"/>
+                      <a:round/>
+                      <a:headEnd type="none" w="med" len="med"/>
+                      <a:tailEnd type="none" w="med" len="med"/>
+                    </a:lnL>
+                    <a:lnR w="12700" cap="flat" cmpd="sng" algn="ctr">
+                      <a:solidFill>
+                        <a:srgbClr val="2A3441"/>
+                      </a:solidFill>
+                      <a:prstDash val="solid"/>
+                      <a:round/>
+                      <a:headEnd type="none" w="med" len="med"/>
+                      <a:tailEnd type="none" w="med" len="med"/>
+                    </a:lnR>
+                    <a:lnT w="12700" cap="flat" cmpd="sng" algn="ctr">
+                      <a:solidFill>
+                        <a:srgbClr val="2A3441"/>
+                      </a:solidFill>
+                      <a:prstDash val="solid"/>
+                      <a:round/>
+                      <a:headEnd type="none" w="med" len="med"/>
+                      <a:tailEnd type="none" w="med" len="med"/>
+                    </a:lnT>
+                    <a:lnB w="12700" cap="flat" cmpd="sng" algn="ctr">
+                      <a:solidFill>
+                        <a:srgbClr val="2A3441"/>
+                      </a:solidFill>
+                      <a:prstDash val="solid"/>
+                      <a:round/>
+                      <a:headEnd type="none" w="med" len="med"/>
+                      <a:tailEnd type="none" w="med" len="med"/>
+                    </a:lnB>
+                    <a:solidFill>
+                      <a:srgbClr val="141B24"/>
+                    </a:solidFill>
+                  </a:tcPr>
+                </a:tc>
+                <a:tc>
+                  <a:txBody>
+                    <a:bodyPr/>
+                    <a:lstStyle/>
+                    <a:p>
+                      <a:pPr indent="0" marL="0">
+                        <a:buNone/>
+                      </a:pPr>
+                      <a:r>
+                        <a:rPr lang="en-US" sz="1300" dirty="0">
+                          <a:solidFill>
+                            <a:srgbClr val="E6EDF3"/>
+                          </a:solidFill>
+                          <a:latin typeface="Calibri" pitchFamily="34" charset="0"/>
+                          <a:ea typeface="Calibri" pitchFamily="34" charset="-122"/>
+                          <a:cs typeface="Calibri" pitchFamily="34" charset="-120"/>
+                        </a:rPr>
+                        <a:t>19.8</a:t>
+                      </a:r>
+                      <a:endParaRPr lang="en-US" sz="1300" dirty="0">
+                        <a:latin typeface="Calibri" charset="0"/>
+                        <a:ea typeface="Calibri" charset="0"/>
+                        <a:cs typeface="Calibri" charset="0"/>
+                      </a:endParaRPr>
+                    </a:p>
+                  </a:txBody>
+                  <a:tcPr marL="91440" marR="91440" marT="45720" marB="45720">
+                    <a:lnL w="12700" cap="flat" cmpd="sng" algn="ctr">
+                      <a:solidFill>
+                        <a:srgbClr val="2A3441"/>
+                      </a:solidFill>
+                      <a:prstDash val="solid"/>
+                      <a:round/>
+                      <a:headEnd type="none" w="med" len="med"/>
+                      <a:tailEnd type="none" w="med" len="med"/>
+                    </a:lnL>
+                    <a:lnR w="12700" cap="flat" cmpd="sng" algn="ctr">
+                      <a:solidFill>
+                        <a:srgbClr val="2A3441"/>
+                      </a:solidFill>
+                      <a:prstDash val="solid"/>
+                      <a:round/>
+                      <a:headEnd type="none" w="med" len="med"/>
+                      <a:tailEnd type="none" w="med" len="med"/>
+                    </a:lnR>
+                    <a:lnT w="12700" cap="flat" cmpd="sng" algn="ctr">
+                      <a:solidFill>
+                        <a:srgbClr val="2A3441"/>
+                      </a:solidFill>
+                      <a:prstDash val="solid"/>
+                      <a:round/>
+                      <a:headEnd type="none" w="med" len="med"/>
+                      <a:tailEnd type="none" w="med" len="med"/>
+                    </a:lnT>
+                    <a:lnB w="12700" cap="flat" cmpd="sng" algn="ctr">
+                      <a:solidFill>
+                        <a:srgbClr val="2A3441"/>
+                      </a:solidFill>
+                      <a:prstDash val="solid"/>
+                      <a:round/>
+                      <a:headEnd type="none" w="med" len="med"/>
+                      <a:tailEnd type="none" w="med" len="med"/>
+                    </a:lnB>
+                    <a:solidFill>
+                      <a:srgbClr val="141B24"/>
+                    </a:solidFill>
+                  </a:tcPr>
+                </a:tc>
+              </a:tr>
+              <a:tr h="402336">
+                <a:tc>
+                  <a:txBody>
+                    <a:bodyPr/>
+                    <a:lstStyle/>
+                    <a:p>
+                      <a:pPr indent="0" marL="0">
+                        <a:buNone/>
+                      </a:pPr>
+                      <a:r>
+                        <a:rPr lang="en-US" sz="1300" dirty="0">
+                          <a:solidFill>
+                            <a:srgbClr val="E6EDF3"/>
+                          </a:solidFill>
+                          <a:latin typeface="Calibri" pitchFamily="34" charset="0"/>
+                          <a:ea typeface="Calibri" pitchFamily="34" charset="-122"/>
+                          <a:cs typeface="Calibri" pitchFamily="34" charset="-120"/>
+                        </a:rPr>
+                        <a:t>Hand-over pattern</a:t>
+                      </a:r>
+                      <a:endParaRPr lang="en-US" sz="1300" dirty="0">
+                        <a:latin typeface="Calibri" charset="0"/>
+                        <a:ea typeface="Calibri" charset="0"/>
+                        <a:cs typeface="Calibri" charset="0"/>
+                      </a:endParaRPr>
+                    </a:p>
+                  </a:txBody>
+                  <a:tcPr marL="91440" marR="91440" marT="45720" marB="45720">
+                    <a:lnL w="12700" cap="flat" cmpd="sng" algn="ctr">
+                      <a:solidFill>
+                        <a:srgbClr val="2A3441"/>
+                      </a:solidFill>
+                      <a:prstDash val="solid"/>
+                      <a:round/>
+                      <a:headEnd type="none" w="med" len="med"/>
+                      <a:tailEnd type="none" w="med" len="med"/>
+                    </a:lnL>
+                    <a:lnR w="12700" cap="flat" cmpd="sng" algn="ctr">
+                      <a:solidFill>
+                        <a:srgbClr val="2A3441"/>
+                      </a:solidFill>
+                      <a:prstDash val="solid"/>
+                      <a:round/>
+                      <a:headEnd type="none" w="med" len="med"/>
+                      <a:tailEnd type="none" w="med" len="med"/>
+                    </a:lnR>
+                    <a:lnT w="12700" cap="flat" cmpd="sng" algn="ctr">
+                      <a:solidFill>
+                        <a:srgbClr val="2A3441"/>
+                      </a:solidFill>
+                      <a:prstDash val="solid"/>
+                      <a:round/>
+                      <a:headEnd type="none" w="med" len="med"/>
+                      <a:tailEnd type="none" w="med" len="med"/>
+                    </a:lnT>
+                    <a:lnB w="12700" cap="flat" cmpd="sng" algn="ctr">
+                      <a:solidFill>
+                        <a:srgbClr val="2A3441"/>
+                      </a:solidFill>
+                      <a:prstDash val="solid"/>
+                      <a:round/>
+                      <a:headEnd type="none" w="med" len="med"/>
+                      <a:tailEnd type="none" w="med" len="med"/>
+                    </a:lnB>
+                    <a:solidFill>
+                      <a:srgbClr val="141B24"/>
+                    </a:solidFill>
+                  </a:tcPr>
+                </a:tc>
+                <a:tc>
+                  <a:txBody>
+                    <a:bodyPr/>
+                    <a:lstStyle/>
+                    <a:p>
+                      <a:pPr indent="0" marL="0">
+                        <a:buNone/>
+                      </a:pPr>
+                      <a:r>
+                        <a:rPr lang="en-US" sz="1300" dirty="0">
+                          <a:solidFill>
+                            <a:srgbClr val="E6EDF3"/>
+                          </a:solidFill>
+                          <a:latin typeface="Calibri" pitchFamily="34" charset="0"/>
+                          <a:ea typeface="Calibri" pitchFamily="34" charset="-122"/>
+                          <a:cs typeface="Calibri" pitchFamily="34" charset="-120"/>
+                        </a:rPr>
+                        <a:t>12.8</a:t>
+                      </a:r>
+                      <a:endParaRPr lang="en-US" sz="1300" dirty="0">
+                        <a:latin typeface="Calibri" charset="0"/>
+                        <a:ea typeface="Calibri" charset="0"/>
+                        <a:cs typeface="Calibri" charset="0"/>
+                      </a:endParaRPr>
+                    </a:p>
+                  </a:txBody>
+                  <a:tcPr marL="91440" marR="91440" marT="45720" marB="45720">
+                    <a:lnL w="12700" cap="flat" cmpd="sng" algn="ctr">
+                      <a:solidFill>
+                        <a:srgbClr val="2A3441"/>
+                      </a:solidFill>
+                      <a:prstDash val="solid"/>
+                      <a:round/>
+                      <a:headEnd type="none" w="med" len="med"/>
+                      <a:tailEnd type="none" w="med" len="med"/>
+                    </a:lnL>
+                    <a:lnR w="12700" cap="flat" cmpd="sng" algn="ctr">
+                      <a:solidFill>
+                        <a:srgbClr val="2A3441"/>
+                      </a:solidFill>
+                      <a:prstDash val="solid"/>
+                      <a:round/>
+                      <a:headEnd type="none" w="med" len="med"/>
+                      <a:tailEnd type="none" w="med" len="med"/>
+                    </a:lnR>
+                    <a:lnT w="12700" cap="flat" cmpd="sng" algn="ctr">
+                      <a:solidFill>
+                        <a:srgbClr val="2A3441"/>
+                      </a:solidFill>
+                      <a:prstDash val="solid"/>
+                      <a:round/>
+                      <a:headEnd type="none" w="med" len="med"/>
+                      <a:tailEnd type="none" w="med" len="med"/>
+                    </a:lnT>
+                    <a:lnB w="12700" cap="flat" cmpd="sng" algn="ctr">
+                      <a:solidFill>
+                        <a:srgbClr val="2A3441"/>
+                      </a:solidFill>
+                      <a:prstDash val="solid"/>
+                      <a:round/>
+                      <a:headEnd type="none" w="med" len="med"/>
+                      <a:tailEnd type="none" w="med" len="med"/>
+                    </a:lnB>
+                    <a:solidFill>
+                      <a:srgbClr val="141B24"/>
+                    </a:solidFill>
+                  </a:tcPr>
+                </a:tc>
+                <a:tc>
+                  <a:txBody>
+                    <a:bodyPr/>
+                    <a:lstStyle/>
+                    <a:p>
+                      <a:pPr indent="0" marL="0">
+                        <a:buNone/>
+                      </a:pPr>
+                      <a:r>
+                        <a:rPr lang="en-US" sz="1300" dirty="0">
+                          <a:solidFill>
+                            <a:srgbClr val="E6EDF3"/>
+                          </a:solidFill>
+                          <a:latin typeface="Calibri" pitchFamily="34" charset="0"/>
+                          <a:ea typeface="Calibri" pitchFamily="34" charset="-122"/>
+                          <a:cs typeface="Calibri" pitchFamily="34" charset="-120"/>
+                        </a:rPr>
+                        <a:t>21.4</a:t>
+                      </a:r>
+                      <a:endParaRPr lang="en-US" sz="1300" dirty="0">
+                        <a:latin typeface="Calibri" charset="0"/>
+                        <a:ea typeface="Calibri" charset="0"/>
+                        <a:cs typeface="Calibri" charset="0"/>
+                      </a:endParaRPr>
+                    </a:p>
+                  </a:txBody>
+                  <a:tcPr marL="91440" marR="91440" marT="45720" marB="45720">
+                    <a:lnL w="12700" cap="flat" cmpd="sng" algn="ctr">
+                      <a:solidFill>
+                        <a:srgbClr val="2A3441"/>
+                      </a:solidFill>
+                      <a:prstDash val="solid"/>
+                      <a:round/>
+                      <a:headEnd type="none" w="med" len="med"/>
+                      <a:tailEnd type="none" w="med" len="med"/>
+                    </a:lnL>
+                    <a:lnR w="12700" cap="flat" cmpd="sng" algn="ctr">
+                      <a:solidFill>
+                        <a:srgbClr val="2A3441"/>
+                      </a:solidFill>
+                      <a:prstDash val="solid"/>
+                      <a:round/>
+                      <a:headEnd type="none" w="med" len="med"/>
+                      <a:tailEnd type="none" w="med" len="med"/>
+                    </a:lnR>
+                    <a:lnT w="12700" cap="flat" cmpd="sng" algn="ctr">
+                      <a:solidFill>
+                        <a:srgbClr val="2A3441"/>
+                      </a:solidFill>
+                      <a:prstDash val="solid"/>
+                      <a:round/>
+                      <a:headEnd type="none" w="med" len="med"/>
+                      <a:tailEnd type="none" w="med" len="med"/>
+                    </a:lnT>
+                    <a:lnB w="12700" cap="flat" cmpd="sng" algn="ctr">
+                      <a:solidFill>
+                        <a:srgbClr val="2A3441"/>
+                      </a:solidFill>
+                      <a:prstDash val="solid"/>
+                      <a:round/>
+                      <a:headEnd type="none" w="med" len="med"/>
+                      <a:tailEnd type="none" w="med" len="med"/>
+                    </a:lnB>
+                    <a:solidFill>
+                      <a:srgbClr val="141B24"/>
+                    </a:solidFill>
+                  </a:tcPr>
+                </a:tc>
+                <a:tc>
+                  <a:txBody>
+                    <a:bodyPr/>
+                    <a:lstStyle/>
+                    <a:p>
+                      <a:pPr indent="0" marL="0">
+                        <a:buNone/>
+                      </a:pPr>
+                      <a:r>
+                        <a:rPr lang="en-US" sz="1300" dirty="0">
+                          <a:solidFill>
+                            <a:srgbClr val="E6EDF3"/>
+                          </a:solidFill>
+                          <a:latin typeface="Calibri" pitchFamily="34" charset="0"/>
+                          <a:ea typeface="Calibri" pitchFamily="34" charset="-122"/>
+                          <a:cs typeface="Calibri" pitchFamily="34" charset="-120"/>
+                        </a:rPr>
+                        <a:t>10.8</a:t>
+                      </a:r>
+                      <a:endParaRPr lang="en-US" sz="1300" dirty="0">
+                        <a:latin typeface="Calibri" charset="0"/>
+                        <a:ea typeface="Calibri" charset="0"/>
+                        <a:cs typeface="Calibri" charset="0"/>
+                      </a:endParaRPr>
+                    </a:p>
+                  </a:txBody>
+                  <a:tcPr marL="91440" marR="91440" marT="45720" marB="45720">
+                    <a:lnL w="12700" cap="flat" cmpd="sng" algn="ctr">
+                      <a:solidFill>
+                        <a:srgbClr val="2A3441"/>
+                      </a:solidFill>
+                      <a:prstDash val="solid"/>
+                      <a:round/>
+                      <a:headEnd type="none" w="med" len="med"/>
+                      <a:tailEnd type="none" w="med" len="med"/>
+                    </a:lnL>
+                    <a:lnR w="12700" cap="flat" cmpd="sng" algn="ctr">
+                      <a:solidFill>
+                        <a:srgbClr val="2A3441"/>
+                      </a:solidFill>
+                      <a:prstDash val="solid"/>
+                      <a:round/>
+                      <a:headEnd type="none" w="med" len="med"/>
+                      <a:tailEnd type="none" w="med" len="med"/>
+                    </a:lnR>
+                    <a:lnT w="12700" cap="flat" cmpd="sng" algn="ctr">
+                      <a:solidFill>
+                        <a:srgbClr val="2A3441"/>
+                      </a:solidFill>
+                      <a:prstDash val="solid"/>
+                      <a:round/>
+                      <a:headEnd type="none" w="med" len="med"/>
+                      <a:tailEnd type="none" w="med" len="med"/>
+                    </a:lnT>
+                    <a:lnB w="12700" cap="flat" cmpd="sng" algn="ctr">
+                      <a:solidFill>
+                        <a:srgbClr val="2A3441"/>
+                      </a:solidFill>
+                      <a:prstDash val="solid"/>
+                      <a:round/>
+                      <a:headEnd type="none" w="med" len="med"/>
+                      <a:tailEnd type="none" w="med" len="med"/>
+                    </a:lnB>
+                    <a:solidFill>
+                      <a:srgbClr val="141B24"/>
+                    </a:solidFill>
+                  </a:tcPr>
+                </a:tc>
+                <a:tc>
+                  <a:txBody>
+                    <a:bodyPr/>
+                    <a:lstStyle/>
+                    <a:p>
+                      <a:pPr indent="0" marL="0">
+                        <a:buNone/>
+                      </a:pPr>
+                      <a:r>
+                        <a:rPr lang="en-US" sz="1300" dirty="0">
+                          <a:solidFill>
+                            <a:srgbClr val="E6EDF3"/>
+                          </a:solidFill>
+                          <a:latin typeface="Calibri" pitchFamily="34" charset="0"/>
+                          <a:ea typeface="Calibri" pitchFamily="34" charset="-122"/>
+                          <a:cs typeface="Calibri" pitchFamily="34" charset="-120"/>
+                        </a:rPr>
+                        <a:t>8.2</a:t>
+                      </a:r>
+                      <a:endParaRPr lang="en-US" sz="1300" dirty="0">
+                        <a:latin typeface="Calibri" charset="0"/>
+                        <a:ea typeface="Calibri" charset="0"/>
+                        <a:cs typeface="Calibri" charset="0"/>
+                      </a:endParaRPr>
+                    </a:p>
+                  </a:txBody>
+                  <a:tcPr marL="91440" marR="91440" marT="45720" marB="45720">
+                    <a:lnL w="12700" cap="flat" cmpd="sng" algn="ctr">
+                      <a:solidFill>
+                        <a:srgbClr val="2A3441"/>
+                      </a:solidFill>
+                      <a:prstDash val="solid"/>
+                      <a:round/>
+                      <a:headEnd type="none" w="med" len="med"/>
+                      <a:tailEnd type="none" w="med" len="med"/>
+                    </a:lnL>
+                    <a:lnR w="12700" cap="flat" cmpd="sng" algn="ctr">
+                      <a:solidFill>
+                        <a:srgbClr val="2A3441"/>
+                      </a:solidFill>
+                      <a:prstDash val="solid"/>
+                      <a:round/>
+                      <a:headEnd type="none" w="med" len="med"/>
+                      <a:tailEnd type="none" w="med" len="med"/>
+                    </a:lnR>
+                    <a:lnT w="12700" cap="flat" cmpd="sng" algn="ctr">
+                      <a:solidFill>
+                        <a:srgbClr val="2A3441"/>
+                      </a:solidFill>
+                      <a:prstDash val="solid"/>
+                      <a:round/>
+                      <a:headEnd type="none" w="med" len="med"/>
+                      <a:tailEnd type="none" w="med" len="med"/>
+                    </a:lnT>
+                    <a:lnB w="12700" cap="flat" cmpd="sng" algn="ctr">
+                      <a:solidFill>
+                        <a:srgbClr val="2A3441"/>
+                      </a:solidFill>
+                      <a:prstDash val="solid"/>
+                      <a:round/>
+                      <a:headEnd type="none" w="med" len="med"/>
+                      <a:tailEnd type="none" w="med" len="med"/>
+                    </a:lnB>
+                    <a:solidFill>
+                      <a:srgbClr val="141B24"/>
+                    </a:solidFill>
+                  </a:tcPr>
+                </a:tc>
+              </a:tr>
+              <a:tr h="402336">
+                <a:tc>
+                  <a:txBody>
+                    <a:bodyPr/>
+                    <a:lstStyle/>
+                    <a:p>
+                      <a:pPr indent="0" marL="0">
+                        <a:buNone/>
+                      </a:pPr>
+                      <a:r>
+                        <a:rPr lang="en-US" sz="1300" dirty="0">
+                          <a:solidFill>
+                            <a:srgbClr val="E6EDF3"/>
+                          </a:solidFill>
+                          <a:latin typeface="Calibri" pitchFamily="34" charset="0"/>
+                          <a:ea typeface="Calibri" pitchFamily="34" charset="-122"/>
+                          <a:cs typeface="Calibri" pitchFamily="34" charset="-120"/>
+                        </a:rPr>
+                        <a:t>2% lossy path (3,000 pkts)</a:t>
+                      </a:r>
+                      <a:endParaRPr lang="en-US" sz="1300" dirty="0">
+                        <a:latin typeface="Calibri" charset="0"/>
+                        <a:ea typeface="Calibri" charset="0"/>
+                        <a:cs typeface="Calibri" charset="0"/>
+                      </a:endParaRPr>
+                    </a:p>
+                  </a:txBody>
+                  <a:tcPr marL="91440" marR="91440" marT="45720" marB="45720">
+                    <a:lnL w="12700" cap="flat" cmpd="sng" algn="ctr">
+                      <a:solidFill>
+                        <a:srgbClr val="2A3441"/>
+                      </a:solidFill>
+                      <a:prstDash val="solid"/>
+                      <a:round/>
+                      <a:headEnd type="none" w="med" len="med"/>
+                      <a:tailEnd type="none" w="med" len="med"/>
+                    </a:lnL>
+                    <a:lnR w="12700" cap="flat" cmpd="sng" algn="ctr">
+                      <a:solidFill>
+                        <a:srgbClr val="2A3441"/>
+                      </a:solidFill>
+                      <a:prstDash val="solid"/>
+                      <a:round/>
+                      <a:headEnd type="none" w="med" len="med"/>
+                      <a:tailEnd type="none" w="med" len="med"/>
+                    </a:lnR>
+                    <a:lnT w="12700" cap="flat" cmpd="sng" algn="ctr">
+                      <a:solidFill>
+                        <a:srgbClr val="2A3441"/>
+                      </a:solidFill>
+                      <a:prstDash val="solid"/>
+                      <a:round/>
+                      <a:headEnd type="none" w="med" len="med"/>
+                      <a:tailEnd type="none" w="med" len="med"/>
+                    </a:lnT>
+                    <a:lnB w="12700" cap="flat" cmpd="sng" algn="ctr">
+                      <a:solidFill>
+                        <a:srgbClr val="2A3441"/>
+                      </a:solidFill>
+                      <a:prstDash val="solid"/>
+                      <a:round/>
+                      <a:headEnd type="none" w="med" len="med"/>
+                      <a:tailEnd type="none" w="med" len="med"/>
+                    </a:lnB>
+                    <a:solidFill>
+                      <a:srgbClr val="141B24"/>
+                    </a:solidFill>
+                  </a:tcPr>
+                </a:tc>
+                <a:tc>
+                  <a:txBody>
+                    <a:bodyPr/>
+                    <a:lstStyle/>
+                    <a:p>
+                      <a:pPr indent="0" marL="0">
+                        <a:buNone/>
+                      </a:pPr>
+                      <a:r>
+                        <a:rPr lang="en-US" sz="1300" dirty="0">
+                          <a:solidFill>
+                            <a:srgbClr val="E6EDF3"/>
+                          </a:solidFill>
+                          <a:latin typeface="Calibri" pitchFamily="34" charset="0"/>
+                          <a:ea typeface="Calibri" pitchFamily="34" charset="-122"/>
+                          <a:cs typeface="Calibri" pitchFamily="34" charset="-120"/>
+                        </a:rPr>
+                        <a:t>19.8</a:t>
+                      </a:r>
+                      <a:endParaRPr lang="en-US" sz="1300" dirty="0">
+                        <a:latin typeface="Calibri" charset="0"/>
+                        <a:ea typeface="Calibri" charset="0"/>
+                        <a:cs typeface="Calibri" charset="0"/>
+                      </a:endParaRPr>
+                    </a:p>
+                  </a:txBody>
+                  <a:tcPr marL="91440" marR="91440" marT="45720" marB="45720">
+                    <a:lnL w="12700" cap="flat" cmpd="sng" algn="ctr">
+                      <a:solidFill>
+                        <a:srgbClr val="2A3441"/>
+                      </a:solidFill>
+                      <a:prstDash val="solid"/>
+                      <a:round/>
+                      <a:headEnd type="none" w="med" len="med"/>
+                      <a:tailEnd type="none" w="med" len="med"/>
+                    </a:lnL>
+                    <a:lnR w="12700" cap="flat" cmpd="sng" algn="ctr">
+                      <a:solidFill>
+                        <a:srgbClr val="2A3441"/>
+                      </a:solidFill>
+                      <a:prstDash val="solid"/>
+                      <a:round/>
+                      <a:headEnd type="none" w="med" len="med"/>
+                      <a:tailEnd type="none" w="med" len="med"/>
+                    </a:lnR>
+                    <a:lnT w="12700" cap="flat" cmpd="sng" algn="ctr">
+                      <a:solidFill>
+                        <a:srgbClr val="2A3441"/>
+                      </a:solidFill>
+                      <a:prstDash val="solid"/>
+                      <a:round/>
+                      <a:headEnd type="none" w="med" len="med"/>
+                      <a:tailEnd type="none" w="med" len="med"/>
+                    </a:lnT>
+                    <a:lnB w="12700" cap="flat" cmpd="sng" algn="ctr">
+                      <a:solidFill>
+                        <a:srgbClr val="2A3441"/>
+                      </a:solidFill>
+                      <a:prstDash val="solid"/>
+                      <a:round/>
+                      <a:headEnd type="none" w="med" len="med"/>
+                      <a:tailEnd type="none" w="med" len="med"/>
+                    </a:lnB>
+                    <a:solidFill>
+                      <a:srgbClr val="141B24"/>
+                    </a:solidFill>
+                  </a:tcPr>
+                </a:tc>
+                <a:tc>
+                  <a:txBody>
+                    <a:bodyPr/>
+                    <a:lstStyle/>
+                    <a:p>
+                      <a:pPr indent="0" marL="0">
+                        <a:buNone/>
+                      </a:pPr>
+                      <a:r>
+                        <a:rPr lang="en-US" sz="1300" dirty="0">
+                          <a:solidFill>
+                            <a:srgbClr val="E6EDF3"/>
+                          </a:solidFill>
+                          <a:latin typeface="Calibri" pitchFamily="34" charset="0"/>
+                          <a:ea typeface="Calibri" pitchFamily="34" charset="-122"/>
+                          <a:cs typeface="Calibri" pitchFamily="34" charset="-120"/>
+                        </a:rPr>
+                        <a:t>53.3</a:t>
+                      </a:r>
+                      <a:endParaRPr lang="en-US" sz="1300" dirty="0">
+                        <a:latin typeface="Calibri" charset="0"/>
+                        <a:ea typeface="Calibri" charset="0"/>
+                        <a:cs typeface="Calibri" charset="0"/>
+                      </a:endParaRPr>
+                    </a:p>
+                  </a:txBody>
+                  <a:tcPr marL="91440" marR="91440" marT="45720" marB="45720">
+                    <a:lnL w="12700" cap="flat" cmpd="sng" algn="ctr">
+                      <a:solidFill>
+                        <a:srgbClr val="2A3441"/>
+                      </a:solidFill>
+                      <a:prstDash val="solid"/>
+                      <a:round/>
+                      <a:headEnd type="none" w="med" len="med"/>
+                      <a:tailEnd type="none" w="med" len="med"/>
+                    </a:lnL>
+                    <a:lnR w="12700" cap="flat" cmpd="sng" algn="ctr">
+                      <a:solidFill>
+                        <a:srgbClr val="2A3441"/>
+                      </a:solidFill>
+                      <a:prstDash val="solid"/>
+                      <a:round/>
+                      <a:headEnd type="none" w="med" len="med"/>
+                      <a:tailEnd type="none" w="med" len="med"/>
+                    </a:lnR>
+                    <a:lnT w="12700" cap="flat" cmpd="sng" algn="ctr">
+                      <a:solidFill>
+                        <a:srgbClr val="2A3441"/>
+                      </a:solidFill>
+                      <a:prstDash val="solid"/>
+                      <a:round/>
+                      <a:headEnd type="none" w="med" len="med"/>
+                      <a:tailEnd type="none" w="med" len="med"/>
+                    </a:lnT>
+                    <a:lnB w="12700" cap="flat" cmpd="sng" algn="ctr">
+                      <a:solidFill>
+                        <a:srgbClr val="2A3441"/>
+                      </a:solidFill>
+                      <a:prstDash val="solid"/>
+                      <a:round/>
+                      <a:headEnd type="none" w="med" len="med"/>
+                      <a:tailEnd type="none" w="med" len="med"/>
+                    </a:lnB>
+                    <a:solidFill>
+                      <a:srgbClr val="141B24"/>
+                    </a:solidFill>
+                  </a:tcPr>
+                </a:tc>
+                <a:tc>
+                  <a:txBody>
+                    <a:bodyPr/>
+                    <a:lstStyle/>
+                    <a:p>
+                      <a:pPr indent="0" marL="0">
+                        <a:buNone/>
+                      </a:pPr>
+                      <a:r>
+                        <a:rPr lang="en-US" sz="1300" dirty="0">
+                          <a:solidFill>
+                            <a:srgbClr val="E6EDF3"/>
+                          </a:solidFill>
+                          <a:latin typeface="Calibri" pitchFamily="34" charset="0"/>
+                          <a:ea typeface="Calibri" pitchFamily="34" charset="-122"/>
+                          <a:cs typeface="Calibri" pitchFamily="34" charset="-120"/>
+                        </a:rPr>
+                        <a:t>8.2</a:t>
+                      </a:r>
+                      <a:endParaRPr lang="en-US" sz="1300" dirty="0">
+                        <a:latin typeface="Calibri" charset="0"/>
+                        <a:ea typeface="Calibri" charset="0"/>
+                        <a:cs typeface="Calibri" charset="0"/>
+                      </a:endParaRPr>
+                    </a:p>
+                  </a:txBody>
+                  <a:tcPr marL="91440" marR="91440" marT="45720" marB="45720">
+                    <a:lnL w="12700" cap="flat" cmpd="sng" algn="ctr">
+                      <a:solidFill>
+                        <a:srgbClr val="2A3441"/>
+                      </a:solidFill>
+                      <a:prstDash val="solid"/>
+                      <a:round/>
+                      <a:headEnd type="none" w="med" len="med"/>
+                      <a:tailEnd type="none" w="med" len="med"/>
+                    </a:lnL>
+                    <a:lnR w="12700" cap="flat" cmpd="sng" algn="ctr">
+                      <a:solidFill>
+                        <a:srgbClr val="2A3441"/>
+                      </a:solidFill>
+                      <a:prstDash val="solid"/>
+                      <a:round/>
+                      <a:headEnd type="none" w="med" len="med"/>
+                      <a:tailEnd type="none" w="med" len="med"/>
+                    </a:lnR>
+                    <a:lnT w="12700" cap="flat" cmpd="sng" algn="ctr">
+                      <a:solidFill>
+                        <a:srgbClr val="2A3441"/>
+                      </a:solidFill>
+                      <a:prstDash val="solid"/>
+                      <a:round/>
+                      <a:headEnd type="none" w="med" len="med"/>
+                      <a:tailEnd type="none" w="med" len="med"/>
+                    </a:lnT>
+                    <a:lnB w="12700" cap="flat" cmpd="sng" algn="ctr">
+                      <a:solidFill>
+                        <a:srgbClr val="2A3441"/>
+                      </a:solidFill>
+                      <a:prstDash val="solid"/>
+                      <a:round/>
+                      <a:headEnd type="none" w="med" len="med"/>
+                      <a:tailEnd type="none" w="med" len="med"/>
+                    </a:lnB>
+                    <a:solidFill>
+                      <a:srgbClr val="141B24"/>
+                    </a:solidFill>
+                  </a:tcPr>
+                </a:tc>
+                <a:tc>
+                  <a:txBody>
+                    <a:bodyPr/>
+                    <a:lstStyle/>
+                    <a:p>
+                      <a:pPr indent="0" marL="0">
+                        <a:buNone/>
+                      </a:pPr>
+                      <a:r>
+                        <a:rPr lang="en-US" sz="1300" dirty="0">
+                          <a:solidFill>
+                            <a:srgbClr val="E6EDF3"/>
+                          </a:solidFill>
+                          <a:latin typeface="Calibri" pitchFamily="34" charset="0"/>
+                          <a:ea typeface="Calibri" pitchFamily="34" charset="-122"/>
+                          <a:cs typeface="Calibri" pitchFamily="34" charset="-120"/>
+                        </a:rPr>
+                        <a:t>9.8</a:t>
+                      </a:r>
+                      <a:endParaRPr lang="en-US" sz="1300" dirty="0">
+                        <a:latin typeface="Calibri" charset="0"/>
+                        <a:ea typeface="Calibri" charset="0"/>
+                        <a:cs typeface="Calibri" charset="0"/>
+                      </a:endParaRPr>
+                    </a:p>
+                  </a:txBody>
+                  <a:tcPr marL="91440" marR="91440" marT="45720" marB="45720">
+                    <a:lnL w="12700" cap="flat" cmpd="sng" algn="ctr">
+                      <a:solidFill>
+                        <a:srgbClr val="2A3441"/>
+                      </a:solidFill>
+                      <a:prstDash val="solid"/>
+                      <a:round/>
+                      <a:headEnd type="none" w="med" len="med"/>
+                      <a:tailEnd type="none" w="med" len="med"/>
+                    </a:lnL>
+                    <a:lnR w="12700" cap="flat" cmpd="sng" algn="ctr">
+                      <a:solidFill>
+                        <a:srgbClr val="2A3441"/>
+                      </a:solidFill>
+                      <a:prstDash val="solid"/>
+                      <a:round/>
+                      <a:headEnd type="none" w="med" len="med"/>
+                      <a:tailEnd type="none" w="med" len="med"/>
+                    </a:lnR>
+                    <a:lnT w="12700" cap="flat" cmpd="sng" algn="ctr">
+                      <a:solidFill>
+                        <a:srgbClr val="2A3441"/>
+                      </a:solidFill>
+                      <a:prstDash val="solid"/>
+                      <a:round/>
+                      <a:headEnd type="none" w="med" len="med"/>
+                      <a:tailEnd type="none" w="med" len="med"/>
+                    </a:lnT>
+                    <a:lnB w="12700" cap="flat" cmpd="sng" algn="ctr">
+                      <a:solidFill>
+                        <a:srgbClr val="2A3441"/>
+                      </a:solidFill>
+                      <a:prstDash val="solid"/>
+                      <a:round/>
+                      <a:headEnd type="none" w="med" len="med"/>
+                      <a:tailEnd type="none" w="med" len="med"/>
+                    </a:lnB>
+                    <a:solidFill>
+                      <a:srgbClr val="141B24"/>
+                    </a:solidFill>
+                  </a:tcPr>
+                </a:tc>
+              </a:tr>
+              <a:tr h="402336">
+                <a:tc>
+                  <a:txBody>
+                    <a:bodyPr/>
+                    <a:lstStyle/>
+                    <a:p>
+                      <a:pPr indent="0" marL="0">
+                        <a:buNone/>
+                      </a:pPr>
+                      <a:r>
+                        <a:rPr lang="en-US" sz="1300" dirty="0">
+                          <a:solidFill>
+                            <a:srgbClr val="E6EDF3"/>
+                          </a:solidFill>
+                          <a:latin typeface="Calibri" pitchFamily="34" charset="0"/>
+                          <a:ea typeface="Calibri" pitchFamily="34" charset="-122"/>
+                          <a:cs typeface="Calibri" pitchFamily="34" charset="-120"/>
+                        </a:rPr>
+                        <a:t>Satellite-like path</a:t>
+                      </a:r>
+                      <a:endParaRPr lang="en-US" sz="1300" dirty="0">
+                        <a:latin typeface="Calibri" charset="0"/>
+                        <a:ea typeface="Calibri" charset="0"/>
+                        <a:cs typeface="Calibri" charset="0"/>
+                      </a:endParaRPr>
+                    </a:p>
+                  </a:txBody>
+                  <a:tcPr marL="91440" marR="91440" marT="45720" marB="45720">
+                    <a:lnL w="12700" cap="flat" cmpd="sng" algn="ctr">
+                      <a:solidFill>
+                        <a:srgbClr val="2A3441"/>
+                      </a:solidFill>
+                      <a:prstDash val="solid"/>
+                      <a:round/>
+                      <a:headEnd type="none" w="med" len="med"/>
+                      <a:tailEnd type="none" w="med" len="med"/>
+                    </a:lnL>
+                    <a:lnR w="12700" cap="flat" cmpd="sng" algn="ctr">
+                      <a:solidFill>
+                        <a:srgbClr val="2A3441"/>
+                      </a:solidFill>
+                      <a:prstDash val="solid"/>
+                      <a:round/>
+                      <a:headEnd type="none" w="med" len="med"/>
+                      <a:tailEnd type="none" w="med" len="med"/>
+                    </a:lnR>
+                    <a:lnT w="12700" cap="flat" cmpd="sng" algn="ctr">
+                      <a:solidFill>
+                        <a:srgbClr val="2A3441"/>
+                      </a:solidFill>
+                      <a:prstDash val="solid"/>
+                      <a:round/>
+                      <a:headEnd type="none" w="med" len="med"/>
+                      <a:tailEnd type="none" w="med" len="med"/>
+                    </a:lnT>
+                    <a:lnB w="12700" cap="flat" cmpd="sng" algn="ctr">
+                      <a:solidFill>
+                        <a:srgbClr val="2A3441"/>
+                      </a:solidFill>
+                      <a:prstDash val="solid"/>
+                      <a:round/>
+                      <a:headEnd type="none" w="med" len="med"/>
+                      <a:tailEnd type="none" w="med" len="med"/>
+                    </a:lnB>
+                    <a:solidFill>
+                      <a:srgbClr val="141B24"/>
+                    </a:solidFill>
+                  </a:tcPr>
+                </a:tc>
+                <a:tc>
+                  <a:txBody>
+                    <a:bodyPr/>
+                    <a:lstStyle/>
+                    <a:p>
+                      <a:pPr indent="0" marL="0">
+                        <a:buNone/>
+                      </a:pPr>
+                      <a:r>
+                        <a:rPr lang="en-US" sz="1300" dirty="0">
+                          <a:solidFill>
+                            <a:srgbClr val="E6EDF3"/>
+                          </a:solidFill>
+                          <a:latin typeface="Calibri" pitchFamily="34" charset="0"/>
+                          <a:ea typeface="Calibri" pitchFamily="34" charset="-122"/>
+                          <a:cs typeface="Calibri" pitchFamily="34" charset="-120"/>
+                        </a:rPr>
+                        <a:t>32.8</a:t>
+                      </a:r>
+                      <a:endParaRPr lang="en-US" sz="1300" dirty="0">
+                        <a:latin typeface="Calibri" charset="0"/>
+                        <a:ea typeface="Calibri" charset="0"/>
+                        <a:cs typeface="Calibri" charset="0"/>
+                      </a:endParaRPr>
+                    </a:p>
+                  </a:txBody>
+                  <a:tcPr marL="91440" marR="91440" marT="45720" marB="45720">
+                    <a:lnL w="12700" cap="flat" cmpd="sng" algn="ctr">
+                      <a:solidFill>
+                        <a:srgbClr val="2A3441"/>
+                      </a:solidFill>
+                      <a:prstDash val="solid"/>
+                      <a:round/>
+                      <a:headEnd type="none" w="med" len="med"/>
+                      <a:tailEnd type="none" w="med" len="med"/>
+                    </a:lnL>
+                    <a:lnR w="12700" cap="flat" cmpd="sng" algn="ctr">
+                      <a:solidFill>
+                        <a:srgbClr val="2A3441"/>
+                      </a:solidFill>
+                      <a:prstDash val="solid"/>
+                      <a:round/>
+                      <a:headEnd type="none" w="med" len="med"/>
+                      <a:tailEnd type="none" w="med" len="med"/>
+                    </a:lnR>
+                    <a:lnT w="12700" cap="flat" cmpd="sng" algn="ctr">
+                      <a:solidFill>
+                        <a:srgbClr val="2A3441"/>
+                      </a:solidFill>
+                      <a:prstDash val="solid"/>
+                      <a:round/>
+                      <a:headEnd type="none" w="med" len="med"/>
+                      <a:tailEnd type="none" w="med" len="med"/>
+                    </a:lnT>
+                    <a:lnB w="12700" cap="flat" cmpd="sng" algn="ctr">
+                      <a:solidFill>
+                        <a:srgbClr val="2A3441"/>
+                      </a:solidFill>
+                      <a:prstDash val="solid"/>
+                      <a:round/>
+                      <a:headEnd type="none" w="med" len="med"/>
+                      <a:tailEnd type="none" w="med" len="med"/>
+                    </a:lnB>
+                    <a:solidFill>
+                      <a:srgbClr val="141B24"/>
+                    </a:solidFill>
+                  </a:tcPr>
+                </a:tc>
+                <a:tc>
+                  <a:txBody>
+                    <a:bodyPr/>
+                    <a:lstStyle/>
+                    <a:p>
+                      <a:pPr indent="0" marL="0">
+                        <a:buNone/>
+                      </a:pPr>
+                      <a:r>
+                        <a:rPr lang="en-US" sz="1300" dirty="0">
+                          <a:solidFill>
+                            <a:srgbClr val="E6EDF3"/>
+                          </a:solidFill>
+                          <a:latin typeface="Calibri" pitchFamily="34" charset="0"/>
+                          <a:ea typeface="Calibri" pitchFamily="34" charset="-122"/>
+                          <a:cs typeface="Calibri" pitchFamily="34" charset="-120"/>
+                        </a:rPr>
+                        <a:t>26.6</a:t>
+                      </a:r>
+                      <a:endParaRPr lang="en-US" sz="1300" dirty="0">
+                        <a:latin typeface="Calibri" charset="0"/>
+                        <a:ea typeface="Calibri" charset="0"/>
+                        <a:cs typeface="Calibri" charset="0"/>
+                      </a:endParaRPr>
+                    </a:p>
+                  </a:txBody>
+                  <a:tcPr marL="91440" marR="91440" marT="45720" marB="45720">
+                    <a:lnL w="12700" cap="flat" cmpd="sng" algn="ctr">
+                      <a:solidFill>
+                        <a:srgbClr val="2A3441"/>
+                      </a:solidFill>
+                      <a:prstDash val="solid"/>
+                      <a:round/>
+                      <a:headEnd type="none" w="med" len="med"/>
+                      <a:tailEnd type="none" w="med" len="med"/>
+                    </a:lnL>
+                    <a:lnR w="12700" cap="flat" cmpd="sng" algn="ctr">
+                      <a:solidFill>
+                        <a:srgbClr val="2A3441"/>
+                      </a:solidFill>
+                      <a:prstDash val="solid"/>
+                      <a:round/>
+                      <a:headEnd type="none" w="med" len="med"/>
+                      <a:tailEnd type="none" w="med" len="med"/>
+                    </a:lnR>
+                    <a:lnT w="12700" cap="flat" cmpd="sng" algn="ctr">
+                      <a:solidFill>
+                        <a:srgbClr val="2A3441"/>
+                      </a:solidFill>
+                      <a:prstDash val="solid"/>
+                      <a:round/>
+                      <a:headEnd type="none" w="med" len="med"/>
+                      <a:tailEnd type="none" w="med" len="med"/>
+                    </a:lnT>
+                    <a:lnB w="12700" cap="flat" cmpd="sng" algn="ctr">
+                      <a:solidFill>
+                        <a:srgbClr val="2A3441"/>
+                      </a:solidFill>
+                      <a:prstDash val="solid"/>
+                      <a:round/>
+                      <a:headEnd type="none" w="med" len="med"/>
+                      <a:tailEnd type="none" w="med" len="med"/>
+                    </a:lnB>
+                    <a:solidFill>
+                      <a:srgbClr val="141B24"/>
+                    </a:solidFill>
+                  </a:tcPr>
+                </a:tc>
+                <a:tc>
+                  <a:txBody>
+                    <a:bodyPr/>
+                    <a:lstStyle/>
+                    <a:p>
+                      <a:pPr indent="0" marL="0">
+                        <a:buNone/>
+                      </a:pPr>
+                      <a:r>
+                        <a:rPr lang="en-US" sz="1300" dirty="0">
+                          <a:solidFill>
+                            <a:srgbClr val="E6EDF3"/>
+                          </a:solidFill>
+                          <a:latin typeface="Calibri" pitchFamily="34" charset="0"/>
+                          <a:ea typeface="Calibri" pitchFamily="34" charset="-122"/>
+                          <a:cs typeface="Calibri" pitchFamily="34" charset="-120"/>
+                        </a:rPr>
+                        <a:t>16.8</a:t>
+                      </a:r>
+                      <a:endParaRPr lang="en-US" sz="1300" dirty="0">
+                        <a:latin typeface="Calibri" charset="0"/>
+                        <a:ea typeface="Calibri" charset="0"/>
+                        <a:cs typeface="Calibri" charset="0"/>
+                      </a:endParaRPr>
+                    </a:p>
+                  </a:txBody>
+                  <a:tcPr marL="91440" marR="91440" marT="45720" marB="45720">
+                    <a:lnL w="12700" cap="flat" cmpd="sng" algn="ctr">
+                      <a:solidFill>
+                        <a:srgbClr val="2A3441"/>
+                      </a:solidFill>
+                      <a:prstDash val="solid"/>
+                      <a:round/>
+                      <a:headEnd type="none" w="med" len="med"/>
+                      <a:tailEnd type="none" w="med" len="med"/>
+                    </a:lnL>
+                    <a:lnR w="12700" cap="flat" cmpd="sng" algn="ctr">
+                      <a:solidFill>
+                        <a:srgbClr val="2A3441"/>
+                      </a:solidFill>
+                      <a:prstDash val="solid"/>
+                      <a:round/>
+                      <a:headEnd type="none" w="med" len="med"/>
+                      <a:tailEnd type="none" w="med" len="med"/>
+                    </a:lnR>
+                    <a:lnT w="12700" cap="flat" cmpd="sng" algn="ctr">
+                      <a:solidFill>
+                        <a:srgbClr val="2A3441"/>
+                      </a:solidFill>
+                      <a:prstDash val="solid"/>
+                      <a:round/>
+                      <a:headEnd type="none" w="med" len="med"/>
+                      <a:tailEnd type="none" w="med" len="med"/>
+                    </a:lnT>
+                    <a:lnB w="12700" cap="flat" cmpd="sng" algn="ctr">
+                      <a:solidFill>
+                        <a:srgbClr val="2A3441"/>
+                      </a:solidFill>
+                      <a:prstDash val="solid"/>
+                      <a:round/>
+                      <a:headEnd type="none" w="med" len="med"/>
+                      <a:tailEnd type="none" w="med" len="med"/>
+                    </a:lnB>
+                    <a:solidFill>
+                      <a:srgbClr val="141B24"/>
+                    </a:solidFill>
+                  </a:tcPr>
+                </a:tc>
+                <a:tc>
+                  <a:txBody>
+                    <a:bodyPr/>
+                    <a:lstStyle/>
+                    <a:p>
+                      <a:pPr indent="0" marL="0">
+                        <a:buNone/>
+                      </a:pPr>
+                      <a:r>
+                        <a:rPr lang="en-US" sz="1300" dirty="0">
+                          <a:solidFill>
+                            <a:srgbClr val="E6EDF3"/>
+                          </a:solidFill>
+                          <a:latin typeface="Calibri" pitchFamily="34" charset="0"/>
+                          <a:ea typeface="Calibri" pitchFamily="34" charset="-122"/>
+                          <a:cs typeface="Calibri" pitchFamily="34" charset="-120"/>
+                        </a:rPr>
+                        <a:t>11.2</a:t>
+                      </a:r>
+                      <a:endParaRPr lang="en-US" sz="1300" dirty="0">
+                        <a:latin typeface="Calibri" charset="0"/>
+                        <a:ea typeface="Calibri" charset="0"/>
+                        <a:cs typeface="Calibri" charset="0"/>
+                      </a:endParaRPr>
+                    </a:p>
+                  </a:txBody>
+                  <a:tcPr marL="91440" marR="91440" marT="45720" marB="45720">
+                    <a:lnL w="12700" cap="flat" cmpd="sng" algn="ctr">
+                      <a:solidFill>
+                        <a:srgbClr val="2A3441"/>
+                      </a:solidFill>
+                      <a:prstDash val="solid"/>
+                      <a:round/>
+                      <a:headEnd type="none" w="med" len="med"/>
+                      <a:tailEnd type="none" w="med" len="med"/>
+                    </a:lnL>
+                    <a:lnR w="12700" cap="flat" cmpd="sng" algn="ctr">
+                      <a:solidFill>
+                        <a:srgbClr val="2A3441"/>
+                      </a:solidFill>
+                      <a:prstDash val="solid"/>
+                      <a:round/>
+                      <a:headEnd type="none" w="med" len="med"/>
+                      <a:tailEnd type="none" w="med" len="med"/>
+                    </a:lnR>
+                    <a:lnT w="12700" cap="flat" cmpd="sng" algn="ctr">
+                      <a:solidFill>
+                        <a:srgbClr val="2A3441"/>
+                      </a:solidFill>
+                      <a:prstDash val="solid"/>
+                      <a:round/>
+                      <a:headEnd type="none" w="med" len="med"/>
+                      <a:tailEnd type="none" w="med" len="med"/>
+                    </a:lnT>
+                    <a:lnB w="12700" cap="flat" cmpd="sng" algn="ctr">
+                      <a:solidFill>
+                        <a:srgbClr val="2A3441"/>
+                      </a:solidFill>
+                      <a:prstDash val="solid"/>
+                      <a:round/>
+                      <a:headEnd type="none" w="med" len="med"/>
+                      <a:tailEnd type="none" w="med" len="med"/>
+                    </a:lnB>
+                    <a:solidFill>
+                      <a:srgbClr val="141B24"/>
+                    </a:solidFill>
+                  </a:tcPr>
+                </a:tc>
+              </a:tr>
+            </a:tbl>
+          </a:graphicData>
+        </a:graphic>
+      </p:graphicFrame>
       <p:sp>
         <p:nvSpPr>
-          <p:cNvPr id="4" name="Shape 2"/>
+          <p:cNvPr id="5" name="Text 2"/>
           <p:cNvSpPr/>
           <p:nvPr/>
         </p:nvSpPr>
         <p:spPr>
           <a:xfrm>
-            <a:off x="548640" y="1371600"/>
-            <a:ext cx="5394960" cy="4206240"/>
-          </a:xfrm>
-          <a:prstGeom prst="rect">
-            <a:avLst/>
-          </a:prstGeom>
-          <a:solidFill>
-            <a:srgbClr val="141B24"/>
-          </a:solidFill>
-          <a:ln w="12700">
-            <a:solidFill>
-              <a:srgbClr val="39FF88"/>
-            </a:solidFill>
-            <a:prstDash val="solid"/>
-          </a:ln>
-        </p:spPr>
-      </p:sp>
-      <p:sp>
-        <p:nvSpPr>
-          <p:cNvPr id="5" name="Text 3"/>
-          <p:cNvSpPr/>
-          <p:nvPr/>
-        </p:nvSpPr>
-        <p:spPr>
-          <a:xfrm>
-            <a:off x="731520" y="1508760"/>
-            <a:ext cx="5029200" cy="457200"/>
-          </a:xfrm>
-          <a:prstGeom prst="rect">
-            <a:avLst/>
-          </a:prstGeom>
-          <a:noFill/>
-          <a:ln/>
-        </p:spPr>
-        <p:txBody>
-          <a:bodyPr wrap="square" lIns="0" tIns="0" rIns="0" bIns="0" rtlCol="0" anchor="ctr"/>
-          <a:lstStyle/>
-          <a:p>
-            <a:pPr indent="0" marL="0">
-              <a:buNone/>
-            </a:pPr>
-            <a:r>
-              <a:rPr lang="en-US" sz="2000" b="1" dirty="0">
-                <a:solidFill>
-                  <a:srgbClr val="39FF88"/>
-                </a:solidFill>
-                <a:latin typeface="Courier New" pitchFamily="34" charset="0"/>
-                <a:ea typeface="Courier New" pitchFamily="34" charset="-122"/>
-                <a:cs typeface="Courier New" pitchFamily="34" charset="-120"/>
-              </a:rPr>
-              <a:t>Learned</a:t>
-            </a:r>
-            <a:endParaRPr lang="en-US" sz="2000" dirty="0"/>
-          </a:p>
-        </p:txBody>
-      </p:sp>
-      <p:sp>
-        <p:nvSpPr>
-          <p:cNvPr id="6" name="Text 4"/>
-          <p:cNvSpPr/>
-          <p:nvPr/>
-        </p:nvSpPr>
-        <p:spPr>
-          <a:xfrm>
-            <a:off x="731520" y="2011680"/>
-            <a:ext cx="5029200" cy="3429000"/>
+            <a:off x="548640" y="4114800"/>
+            <a:ext cx="11064240" cy="2194560"/>
           </a:xfrm>
           <a:prstGeom prst="rect">
             <a:avLst/>
@@ -27799,11 +30340,15 @@
           <a:bodyPr wrap="square" lIns="0" tIns="0" rIns="0" bIns="0" rtlCol="0" anchor="t"/>
           <a:lstStyle/>
           <a:p>
-            <a:pPr indent="0" marL="0">
-              <a:buNone/>
+            <a:pPr marL="342900" indent="-342900">
+              <a:spcAft>
+                <a:spcPts val="800"/>
+              </a:spcAft>
+              <a:buSzPct val="100000"/>
+              <a:buChar char="•"/>
             </a:pPr>
             <a:r>
-              <a:rPr lang="en-US" sz="2000" dirty="0">
+              <a:rPr lang="en-US" sz="1600" dirty="0">
                 <a:solidFill>
                   <a:srgbClr val="E6EDF3"/>
                 </a:solidFill>
@@ -27811,16 +30356,20 @@
                 <a:ea typeface="Calibri" pitchFamily="34" charset="-122"/>
                 <a:cs typeface="Calibri" pitchFamily="34" charset="-120"/>
               </a:rPr>
-              <a:t>Reliability is a set of simple rules working together.</a:t>
+              <a:t>Paths that change mid-transfer: neural fastest in 4 of 4 cases, at the cost of 1% to 6% retransmissions</a:t>
             </a:r>
-            <a:endParaRPr lang="en-US" sz="2000" dirty="0"/>
-          </a:p>
-          <a:p>
-            <a:pPr indent="0" marL="0">
-              <a:buNone/>
+            <a:endParaRPr lang="en-US" sz="1600" dirty="0"/>
+          </a:p>
+          <a:p>
+            <a:pPr marL="342900" indent="-342900">
+              <a:spcAft>
+                <a:spcPts val="800"/>
+              </a:spcAft>
+              <a:buSzPct val="100000"/>
+              <a:buChar char="•"/>
             </a:pPr>
             <a:r>
-              <a:rPr lang="en-US" sz="2000" dirty="0">
+              <a:rPr lang="en-US" sz="1600" dirty="0">
                 <a:solidFill>
                   <a:srgbClr val="E6EDF3"/>
                 </a:solidFill>
@@ -27828,16 +30377,20 @@
                 <a:ea typeface="Calibri" pitchFamily="34" charset="-122"/>
                 <a:cs typeface="Calibri" pitchFamily="34" charset="-120"/>
               </a:rPr>
-              <a:t>Congestion control matters as much as retransmission.</a:t>
+              <a:t>A simplified BBR beats tuned AIMD on 4 of 5 paths and is faster than the agent on the 2% lossy path</a:t>
             </a:r>
-            <a:endParaRPr lang="en-US" sz="2000" dirty="0"/>
-          </a:p>
-          <a:p>
-            <a:pPr indent="0" marL="0">
-              <a:buNone/>
+            <a:endParaRPr lang="en-US" sz="1600" dirty="0"/>
+          </a:p>
+          <a:p>
+            <a:pPr marL="342900" indent="-342900">
+              <a:spcAft>
+                <a:spcPts val="800"/>
+              </a:spcAft>
+              <a:buSzPct val="100000"/>
+              <a:buChar char="•"/>
             </a:pPr>
             <a:r>
-              <a:rPr lang="en-US" sz="2000" dirty="0">
+              <a:rPr lang="en-US" sz="1600" dirty="0">
                 <a:solidFill>
                   <a:srgbClr val="E6EDF3"/>
                 </a:solidFill>
@@ -27845,102 +30398,20 @@
                 <a:ea typeface="Calibri" pitchFamily="34" charset="-122"/>
                 <a:cs typeface="Calibri" pitchFamily="34" charset="-120"/>
               </a:rPr>
-              <a:t>Testing tools fail in surprising ways.</a:t>
+              <a:t>Two bugs in our own BBR (stall at 10% loss; 163 s after a delay jump) found by these tests and fixed</a:t>
             </a:r>
-            <a:endParaRPr lang="en-US" sz="2000" dirty="0"/>
-          </a:p>
-        </p:txBody>
-      </p:sp>
-      <p:sp>
-        <p:nvSpPr>
-          <p:cNvPr id="7" name="Shape 5"/>
-          <p:cNvSpPr/>
-          <p:nvPr/>
-        </p:nvSpPr>
-        <p:spPr>
-          <a:xfrm>
-            <a:off x="6217920" y="1371600"/>
-            <a:ext cx="5394960" cy="4206240"/>
-          </a:xfrm>
-          <a:prstGeom prst="rect">
-            <a:avLst/>
-          </a:prstGeom>
-          <a:solidFill>
-            <a:srgbClr val="141B24"/>
-          </a:solidFill>
-          <a:ln w="12700">
-            <a:solidFill>
-              <a:srgbClr val="FFB000"/>
-            </a:solidFill>
-            <a:prstDash val="solid"/>
-          </a:ln>
-        </p:spPr>
-      </p:sp>
-      <p:sp>
-        <p:nvSpPr>
-          <p:cNvPr id="8" name="Text 6"/>
-          <p:cNvSpPr/>
-          <p:nvPr/>
-        </p:nvSpPr>
-        <p:spPr>
-          <a:xfrm>
-            <a:off x="6400800" y="1508760"/>
-            <a:ext cx="5029200" cy="457200"/>
-          </a:xfrm>
-          <a:prstGeom prst="rect">
-            <a:avLst/>
-          </a:prstGeom>
-          <a:noFill/>
-          <a:ln/>
-        </p:spPr>
-        <p:txBody>
-          <a:bodyPr wrap="square" lIns="0" tIns="0" rIns="0" bIns="0" rtlCol="0" anchor="ctr"/>
-          <a:lstStyle/>
-          <a:p>
-            <a:pPr indent="0" marL="0">
-              <a:buNone/>
+            <a:endParaRPr lang="en-US" sz="1600" dirty="0"/>
+          </a:p>
+          <a:p>
+            <a:pPr marL="342900" indent="-342900">
+              <a:spcAft>
+                <a:spcPts val="800"/>
+              </a:spcAft>
+              <a:buSzPct val="100000"/>
+              <a:buChar char="•"/>
             </a:pPr>
             <a:r>
-              <a:rPr lang="en-US" sz="2000" b="1" dirty="0">
-                <a:solidFill>
-                  <a:srgbClr val="FFB000"/>
-                </a:solidFill>
-                <a:latin typeface="Courier New" pitchFamily="34" charset="0"/>
-                <a:ea typeface="Courier New" pitchFamily="34" charset="-122"/>
-                <a:cs typeface="Courier New" pitchFamily="34" charset="-120"/>
-              </a:rPr>
-              <a:t>Next</a:t>
-            </a:r>
-            <a:endParaRPr lang="en-US" sz="2000" dirty="0"/>
-          </a:p>
-        </p:txBody>
-      </p:sp>
-      <p:sp>
-        <p:nvSpPr>
-          <p:cNvPr id="9" name="Text 7"/>
-          <p:cNvSpPr/>
-          <p:nvPr/>
-        </p:nvSpPr>
-        <p:spPr>
-          <a:xfrm>
-            <a:off x="6400800" y="2011680"/>
-            <a:ext cx="5029200" cy="3429000"/>
-          </a:xfrm>
-          <a:prstGeom prst="rect">
-            <a:avLst/>
-          </a:prstGeom>
-          <a:noFill/>
-          <a:ln/>
-        </p:spPr>
-        <p:txBody>
-          <a:bodyPr wrap="square" lIns="0" tIns="0" rIns="0" bIns="0" rtlCol="0" anchor="t"/>
-          <a:lstStyle/>
-          <a:p>
-            <a:pPr indent="0" marL="0">
-              <a:buNone/>
-            </a:pPr>
-            <a:r>
-              <a:rPr lang="en-US" sz="2000" dirty="0">
+              <a:rPr lang="en-US" sz="1600" dirty="0">
                 <a:solidFill>
                   <a:srgbClr val="E6EDF3"/>
                 </a:solidFill>
@@ -27948,82 +30419,9 @@
                 <a:ea typeface="Calibri" pitchFamily="34" charset="-122"/>
                 <a:cs typeface="Calibri" pitchFamily="34" charset="-120"/>
               </a:rPr>
-              <a:t>Fairness-aware training, TCP coexistence</a:t>
+              <a:t>Virtual time, 20 paired seeds; not the Linux BBR</a:t>
             </a:r>
-            <a:endParaRPr lang="en-US" sz="2000" dirty="0"/>
-          </a:p>
-          <a:p>
-            <a:pPr indent="0" marL="0">
-              <a:buNone/>
-            </a:pPr>
-            <a:r>
-              <a:rPr lang="en-US" sz="2000" dirty="0">
-                <a:solidFill>
-                  <a:srgbClr val="E6EDF3"/>
-                </a:solidFill>
-                <a:latin typeface="Calibri" pitchFamily="34" charset="0"/>
-                <a:ea typeface="Calibri" pitchFamily="34" charset="-122"/>
-                <a:cs typeface="Calibri" pitchFamily="34" charset="-120"/>
-              </a:rPr>
-              <a:t>Train on real traces with cross traffic</a:t>
-            </a:r>
-            <a:endParaRPr lang="en-US" sz="2000" dirty="0"/>
-          </a:p>
-          <a:p>
-            <a:pPr indent="0" marL="0">
-              <a:buNone/>
-            </a:pPr>
-            <a:r>
-              <a:rPr lang="en-US" sz="2000" dirty="0">
-                <a:solidFill>
-                  <a:srgbClr val="E6EDF3"/>
-                </a:solidFill>
-                <a:latin typeface="Calibri" pitchFamily="34" charset="0"/>
-                <a:ea typeface="Calibri" pitchFamily="34" charset="-122"/>
-                <a:cs typeface="Calibri" pitchFamily="34" charset="-120"/>
-              </a:rPr>
-              <a:t>Close the gap to kernel TCP; real multi-machine tests</a:t>
-            </a:r>
-            <a:endParaRPr lang="en-US" sz="2000" dirty="0"/>
-          </a:p>
-        </p:txBody>
-      </p:sp>
-      <p:sp>
-        <p:nvSpPr>
-          <p:cNvPr id="10" name="Text 8"/>
-          <p:cNvSpPr/>
-          <p:nvPr/>
-        </p:nvSpPr>
-        <p:spPr>
-          <a:xfrm>
-            <a:off x="548640" y="5852160"/>
-            <a:ext cx="10972800" cy="365760"/>
-          </a:xfrm>
-          <a:prstGeom prst="rect">
-            <a:avLst/>
-          </a:prstGeom>
-          <a:noFill/>
-          <a:ln/>
-        </p:spPr>
-        <p:txBody>
-          <a:bodyPr wrap="square" lIns="0" tIns="0" rIns="0" bIns="0" rtlCol="0" anchor="ctr"/>
-          <a:lstStyle/>
-          <a:p>
-            <a:pPr indent="0" marL="0">
-              <a:buNone/>
-            </a:pPr>
-            <a:r>
-              <a:rPr lang="en-US" sz="1400" dirty="0">
-                <a:solidFill>
-                  <a:srgbClr val="8B98A5"/>
-                </a:solidFill>
-                <a:latin typeface="Calibri" pitchFamily="34" charset="0"/>
-                <a:ea typeface="Calibri" pitchFamily="34" charset="-122"/>
-                <a:cs typeface="Calibri" pitchFamily="34" charset="-120"/>
-              </a:rPr>
-              <a:t>Limits: kernel TCP is 1.5x to 3.2x faster; no multi-machine test; polite mode is a hand-made rule that costs speed; level with CUBIC under bursty cross traffic; no gain at 10% random loss.</a:t>
-            </a:r>
-            <a:endParaRPr lang="en-US" sz="1400" dirty="0"/>
+            <a:endParaRPr lang="en-US" sz="1600" dirty="0"/>
           </a:p>
         </p:txBody>
       </p:sp>
@@ -28067,8 +30465,8 @@
         </p:nvSpPr>
         <p:spPr>
           <a:xfrm>
-            <a:off x="731520" y="2103120"/>
-            <a:ext cx="10058400" cy="1097280"/>
+            <a:off x="548640" y="320040"/>
+            <a:ext cx="11064240" cy="731520"/>
           </a:xfrm>
           <a:prstGeom prst="rect">
             <a:avLst/>
@@ -28084,7 +30482,7 @@
               <a:buNone/>
             </a:pPr>
             <a:r>
-              <a:rPr lang="en-US" sz="6400" b="1" dirty="0">
+              <a:rPr lang="en-US" sz="3000" b="1" dirty="0">
                 <a:solidFill>
                   <a:srgbClr val="39FF88"/>
                 </a:solidFill>
@@ -28092,9 +30490,9 @@
                 <a:ea typeface="Courier New" pitchFamily="34" charset="-122"/>
                 <a:cs typeface="Courier New" pitchFamily="34" charset="-120"/>
               </a:rPr>
-              <a:t>Thank you</a:t>
+              <a:t>Research gaps: fairness and trust</a:t>
             </a:r>
-            <a:endParaRPr lang="en-US" sz="6400" dirty="0"/>
+            <a:endParaRPr lang="en-US" sz="3000" dirty="0"/>
           </a:p>
         </p:txBody>
       </p:sp>
@@ -28106,8 +30504,8 @@
         </p:nvSpPr>
         <p:spPr>
           <a:xfrm>
-            <a:off x="731520" y="3474720"/>
-            <a:ext cx="10058400" cy="548640"/>
+            <a:off x="9418320" y="6446520"/>
+            <a:ext cx="2377440" cy="274320"/>
           </a:xfrm>
           <a:prstGeom prst="rect">
             <a:avLst/>
@@ -28119,34 +30517,888 @@
           <a:bodyPr wrap="square" lIns="0" tIns="0" rIns="0" bIns="0" rtlCol="0" anchor="ctr"/>
           <a:lstStyle/>
           <a:p>
-            <a:pPr indent="0" marL="0">
+            <a:pPr algn="r" indent="0" marL="0">
               <a:buNone/>
             </a:pPr>
             <a:r>
-              <a:rPr lang="en-US" sz="2600" dirty="0">
+              <a:rPr lang="en-US" sz="1000" dirty="0">
                 <a:solidFill>
-                  <a:srgbClr val="E6EDF3"/>
+                  <a:srgbClr val="8B98A5"/>
                 </a:solidFill>
                 <a:latin typeface="Courier New" pitchFamily="34" charset="0"/>
                 <a:ea typeface="Courier New" pitchFamily="34" charset="-122"/>
                 <a:cs typeface="Courier New" pitchFamily="34" charset="-120"/>
               </a:rPr>
-              <a:t>github.com/Capsturrrr/rudp</a:t>
+              <a:t>34 / 37   Smart-RUDP</a:t>
             </a:r>
-            <a:endParaRPr lang="en-US" sz="2600" dirty="0"/>
+            <a:endParaRPr lang="en-US" sz="1000" dirty="0"/>
           </a:p>
         </p:txBody>
       </p:sp>
+      <p:graphicFrame>
+        <p:nvGraphicFramePr>
+          <p:cNvPr id="35" name="Table 0"/>
+          <p:cNvGraphicFramePr>
+            <a:graphicFrameLocks noGrp="1"/>
+          </p:cNvGraphicFramePr>
+          <p:nvPr>
+            <p:extLst>
+              <p:ext uri="{D42A27DB-BD31-4B8C-83A1-F6EECF244321}">
+                <p14:modId xmlns:p14="http://schemas.microsoft.com/office/powerpoint/2010/main" val="1579011935"/>
+              </p:ext>
+            </p:extLst>
+          </p:nvPr>
+        </p:nvGraphicFramePr>
+        <p:xfrm>
+          <a:off x="548640" y="1188720"/>
+          <a:ext cx="6400800" cy="914400"/>
+        </p:xfrm>
+        <a:graphic>
+          <a:graphicData uri="http://schemas.openxmlformats.org/drawingml/2006/table">
+            <a:tbl>
+              <a:tblPr/>
+              <a:tblGrid>
+                <a:gridCol w="2377440"/>
+                <a:gridCol w="1188720"/>
+                <a:gridCol w="1645920"/>
+                <a:gridCol w="1188720"/>
+              </a:tblGrid>
+              <a:tr h="402336">
+                <a:tc>
+                  <a:txBody>
+                    <a:bodyPr/>
+                    <a:lstStyle/>
+                    <a:p>
+                      <a:pPr indent="0" marL="0">
+                        <a:buNone/>
+                      </a:pPr>
+                      <a:r>
+                        <a:rPr lang="en-US" sz="1300" b="1" dirty="0">
+                          <a:solidFill>
+                            <a:srgbClr val="0B0F14"/>
+                          </a:solidFill>
+                          <a:latin typeface="Courier New" pitchFamily="34" charset="0"/>
+                          <a:ea typeface="Courier New" pitchFamily="34" charset="-122"/>
+                          <a:cs typeface="Courier New" pitchFamily="34" charset="-120"/>
+                        </a:rPr>
+                        <a:t>Two identical flows</a:t>
+                      </a:r>
+                      <a:endParaRPr lang="en-US" sz="1300" dirty="0">
+                        <a:latin typeface="Courier New" charset="0"/>
+                        <a:ea typeface="Courier New" charset="0"/>
+                        <a:cs typeface="Courier New" charset="0"/>
+                      </a:endParaRPr>
+                    </a:p>
+                  </a:txBody>
+                  <a:tcPr marL="91440" marR="91440" marT="45720" marB="45720">
+                    <a:lnL w="12700" cap="flat" cmpd="sng" algn="ctr">
+                      <a:solidFill>
+                        <a:srgbClr val="2A3441"/>
+                      </a:solidFill>
+                      <a:prstDash val="solid"/>
+                      <a:round/>
+                      <a:headEnd type="none" w="med" len="med"/>
+                      <a:tailEnd type="none" w="med" len="med"/>
+                    </a:lnL>
+                    <a:lnR w="12700" cap="flat" cmpd="sng" algn="ctr">
+                      <a:solidFill>
+                        <a:srgbClr val="2A3441"/>
+                      </a:solidFill>
+                      <a:prstDash val="solid"/>
+                      <a:round/>
+                      <a:headEnd type="none" w="med" len="med"/>
+                      <a:tailEnd type="none" w="med" len="med"/>
+                    </a:lnR>
+                    <a:lnT w="12700" cap="flat" cmpd="sng" algn="ctr">
+                      <a:solidFill>
+                        <a:srgbClr val="2A3441"/>
+                      </a:solidFill>
+                      <a:prstDash val="solid"/>
+                      <a:round/>
+                      <a:headEnd type="none" w="med" len="med"/>
+                      <a:tailEnd type="none" w="med" len="med"/>
+                    </a:lnT>
+                    <a:lnB w="12700" cap="flat" cmpd="sng" algn="ctr">
+                      <a:solidFill>
+                        <a:srgbClr val="2A3441"/>
+                      </a:solidFill>
+                      <a:prstDash val="solid"/>
+                      <a:round/>
+                      <a:headEnd type="none" w="med" len="med"/>
+                      <a:tailEnd type="none" w="med" len="med"/>
+                    </a:lnB>
+                    <a:solidFill>
+                      <a:srgbClr val="39FF88"/>
+                    </a:solidFill>
+                  </a:tcPr>
+                </a:tc>
+                <a:tc>
+                  <a:txBody>
+                    <a:bodyPr/>
+                    <a:lstStyle/>
+                    <a:p>
+                      <a:pPr indent="0" marL="0">
+                        <a:buNone/>
+                      </a:pPr>
+                      <a:r>
+                        <a:rPr lang="en-US" sz="1300" b="1" dirty="0">
+                          <a:solidFill>
+                            <a:srgbClr val="0B0F14"/>
+                          </a:solidFill>
+                          <a:latin typeface="Courier New" pitchFamily="34" charset="0"/>
+                          <a:ea typeface="Courier New" pitchFamily="34" charset="-122"/>
+                          <a:cs typeface="Courier New" pitchFamily="34" charset="-120"/>
+                        </a:rPr>
+                        <a:t>Extra RTT</a:t>
+                      </a:r>
+                      <a:endParaRPr lang="en-US" sz="1300" dirty="0">
+                        <a:latin typeface="Courier New" charset="0"/>
+                        <a:ea typeface="Courier New" charset="0"/>
+                        <a:cs typeface="Courier New" charset="0"/>
+                      </a:endParaRPr>
+                    </a:p>
+                  </a:txBody>
+                  <a:tcPr marL="91440" marR="91440" marT="45720" marB="45720">
+                    <a:lnL w="12700" cap="flat" cmpd="sng" algn="ctr">
+                      <a:solidFill>
+                        <a:srgbClr val="2A3441"/>
+                      </a:solidFill>
+                      <a:prstDash val="solid"/>
+                      <a:round/>
+                      <a:headEnd type="none" w="med" len="med"/>
+                      <a:tailEnd type="none" w="med" len="med"/>
+                    </a:lnL>
+                    <a:lnR w="12700" cap="flat" cmpd="sng" algn="ctr">
+                      <a:solidFill>
+                        <a:srgbClr val="2A3441"/>
+                      </a:solidFill>
+                      <a:prstDash val="solid"/>
+                      <a:round/>
+                      <a:headEnd type="none" w="med" len="med"/>
+                      <a:tailEnd type="none" w="med" len="med"/>
+                    </a:lnR>
+                    <a:lnT w="12700" cap="flat" cmpd="sng" algn="ctr">
+                      <a:solidFill>
+                        <a:srgbClr val="2A3441"/>
+                      </a:solidFill>
+                      <a:prstDash val="solid"/>
+                      <a:round/>
+                      <a:headEnd type="none" w="med" len="med"/>
+                      <a:tailEnd type="none" w="med" len="med"/>
+                    </a:lnT>
+                    <a:lnB w="12700" cap="flat" cmpd="sng" algn="ctr">
+                      <a:solidFill>
+                        <a:srgbClr val="2A3441"/>
+                      </a:solidFill>
+                      <a:prstDash val="solid"/>
+                      <a:round/>
+                      <a:headEnd type="none" w="med" len="med"/>
+                      <a:tailEnd type="none" w="med" len="med"/>
+                    </a:lnB>
+                    <a:solidFill>
+                      <a:srgbClr val="39FF88"/>
+                    </a:solidFill>
+                  </a:tcPr>
+                </a:tc>
+                <a:tc>
+                  <a:txBody>
+                    <a:bodyPr/>
+                    <a:lstStyle/>
+                    <a:p>
+                      <a:pPr indent="0" marL="0">
+                        <a:buNone/>
+                      </a:pPr>
+                      <a:r>
+                        <a:rPr lang="en-US" sz="1300" b="1" dirty="0">
+                          <a:solidFill>
+                            <a:srgbClr val="0B0F14"/>
+                          </a:solidFill>
+                          <a:latin typeface="Courier New" pitchFamily="34" charset="0"/>
+                          <a:ea typeface="Courier New" pitchFamily="34" charset="-122"/>
+                          <a:cs typeface="Courier New" pitchFamily="34" charset="-120"/>
+                        </a:rPr>
+                        <a:t>Share short-RTT</a:t>
+                      </a:r>
+                      <a:endParaRPr lang="en-US" sz="1300" dirty="0">
+                        <a:latin typeface="Courier New" charset="0"/>
+                        <a:ea typeface="Courier New" charset="0"/>
+                        <a:cs typeface="Courier New" charset="0"/>
+                      </a:endParaRPr>
+                    </a:p>
+                  </a:txBody>
+                  <a:tcPr marL="91440" marR="91440" marT="45720" marB="45720">
+                    <a:lnL w="12700" cap="flat" cmpd="sng" algn="ctr">
+                      <a:solidFill>
+                        <a:srgbClr val="2A3441"/>
+                      </a:solidFill>
+                      <a:prstDash val="solid"/>
+                      <a:round/>
+                      <a:headEnd type="none" w="med" len="med"/>
+                      <a:tailEnd type="none" w="med" len="med"/>
+                    </a:lnL>
+                    <a:lnR w="12700" cap="flat" cmpd="sng" algn="ctr">
+                      <a:solidFill>
+                        <a:srgbClr val="2A3441"/>
+                      </a:solidFill>
+                      <a:prstDash val="solid"/>
+                      <a:round/>
+                      <a:headEnd type="none" w="med" len="med"/>
+                      <a:tailEnd type="none" w="med" len="med"/>
+                    </a:lnR>
+                    <a:lnT w="12700" cap="flat" cmpd="sng" algn="ctr">
+                      <a:solidFill>
+                        <a:srgbClr val="2A3441"/>
+                      </a:solidFill>
+                      <a:prstDash val="solid"/>
+                      <a:round/>
+                      <a:headEnd type="none" w="med" len="med"/>
+                      <a:tailEnd type="none" w="med" len="med"/>
+                    </a:lnT>
+                    <a:lnB w="12700" cap="flat" cmpd="sng" algn="ctr">
+                      <a:solidFill>
+                        <a:srgbClr val="2A3441"/>
+                      </a:solidFill>
+                      <a:prstDash val="solid"/>
+                      <a:round/>
+                      <a:headEnd type="none" w="med" len="med"/>
+                      <a:tailEnd type="none" w="med" len="med"/>
+                    </a:lnB>
+                    <a:solidFill>
+                      <a:srgbClr val="39FF88"/>
+                    </a:solidFill>
+                  </a:tcPr>
+                </a:tc>
+                <a:tc>
+                  <a:txBody>
+                    <a:bodyPr/>
+                    <a:lstStyle/>
+                    <a:p>
+                      <a:pPr indent="0" marL="0">
+                        <a:buNone/>
+                      </a:pPr>
+                      <a:r>
+                        <a:rPr lang="en-US" sz="1300" b="1" dirty="0">
+                          <a:solidFill>
+                            <a:srgbClr val="0B0F14"/>
+                          </a:solidFill>
+                          <a:latin typeface="Courier New" pitchFamily="34" charset="0"/>
+                          <a:ea typeface="Courier New" pitchFamily="34" charset="-122"/>
+                          <a:cs typeface="Courier New" pitchFamily="34" charset="-120"/>
+                        </a:rPr>
+                        <a:t>Jain</a:t>
+                      </a:r>
+                      <a:endParaRPr lang="en-US" sz="1300" dirty="0">
+                        <a:latin typeface="Courier New" charset="0"/>
+                        <a:ea typeface="Courier New" charset="0"/>
+                        <a:cs typeface="Courier New" charset="0"/>
+                      </a:endParaRPr>
+                    </a:p>
+                  </a:txBody>
+                  <a:tcPr marL="91440" marR="91440" marT="45720" marB="45720">
+                    <a:lnL w="12700" cap="flat" cmpd="sng" algn="ctr">
+                      <a:solidFill>
+                        <a:srgbClr val="2A3441"/>
+                      </a:solidFill>
+                      <a:prstDash val="solid"/>
+                      <a:round/>
+                      <a:headEnd type="none" w="med" len="med"/>
+                      <a:tailEnd type="none" w="med" len="med"/>
+                    </a:lnL>
+                    <a:lnR w="12700" cap="flat" cmpd="sng" algn="ctr">
+                      <a:solidFill>
+                        <a:srgbClr val="2A3441"/>
+                      </a:solidFill>
+                      <a:prstDash val="solid"/>
+                      <a:round/>
+                      <a:headEnd type="none" w="med" len="med"/>
+                      <a:tailEnd type="none" w="med" len="med"/>
+                    </a:lnR>
+                    <a:lnT w="12700" cap="flat" cmpd="sng" algn="ctr">
+                      <a:solidFill>
+                        <a:srgbClr val="2A3441"/>
+                      </a:solidFill>
+                      <a:prstDash val="solid"/>
+                      <a:round/>
+                      <a:headEnd type="none" w="med" len="med"/>
+                      <a:tailEnd type="none" w="med" len="med"/>
+                    </a:lnT>
+                    <a:lnB w="12700" cap="flat" cmpd="sng" algn="ctr">
+                      <a:solidFill>
+                        <a:srgbClr val="2A3441"/>
+                      </a:solidFill>
+                      <a:prstDash val="solid"/>
+                      <a:round/>
+                      <a:headEnd type="none" w="med" len="med"/>
+                      <a:tailEnd type="none" w="med" len="med"/>
+                    </a:lnB>
+                    <a:solidFill>
+                      <a:srgbClr val="39FF88"/>
+                    </a:solidFill>
+                  </a:tcPr>
+                </a:tc>
+              </a:tr>
+              <a:tr h="402336">
+                <a:tc>
+                  <a:txBody>
+                    <a:bodyPr/>
+                    <a:lstStyle/>
+                    <a:p>
+                      <a:pPr indent="0" marL="0">
+                        <a:buNone/>
+                      </a:pPr>
+                      <a:r>
+                        <a:rPr lang="en-US" sz="1300" dirty="0">
+                          <a:solidFill>
+                            <a:srgbClr val="E6EDF3"/>
+                          </a:solidFill>
+                          <a:latin typeface="Calibri" pitchFamily="34" charset="0"/>
+                          <a:ea typeface="Calibri" pitchFamily="34" charset="-122"/>
+                          <a:cs typeface="Calibri" pitchFamily="34" charset="-120"/>
+                        </a:rPr>
+                        <a:t>AIMD / AIMD</a:t>
+                      </a:r>
+                      <a:endParaRPr lang="en-US" sz="1300" dirty="0">
+                        <a:latin typeface="Calibri" charset="0"/>
+                        <a:ea typeface="Calibri" charset="0"/>
+                        <a:cs typeface="Calibri" charset="0"/>
+                      </a:endParaRPr>
+                    </a:p>
+                  </a:txBody>
+                  <a:tcPr marL="91440" marR="91440" marT="45720" marB="45720">
+                    <a:lnL w="12700" cap="flat" cmpd="sng" algn="ctr">
+                      <a:solidFill>
+                        <a:srgbClr val="2A3441"/>
+                      </a:solidFill>
+                      <a:prstDash val="solid"/>
+                      <a:round/>
+                      <a:headEnd type="none" w="med" len="med"/>
+                      <a:tailEnd type="none" w="med" len="med"/>
+                    </a:lnL>
+                    <a:lnR w="12700" cap="flat" cmpd="sng" algn="ctr">
+                      <a:solidFill>
+                        <a:srgbClr val="2A3441"/>
+                      </a:solidFill>
+                      <a:prstDash val="solid"/>
+                      <a:round/>
+                      <a:headEnd type="none" w="med" len="med"/>
+                      <a:tailEnd type="none" w="med" len="med"/>
+                    </a:lnR>
+                    <a:lnT w="12700" cap="flat" cmpd="sng" algn="ctr">
+                      <a:solidFill>
+                        <a:srgbClr val="2A3441"/>
+                      </a:solidFill>
+                      <a:prstDash val="solid"/>
+                      <a:round/>
+                      <a:headEnd type="none" w="med" len="med"/>
+                      <a:tailEnd type="none" w="med" len="med"/>
+                    </a:lnT>
+                    <a:lnB w="12700" cap="flat" cmpd="sng" algn="ctr">
+                      <a:solidFill>
+                        <a:srgbClr val="2A3441"/>
+                      </a:solidFill>
+                      <a:prstDash val="solid"/>
+                      <a:round/>
+                      <a:headEnd type="none" w="med" len="med"/>
+                      <a:tailEnd type="none" w="med" len="med"/>
+                    </a:lnB>
+                    <a:solidFill>
+                      <a:srgbClr val="141B24"/>
+                    </a:solidFill>
+                  </a:tcPr>
+                </a:tc>
+                <a:tc>
+                  <a:txBody>
+                    <a:bodyPr/>
+                    <a:lstStyle/>
+                    <a:p>
+                      <a:pPr indent="0" marL="0">
+                        <a:buNone/>
+                      </a:pPr>
+                      <a:r>
+                        <a:rPr lang="en-US" sz="1300" dirty="0">
+                          <a:solidFill>
+                            <a:srgbClr val="E6EDF3"/>
+                          </a:solidFill>
+                          <a:latin typeface="Calibri" pitchFamily="34" charset="0"/>
+                          <a:ea typeface="Calibri" pitchFamily="34" charset="-122"/>
+                          <a:cs typeface="Calibri" pitchFamily="34" charset="-120"/>
+                        </a:rPr>
+                        <a:t>150 ms</a:t>
+                      </a:r>
+                      <a:endParaRPr lang="en-US" sz="1300" dirty="0">
+                        <a:latin typeface="Calibri" charset="0"/>
+                        <a:ea typeface="Calibri" charset="0"/>
+                        <a:cs typeface="Calibri" charset="0"/>
+                      </a:endParaRPr>
+                    </a:p>
+                  </a:txBody>
+                  <a:tcPr marL="91440" marR="91440" marT="45720" marB="45720">
+                    <a:lnL w="12700" cap="flat" cmpd="sng" algn="ctr">
+                      <a:solidFill>
+                        <a:srgbClr val="2A3441"/>
+                      </a:solidFill>
+                      <a:prstDash val="solid"/>
+                      <a:round/>
+                      <a:headEnd type="none" w="med" len="med"/>
+                      <a:tailEnd type="none" w="med" len="med"/>
+                    </a:lnL>
+                    <a:lnR w="12700" cap="flat" cmpd="sng" algn="ctr">
+                      <a:solidFill>
+                        <a:srgbClr val="2A3441"/>
+                      </a:solidFill>
+                      <a:prstDash val="solid"/>
+                      <a:round/>
+                      <a:headEnd type="none" w="med" len="med"/>
+                      <a:tailEnd type="none" w="med" len="med"/>
+                    </a:lnR>
+                    <a:lnT w="12700" cap="flat" cmpd="sng" algn="ctr">
+                      <a:solidFill>
+                        <a:srgbClr val="2A3441"/>
+                      </a:solidFill>
+                      <a:prstDash val="solid"/>
+                      <a:round/>
+                      <a:headEnd type="none" w="med" len="med"/>
+                      <a:tailEnd type="none" w="med" len="med"/>
+                    </a:lnT>
+                    <a:lnB w="12700" cap="flat" cmpd="sng" algn="ctr">
+                      <a:solidFill>
+                        <a:srgbClr val="2A3441"/>
+                      </a:solidFill>
+                      <a:prstDash val="solid"/>
+                      <a:round/>
+                      <a:headEnd type="none" w="med" len="med"/>
+                      <a:tailEnd type="none" w="med" len="med"/>
+                    </a:lnB>
+                    <a:solidFill>
+                      <a:srgbClr val="141B24"/>
+                    </a:solidFill>
+                  </a:tcPr>
+                </a:tc>
+                <a:tc>
+                  <a:txBody>
+                    <a:bodyPr/>
+                    <a:lstStyle/>
+                    <a:p>
+                      <a:pPr indent="0" marL="0">
+                        <a:buNone/>
+                      </a:pPr>
+                      <a:r>
+                        <a:rPr lang="en-US" sz="1300" dirty="0">
+                          <a:solidFill>
+                            <a:srgbClr val="E6EDF3"/>
+                          </a:solidFill>
+                          <a:latin typeface="Calibri" pitchFamily="34" charset="0"/>
+                          <a:ea typeface="Calibri" pitchFamily="34" charset="-122"/>
+                          <a:cs typeface="Calibri" pitchFamily="34" charset="-120"/>
+                        </a:rPr>
+                        <a:t>88%</a:t>
+                      </a:r>
+                      <a:endParaRPr lang="en-US" sz="1300" dirty="0">
+                        <a:latin typeface="Calibri" charset="0"/>
+                        <a:ea typeface="Calibri" charset="0"/>
+                        <a:cs typeface="Calibri" charset="0"/>
+                      </a:endParaRPr>
+                    </a:p>
+                  </a:txBody>
+                  <a:tcPr marL="91440" marR="91440" marT="45720" marB="45720">
+                    <a:lnL w="12700" cap="flat" cmpd="sng" algn="ctr">
+                      <a:solidFill>
+                        <a:srgbClr val="2A3441"/>
+                      </a:solidFill>
+                      <a:prstDash val="solid"/>
+                      <a:round/>
+                      <a:headEnd type="none" w="med" len="med"/>
+                      <a:tailEnd type="none" w="med" len="med"/>
+                    </a:lnL>
+                    <a:lnR w="12700" cap="flat" cmpd="sng" algn="ctr">
+                      <a:solidFill>
+                        <a:srgbClr val="2A3441"/>
+                      </a:solidFill>
+                      <a:prstDash val="solid"/>
+                      <a:round/>
+                      <a:headEnd type="none" w="med" len="med"/>
+                      <a:tailEnd type="none" w="med" len="med"/>
+                    </a:lnR>
+                    <a:lnT w="12700" cap="flat" cmpd="sng" algn="ctr">
+                      <a:solidFill>
+                        <a:srgbClr val="2A3441"/>
+                      </a:solidFill>
+                      <a:prstDash val="solid"/>
+                      <a:round/>
+                      <a:headEnd type="none" w="med" len="med"/>
+                      <a:tailEnd type="none" w="med" len="med"/>
+                    </a:lnT>
+                    <a:lnB w="12700" cap="flat" cmpd="sng" algn="ctr">
+                      <a:solidFill>
+                        <a:srgbClr val="2A3441"/>
+                      </a:solidFill>
+                      <a:prstDash val="solid"/>
+                      <a:round/>
+                      <a:headEnd type="none" w="med" len="med"/>
+                      <a:tailEnd type="none" w="med" len="med"/>
+                    </a:lnB>
+                    <a:solidFill>
+                      <a:srgbClr val="141B24"/>
+                    </a:solidFill>
+                  </a:tcPr>
+                </a:tc>
+                <a:tc>
+                  <a:txBody>
+                    <a:bodyPr/>
+                    <a:lstStyle/>
+                    <a:p>
+                      <a:pPr indent="0" marL="0">
+                        <a:buNone/>
+                      </a:pPr>
+                      <a:r>
+                        <a:rPr lang="en-US" sz="1300" dirty="0">
+                          <a:solidFill>
+                            <a:srgbClr val="E6EDF3"/>
+                          </a:solidFill>
+                          <a:latin typeface="Calibri" pitchFamily="34" charset="0"/>
+                          <a:ea typeface="Calibri" pitchFamily="34" charset="-122"/>
+                          <a:cs typeface="Calibri" pitchFamily="34" charset="-120"/>
+                        </a:rPr>
+                        <a:t>0.64</a:t>
+                      </a:r>
+                      <a:endParaRPr lang="en-US" sz="1300" dirty="0">
+                        <a:latin typeface="Calibri" charset="0"/>
+                        <a:ea typeface="Calibri" charset="0"/>
+                        <a:cs typeface="Calibri" charset="0"/>
+                      </a:endParaRPr>
+                    </a:p>
+                  </a:txBody>
+                  <a:tcPr marL="91440" marR="91440" marT="45720" marB="45720">
+                    <a:lnL w="12700" cap="flat" cmpd="sng" algn="ctr">
+                      <a:solidFill>
+                        <a:srgbClr val="2A3441"/>
+                      </a:solidFill>
+                      <a:prstDash val="solid"/>
+                      <a:round/>
+                      <a:headEnd type="none" w="med" len="med"/>
+                      <a:tailEnd type="none" w="med" len="med"/>
+                    </a:lnL>
+                    <a:lnR w="12700" cap="flat" cmpd="sng" algn="ctr">
+                      <a:solidFill>
+                        <a:srgbClr val="2A3441"/>
+                      </a:solidFill>
+                      <a:prstDash val="solid"/>
+                      <a:round/>
+                      <a:headEnd type="none" w="med" len="med"/>
+                      <a:tailEnd type="none" w="med" len="med"/>
+                    </a:lnR>
+                    <a:lnT w="12700" cap="flat" cmpd="sng" algn="ctr">
+                      <a:solidFill>
+                        <a:srgbClr val="2A3441"/>
+                      </a:solidFill>
+                      <a:prstDash val="solid"/>
+                      <a:round/>
+                      <a:headEnd type="none" w="med" len="med"/>
+                      <a:tailEnd type="none" w="med" len="med"/>
+                    </a:lnT>
+                    <a:lnB w="12700" cap="flat" cmpd="sng" algn="ctr">
+                      <a:solidFill>
+                        <a:srgbClr val="2A3441"/>
+                      </a:solidFill>
+                      <a:prstDash val="solid"/>
+                      <a:round/>
+                      <a:headEnd type="none" w="med" len="med"/>
+                      <a:tailEnd type="none" w="med" len="med"/>
+                    </a:lnB>
+                    <a:solidFill>
+                      <a:srgbClr val="141B24"/>
+                    </a:solidFill>
+                  </a:tcPr>
+                </a:tc>
+              </a:tr>
+              <a:tr h="402336">
+                <a:tc>
+                  <a:txBody>
+                    <a:bodyPr/>
+                    <a:lstStyle/>
+                    <a:p>
+                      <a:pPr indent="0" marL="0">
+                        <a:buNone/>
+                      </a:pPr>
+                      <a:r>
+                        <a:rPr lang="en-US" sz="1300" dirty="0">
+                          <a:solidFill>
+                            <a:srgbClr val="E6EDF3"/>
+                          </a:solidFill>
+                          <a:latin typeface="Calibri" pitchFamily="34" charset="0"/>
+                          <a:ea typeface="Calibri" pitchFamily="34" charset="-122"/>
+                          <a:cs typeface="Calibri" pitchFamily="34" charset="-120"/>
+                        </a:rPr>
+                        <a:t>Neural / neural</a:t>
+                      </a:r>
+                      <a:endParaRPr lang="en-US" sz="1300" dirty="0">
+                        <a:latin typeface="Calibri" charset="0"/>
+                        <a:ea typeface="Calibri" charset="0"/>
+                        <a:cs typeface="Calibri" charset="0"/>
+                      </a:endParaRPr>
+                    </a:p>
+                  </a:txBody>
+                  <a:tcPr marL="91440" marR="91440" marT="45720" marB="45720">
+                    <a:lnL w="12700" cap="flat" cmpd="sng" algn="ctr">
+                      <a:solidFill>
+                        <a:srgbClr val="2A3441"/>
+                      </a:solidFill>
+                      <a:prstDash val="solid"/>
+                      <a:round/>
+                      <a:headEnd type="none" w="med" len="med"/>
+                      <a:tailEnd type="none" w="med" len="med"/>
+                    </a:lnL>
+                    <a:lnR w="12700" cap="flat" cmpd="sng" algn="ctr">
+                      <a:solidFill>
+                        <a:srgbClr val="2A3441"/>
+                      </a:solidFill>
+                      <a:prstDash val="solid"/>
+                      <a:round/>
+                      <a:headEnd type="none" w="med" len="med"/>
+                      <a:tailEnd type="none" w="med" len="med"/>
+                    </a:lnR>
+                    <a:lnT w="12700" cap="flat" cmpd="sng" algn="ctr">
+                      <a:solidFill>
+                        <a:srgbClr val="2A3441"/>
+                      </a:solidFill>
+                      <a:prstDash val="solid"/>
+                      <a:round/>
+                      <a:headEnd type="none" w="med" len="med"/>
+                      <a:tailEnd type="none" w="med" len="med"/>
+                    </a:lnT>
+                    <a:lnB w="12700" cap="flat" cmpd="sng" algn="ctr">
+                      <a:solidFill>
+                        <a:srgbClr val="2A3441"/>
+                      </a:solidFill>
+                      <a:prstDash val="solid"/>
+                      <a:round/>
+                      <a:headEnd type="none" w="med" len="med"/>
+                      <a:tailEnd type="none" w="med" len="med"/>
+                    </a:lnB>
+                    <a:solidFill>
+                      <a:srgbClr val="141B24"/>
+                    </a:solidFill>
+                  </a:tcPr>
+                </a:tc>
+                <a:tc>
+                  <a:txBody>
+                    <a:bodyPr/>
+                    <a:lstStyle/>
+                    <a:p>
+                      <a:pPr indent="0" marL="0">
+                        <a:buNone/>
+                      </a:pPr>
+                      <a:r>
+                        <a:rPr lang="en-US" sz="1300" dirty="0">
+                          <a:solidFill>
+                            <a:srgbClr val="E6EDF3"/>
+                          </a:solidFill>
+                          <a:latin typeface="Calibri" pitchFamily="34" charset="0"/>
+                          <a:ea typeface="Calibri" pitchFamily="34" charset="-122"/>
+                          <a:cs typeface="Calibri" pitchFamily="34" charset="-120"/>
+                        </a:rPr>
+                        <a:t>150 ms</a:t>
+                      </a:r>
+                      <a:endParaRPr lang="en-US" sz="1300" dirty="0">
+                        <a:latin typeface="Calibri" charset="0"/>
+                        <a:ea typeface="Calibri" charset="0"/>
+                        <a:cs typeface="Calibri" charset="0"/>
+                      </a:endParaRPr>
+                    </a:p>
+                  </a:txBody>
+                  <a:tcPr marL="91440" marR="91440" marT="45720" marB="45720">
+                    <a:lnL w="12700" cap="flat" cmpd="sng" algn="ctr">
+                      <a:solidFill>
+                        <a:srgbClr val="2A3441"/>
+                      </a:solidFill>
+                      <a:prstDash val="solid"/>
+                      <a:round/>
+                      <a:headEnd type="none" w="med" len="med"/>
+                      <a:tailEnd type="none" w="med" len="med"/>
+                    </a:lnL>
+                    <a:lnR w="12700" cap="flat" cmpd="sng" algn="ctr">
+                      <a:solidFill>
+                        <a:srgbClr val="2A3441"/>
+                      </a:solidFill>
+                      <a:prstDash val="solid"/>
+                      <a:round/>
+                      <a:headEnd type="none" w="med" len="med"/>
+                      <a:tailEnd type="none" w="med" len="med"/>
+                    </a:lnR>
+                    <a:lnT w="12700" cap="flat" cmpd="sng" algn="ctr">
+                      <a:solidFill>
+                        <a:srgbClr val="2A3441"/>
+                      </a:solidFill>
+                      <a:prstDash val="solid"/>
+                      <a:round/>
+                      <a:headEnd type="none" w="med" len="med"/>
+                      <a:tailEnd type="none" w="med" len="med"/>
+                    </a:lnT>
+                    <a:lnB w="12700" cap="flat" cmpd="sng" algn="ctr">
+                      <a:solidFill>
+                        <a:srgbClr val="2A3441"/>
+                      </a:solidFill>
+                      <a:prstDash val="solid"/>
+                      <a:round/>
+                      <a:headEnd type="none" w="med" len="med"/>
+                      <a:tailEnd type="none" w="med" len="med"/>
+                    </a:lnB>
+                    <a:solidFill>
+                      <a:srgbClr val="141B24"/>
+                    </a:solidFill>
+                  </a:tcPr>
+                </a:tc>
+                <a:tc>
+                  <a:txBody>
+                    <a:bodyPr/>
+                    <a:lstStyle/>
+                    <a:p>
+                      <a:pPr indent="0" marL="0">
+                        <a:buNone/>
+                      </a:pPr>
+                      <a:r>
+                        <a:rPr lang="en-US" sz="1300" dirty="0">
+                          <a:solidFill>
+                            <a:srgbClr val="E6EDF3"/>
+                          </a:solidFill>
+                          <a:latin typeface="Calibri" pitchFamily="34" charset="0"/>
+                          <a:ea typeface="Calibri" pitchFamily="34" charset="-122"/>
+                          <a:cs typeface="Calibri" pitchFamily="34" charset="-120"/>
+                        </a:rPr>
+                        <a:t>71%</a:t>
+                      </a:r>
+                      <a:endParaRPr lang="en-US" sz="1300" dirty="0">
+                        <a:latin typeface="Calibri" charset="0"/>
+                        <a:ea typeface="Calibri" charset="0"/>
+                        <a:cs typeface="Calibri" charset="0"/>
+                      </a:endParaRPr>
+                    </a:p>
+                  </a:txBody>
+                  <a:tcPr marL="91440" marR="91440" marT="45720" marB="45720">
+                    <a:lnL w="12700" cap="flat" cmpd="sng" algn="ctr">
+                      <a:solidFill>
+                        <a:srgbClr val="2A3441"/>
+                      </a:solidFill>
+                      <a:prstDash val="solid"/>
+                      <a:round/>
+                      <a:headEnd type="none" w="med" len="med"/>
+                      <a:tailEnd type="none" w="med" len="med"/>
+                    </a:lnL>
+                    <a:lnR w="12700" cap="flat" cmpd="sng" algn="ctr">
+                      <a:solidFill>
+                        <a:srgbClr val="2A3441"/>
+                      </a:solidFill>
+                      <a:prstDash val="solid"/>
+                      <a:round/>
+                      <a:headEnd type="none" w="med" len="med"/>
+                      <a:tailEnd type="none" w="med" len="med"/>
+                    </a:lnR>
+                    <a:lnT w="12700" cap="flat" cmpd="sng" algn="ctr">
+                      <a:solidFill>
+                        <a:srgbClr val="2A3441"/>
+                      </a:solidFill>
+                      <a:prstDash val="solid"/>
+                      <a:round/>
+                      <a:headEnd type="none" w="med" len="med"/>
+                      <a:tailEnd type="none" w="med" len="med"/>
+                    </a:lnT>
+                    <a:lnB w="12700" cap="flat" cmpd="sng" algn="ctr">
+                      <a:solidFill>
+                        <a:srgbClr val="2A3441"/>
+                      </a:solidFill>
+                      <a:prstDash val="solid"/>
+                      <a:round/>
+                      <a:headEnd type="none" w="med" len="med"/>
+                      <a:tailEnd type="none" w="med" len="med"/>
+                    </a:lnB>
+                    <a:solidFill>
+                      <a:srgbClr val="141B24"/>
+                    </a:solidFill>
+                  </a:tcPr>
+                </a:tc>
+                <a:tc>
+                  <a:txBody>
+                    <a:bodyPr/>
+                    <a:lstStyle/>
+                    <a:p>
+                      <a:pPr indent="0" marL="0">
+                        <a:buNone/>
+                      </a:pPr>
+                      <a:r>
+                        <a:rPr lang="en-US" sz="1300" dirty="0">
+                          <a:solidFill>
+                            <a:srgbClr val="E6EDF3"/>
+                          </a:solidFill>
+                          <a:latin typeface="Calibri" pitchFamily="34" charset="0"/>
+                          <a:ea typeface="Calibri" pitchFamily="34" charset="-122"/>
+                          <a:cs typeface="Calibri" pitchFamily="34" charset="-120"/>
+                        </a:rPr>
+                        <a:t>0.84</a:t>
+                      </a:r>
+                      <a:endParaRPr lang="en-US" sz="1300" dirty="0">
+                        <a:latin typeface="Calibri" charset="0"/>
+                        <a:ea typeface="Calibri" charset="0"/>
+                        <a:cs typeface="Calibri" charset="0"/>
+                      </a:endParaRPr>
+                    </a:p>
+                  </a:txBody>
+                  <a:tcPr marL="91440" marR="91440" marT="45720" marB="45720">
+                    <a:lnL w="12700" cap="flat" cmpd="sng" algn="ctr">
+                      <a:solidFill>
+                        <a:srgbClr val="2A3441"/>
+                      </a:solidFill>
+                      <a:prstDash val="solid"/>
+                      <a:round/>
+                      <a:headEnd type="none" w="med" len="med"/>
+                      <a:tailEnd type="none" w="med" len="med"/>
+                    </a:lnL>
+                    <a:lnR w="12700" cap="flat" cmpd="sng" algn="ctr">
+                      <a:solidFill>
+                        <a:srgbClr val="2A3441"/>
+                      </a:solidFill>
+                      <a:prstDash val="solid"/>
+                      <a:round/>
+                      <a:headEnd type="none" w="med" len="med"/>
+                      <a:tailEnd type="none" w="med" len="med"/>
+                    </a:lnR>
+                    <a:lnT w="12700" cap="flat" cmpd="sng" algn="ctr">
+                      <a:solidFill>
+                        <a:srgbClr val="2A3441"/>
+                      </a:solidFill>
+                      <a:prstDash val="solid"/>
+                      <a:round/>
+                      <a:headEnd type="none" w="med" len="med"/>
+                      <a:tailEnd type="none" w="med" len="med"/>
+                    </a:lnT>
+                    <a:lnB w="12700" cap="flat" cmpd="sng" algn="ctr">
+                      <a:solidFill>
+                        <a:srgbClr val="2A3441"/>
+                      </a:solidFill>
+                      <a:prstDash val="solid"/>
+                      <a:round/>
+                      <a:headEnd type="none" w="med" len="med"/>
+                      <a:tailEnd type="none" w="med" len="med"/>
+                    </a:lnB>
+                    <a:solidFill>
+                      <a:srgbClr val="141B24"/>
+                    </a:solidFill>
+                  </a:tcPr>
+                </a:tc>
+              </a:tr>
+            </a:tbl>
+          </a:graphicData>
+        </a:graphic>
+      </p:graphicFrame>
       <p:sp>
         <p:nvSpPr>
-          <p:cNvPr id="4" name="Text 2"/>
+          <p:cNvPr id="5" name="Text 2"/>
           <p:cNvSpPr/>
           <p:nvPr/>
         </p:nvSpPr>
         <p:spPr>
           <a:xfrm>
-            <a:off x="731520" y="4206240"/>
-            <a:ext cx="10058400" cy="457200"/>
+            <a:off x="548640" y="2743200"/>
+            <a:ext cx="11064240" cy="3474720"/>
           </a:xfrm>
           <a:prstGeom prst="rect">
             <a:avLst/>
@@ -28155,24 +31407,112 @@
           <a:ln/>
         </p:spPr>
         <p:txBody>
-          <a:bodyPr wrap="square" lIns="0" tIns="0" rIns="0" bIns="0" rtlCol="0" anchor="ctr"/>
+          <a:bodyPr wrap="square" lIns="0" tIns="0" rIns="0" bIns="0" rtlCol="0" anchor="t"/>
           <a:lstStyle/>
           <a:p>
-            <a:pPr indent="0" marL="0">
-              <a:buNone/>
+            <a:pPr marL="342900" indent="-342900">
+              <a:spcAft>
+                <a:spcPts val="800"/>
+              </a:spcAft>
+              <a:buSzPct val="100000"/>
+              <a:buChar char="•"/>
             </a:pPr>
             <a:r>
-              <a:rPr lang="en-US" sz="1800" dirty="0">
+              <a:rPr lang="en-US" sz="1600" dirty="0">
                 <a:solidFill>
-                  <a:srgbClr val="8B98A5"/>
+                  <a:srgbClr val="E6EDF3"/>
                 </a:solidFill>
                 <a:latin typeface="Calibri" pitchFamily="34" charset="0"/>
                 <a:ea typeface="Calibri" pitchFamily="34" charset="-122"/>
                 <a:cs typeface="Calibri" pitchFamily="34" charset="-120"/>
               </a:rPr>
-              <a:t>Harshavardhan Mallela   Rohit Arya   Shloak Sinha</a:t>
+              <a:t>Neural flows are fairer than AIMD under unequal RTTs, but still favour the short-RTT flow (6 pairs per cell)</a:t>
             </a:r>
-            <a:endParaRPr lang="en-US" sz="1800" dirty="0"/>
+            <a:endParaRPr lang="en-US" sz="1600" dirty="0"/>
+          </a:p>
+          <a:p>
+            <a:pPr marL="342900" indent="-342900">
+              <a:spcAft>
+                <a:spcPts val="800"/>
+              </a:spcAft>
+              <a:buSzPct val="100000"/>
+              <a:buChar char="•"/>
+            </a:pPr>
+            <a:r>
+              <a:rPr lang="en-US" sz="1600" dirty="0">
+                <a:solidFill>
+                  <a:srgbClr val="E6EDF3"/>
+                </a:solidFill>
+                <a:latin typeface="Calibri" pitchFamily="34" charset="0"/>
+                <a:ea typeface="Calibri" pitchFamily="34" charset="-122"/>
+                <a:cs typeface="Calibri" pitchFamily="34" charset="-120"/>
+              </a:rPr>
+              <a:t>A depth-5 decision tree matches the network on only 79% of decisions, yet gives the same transfer time on 4 of 5 paths</a:t>
+            </a:r>
+            <a:endParaRPr lang="en-US" sz="1600" dirty="0"/>
+          </a:p>
+          <a:p>
+            <a:pPr marL="342900" indent="-342900">
+              <a:spcAft>
+                <a:spcPts val="800"/>
+              </a:spcAft>
+              <a:buSzPct val="100000"/>
+              <a:buChar char="•"/>
+            </a:pPr>
+            <a:r>
+              <a:rPr lang="en-US" sz="1600" dirty="0">
+                <a:solidFill>
+                  <a:srgbClr val="E6EDF3"/>
+                </a:solidFill>
+                <a:latin typeface="Calibri" pitchFamily="34" charset="0"/>
+                <a:ea typeface="Calibri" pitchFamily="34" charset="-122"/>
+                <a:cs typeface="Calibri" pitchFamily="34" charset="-120"/>
+              </a:rPr>
+              <a:t>Noise of 0.2 on the inputs costs at most 12%</a:t>
+            </a:r>
+            <a:endParaRPr lang="en-US" sz="1600" dirty="0"/>
+          </a:p>
+          <a:p>
+            <a:pPr marL="342900" indent="-342900">
+              <a:spcAft>
+                <a:spcPts val="800"/>
+              </a:spcAft>
+              <a:buSzPct val="100000"/>
+              <a:buChar char="•"/>
+            </a:pPr>
+            <a:r>
+              <a:rPr lang="en-US" sz="1600" dirty="0">
+                <a:solidFill>
+                  <a:srgbClr val="E6EDF3"/>
+                </a:solidFill>
+                <a:latin typeface="Calibri" pitchFamily="34" charset="0"/>
+                <a:ea typeface="Calibri" pitchFamily="34" charset="-122"/>
+                <a:cs typeface="Calibri" pitchFamily="34" charset="-120"/>
+              </a:rPr>
+              <a:t>Formal interval-bound certification: 43% of decisions at +-0.001, none at +-0.03. It is robust in practice but not proven</a:t>
+            </a:r>
+            <a:endParaRPr lang="en-US" sz="1600" dirty="0"/>
+          </a:p>
+          <a:p>
+            <a:pPr marL="342900" indent="-342900">
+              <a:spcAft>
+                <a:spcPts val="800"/>
+              </a:spcAft>
+              <a:buSzPct val="100000"/>
+              <a:buChar char="•"/>
+            </a:pPr>
+            <a:r>
+              <a:rPr lang="en-US" sz="1600" dirty="0">
+                <a:solidFill>
+                  <a:srgbClr val="E6EDF3"/>
+                </a:solidFill>
+                <a:latin typeface="Calibri" pitchFamily="34" charset="0"/>
+                <a:ea typeface="Calibri" pitchFamily="34" charset="-122"/>
+                <a:cs typeface="Calibri" pitchFamily="34" charset="-120"/>
+              </a:rPr>
+              <a:t>Coexistence with kernel TCP: script written (netem_coexist.sh), measurement still to run</a:t>
+            </a:r>
+            <a:endParaRPr lang="en-US" sz="1600" dirty="0"/>
           </a:p>
         </p:txBody>
       </p:sp>
@@ -28241,6 +31581,578 @@
                 <a:ea typeface="Courier New" pitchFamily="34" charset="-122"/>
                 <a:cs typeface="Courier New" pitchFamily="34" charset="-120"/>
               </a:rPr>
+              <a:t>Learnings and future work</a:t>
+            </a:r>
+            <a:endParaRPr lang="en-US" sz="3000" dirty="0"/>
+          </a:p>
+        </p:txBody>
+      </p:sp>
+      <p:sp>
+        <p:nvSpPr>
+          <p:cNvPr id="3" name="Text 1"/>
+          <p:cNvSpPr/>
+          <p:nvPr/>
+        </p:nvSpPr>
+        <p:spPr>
+          <a:xfrm>
+            <a:off x="9418320" y="6446520"/>
+            <a:ext cx="2377440" cy="274320"/>
+          </a:xfrm>
+          <a:prstGeom prst="rect">
+            <a:avLst/>
+          </a:prstGeom>
+          <a:noFill/>
+          <a:ln/>
+        </p:spPr>
+        <p:txBody>
+          <a:bodyPr wrap="square" lIns="0" tIns="0" rIns="0" bIns="0" rtlCol="0" anchor="ctr"/>
+          <a:lstStyle/>
+          <a:p>
+            <a:pPr algn="r" indent="0" marL="0">
+              <a:buNone/>
+            </a:pPr>
+            <a:r>
+              <a:rPr lang="en-US" sz="1000" dirty="0">
+                <a:solidFill>
+                  <a:srgbClr val="8B98A5"/>
+                </a:solidFill>
+                <a:latin typeface="Courier New" pitchFamily="34" charset="0"/>
+                <a:ea typeface="Courier New" pitchFamily="34" charset="-122"/>
+                <a:cs typeface="Courier New" pitchFamily="34" charset="-120"/>
+              </a:rPr>
+              <a:t>35 / 37   Smart-RUDP</a:t>
+            </a:r>
+            <a:endParaRPr lang="en-US" sz="1000" dirty="0"/>
+          </a:p>
+        </p:txBody>
+      </p:sp>
+      <p:sp>
+        <p:nvSpPr>
+          <p:cNvPr id="4" name="Shape 2"/>
+          <p:cNvSpPr/>
+          <p:nvPr/>
+        </p:nvSpPr>
+        <p:spPr>
+          <a:xfrm>
+            <a:off x="548640" y="1371600"/>
+            <a:ext cx="5394960" cy="4206240"/>
+          </a:xfrm>
+          <a:prstGeom prst="rect">
+            <a:avLst/>
+          </a:prstGeom>
+          <a:solidFill>
+            <a:srgbClr val="141B24"/>
+          </a:solidFill>
+          <a:ln w="12700">
+            <a:solidFill>
+              <a:srgbClr val="39FF88"/>
+            </a:solidFill>
+            <a:prstDash val="solid"/>
+          </a:ln>
+        </p:spPr>
+      </p:sp>
+      <p:sp>
+        <p:nvSpPr>
+          <p:cNvPr id="5" name="Text 3"/>
+          <p:cNvSpPr/>
+          <p:nvPr/>
+        </p:nvSpPr>
+        <p:spPr>
+          <a:xfrm>
+            <a:off x="731520" y="1508760"/>
+            <a:ext cx="5029200" cy="457200"/>
+          </a:xfrm>
+          <a:prstGeom prst="rect">
+            <a:avLst/>
+          </a:prstGeom>
+          <a:noFill/>
+          <a:ln/>
+        </p:spPr>
+        <p:txBody>
+          <a:bodyPr wrap="square" lIns="0" tIns="0" rIns="0" bIns="0" rtlCol="0" anchor="ctr"/>
+          <a:lstStyle/>
+          <a:p>
+            <a:pPr indent="0" marL="0">
+              <a:buNone/>
+            </a:pPr>
+            <a:r>
+              <a:rPr lang="en-US" sz="2000" b="1" dirty="0">
+                <a:solidFill>
+                  <a:srgbClr val="39FF88"/>
+                </a:solidFill>
+                <a:latin typeface="Courier New" pitchFamily="34" charset="0"/>
+                <a:ea typeface="Courier New" pitchFamily="34" charset="-122"/>
+                <a:cs typeface="Courier New" pitchFamily="34" charset="-120"/>
+              </a:rPr>
+              <a:t>Learned</a:t>
+            </a:r>
+            <a:endParaRPr lang="en-US" sz="2000" dirty="0"/>
+          </a:p>
+        </p:txBody>
+      </p:sp>
+      <p:sp>
+        <p:nvSpPr>
+          <p:cNvPr id="6" name="Text 4"/>
+          <p:cNvSpPr/>
+          <p:nvPr/>
+        </p:nvSpPr>
+        <p:spPr>
+          <a:xfrm>
+            <a:off x="731520" y="2011680"/>
+            <a:ext cx="5029200" cy="3429000"/>
+          </a:xfrm>
+          <a:prstGeom prst="rect">
+            <a:avLst/>
+          </a:prstGeom>
+          <a:noFill/>
+          <a:ln/>
+        </p:spPr>
+        <p:txBody>
+          <a:bodyPr wrap="square" lIns="0" tIns="0" rIns="0" bIns="0" rtlCol="0" anchor="t"/>
+          <a:lstStyle/>
+          <a:p>
+            <a:pPr indent="0" marL="0">
+              <a:buNone/>
+            </a:pPr>
+            <a:r>
+              <a:rPr lang="en-US" sz="2000" dirty="0">
+                <a:solidFill>
+                  <a:srgbClr val="E6EDF3"/>
+                </a:solidFill>
+                <a:latin typeface="Calibri" pitchFamily="34" charset="0"/>
+                <a:ea typeface="Calibri" pitchFamily="34" charset="-122"/>
+                <a:cs typeface="Calibri" pitchFamily="34" charset="-120"/>
+              </a:rPr>
+              <a:t>Reliability is a set of simple rules working together.</a:t>
+            </a:r>
+            <a:endParaRPr lang="en-US" sz="2000" dirty="0"/>
+          </a:p>
+          <a:p>
+            <a:pPr indent="0" marL="0">
+              <a:buNone/>
+            </a:pPr>
+            <a:r>
+              <a:rPr lang="en-US" sz="2000" dirty="0">
+                <a:solidFill>
+                  <a:srgbClr val="E6EDF3"/>
+                </a:solidFill>
+                <a:latin typeface="Calibri" pitchFamily="34" charset="0"/>
+                <a:ea typeface="Calibri" pitchFamily="34" charset="-122"/>
+                <a:cs typeface="Calibri" pitchFamily="34" charset="-120"/>
+              </a:rPr>
+              <a:t>Congestion control matters as much as retransmission.</a:t>
+            </a:r>
+            <a:endParaRPr lang="en-US" sz="2000" dirty="0"/>
+          </a:p>
+          <a:p>
+            <a:pPr indent="0" marL="0">
+              <a:buNone/>
+            </a:pPr>
+            <a:r>
+              <a:rPr lang="en-US" sz="2000" dirty="0">
+                <a:solidFill>
+                  <a:srgbClr val="E6EDF3"/>
+                </a:solidFill>
+                <a:latin typeface="Calibri" pitchFamily="34" charset="0"/>
+                <a:ea typeface="Calibri" pitchFamily="34" charset="-122"/>
+                <a:cs typeface="Calibri" pitchFamily="34" charset="-120"/>
+              </a:rPr>
+              <a:t>Testing tools fail in surprising ways.</a:t>
+            </a:r>
+            <a:endParaRPr lang="en-US" sz="2000" dirty="0"/>
+          </a:p>
+        </p:txBody>
+      </p:sp>
+      <p:sp>
+        <p:nvSpPr>
+          <p:cNvPr id="7" name="Shape 5"/>
+          <p:cNvSpPr/>
+          <p:nvPr/>
+        </p:nvSpPr>
+        <p:spPr>
+          <a:xfrm>
+            <a:off x="6217920" y="1371600"/>
+            <a:ext cx="5394960" cy="4206240"/>
+          </a:xfrm>
+          <a:prstGeom prst="rect">
+            <a:avLst/>
+          </a:prstGeom>
+          <a:solidFill>
+            <a:srgbClr val="141B24"/>
+          </a:solidFill>
+          <a:ln w="12700">
+            <a:solidFill>
+              <a:srgbClr val="FFB000"/>
+            </a:solidFill>
+            <a:prstDash val="solid"/>
+          </a:ln>
+        </p:spPr>
+      </p:sp>
+      <p:sp>
+        <p:nvSpPr>
+          <p:cNvPr id="8" name="Text 6"/>
+          <p:cNvSpPr/>
+          <p:nvPr/>
+        </p:nvSpPr>
+        <p:spPr>
+          <a:xfrm>
+            <a:off x="6400800" y="1508760"/>
+            <a:ext cx="5029200" cy="457200"/>
+          </a:xfrm>
+          <a:prstGeom prst="rect">
+            <a:avLst/>
+          </a:prstGeom>
+          <a:noFill/>
+          <a:ln/>
+        </p:spPr>
+        <p:txBody>
+          <a:bodyPr wrap="square" lIns="0" tIns="0" rIns="0" bIns="0" rtlCol="0" anchor="ctr"/>
+          <a:lstStyle/>
+          <a:p>
+            <a:pPr indent="0" marL="0">
+              <a:buNone/>
+            </a:pPr>
+            <a:r>
+              <a:rPr lang="en-US" sz="2000" b="1" dirty="0">
+                <a:solidFill>
+                  <a:srgbClr val="FFB000"/>
+                </a:solidFill>
+                <a:latin typeface="Courier New" pitchFamily="34" charset="0"/>
+                <a:ea typeface="Courier New" pitchFamily="34" charset="-122"/>
+                <a:cs typeface="Courier New" pitchFamily="34" charset="-120"/>
+              </a:rPr>
+              <a:t>Next</a:t>
+            </a:r>
+            <a:endParaRPr lang="en-US" sz="2000" dirty="0"/>
+          </a:p>
+        </p:txBody>
+      </p:sp>
+      <p:sp>
+        <p:nvSpPr>
+          <p:cNvPr id="9" name="Text 7"/>
+          <p:cNvSpPr/>
+          <p:nvPr/>
+        </p:nvSpPr>
+        <p:spPr>
+          <a:xfrm>
+            <a:off x="6400800" y="2011680"/>
+            <a:ext cx="5029200" cy="3429000"/>
+          </a:xfrm>
+          <a:prstGeom prst="rect">
+            <a:avLst/>
+          </a:prstGeom>
+          <a:noFill/>
+          <a:ln/>
+        </p:spPr>
+        <p:txBody>
+          <a:bodyPr wrap="square" lIns="0" tIns="0" rIns="0" bIns="0" rtlCol="0" anchor="t"/>
+          <a:lstStyle/>
+          <a:p>
+            <a:pPr indent="0" marL="0">
+              <a:buNone/>
+            </a:pPr>
+            <a:r>
+              <a:rPr lang="en-US" sz="2000" dirty="0">
+                <a:solidFill>
+                  <a:srgbClr val="E6EDF3"/>
+                </a:solidFill>
+                <a:latin typeface="Calibri" pitchFamily="34" charset="0"/>
+                <a:ea typeface="Calibri" pitchFamily="34" charset="-122"/>
+                <a:cs typeface="Calibri" pitchFamily="34" charset="-120"/>
+              </a:rPr>
+              <a:t>Fairness-aware training, TCP coexistence</a:t>
+            </a:r>
+            <a:endParaRPr lang="en-US" sz="2000" dirty="0"/>
+          </a:p>
+          <a:p>
+            <a:pPr indent="0" marL="0">
+              <a:buNone/>
+            </a:pPr>
+            <a:r>
+              <a:rPr lang="en-US" sz="2000" dirty="0">
+                <a:solidFill>
+                  <a:srgbClr val="E6EDF3"/>
+                </a:solidFill>
+                <a:latin typeface="Calibri" pitchFamily="34" charset="0"/>
+                <a:ea typeface="Calibri" pitchFamily="34" charset="-122"/>
+                <a:cs typeface="Calibri" pitchFamily="34" charset="-120"/>
+              </a:rPr>
+              <a:t>Train on real traces with cross traffic</a:t>
+            </a:r>
+            <a:endParaRPr lang="en-US" sz="2000" dirty="0"/>
+          </a:p>
+          <a:p>
+            <a:pPr indent="0" marL="0">
+              <a:buNone/>
+            </a:pPr>
+            <a:r>
+              <a:rPr lang="en-US" sz="2000" dirty="0">
+                <a:solidFill>
+                  <a:srgbClr val="E6EDF3"/>
+                </a:solidFill>
+                <a:latin typeface="Calibri" pitchFamily="34" charset="0"/>
+                <a:ea typeface="Calibri" pitchFamily="34" charset="-122"/>
+                <a:cs typeface="Calibri" pitchFamily="34" charset="-120"/>
+              </a:rPr>
+              <a:t>Close the gap to kernel TCP; real multi-machine tests</a:t>
+            </a:r>
+            <a:endParaRPr lang="en-US" sz="2000" dirty="0"/>
+          </a:p>
+        </p:txBody>
+      </p:sp>
+      <p:sp>
+        <p:nvSpPr>
+          <p:cNvPr id="10" name="Text 8"/>
+          <p:cNvSpPr/>
+          <p:nvPr/>
+        </p:nvSpPr>
+        <p:spPr>
+          <a:xfrm>
+            <a:off x="548640" y="5852160"/>
+            <a:ext cx="10972800" cy="365760"/>
+          </a:xfrm>
+          <a:prstGeom prst="rect">
+            <a:avLst/>
+          </a:prstGeom>
+          <a:noFill/>
+          <a:ln/>
+        </p:spPr>
+        <p:txBody>
+          <a:bodyPr wrap="square" lIns="0" tIns="0" rIns="0" bIns="0" rtlCol="0" anchor="ctr"/>
+          <a:lstStyle/>
+          <a:p>
+            <a:pPr indent="0" marL="0">
+              <a:buNone/>
+            </a:pPr>
+            <a:r>
+              <a:rPr lang="en-US" sz="1400" dirty="0">
+                <a:solidFill>
+                  <a:srgbClr val="8B98A5"/>
+                </a:solidFill>
+                <a:latin typeface="Calibri" pitchFamily="34" charset="0"/>
+                <a:ea typeface="Calibri" pitchFamily="34" charset="-122"/>
+                <a:cs typeface="Calibri" pitchFamily="34" charset="-120"/>
+              </a:rPr>
+              <a:t>Limits: kernel TCP is 1.5x to 3.2x faster; no multi-machine test; polite mode is a hand-made rule that costs speed; level with CUBIC under bursty cross traffic; no gain at 10% random loss; BBR-style baseline is faster on the 2% lossy path; coexistence with kernel TCP not yet measured.</a:t>
+            </a:r>
+            <a:endParaRPr lang="en-US" sz="1400" dirty="0"/>
+          </a:p>
+        </p:txBody>
+      </p:sp>
+    </p:spTree>
+  </p:cSld>
+  <p:clrMapOvr>
+    <a:masterClrMapping/>
+  </p:clrMapOvr>
+</p:sld>
+</file>
+
+<file path=ppt/slides/slide36.xml><?xml version="1.0" encoding="utf-8"?>
+<p:sld xmlns:a="http://schemas.openxmlformats.org/drawingml/2006/main" xmlns:r="http://schemas.openxmlformats.org/officeDocument/2006/relationships" xmlns:p="http://schemas.openxmlformats.org/presentationml/2006/main">
+  <p:cSld name="Slide 36">
+    <p:bg>
+      <p:bgPr>
+        <a:solidFill>
+          <a:srgbClr val="0B0F14"/>
+        </a:solidFill>
+      </p:bgPr>
+    </p:bg>
+    <p:spTree>
+      <p:nvGrpSpPr>
+        <p:cNvPr id="1" name=""/>
+        <p:cNvGrpSpPr/>
+        <p:nvPr/>
+      </p:nvGrpSpPr>
+      <p:grpSpPr>
+        <a:xfrm>
+          <a:off x="0" y="0"/>
+          <a:ext cx="0" cy="0"/>
+          <a:chOff x="0" y="0"/>
+          <a:chExt cx="0" cy="0"/>
+        </a:xfrm>
+      </p:grpSpPr>
+      <p:sp>
+        <p:nvSpPr>
+          <p:cNvPr id="2" name="Text 0"/>
+          <p:cNvSpPr/>
+          <p:nvPr/>
+        </p:nvSpPr>
+        <p:spPr>
+          <a:xfrm>
+            <a:off x="731520" y="2103120"/>
+            <a:ext cx="10058400" cy="1097280"/>
+          </a:xfrm>
+          <a:prstGeom prst="rect">
+            <a:avLst/>
+          </a:prstGeom>
+          <a:noFill/>
+          <a:ln/>
+        </p:spPr>
+        <p:txBody>
+          <a:bodyPr wrap="square" lIns="0" tIns="0" rIns="0" bIns="0" rtlCol="0" anchor="ctr"/>
+          <a:lstStyle/>
+          <a:p>
+            <a:pPr indent="0" marL="0">
+              <a:buNone/>
+            </a:pPr>
+            <a:r>
+              <a:rPr lang="en-US" sz="6400" b="1" dirty="0">
+                <a:solidFill>
+                  <a:srgbClr val="39FF88"/>
+                </a:solidFill>
+                <a:latin typeface="Courier New" pitchFamily="34" charset="0"/>
+                <a:ea typeface="Courier New" pitchFamily="34" charset="-122"/>
+                <a:cs typeface="Courier New" pitchFamily="34" charset="-120"/>
+              </a:rPr>
+              <a:t>Thank you</a:t>
+            </a:r>
+            <a:endParaRPr lang="en-US" sz="6400" dirty="0"/>
+          </a:p>
+        </p:txBody>
+      </p:sp>
+      <p:sp>
+        <p:nvSpPr>
+          <p:cNvPr id="3" name="Text 1"/>
+          <p:cNvSpPr/>
+          <p:nvPr/>
+        </p:nvSpPr>
+        <p:spPr>
+          <a:xfrm>
+            <a:off x="731520" y="3474720"/>
+            <a:ext cx="10058400" cy="548640"/>
+          </a:xfrm>
+          <a:prstGeom prst="rect">
+            <a:avLst/>
+          </a:prstGeom>
+          <a:noFill/>
+          <a:ln/>
+        </p:spPr>
+        <p:txBody>
+          <a:bodyPr wrap="square" lIns="0" tIns="0" rIns="0" bIns="0" rtlCol="0" anchor="ctr"/>
+          <a:lstStyle/>
+          <a:p>
+            <a:pPr indent="0" marL="0">
+              <a:buNone/>
+            </a:pPr>
+            <a:r>
+              <a:rPr lang="en-US" sz="2600" dirty="0">
+                <a:solidFill>
+                  <a:srgbClr val="E6EDF3"/>
+                </a:solidFill>
+                <a:latin typeface="Courier New" pitchFamily="34" charset="0"/>
+                <a:ea typeface="Courier New" pitchFamily="34" charset="-122"/>
+                <a:cs typeface="Courier New" pitchFamily="34" charset="-120"/>
+              </a:rPr>
+              <a:t>github.com/Capsturrrr/rudp</a:t>
+            </a:r>
+            <a:endParaRPr lang="en-US" sz="2600" dirty="0"/>
+          </a:p>
+        </p:txBody>
+      </p:sp>
+      <p:sp>
+        <p:nvSpPr>
+          <p:cNvPr id="4" name="Text 2"/>
+          <p:cNvSpPr/>
+          <p:nvPr/>
+        </p:nvSpPr>
+        <p:spPr>
+          <a:xfrm>
+            <a:off x="731520" y="4206240"/>
+            <a:ext cx="10058400" cy="457200"/>
+          </a:xfrm>
+          <a:prstGeom prst="rect">
+            <a:avLst/>
+          </a:prstGeom>
+          <a:noFill/>
+          <a:ln/>
+        </p:spPr>
+        <p:txBody>
+          <a:bodyPr wrap="square" lIns="0" tIns="0" rIns="0" bIns="0" rtlCol="0" anchor="ctr"/>
+          <a:lstStyle/>
+          <a:p>
+            <a:pPr indent="0" marL="0">
+              <a:buNone/>
+            </a:pPr>
+            <a:r>
+              <a:rPr lang="en-US" sz="1800" dirty="0">
+                <a:solidFill>
+                  <a:srgbClr val="8B98A5"/>
+                </a:solidFill>
+                <a:latin typeface="Calibri" pitchFamily="34" charset="0"/>
+                <a:ea typeface="Calibri" pitchFamily="34" charset="-122"/>
+                <a:cs typeface="Calibri" pitchFamily="34" charset="-120"/>
+              </a:rPr>
+              <a:t>Harshavardhan Mallela   Rohit Arya   Shloak Sinha</a:t>
+            </a:r>
+            <a:endParaRPr lang="en-US" sz="1800" dirty="0"/>
+          </a:p>
+        </p:txBody>
+      </p:sp>
+    </p:spTree>
+  </p:cSld>
+  <p:clrMapOvr>
+    <a:masterClrMapping/>
+  </p:clrMapOvr>
+</p:sld>
+</file>
+
+<file path=ppt/slides/slide37.xml><?xml version="1.0" encoding="utf-8"?>
+<p:sld xmlns:a="http://schemas.openxmlformats.org/drawingml/2006/main" xmlns:r="http://schemas.openxmlformats.org/officeDocument/2006/relationships" xmlns:p="http://schemas.openxmlformats.org/presentationml/2006/main">
+  <p:cSld name="Slide 37">
+    <p:bg>
+      <p:bgPr>
+        <a:solidFill>
+          <a:srgbClr val="0B0F14"/>
+        </a:solidFill>
+      </p:bgPr>
+    </p:bg>
+    <p:spTree>
+      <p:nvGrpSpPr>
+        <p:cNvPr id="1" name=""/>
+        <p:cNvGrpSpPr/>
+        <p:nvPr/>
+      </p:nvGrpSpPr>
+      <p:grpSpPr>
+        <a:xfrm>
+          <a:off x="0" y="0"/>
+          <a:ext cx="0" cy="0"/>
+          <a:chOff x="0" y="0"/>
+          <a:chExt cx="0" cy="0"/>
+        </a:xfrm>
+      </p:grpSpPr>
+      <p:sp>
+        <p:nvSpPr>
+          <p:cNvPr id="2" name="Text 0"/>
+          <p:cNvSpPr/>
+          <p:nvPr/>
+        </p:nvSpPr>
+        <p:spPr>
+          <a:xfrm>
+            <a:off x="548640" y="320040"/>
+            <a:ext cx="11064240" cy="731520"/>
+          </a:xfrm>
+          <a:prstGeom prst="rect">
+            <a:avLst/>
+          </a:prstGeom>
+          <a:noFill/>
+          <a:ln/>
+        </p:spPr>
+        <p:txBody>
+          <a:bodyPr wrap="square" lIns="0" tIns="0" rIns="0" bIns="0" rtlCol="0" anchor="ctr"/>
+          <a:lstStyle/>
+          <a:p>
+            <a:pPr indent="0" marL="0">
+              <a:buNone/>
+            </a:pPr>
+            <a:r>
+              <a:rPr lang="en-US" sz="3000" b="1" dirty="0">
+                <a:solidFill>
+                  <a:srgbClr val="39FF88"/>
+                </a:solidFill>
+                <a:latin typeface="Courier New" pitchFamily="34" charset="0"/>
+                <a:ea typeface="Courier New" pitchFamily="34" charset="-122"/>
+                <a:cs typeface="Courier New" pitchFamily="34" charset="-120"/>
+              </a:rPr>
               <a:t>Appendix: slow start and congestion avoidance</a:t>
             </a:r>
             <a:endParaRPr lang="en-US" sz="3000" dirty="0"/>
@@ -28520,7 +32432,7 @@
                 <a:ea typeface="Courier New" pitchFamily="34" charset="-122"/>
                 <a:cs typeface="Courier New" pitchFamily="34" charset="-120"/>
               </a:rPr>
-              <a:t>4 / 35   Smart-RUDP</a:t>
+              <a:t>4 / 37   Smart-RUDP</a:t>
             </a:r>
             <a:endParaRPr lang="en-US" sz="1000" dirty="0"/>
           </a:p>
@@ -29081,7 +32993,7 @@
                 <a:ea typeface="Courier New" pitchFamily="34" charset="-122"/>
                 <a:cs typeface="Courier New" pitchFamily="34" charset="-120"/>
               </a:rPr>
-              <a:t>5 / 35   Smart-RUDP</a:t>
+              <a:t>5 / 37   Smart-RUDP</a:t>
             </a:r>
             <a:endParaRPr lang="en-US" sz="1000" dirty="0"/>
           </a:p>
@@ -30520,7 +34432,7 @@
                 <a:ea typeface="Courier New" pitchFamily="34" charset="-122"/>
                 <a:cs typeface="Courier New" pitchFamily="34" charset="-120"/>
               </a:rPr>
-              <a:t>6 / 35   Smart-RUDP</a:t>
+              <a:t>6 / 37   Smart-RUDP</a:t>
             </a:r>
             <a:endParaRPr lang="en-US" sz="1000" dirty="0"/>
           </a:p>
@@ -31755,7 +35667,7 @@
                 <a:ea typeface="Courier New" pitchFamily="34" charset="-122"/>
                 <a:cs typeface="Courier New" pitchFamily="34" charset="-120"/>
               </a:rPr>
-              <a:t>7 / 35   Smart-RUDP</a:t>
+              <a:t>7 / 37   Smart-RUDP</a:t>
             </a:r>
             <a:endParaRPr lang="en-US" sz="1000" dirty="0"/>
           </a:p>
@@ -32198,7 +36110,7 @@
                 <a:ea typeface="Courier New" pitchFamily="34" charset="-122"/>
                 <a:cs typeface="Courier New" pitchFamily="34" charset="-120"/>
               </a:rPr>
-              <a:t>8 / 35   Smart-RUDP</a:t>
+              <a:t>8 / 37   Smart-RUDP</a:t>
             </a:r>
             <a:endParaRPr lang="en-US" sz="1000" dirty="0"/>
           </a:p>
@@ -32498,7 +36410,7 @@
                 <a:ea typeface="Courier New" pitchFamily="34" charset="-122"/>
                 <a:cs typeface="Courier New" pitchFamily="34" charset="-120"/>
               </a:rPr>
-              <a:t>9 / 35   Smart-RUDP</a:t>
+              <a:t>9 / 37   Smart-RUDP</a:t>
             </a:r>
             <a:endParaRPr lang="en-US" sz="1000" dirty="0"/>
           </a:p>

</xml_diff>